<commit_message>
Removed unused placeholders in template
</commit_message>
<xml_diff>
--- a/src/report_generator/presets/templates/sigrid-template.pptx
+++ b/src/report_generator/presets/templates/sigrid-template.pptx
@@ -5,17 +5,16 @@
     <p:sldMasterId id="2147483648" r:id="rId4"/>
   </p:sldMasterIdLst>
   <p:notesMasterIdLst>
-    <p:notesMasterId r:id="rId10"/>
+    <p:notesMasterId r:id="rId9"/>
   </p:notesMasterIdLst>
   <p:handoutMasterIdLst>
-    <p:handoutMasterId r:id="rId11"/>
+    <p:handoutMasterId r:id="rId10"/>
   </p:handoutMasterIdLst>
   <p:sldIdLst>
     <p:sldId id="561" r:id="rId5"/>
     <p:sldId id="10721" r:id="rId6"/>
     <p:sldId id="10723" r:id="rId7"/>
-    <p:sldId id="10722" r:id="rId8"/>
-    <p:sldId id="597" r:id="rId9"/>
+    <p:sldId id="597" r:id="rId8"/>
   </p:sldIdLst>
   <p:sldSz cx="12192000" cy="6858000"/>
   <p:notesSz cx="6858000" cy="9144000"/>
@@ -21143,145 +21142,6 @@
       </p:sp>
       <p:sp>
         <p:nvSpPr>
-          <p:cNvPr id="5" name="Footer Placeholder 4">
-            <a:extLst>
-              <a:ext uri="{FF2B5EF4-FFF2-40B4-BE49-F238E27FC236}">
-                <a16:creationId xmlns:a16="http://schemas.microsoft.com/office/drawing/2014/main" id="{F845371E-84E5-F7D9-2E92-78DA0190B33D}"/>
-              </a:ext>
-            </a:extLst>
-          </p:cNvPr>
-          <p:cNvSpPr>
-            <a:spLocks noGrp="1"/>
-          </p:cNvSpPr>
-          <p:nvPr>
-            <p:ph type="ftr" sz="quarter" idx="3"/>
-          </p:nvPr>
-        </p:nvSpPr>
-        <p:spPr>
-          <a:xfrm>
-            <a:off x="2669790" y="6549140"/>
-            <a:ext cx="804066" cy="236406"/>
-          </a:xfrm>
-          <a:prstGeom prst="rect">
-            <a:avLst/>
-          </a:prstGeom>
-          <a:noFill/>
-          <a:ln w="12700" cap="flat" cmpd="sng" algn="ctr">
-            <a:noFill/>
-            <a:prstDash val="solid"/>
-            <a:miter lim="800000"/>
-          </a:ln>
-        </p:spPr>
-        <p:txBody>
-          <a:bodyPr wrap="none" lIns="0" tIns="36000" rIns="0" rtlCol="0" anchor="ctr">
-            <a:spAutoFit/>
-          </a:bodyPr>
-          <a:lstStyle>
-            <a:defPPr>
-              <a:defRPr lang="en-US"/>
-            </a:defPPr>
-            <a:lvl1pPr marL="0" algn="l" defTabSz="914400" rtl="0" eaLnBrk="1" latinLnBrk="0" hangingPunct="1">
-              <a:defRPr lang="en-US" sz="1000" b="1" kern="1200" cap="all" spc="10" baseline="0" dirty="0">
-                <a:solidFill>
-                  <a:srgbClr val="B2BECD"/>
-                </a:solidFill>
-                <a:latin typeface="+mn-lt"/>
-                <a:ea typeface="+mn-ea"/>
-                <a:cs typeface="+mn-cs"/>
-              </a:defRPr>
-            </a:lvl1pPr>
-            <a:lvl2pPr marL="457200" algn="l" defTabSz="914400" rtl="0" eaLnBrk="1" latinLnBrk="0" hangingPunct="1">
-              <a:defRPr sz="1800" kern="1200">
-                <a:solidFill>
-                  <a:schemeClr val="lt1"/>
-                </a:solidFill>
-                <a:latin typeface="+mn-lt"/>
-                <a:ea typeface="+mn-ea"/>
-                <a:cs typeface="+mn-cs"/>
-              </a:defRPr>
-            </a:lvl2pPr>
-            <a:lvl3pPr marL="914400" algn="l" defTabSz="914400" rtl="0" eaLnBrk="1" latinLnBrk="0" hangingPunct="1">
-              <a:defRPr sz="1800" kern="1200">
-                <a:solidFill>
-                  <a:schemeClr val="lt1"/>
-                </a:solidFill>
-                <a:latin typeface="+mn-lt"/>
-                <a:ea typeface="+mn-ea"/>
-                <a:cs typeface="+mn-cs"/>
-              </a:defRPr>
-            </a:lvl3pPr>
-            <a:lvl4pPr marL="1371600" algn="l" defTabSz="914400" rtl="0" eaLnBrk="1" latinLnBrk="0" hangingPunct="1">
-              <a:defRPr sz="1800" kern="1200">
-                <a:solidFill>
-                  <a:schemeClr val="lt1"/>
-                </a:solidFill>
-                <a:latin typeface="+mn-lt"/>
-                <a:ea typeface="+mn-ea"/>
-                <a:cs typeface="+mn-cs"/>
-              </a:defRPr>
-            </a:lvl4pPr>
-            <a:lvl5pPr marL="1828800" algn="l" defTabSz="914400" rtl="0" eaLnBrk="1" latinLnBrk="0" hangingPunct="1">
-              <a:defRPr sz="1800" kern="1200">
-                <a:solidFill>
-                  <a:schemeClr val="lt1"/>
-                </a:solidFill>
-                <a:latin typeface="+mn-lt"/>
-                <a:ea typeface="+mn-ea"/>
-                <a:cs typeface="+mn-cs"/>
-              </a:defRPr>
-            </a:lvl5pPr>
-            <a:lvl6pPr marL="2286000" algn="l" defTabSz="914400" rtl="0" eaLnBrk="1" latinLnBrk="0" hangingPunct="1">
-              <a:defRPr sz="1800" kern="1200">
-                <a:solidFill>
-                  <a:schemeClr val="lt1"/>
-                </a:solidFill>
-                <a:latin typeface="+mn-lt"/>
-                <a:ea typeface="+mn-ea"/>
-                <a:cs typeface="+mn-cs"/>
-              </a:defRPr>
-            </a:lvl6pPr>
-            <a:lvl7pPr marL="2743200" algn="l" defTabSz="914400" rtl="0" eaLnBrk="1" latinLnBrk="0" hangingPunct="1">
-              <a:defRPr sz="1800" kern="1200">
-                <a:solidFill>
-                  <a:schemeClr val="lt1"/>
-                </a:solidFill>
-                <a:latin typeface="+mn-lt"/>
-                <a:ea typeface="+mn-ea"/>
-                <a:cs typeface="+mn-cs"/>
-              </a:defRPr>
-            </a:lvl7pPr>
-            <a:lvl8pPr marL="3200400" algn="l" defTabSz="914400" rtl="0" eaLnBrk="1" latinLnBrk="0" hangingPunct="1">
-              <a:defRPr sz="1800" kern="1200">
-                <a:solidFill>
-                  <a:schemeClr val="lt1"/>
-                </a:solidFill>
-                <a:latin typeface="+mn-lt"/>
-                <a:ea typeface="+mn-ea"/>
-                <a:cs typeface="+mn-cs"/>
-              </a:defRPr>
-            </a:lvl8pPr>
-            <a:lvl9pPr marL="3657600" algn="l" defTabSz="914400" rtl="0" eaLnBrk="1" latinLnBrk="0" hangingPunct="1">
-              <a:defRPr sz="1800" kern="1200">
-                <a:solidFill>
-                  <a:schemeClr val="lt1"/>
-                </a:solidFill>
-                <a:latin typeface="+mn-lt"/>
-                <a:ea typeface="+mn-ea"/>
-                <a:cs typeface="+mn-cs"/>
-              </a:defRPr>
-            </a:lvl9pPr>
-          </a:lstStyle>
-          <a:p>
-            <a:r>
-              <a:rPr lang="en-US"/>
-              <a:t>Confidential</a:t>
-            </a:r>
-            <a:endParaRPr lang="en-US" noProof="0" dirty="0"/>
-          </a:p>
-        </p:txBody>
-      </p:sp>
-      <p:sp>
-        <p:nvSpPr>
           <p:cNvPr id="8" name="Content Placeholder 7">
             <a:extLst>
               <a:ext uri="{FF2B5EF4-FFF2-40B4-BE49-F238E27FC236}">
@@ -23088,66 +22948,6 @@
           </a:p>
         </p:txBody>
       </p:sp>
-      <p:sp>
-        <p:nvSpPr>
-          <p:cNvPr id="2" name="TextBox 1">
-            <a:extLst>
-              <a:ext uri="{FF2B5EF4-FFF2-40B4-BE49-F238E27FC236}">
-                <a16:creationId xmlns:a16="http://schemas.microsoft.com/office/drawing/2014/main" id="{996EDCDD-87F3-96CE-A560-5B1AFA017C6C}"/>
-              </a:ext>
-            </a:extLst>
-          </p:cNvPr>
-          <p:cNvSpPr txBox="1"/>
-          <p:nvPr/>
-        </p:nvSpPr>
-        <p:spPr>
-          <a:xfrm>
-            <a:off x="5667804" y="-487693"/>
-            <a:ext cx="3555738" cy="355225"/>
-          </a:xfrm>
-          <a:prstGeom prst="rect">
-            <a:avLst/>
-          </a:prstGeom>
-          <a:noFill/>
-        </p:spPr>
-        <p:txBody>
-          <a:bodyPr wrap="none" lIns="90000" rtlCol="0" anchor="t">
-            <a:spAutoFit/>
-          </a:bodyPr>
-          <a:lstStyle/>
-          <a:p>
-            <a:pPr algn="l">
-              <a:lnSpc>
-                <a:spcPct val="113000"/>
-              </a:lnSpc>
-            </a:pPr>
-            <a:r>
-              <a:rPr lang="en-US" sz="1600" dirty="0">
-                <a:solidFill>
-                  <a:schemeClr val="tx2"/>
-                </a:solidFill>
-              </a:rPr>
-              <a:t>INTERVAL_</a:t>
-            </a:r>
-            <a:r>
-              <a:rPr lang="en-US" sz="1600">
-                <a:solidFill>
-                  <a:schemeClr val="tx2"/>
-                </a:solidFill>
-              </a:rPr>
-              <a:t>PORTFOLIO_qw:</a:t>
-            </a:r>
-            <a:r>
-              <a:rPr lang="en-US" sz="1600" dirty="0">
-                <a:solidFill>
-                  <a:schemeClr val="tx2"/>
-                </a:solidFill>
-              </a:rPr>
-              <a:t>0.56:3.5:9.57</a:t>
-            </a:r>
-          </a:p>
-        </p:txBody>
-      </p:sp>
       <p:pic>
         <p:nvPicPr>
           <p:cNvPr id="12" name="Graphic 11">
@@ -23184,58 +22984,6 @@
           </a:prstGeom>
         </p:spPr>
       </p:pic>
-      <p:sp>
-        <p:nvSpPr>
-          <p:cNvPr id="4" name="TextBox 3">
-            <a:extLst>
-              <a:ext uri="{FF2B5EF4-FFF2-40B4-BE49-F238E27FC236}">
-                <a16:creationId xmlns:a16="http://schemas.microsoft.com/office/drawing/2014/main" id="{75370DE3-A78F-42E4-002C-0542C31CED92}"/>
-              </a:ext>
-            </a:extLst>
-          </p:cNvPr>
-          <p:cNvSpPr txBox="1"/>
-          <p:nvPr/>
-        </p:nvSpPr>
-        <p:spPr>
-          <a:xfrm>
-            <a:off x="5789382" y="-826903"/>
-            <a:ext cx="3998167" cy="355162"/>
-          </a:xfrm>
-          <a:prstGeom prst="rect">
-            <a:avLst/>
-          </a:prstGeom>
-          <a:noFill/>
-        </p:spPr>
-        <p:txBody>
-          <a:bodyPr wrap="none" lIns="90000" rtlCol="0" anchor="t">
-            <a:spAutoFit/>
-          </a:bodyPr>
-          <a:lstStyle/>
-          <a:p>
-            <a:pPr algn="l">
-              <a:lnSpc>
-                <a:spcPct val="113000"/>
-              </a:lnSpc>
-            </a:pPr>
-            <a:r>
-              <a:rPr lang="en-US" sz="1600" dirty="0" err="1">
-                <a:solidFill>
-                  <a:schemeClr val="tx2"/>
-                </a:solidFill>
-              </a:rPr>
-              <a:t>INTERVAL_PORTFOLIO</a:t>
-            </a:r>
-            <a:r>
-              <a:rPr lang="en-US" sz="1600" dirty="0">
-                <a:solidFill>
-                  <a:schemeClr val="tx2"/>
-                </a:solidFill>
-              </a:rPr>
-              <a:t>_@@MAINTAINABILITY</a:t>
-            </a:r>
-          </a:p>
-        </p:txBody>
-      </p:sp>
       <p:sp>
         <p:nvSpPr>
           <p:cNvPr id="11" name="Rectangle 10">
@@ -24164,145 +23912,6 @@
               <a:rPr lang="en-US" noProof="0" dirty="0"/>
               <a:t>@@</a:t>
             </a:r>
-          </a:p>
-        </p:txBody>
-      </p:sp>
-      <p:sp>
-        <p:nvSpPr>
-          <p:cNvPr id="5" name="Footer Placeholder 4">
-            <a:extLst>
-              <a:ext uri="{FF2B5EF4-FFF2-40B4-BE49-F238E27FC236}">
-                <a16:creationId xmlns:a16="http://schemas.microsoft.com/office/drawing/2014/main" id="{5167BF57-5E4C-ADD6-A093-1222F27C8F3E}"/>
-              </a:ext>
-            </a:extLst>
-          </p:cNvPr>
-          <p:cNvSpPr>
-            <a:spLocks noGrp="1"/>
-          </p:cNvSpPr>
-          <p:nvPr>
-            <p:ph type="ftr" sz="quarter" idx="3"/>
-          </p:nvPr>
-        </p:nvSpPr>
-        <p:spPr>
-          <a:xfrm>
-            <a:off x="2669790" y="6549140"/>
-            <a:ext cx="804066" cy="236406"/>
-          </a:xfrm>
-          <a:prstGeom prst="rect">
-            <a:avLst/>
-          </a:prstGeom>
-          <a:noFill/>
-          <a:ln w="12700" cap="flat" cmpd="sng" algn="ctr">
-            <a:noFill/>
-            <a:prstDash val="solid"/>
-            <a:miter lim="800000"/>
-          </a:ln>
-        </p:spPr>
-        <p:txBody>
-          <a:bodyPr wrap="none" lIns="0" tIns="36000" rIns="0" rtlCol="0" anchor="ctr">
-            <a:spAutoFit/>
-          </a:bodyPr>
-          <a:lstStyle>
-            <a:defPPr>
-              <a:defRPr lang="en-US"/>
-            </a:defPPr>
-            <a:lvl1pPr marL="0" algn="l" defTabSz="914400" rtl="0" eaLnBrk="1" latinLnBrk="0" hangingPunct="1">
-              <a:defRPr lang="en-US" sz="1000" b="1" kern="1200" cap="all" spc="10" baseline="0" dirty="0">
-                <a:solidFill>
-                  <a:srgbClr val="B2BECD"/>
-                </a:solidFill>
-                <a:latin typeface="+mn-lt"/>
-                <a:ea typeface="+mn-ea"/>
-                <a:cs typeface="+mn-cs"/>
-              </a:defRPr>
-            </a:lvl1pPr>
-            <a:lvl2pPr marL="457200" algn="l" defTabSz="914400" rtl="0" eaLnBrk="1" latinLnBrk="0" hangingPunct="1">
-              <a:defRPr sz="1800" kern="1200">
-                <a:solidFill>
-                  <a:schemeClr val="lt1"/>
-                </a:solidFill>
-                <a:latin typeface="+mn-lt"/>
-                <a:ea typeface="+mn-ea"/>
-                <a:cs typeface="+mn-cs"/>
-              </a:defRPr>
-            </a:lvl2pPr>
-            <a:lvl3pPr marL="914400" algn="l" defTabSz="914400" rtl="0" eaLnBrk="1" latinLnBrk="0" hangingPunct="1">
-              <a:defRPr sz="1800" kern="1200">
-                <a:solidFill>
-                  <a:schemeClr val="lt1"/>
-                </a:solidFill>
-                <a:latin typeface="+mn-lt"/>
-                <a:ea typeface="+mn-ea"/>
-                <a:cs typeface="+mn-cs"/>
-              </a:defRPr>
-            </a:lvl3pPr>
-            <a:lvl4pPr marL="1371600" algn="l" defTabSz="914400" rtl="0" eaLnBrk="1" latinLnBrk="0" hangingPunct="1">
-              <a:defRPr sz="1800" kern="1200">
-                <a:solidFill>
-                  <a:schemeClr val="lt1"/>
-                </a:solidFill>
-                <a:latin typeface="+mn-lt"/>
-                <a:ea typeface="+mn-ea"/>
-                <a:cs typeface="+mn-cs"/>
-              </a:defRPr>
-            </a:lvl4pPr>
-            <a:lvl5pPr marL="1828800" algn="l" defTabSz="914400" rtl="0" eaLnBrk="1" latinLnBrk="0" hangingPunct="1">
-              <a:defRPr sz="1800" kern="1200">
-                <a:solidFill>
-                  <a:schemeClr val="lt1"/>
-                </a:solidFill>
-                <a:latin typeface="+mn-lt"/>
-                <a:ea typeface="+mn-ea"/>
-                <a:cs typeface="+mn-cs"/>
-              </a:defRPr>
-            </a:lvl5pPr>
-            <a:lvl6pPr marL="2286000" algn="l" defTabSz="914400" rtl="0" eaLnBrk="1" latinLnBrk="0" hangingPunct="1">
-              <a:defRPr sz="1800" kern="1200">
-                <a:solidFill>
-                  <a:schemeClr val="lt1"/>
-                </a:solidFill>
-                <a:latin typeface="+mn-lt"/>
-                <a:ea typeface="+mn-ea"/>
-                <a:cs typeface="+mn-cs"/>
-              </a:defRPr>
-            </a:lvl6pPr>
-            <a:lvl7pPr marL="2743200" algn="l" defTabSz="914400" rtl="0" eaLnBrk="1" latinLnBrk="0" hangingPunct="1">
-              <a:defRPr sz="1800" kern="1200">
-                <a:solidFill>
-                  <a:schemeClr val="lt1"/>
-                </a:solidFill>
-                <a:latin typeface="+mn-lt"/>
-                <a:ea typeface="+mn-ea"/>
-                <a:cs typeface="+mn-cs"/>
-              </a:defRPr>
-            </a:lvl7pPr>
-            <a:lvl8pPr marL="3200400" algn="l" defTabSz="914400" rtl="0" eaLnBrk="1" latinLnBrk="0" hangingPunct="1">
-              <a:defRPr sz="1800" kern="1200">
-                <a:solidFill>
-                  <a:schemeClr val="lt1"/>
-                </a:solidFill>
-                <a:latin typeface="+mn-lt"/>
-                <a:ea typeface="+mn-ea"/>
-                <a:cs typeface="+mn-cs"/>
-              </a:defRPr>
-            </a:lvl8pPr>
-            <a:lvl9pPr marL="3657600" algn="l" defTabSz="914400" rtl="0" eaLnBrk="1" latinLnBrk="0" hangingPunct="1">
-              <a:defRPr sz="1800" kern="1200">
-                <a:solidFill>
-                  <a:schemeClr val="lt1"/>
-                </a:solidFill>
-                <a:latin typeface="+mn-lt"/>
-                <a:ea typeface="+mn-ea"/>
-                <a:cs typeface="+mn-cs"/>
-              </a:defRPr>
-            </a:lvl9pPr>
-          </a:lstStyle>
-          <a:p>
-            <a:r>
-              <a:rPr lang="en-US"/>
-              <a:t>Confidential</a:t>
-            </a:r>
-            <a:endParaRPr lang="en-US" noProof="0" dirty="0"/>
           </a:p>
         </p:txBody>
       </p:sp>
@@ -26114,66 +25723,6 @@
           </a:p>
         </p:txBody>
       </p:sp>
-      <p:sp>
-        <p:nvSpPr>
-          <p:cNvPr id="2" name="TextBox 1">
-            <a:extLst>
-              <a:ext uri="{FF2B5EF4-FFF2-40B4-BE49-F238E27FC236}">
-                <a16:creationId xmlns:a16="http://schemas.microsoft.com/office/drawing/2014/main" id="{99616722-EA5F-210A-3814-9A28A10700CB}"/>
-              </a:ext>
-            </a:extLst>
-          </p:cNvPr>
-          <p:cNvSpPr txBox="1"/>
-          <p:nvPr/>
-        </p:nvSpPr>
-        <p:spPr>
-          <a:xfrm>
-            <a:off x="5667804" y="-487693"/>
-            <a:ext cx="3555738" cy="355225"/>
-          </a:xfrm>
-          <a:prstGeom prst="rect">
-            <a:avLst/>
-          </a:prstGeom>
-          <a:noFill/>
-        </p:spPr>
-        <p:txBody>
-          <a:bodyPr wrap="none" lIns="90000" rtlCol="0" anchor="t">
-            <a:spAutoFit/>
-          </a:bodyPr>
-          <a:lstStyle/>
-          <a:p>
-            <a:pPr algn="l">
-              <a:lnSpc>
-                <a:spcPct val="113000"/>
-              </a:lnSpc>
-            </a:pPr>
-            <a:r>
-              <a:rPr lang="en-US" sz="1600" dirty="0">
-                <a:solidFill>
-                  <a:schemeClr val="tx2"/>
-                </a:solidFill>
-              </a:rPr>
-              <a:t>INTERVAL_</a:t>
-            </a:r>
-            <a:r>
-              <a:rPr lang="en-US" sz="1600">
-                <a:solidFill>
-                  <a:schemeClr val="tx2"/>
-                </a:solidFill>
-              </a:rPr>
-              <a:t>PORTFOLIO_qw:</a:t>
-            </a:r>
-            <a:r>
-              <a:rPr lang="en-US" sz="1600" dirty="0">
-                <a:solidFill>
-                  <a:schemeClr val="tx2"/>
-                </a:solidFill>
-              </a:rPr>
-              <a:t>0.56:3.5:9.57</a:t>
-            </a:r>
-          </a:p>
-        </p:txBody>
-      </p:sp>
       <p:pic>
         <p:nvPicPr>
           <p:cNvPr id="12" name="Graphic 11">
@@ -26210,58 +25759,6 @@
           </a:prstGeom>
         </p:spPr>
       </p:pic>
-      <p:sp>
-        <p:nvSpPr>
-          <p:cNvPr id="4" name="TextBox 3">
-            <a:extLst>
-              <a:ext uri="{FF2B5EF4-FFF2-40B4-BE49-F238E27FC236}">
-                <a16:creationId xmlns:a16="http://schemas.microsoft.com/office/drawing/2014/main" id="{C2DB1B1D-379C-04B0-0B18-91F9890851D3}"/>
-              </a:ext>
-            </a:extLst>
-          </p:cNvPr>
-          <p:cNvSpPr txBox="1"/>
-          <p:nvPr/>
-        </p:nvSpPr>
-        <p:spPr>
-          <a:xfrm>
-            <a:off x="5789382" y="-826903"/>
-            <a:ext cx="3998167" cy="355162"/>
-          </a:xfrm>
-          <a:prstGeom prst="rect">
-            <a:avLst/>
-          </a:prstGeom>
-          <a:noFill/>
-        </p:spPr>
-        <p:txBody>
-          <a:bodyPr wrap="none" lIns="90000" rtlCol="0" anchor="t">
-            <a:spAutoFit/>
-          </a:bodyPr>
-          <a:lstStyle/>
-          <a:p>
-            <a:pPr algn="l">
-              <a:lnSpc>
-                <a:spcPct val="113000"/>
-              </a:lnSpc>
-            </a:pPr>
-            <a:r>
-              <a:rPr lang="en-US" sz="1600" dirty="0" err="1">
-                <a:solidFill>
-                  <a:schemeClr val="tx2"/>
-                </a:solidFill>
-              </a:rPr>
-              <a:t>INTERVAL_PORTFOLIO</a:t>
-            </a:r>
-            <a:r>
-              <a:rPr lang="en-US" sz="1600" dirty="0">
-                <a:solidFill>
-                  <a:schemeClr val="tx2"/>
-                </a:solidFill>
-              </a:rPr>
-              <a:t>_@@MAINTAINABILITY</a:t>
-            </a:r>
-          </a:p>
-        </p:txBody>
-      </p:sp>
       <p:sp>
         <p:nvSpPr>
           <p:cNvPr id="11" name="Rectangle 10">
@@ -27007,3096 +26504,6 @@
 </file>
 
 <file path=ppt/slides/slide4.xml><?xml version="1.0" encoding="utf-8"?>
-<p:sld xmlns:a="http://schemas.openxmlformats.org/drawingml/2006/main" xmlns:r="http://schemas.openxmlformats.org/officeDocument/2006/relationships" xmlns:p="http://schemas.openxmlformats.org/presentationml/2006/main">
-  <p:cSld>
-    <p:spTree>
-      <p:nvGrpSpPr>
-        <p:cNvPr id="1" name="">
-          <a:extLst>
-            <a:ext uri="{FF2B5EF4-FFF2-40B4-BE49-F238E27FC236}">
-              <a16:creationId xmlns:a16="http://schemas.microsoft.com/office/drawing/2014/main" id="{4862DE67-C3B6-775F-E083-4DFD2BDCF07E}"/>
-            </a:ext>
-          </a:extLst>
-        </p:cNvPr>
-        <p:cNvGrpSpPr/>
-        <p:nvPr/>
-      </p:nvGrpSpPr>
-      <p:grpSpPr>
-        <a:xfrm>
-          <a:off x="0" y="0"/>
-          <a:ext cx="0" cy="0"/>
-          <a:chOff x="0" y="0"/>
-          <a:chExt cx="0" cy="0"/>
-        </a:xfrm>
-      </p:grpSpPr>
-      <p:sp>
-        <p:nvSpPr>
-          <p:cNvPr id="17" name="Rectangle 16">
-            <a:extLst>
-              <a:ext uri="{FF2B5EF4-FFF2-40B4-BE49-F238E27FC236}">
-                <a16:creationId xmlns:a16="http://schemas.microsoft.com/office/drawing/2014/main" id="{8EBEB44A-F671-CCD9-0C79-4D80FBE01CA0}"/>
-              </a:ext>
-            </a:extLst>
-          </p:cNvPr>
-          <p:cNvSpPr/>
-          <p:nvPr/>
-        </p:nvSpPr>
-        <p:spPr>
-          <a:xfrm flipH="1">
-            <a:off x="0" y="1368000"/>
-            <a:ext cx="12192000" cy="1658842"/>
-          </a:xfrm>
-          <a:prstGeom prst="rect">
-            <a:avLst/>
-          </a:prstGeom>
-          <a:gradFill>
-            <a:gsLst>
-              <a:gs pos="0">
-                <a:schemeClr val="bg1"/>
-              </a:gs>
-              <a:gs pos="100000">
-                <a:schemeClr val="bg2"/>
-              </a:gs>
-            </a:gsLst>
-            <a:lin ang="2700000" scaled="0"/>
-          </a:gradFill>
-          <a:ln>
-            <a:noFill/>
-          </a:ln>
-          <a:effectLst>
-            <a:outerShdw blurRad="190500" dist="38100" dir="2700000" algn="tl" rotWithShape="0">
-              <a:prstClr val="black">
-                <a:alpha val="15000"/>
-              </a:prstClr>
-            </a:outerShdw>
-          </a:effectLst>
-        </p:spPr>
-        <p:style>
-          <a:lnRef idx="2">
-            <a:schemeClr val="accent1">
-              <a:shade val="50000"/>
-            </a:schemeClr>
-          </a:lnRef>
-          <a:fillRef idx="1">
-            <a:schemeClr val="accent1"/>
-          </a:fillRef>
-          <a:effectRef idx="0">
-            <a:schemeClr val="accent1"/>
-          </a:effectRef>
-          <a:fontRef idx="minor">
-            <a:schemeClr val="lt1"/>
-          </a:fontRef>
-        </p:style>
-        <p:txBody>
-          <a:bodyPr lIns="731520" tIns="72000" rIns="108000" bIns="72000" rtlCol="0" anchor="ctr"/>
-          <a:lstStyle/>
-          <a:p>
-            <a:endParaRPr lang="nl-NL" sz="1200" b="1" noProof="0" dirty="0">
-              <a:solidFill>
-                <a:schemeClr val="accent1"/>
-              </a:solidFill>
-            </a:endParaRPr>
-          </a:p>
-        </p:txBody>
-      </p:sp>
-      <p:sp>
-        <p:nvSpPr>
-          <p:cNvPr id="3" name="Slide Number Placeholder 2">
-            <a:extLst>
-              <a:ext uri="{FF2B5EF4-FFF2-40B4-BE49-F238E27FC236}">
-                <a16:creationId xmlns:a16="http://schemas.microsoft.com/office/drawing/2014/main" id="{ECB210FA-31AC-8E13-E8A9-3DBD24EB7A2F}"/>
-              </a:ext>
-            </a:extLst>
-          </p:cNvPr>
-          <p:cNvSpPr>
-            <a:spLocks noGrp="1"/>
-          </p:cNvSpPr>
-          <p:nvPr>
-            <p:ph type="sldNum" sz="quarter" idx="4"/>
-          </p:nvPr>
-        </p:nvSpPr>
-        <p:spPr/>
-        <p:txBody>
-          <a:bodyPr/>
-          <a:lstStyle/>
-          <a:p>
-            <a:fld id="{E242BD21-9B61-2246-BCB1-4BE5E1BEBE1C}" type="slidenum">
-              <a:rPr lang="en-US" smtClean="0"/>
-              <a:pPr/>
-              <a:t>4</a:t>
-            </a:fld>
-            <a:endParaRPr lang="en-US"/>
-          </a:p>
-        </p:txBody>
-      </p:sp>
-      <p:sp>
-        <p:nvSpPr>
-          <p:cNvPr id="7" name="Text Placeholder 6">
-            <a:extLst>
-              <a:ext uri="{FF2B5EF4-FFF2-40B4-BE49-F238E27FC236}">
-                <a16:creationId xmlns:a16="http://schemas.microsoft.com/office/drawing/2014/main" id="{AE35BD12-D69D-9356-E41D-9668BC4391A4}"/>
-              </a:ext>
-            </a:extLst>
-          </p:cNvPr>
-          <p:cNvSpPr>
-            <a:spLocks noGrp="1"/>
-          </p:cNvSpPr>
-          <p:nvPr>
-            <p:ph type="body" sz="quarter" idx="12"/>
-          </p:nvPr>
-        </p:nvSpPr>
-        <p:spPr/>
-        <p:txBody>
-          <a:bodyPr/>
-          <a:lstStyle/>
-          <a:p>
-            <a:r>
-              <a:rPr lang="en-US" dirty="0"/>
-              <a:t>Findings – </a:t>
-            </a:r>
-            <a:r>
-              <a:rPr lang="en-US" dirty="0">
-                <a:solidFill>
-                  <a:schemeClr val="accent3"/>
-                </a:solidFill>
-              </a:rPr>
-              <a:t>Maintainability</a:t>
-            </a:r>
-          </a:p>
-        </p:txBody>
-      </p:sp>
-      <p:sp>
-        <p:nvSpPr>
-          <p:cNvPr id="6" name="Title 5">
-            <a:extLst>
-              <a:ext uri="{FF2B5EF4-FFF2-40B4-BE49-F238E27FC236}">
-                <a16:creationId xmlns:a16="http://schemas.microsoft.com/office/drawing/2014/main" id="{5DA9C917-33F0-CABB-50DA-DB9337711EC8}"/>
-              </a:ext>
-            </a:extLst>
-          </p:cNvPr>
-          <p:cNvSpPr>
-            <a:spLocks noGrp="1"/>
-          </p:cNvSpPr>
-          <p:nvPr>
-            <p:ph type="title"/>
-          </p:nvPr>
-        </p:nvSpPr>
-        <p:spPr/>
-        <p:txBody>
-          <a:bodyPr/>
-          <a:lstStyle/>
-          <a:p>
-            <a:r>
-              <a:rPr lang="en-US" noProof="0" dirty="0"/>
-              <a:t>@@</a:t>
-            </a:r>
-          </a:p>
-        </p:txBody>
-      </p:sp>
-      <p:sp>
-        <p:nvSpPr>
-          <p:cNvPr id="5" name="Footer Placeholder 4">
-            <a:extLst>
-              <a:ext uri="{FF2B5EF4-FFF2-40B4-BE49-F238E27FC236}">
-                <a16:creationId xmlns:a16="http://schemas.microsoft.com/office/drawing/2014/main" id="{1ACB9E00-4653-5F3C-61DF-0D977ABC2590}"/>
-              </a:ext>
-            </a:extLst>
-          </p:cNvPr>
-          <p:cNvSpPr>
-            <a:spLocks noGrp="1"/>
-          </p:cNvSpPr>
-          <p:nvPr>
-            <p:ph type="ftr" sz="quarter" idx="3"/>
-          </p:nvPr>
-        </p:nvSpPr>
-        <p:spPr>
-          <a:xfrm>
-            <a:off x="2669790" y="6549140"/>
-            <a:ext cx="804066" cy="236406"/>
-          </a:xfrm>
-          <a:prstGeom prst="rect">
-            <a:avLst/>
-          </a:prstGeom>
-          <a:noFill/>
-          <a:ln w="12700" cap="flat" cmpd="sng" algn="ctr">
-            <a:noFill/>
-            <a:prstDash val="solid"/>
-            <a:miter lim="800000"/>
-          </a:ln>
-        </p:spPr>
-        <p:txBody>
-          <a:bodyPr wrap="none" lIns="0" tIns="36000" rIns="0" rtlCol="0" anchor="ctr">
-            <a:spAutoFit/>
-          </a:bodyPr>
-          <a:lstStyle>
-            <a:defPPr>
-              <a:defRPr lang="en-US"/>
-            </a:defPPr>
-            <a:lvl1pPr marL="0" algn="l" defTabSz="914400" rtl="0" eaLnBrk="1" latinLnBrk="0" hangingPunct="1">
-              <a:defRPr lang="en-US" sz="1000" b="1" kern="1200" cap="all" spc="10" baseline="0" dirty="0">
-                <a:solidFill>
-                  <a:srgbClr val="B2BECD"/>
-                </a:solidFill>
-                <a:latin typeface="+mn-lt"/>
-                <a:ea typeface="+mn-ea"/>
-                <a:cs typeface="+mn-cs"/>
-              </a:defRPr>
-            </a:lvl1pPr>
-            <a:lvl2pPr marL="457200" algn="l" defTabSz="914400" rtl="0" eaLnBrk="1" latinLnBrk="0" hangingPunct="1">
-              <a:defRPr sz="1800" kern="1200">
-                <a:solidFill>
-                  <a:schemeClr val="lt1"/>
-                </a:solidFill>
-                <a:latin typeface="+mn-lt"/>
-                <a:ea typeface="+mn-ea"/>
-                <a:cs typeface="+mn-cs"/>
-              </a:defRPr>
-            </a:lvl2pPr>
-            <a:lvl3pPr marL="914400" algn="l" defTabSz="914400" rtl="0" eaLnBrk="1" latinLnBrk="0" hangingPunct="1">
-              <a:defRPr sz="1800" kern="1200">
-                <a:solidFill>
-                  <a:schemeClr val="lt1"/>
-                </a:solidFill>
-                <a:latin typeface="+mn-lt"/>
-                <a:ea typeface="+mn-ea"/>
-                <a:cs typeface="+mn-cs"/>
-              </a:defRPr>
-            </a:lvl3pPr>
-            <a:lvl4pPr marL="1371600" algn="l" defTabSz="914400" rtl="0" eaLnBrk="1" latinLnBrk="0" hangingPunct="1">
-              <a:defRPr sz="1800" kern="1200">
-                <a:solidFill>
-                  <a:schemeClr val="lt1"/>
-                </a:solidFill>
-                <a:latin typeface="+mn-lt"/>
-                <a:ea typeface="+mn-ea"/>
-                <a:cs typeface="+mn-cs"/>
-              </a:defRPr>
-            </a:lvl4pPr>
-            <a:lvl5pPr marL="1828800" algn="l" defTabSz="914400" rtl="0" eaLnBrk="1" latinLnBrk="0" hangingPunct="1">
-              <a:defRPr sz="1800" kern="1200">
-                <a:solidFill>
-                  <a:schemeClr val="lt1"/>
-                </a:solidFill>
-                <a:latin typeface="+mn-lt"/>
-                <a:ea typeface="+mn-ea"/>
-                <a:cs typeface="+mn-cs"/>
-              </a:defRPr>
-            </a:lvl5pPr>
-            <a:lvl6pPr marL="2286000" algn="l" defTabSz="914400" rtl="0" eaLnBrk="1" latinLnBrk="0" hangingPunct="1">
-              <a:defRPr sz="1800" kern="1200">
-                <a:solidFill>
-                  <a:schemeClr val="lt1"/>
-                </a:solidFill>
-                <a:latin typeface="+mn-lt"/>
-                <a:ea typeface="+mn-ea"/>
-                <a:cs typeface="+mn-cs"/>
-              </a:defRPr>
-            </a:lvl6pPr>
-            <a:lvl7pPr marL="2743200" algn="l" defTabSz="914400" rtl="0" eaLnBrk="1" latinLnBrk="0" hangingPunct="1">
-              <a:defRPr sz="1800" kern="1200">
-                <a:solidFill>
-                  <a:schemeClr val="lt1"/>
-                </a:solidFill>
-                <a:latin typeface="+mn-lt"/>
-                <a:ea typeface="+mn-ea"/>
-                <a:cs typeface="+mn-cs"/>
-              </a:defRPr>
-            </a:lvl7pPr>
-            <a:lvl8pPr marL="3200400" algn="l" defTabSz="914400" rtl="0" eaLnBrk="1" latinLnBrk="0" hangingPunct="1">
-              <a:defRPr sz="1800" kern="1200">
-                <a:solidFill>
-                  <a:schemeClr val="lt1"/>
-                </a:solidFill>
-                <a:latin typeface="+mn-lt"/>
-                <a:ea typeface="+mn-ea"/>
-                <a:cs typeface="+mn-cs"/>
-              </a:defRPr>
-            </a:lvl8pPr>
-            <a:lvl9pPr marL="3657600" algn="l" defTabSz="914400" rtl="0" eaLnBrk="1" latinLnBrk="0" hangingPunct="1">
-              <a:defRPr sz="1800" kern="1200">
-                <a:solidFill>
-                  <a:schemeClr val="lt1"/>
-                </a:solidFill>
-                <a:latin typeface="+mn-lt"/>
-                <a:ea typeface="+mn-ea"/>
-                <a:cs typeface="+mn-cs"/>
-              </a:defRPr>
-            </a:lvl9pPr>
-          </a:lstStyle>
-          <a:p>
-            <a:r>
-              <a:rPr lang="en-US"/>
-              <a:t>Confidential</a:t>
-            </a:r>
-            <a:endParaRPr lang="en-US" noProof="0" dirty="0"/>
-          </a:p>
-        </p:txBody>
-      </p:sp>
-      <p:sp>
-        <p:nvSpPr>
-          <p:cNvPr id="8" name="Content Placeholder 7">
-            <a:extLst>
-              <a:ext uri="{FF2B5EF4-FFF2-40B4-BE49-F238E27FC236}">
-                <a16:creationId xmlns:a16="http://schemas.microsoft.com/office/drawing/2014/main" id="{2FF57A37-49DC-DF38-2B61-28A80A02DA5C}"/>
-              </a:ext>
-            </a:extLst>
-          </p:cNvPr>
-          <p:cNvSpPr>
-            <a:spLocks noGrp="1"/>
-          </p:cNvSpPr>
-          <p:nvPr>
-            <p:ph sz="quarter" idx="13"/>
-          </p:nvPr>
-        </p:nvSpPr>
-        <p:spPr>
-          <a:xfrm>
-            <a:off x="514800" y="1368000"/>
-            <a:ext cx="11232000" cy="1658842"/>
-          </a:xfrm>
-        </p:spPr>
-        <p:txBody>
-          <a:bodyPr anchor="ctr"/>
-          <a:lstStyle/>
-          <a:p>
-            <a:pPr marL="0" indent="0">
-              <a:buNone/>
-            </a:pPr>
-            <a:r>
-              <a:rPr lang="en-US" sz="1400" noProof="0" dirty="0"/>
-              <a:t>@@</a:t>
-            </a:r>
-            <a:endParaRPr lang="en-US" sz="1200" noProof="0" dirty="0"/>
-          </a:p>
-        </p:txBody>
-      </p:sp>
-      <p:sp>
-        <p:nvSpPr>
-          <p:cNvPr id="9" name="Rounded Rectangle 8">
-            <a:extLst>
-              <a:ext uri="{FF2B5EF4-FFF2-40B4-BE49-F238E27FC236}">
-                <a16:creationId xmlns:a16="http://schemas.microsoft.com/office/drawing/2014/main" id="{16161A60-3D4A-607F-5C44-BC23A1DDF4F0}"/>
-              </a:ext>
-            </a:extLst>
-          </p:cNvPr>
-          <p:cNvSpPr/>
-          <p:nvPr/>
-        </p:nvSpPr>
-        <p:spPr>
-          <a:xfrm>
-            <a:off x="-270313" y="3154680"/>
-            <a:ext cx="9725209" cy="3163320"/>
-          </a:xfrm>
-          <a:prstGeom prst="roundRect">
-            <a:avLst>
-              <a:gd name="adj" fmla="val 3161"/>
-            </a:avLst>
-          </a:prstGeom>
-          <a:solidFill>
-            <a:schemeClr val="bg1"/>
-          </a:solidFill>
-          <a:ln>
-            <a:noFill/>
-          </a:ln>
-          <a:effectLst>
-            <a:outerShdw blurRad="190500" dist="38100" dir="2700000" algn="tl" rotWithShape="0">
-              <a:prstClr val="black">
-                <a:alpha val="15000"/>
-              </a:prstClr>
-            </a:outerShdw>
-          </a:effectLst>
-        </p:spPr>
-        <p:style>
-          <a:lnRef idx="2">
-            <a:schemeClr val="accent1">
-              <a:shade val="50000"/>
-            </a:schemeClr>
-          </a:lnRef>
-          <a:fillRef idx="1">
-            <a:schemeClr val="accent1"/>
-          </a:fillRef>
-          <a:effectRef idx="0">
-            <a:schemeClr val="accent1"/>
-          </a:effectRef>
-          <a:fontRef idx="minor">
-            <a:schemeClr val="lt1"/>
-          </a:fontRef>
-        </p:style>
-        <p:txBody>
-          <a:bodyPr lIns="731520" tIns="72000" rIns="108000" bIns="72000" rtlCol="0" anchor="ctr"/>
-          <a:lstStyle/>
-          <a:p>
-            <a:endParaRPr lang="nl-NL" sz="1200" b="1" noProof="0" dirty="0">
-              <a:solidFill>
-                <a:schemeClr val="accent1"/>
-              </a:solidFill>
-            </a:endParaRPr>
-          </a:p>
-        </p:txBody>
-      </p:sp>
-      <p:sp>
-        <p:nvSpPr>
-          <p:cNvPr id="16" name="Rounded Rectangle 15">
-            <a:extLst>
-              <a:ext uri="{FF2B5EF4-FFF2-40B4-BE49-F238E27FC236}">
-                <a16:creationId xmlns:a16="http://schemas.microsoft.com/office/drawing/2014/main" id="{7125B257-7832-71C5-DD8C-221A7BBB2CDC}"/>
-              </a:ext>
-            </a:extLst>
-          </p:cNvPr>
-          <p:cNvSpPr/>
-          <p:nvPr/>
-        </p:nvSpPr>
-        <p:spPr>
-          <a:xfrm flipH="1">
-            <a:off x="9619488" y="3154680"/>
-            <a:ext cx="2724912" cy="3163320"/>
-          </a:xfrm>
-          <a:prstGeom prst="roundRect">
-            <a:avLst>
-              <a:gd name="adj" fmla="val 4851"/>
-            </a:avLst>
-          </a:prstGeom>
-          <a:gradFill>
-            <a:gsLst>
-              <a:gs pos="0">
-                <a:schemeClr val="bg1"/>
-              </a:gs>
-              <a:gs pos="100000">
-                <a:schemeClr val="bg2"/>
-              </a:gs>
-            </a:gsLst>
-            <a:lin ang="2700000" scaled="0"/>
-          </a:gradFill>
-          <a:ln>
-            <a:noFill/>
-          </a:ln>
-          <a:effectLst>
-            <a:outerShdw blurRad="190500" dist="38100" dir="2700000" algn="tl" rotWithShape="0">
-              <a:prstClr val="black">
-                <a:alpha val="15000"/>
-              </a:prstClr>
-            </a:outerShdw>
-          </a:effectLst>
-        </p:spPr>
-        <p:style>
-          <a:lnRef idx="2">
-            <a:schemeClr val="accent1">
-              <a:shade val="50000"/>
-            </a:schemeClr>
-          </a:lnRef>
-          <a:fillRef idx="1">
-            <a:schemeClr val="accent1"/>
-          </a:fillRef>
-          <a:effectRef idx="0">
-            <a:schemeClr val="accent1"/>
-          </a:effectRef>
-          <a:fontRef idx="minor">
-            <a:schemeClr val="lt1"/>
-          </a:fontRef>
-        </p:style>
-        <p:txBody>
-          <a:bodyPr lIns="731520" tIns="72000" rIns="108000" bIns="72000" rtlCol="0" anchor="ctr"/>
-          <a:lstStyle/>
-          <a:p>
-            <a:endParaRPr lang="nl-NL" sz="1200" b="1" noProof="0" dirty="0">
-              <a:solidFill>
-                <a:schemeClr val="accent1"/>
-              </a:solidFill>
-            </a:endParaRPr>
-          </a:p>
-        </p:txBody>
-      </p:sp>
-      <p:sp>
-        <p:nvSpPr>
-          <p:cNvPr id="28" name="TextBox 27">
-            <a:extLst>
-              <a:ext uri="{FF2B5EF4-FFF2-40B4-BE49-F238E27FC236}">
-                <a16:creationId xmlns:a16="http://schemas.microsoft.com/office/drawing/2014/main" id="{6D13BB87-6858-10C5-603D-08B2307C1908}"/>
-              </a:ext>
-            </a:extLst>
-          </p:cNvPr>
-          <p:cNvSpPr txBox="1"/>
-          <p:nvPr/>
-        </p:nvSpPr>
-        <p:spPr>
-          <a:xfrm>
-            <a:off x="-1221448" y="4419492"/>
-            <a:ext cx="628847" cy="633443"/>
-          </a:xfrm>
-          <a:prstGeom prst="rect">
-            <a:avLst/>
-          </a:prstGeom>
-          <a:noFill/>
-        </p:spPr>
-        <p:txBody>
-          <a:bodyPr wrap="none" lIns="90000" rtlCol="0" anchor="t">
-            <a:spAutoFit/>
-          </a:bodyPr>
-          <a:lstStyle/>
-          <a:p>
-            <a:pPr algn="l">
-              <a:lnSpc>
-                <a:spcPct val="113000"/>
-              </a:lnSpc>
-            </a:pPr>
-            <a:r>
-              <a:rPr lang="en-US" sz="1600" dirty="0">
-                <a:solidFill>
-                  <a:schemeClr val="tx2"/>
-                </a:solidFill>
-              </a:rPr>
-              <a:t>3.12”</a:t>
-            </a:r>
-          </a:p>
-          <a:p>
-            <a:pPr algn="l">
-              <a:lnSpc>
-                <a:spcPct val="113000"/>
-              </a:lnSpc>
-            </a:pPr>
-            <a:r>
-              <a:rPr lang="en-US" sz="1600" dirty="0">
-                <a:solidFill>
-                  <a:schemeClr val="tx2"/>
-                </a:solidFill>
-              </a:rPr>
-              <a:t>9.57"</a:t>
-            </a:r>
-          </a:p>
-        </p:txBody>
-      </p:sp>
-      <p:sp>
-        <p:nvSpPr>
-          <p:cNvPr id="35" name="Rounded Rectangle 34">
-            <a:extLst>
-              <a:ext uri="{FF2B5EF4-FFF2-40B4-BE49-F238E27FC236}">
-                <a16:creationId xmlns:a16="http://schemas.microsoft.com/office/drawing/2014/main" id="{7B815996-6C63-D443-AAC0-AA07D79A096B}"/>
-              </a:ext>
-            </a:extLst>
-          </p:cNvPr>
-          <p:cNvSpPr/>
-          <p:nvPr/>
-        </p:nvSpPr>
-        <p:spPr>
-          <a:xfrm>
-            <a:off x="9777184" y="4883651"/>
-            <a:ext cx="2573808" cy="326727"/>
-          </a:xfrm>
-          <a:prstGeom prst="roundRect">
-            <a:avLst>
-              <a:gd name="adj" fmla="val 31904"/>
-            </a:avLst>
-          </a:prstGeom>
-          <a:gradFill>
-            <a:gsLst>
-              <a:gs pos="0">
-                <a:srgbClr val="57C968"/>
-              </a:gs>
-              <a:gs pos="25000">
-                <a:schemeClr val="bg2"/>
-              </a:gs>
-            </a:gsLst>
-            <a:lin ang="2700000" scaled="0"/>
-          </a:gradFill>
-          <a:ln>
-            <a:noFill/>
-          </a:ln>
-          <a:effectLst>
-            <a:outerShdw blurRad="190500" dist="38100" dir="2700000" algn="tl" rotWithShape="0">
-              <a:prstClr val="black">
-                <a:alpha val="15000"/>
-              </a:prstClr>
-            </a:outerShdw>
-          </a:effectLst>
-        </p:spPr>
-        <p:style>
-          <a:lnRef idx="2">
-            <a:schemeClr val="accent1">
-              <a:shade val="50000"/>
-            </a:schemeClr>
-          </a:lnRef>
-          <a:fillRef idx="1">
-            <a:schemeClr val="accent1"/>
-          </a:fillRef>
-          <a:effectRef idx="0">
-            <a:schemeClr val="accent1"/>
-          </a:effectRef>
-          <a:fontRef idx="minor">
-            <a:schemeClr val="lt1"/>
-          </a:fontRef>
-        </p:style>
-        <p:txBody>
-          <a:bodyPr lIns="109728" tIns="72000" rIns="108000" bIns="72000" rtlCol="0" anchor="ctr"/>
-          <a:lstStyle/>
-          <a:p>
-            <a:r>
-              <a:rPr lang="nl-NL" sz="1000" b="1" noProof="0" dirty="0">
-                <a:solidFill>
-                  <a:schemeClr val="accent1"/>
-                </a:solidFill>
-              </a:rPr>
-              <a:t>@@</a:t>
-            </a:r>
-          </a:p>
-        </p:txBody>
-      </p:sp>
-      <p:sp>
-        <p:nvSpPr>
-          <p:cNvPr id="39" name="Rounded Rectangle 38">
-            <a:extLst>
-              <a:ext uri="{FF2B5EF4-FFF2-40B4-BE49-F238E27FC236}">
-                <a16:creationId xmlns:a16="http://schemas.microsoft.com/office/drawing/2014/main" id="{C8F9AE3D-B5D9-40CE-E48F-AE0F52DB42D8}"/>
-              </a:ext>
-            </a:extLst>
-          </p:cNvPr>
-          <p:cNvSpPr/>
-          <p:nvPr/>
-        </p:nvSpPr>
-        <p:spPr>
-          <a:xfrm>
-            <a:off x="9777184" y="4464888"/>
-            <a:ext cx="2573808" cy="326727"/>
-          </a:xfrm>
-          <a:prstGeom prst="roundRect">
-            <a:avLst>
-              <a:gd name="adj" fmla="val 31904"/>
-            </a:avLst>
-          </a:prstGeom>
-          <a:gradFill>
-            <a:gsLst>
-              <a:gs pos="0">
-                <a:srgbClr val="57C968"/>
-              </a:gs>
-              <a:gs pos="25000">
-                <a:schemeClr val="bg2"/>
-              </a:gs>
-            </a:gsLst>
-            <a:lin ang="2700000" scaled="0"/>
-          </a:gradFill>
-          <a:ln>
-            <a:noFill/>
-          </a:ln>
-          <a:effectLst>
-            <a:outerShdw blurRad="190500" dist="38100" dir="2700000" algn="tl" rotWithShape="0">
-              <a:prstClr val="black">
-                <a:alpha val="15000"/>
-              </a:prstClr>
-            </a:outerShdw>
-          </a:effectLst>
-        </p:spPr>
-        <p:style>
-          <a:lnRef idx="2">
-            <a:schemeClr val="accent1">
-              <a:shade val="50000"/>
-            </a:schemeClr>
-          </a:lnRef>
-          <a:fillRef idx="1">
-            <a:schemeClr val="accent1"/>
-          </a:fillRef>
-          <a:effectRef idx="0">
-            <a:schemeClr val="accent1"/>
-          </a:effectRef>
-          <a:fontRef idx="minor">
-            <a:schemeClr val="lt1"/>
-          </a:fontRef>
-        </p:style>
-        <p:txBody>
-          <a:bodyPr lIns="109728" tIns="72000" rIns="108000" bIns="72000" rtlCol="0" anchor="ctr"/>
-          <a:lstStyle/>
-          <a:p>
-            <a:r>
-              <a:rPr lang="nl-NL" sz="1000" b="1" noProof="0" dirty="0">
-                <a:solidFill>
-                  <a:schemeClr val="accent1"/>
-                </a:solidFill>
-              </a:rPr>
-              <a:t>@@</a:t>
-            </a:r>
-          </a:p>
-        </p:txBody>
-      </p:sp>
-      <p:sp>
-        <p:nvSpPr>
-          <p:cNvPr id="33" name="Rounded Rectangle 32">
-            <a:extLst>
-              <a:ext uri="{FF2B5EF4-FFF2-40B4-BE49-F238E27FC236}">
-                <a16:creationId xmlns:a16="http://schemas.microsoft.com/office/drawing/2014/main" id="{BEA72712-55E6-EE17-DB0B-AE08FD16B865}"/>
-              </a:ext>
-            </a:extLst>
-          </p:cNvPr>
-          <p:cNvSpPr/>
-          <p:nvPr/>
-        </p:nvSpPr>
-        <p:spPr>
-          <a:xfrm>
-            <a:off x="9777184" y="4046125"/>
-            <a:ext cx="2573808" cy="326727"/>
-          </a:xfrm>
-          <a:prstGeom prst="roundRect">
-            <a:avLst>
-              <a:gd name="adj" fmla="val 31904"/>
-            </a:avLst>
-          </a:prstGeom>
-          <a:gradFill>
-            <a:gsLst>
-              <a:gs pos="0">
-                <a:srgbClr val="F9C640"/>
-              </a:gs>
-              <a:gs pos="25000">
-                <a:schemeClr val="bg2"/>
-              </a:gs>
-            </a:gsLst>
-            <a:lin ang="2700000" scaled="0"/>
-          </a:gradFill>
-          <a:ln>
-            <a:noFill/>
-          </a:ln>
-          <a:effectLst>
-            <a:outerShdw blurRad="190500" dist="38100" dir="2700000" algn="tl" rotWithShape="0">
-              <a:prstClr val="black">
-                <a:alpha val="15000"/>
-              </a:prstClr>
-            </a:outerShdw>
-          </a:effectLst>
-        </p:spPr>
-        <p:style>
-          <a:lnRef idx="2">
-            <a:schemeClr val="accent1">
-              <a:shade val="50000"/>
-            </a:schemeClr>
-          </a:lnRef>
-          <a:fillRef idx="1">
-            <a:schemeClr val="accent1"/>
-          </a:fillRef>
-          <a:effectRef idx="0">
-            <a:schemeClr val="accent1"/>
-          </a:effectRef>
-          <a:fontRef idx="minor">
-            <a:schemeClr val="lt1"/>
-          </a:fontRef>
-        </p:style>
-        <p:txBody>
-          <a:bodyPr lIns="109728" tIns="72000" rIns="108000" bIns="72000" rtlCol="0" anchor="ctr"/>
-          <a:lstStyle/>
-          <a:p>
-            <a:r>
-              <a:rPr lang="nl-NL" sz="1000" b="1" noProof="0" dirty="0">
-                <a:solidFill>
-                  <a:schemeClr val="accent1"/>
-                </a:solidFill>
-              </a:rPr>
-              <a:t>@@</a:t>
-            </a:r>
-          </a:p>
-        </p:txBody>
-      </p:sp>
-      <p:sp>
-        <p:nvSpPr>
-          <p:cNvPr id="38" name="Rounded Rectangle 37">
-            <a:extLst>
-              <a:ext uri="{FF2B5EF4-FFF2-40B4-BE49-F238E27FC236}">
-                <a16:creationId xmlns:a16="http://schemas.microsoft.com/office/drawing/2014/main" id="{C32BAB89-6CCC-D163-39B5-3D540A188429}"/>
-              </a:ext>
-            </a:extLst>
-          </p:cNvPr>
-          <p:cNvSpPr/>
-          <p:nvPr/>
-        </p:nvSpPr>
-        <p:spPr>
-          <a:xfrm>
-            <a:off x="9777184" y="3627362"/>
-            <a:ext cx="2573808" cy="326727"/>
-          </a:xfrm>
-          <a:prstGeom prst="roundRect">
-            <a:avLst>
-              <a:gd name="adj" fmla="val 31904"/>
-            </a:avLst>
-          </a:prstGeom>
-          <a:gradFill>
-            <a:gsLst>
-              <a:gs pos="0">
-                <a:srgbClr val="F9C640"/>
-              </a:gs>
-              <a:gs pos="25000">
-                <a:schemeClr val="bg2"/>
-              </a:gs>
-            </a:gsLst>
-            <a:lin ang="2700000" scaled="0"/>
-          </a:gradFill>
-          <a:ln>
-            <a:noFill/>
-          </a:ln>
-          <a:effectLst>
-            <a:outerShdw blurRad="190500" dist="38100" dir="2700000" algn="tl" rotWithShape="0">
-              <a:prstClr val="black">
-                <a:alpha val="15000"/>
-              </a:prstClr>
-            </a:outerShdw>
-          </a:effectLst>
-        </p:spPr>
-        <p:style>
-          <a:lnRef idx="2">
-            <a:schemeClr val="accent1">
-              <a:shade val="50000"/>
-            </a:schemeClr>
-          </a:lnRef>
-          <a:fillRef idx="1">
-            <a:schemeClr val="accent1"/>
-          </a:fillRef>
-          <a:effectRef idx="0">
-            <a:schemeClr val="accent1"/>
-          </a:effectRef>
-          <a:fontRef idx="minor">
-            <a:schemeClr val="lt1"/>
-          </a:fontRef>
-        </p:style>
-        <p:txBody>
-          <a:bodyPr lIns="109728" tIns="72000" rIns="108000" bIns="72000" rtlCol="0" anchor="ctr"/>
-          <a:lstStyle/>
-          <a:p>
-            <a:r>
-              <a:rPr lang="nl-NL" sz="1000" b="1" noProof="0" dirty="0">
-                <a:solidFill>
-                  <a:schemeClr val="accent1"/>
-                </a:solidFill>
-              </a:rPr>
-              <a:t>@@</a:t>
-            </a:r>
-          </a:p>
-        </p:txBody>
-      </p:sp>
-      <p:sp>
-        <p:nvSpPr>
-          <p:cNvPr id="37" name="Rounded Rectangle 36">
-            <a:extLst>
-              <a:ext uri="{FF2B5EF4-FFF2-40B4-BE49-F238E27FC236}">
-                <a16:creationId xmlns:a16="http://schemas.microsoft.com/office/drawing/2014/main" id="{1B8F9163-1629-ECF6-F602-2D933703975E}"/>
-              </a:ext>
-            </a:extLst>
-          </p:cNvPr>
-          <p:cNvSpPr/>
-          <p:nvPr/>
-        </p:nvSpPr>
-        <p:spPr>
-          <a:xfrm>
-            <a:off x="9777184" y="5721177"/>
-            <a:ext cx="2573808" cy="326727"/>
-          </a:xfrm>
-          <a:prstGeom prst="roundRect">
-            <a:avLst>
-              <a:gd name="adj" fmla="val 31904"/>
-            </a:avLst>
-          </a:prstGeom>
-          <a:gradFill>
-            <a:gsLst>
-              <a:gs pos="0">
-                <a:srgbClr val="57C968"/>
-              </a:gs>
-              <a:gs pos="25000">
-                <a:schemeClr val="bg2"/>
-              </a:gs>
-            </a:gsLst>
-            <a:lin ang="2700000" scaled="0"/>
-          </a:gradFill>
-          <a:ln>
-            <a:noFill/>
-          </a:ln>
-          <a:effectLst>
-            <a:outerShdw blurRad="190500" dist="38100" dir="2700000" algn="tl" rotWithShape="0">
-              <a:prstClr val="black">
-                <a:alpha val="15000"/>
-              </a:prstClr>
-            </a:outerShdw>
-          </a:effectLst>
-        </p:spPr>
-        <p:style>
-          <a:lnRef idx="2">
-            <a:schemeClr val="accent1">
-              <a:shade val="50000"/>
-            </a:schemeClr>
-          </a:lnRef>
-          <a:fillRef idx="1">
-            <a:schemeClr val="accent1"/>
-          </a:fillRef>
-          <a:effectRef idx="0">
-            <a:schemeClr val="accent1"/>
-          </a:effectRef>
-          <a:fontRef idx="minor">
-            <a:schemeClr val="lt1"/>
-          </a:fontRef>
-        </p:style>
-        <p:txBody>
-          <a:bodyPr lIns="109728" tIns="72000" rIns="108000" bIns="72000" rtlCol="0" anchor="ctr"/>
-          <a:lstStyle/>
-          <a:p>
-            <a:r>
-              <a:rPr lang="nl-NL" sz="1000" b="1" noProof="0" dirty="0">
-                <a:solidFill>
-                  <a:schemeClr val="accent1"/>
-                </a:solidFill>
-              </a:rPr>
-              <a:t>@@</a:t>
-            </a:r>
-          </a:p>
-        </p:txBody>
-      </p:sp>
-      <p:sp>
-        <p:nvSpPr>
-          <p:cNvPr id="36" name="Rounded Rectangle 35">
-            <a:extLst>
-              <a:ext uri="{FF2B5EF4-FFF2-40B4-BE49-F238E27FC236}">
-                <a16:creationId xmlns:a16="http://schemas.microsoft.com/office/drawing/2014/main" id="{1EBA573D-E7CD-B1E6-9DF9-5208174F68A5}"/>
-              </a:ext>
-            </a:extLst>
-          </p:cNvPr>
-          <p:cNvSpPr/>
-          <p:nvPr/>
-        </p:nvSpPr>
-        <p:spPr>
-          <a:xfrm>
-            <a:off x="9777184" y="5302414"/>
-            <a:ext cx="2573808" cy="326727"/>
-          </a:xfrm>
-          <a:prstGeom prst="roundRect">
-            <a:avLst>
-              <a:gd name="adj" fmla="val 31904"/>
-            </a:avLst>
-          </a:prstGeom>
-          <a:gradFill>
-            <a:gsLst>
-              <a:gs pos="0">
-                <a:srgbClr val="57C968"/>
-              </a:gs>
-              <a:gs pos="25000">
-                <a:schemeClr val="bg2"/>
-              </a:gs>
-            </a:gsLst>
-            <a:lin ang="2700000" scaled="0"/>
-          </a:gradFill>
-          <a:ln>
-            <a:noFill/>
-          </a:ln>
-          <a:effectLst>
-            <a:outerShdw blurRad="190500" dist="38100" dir="2700000" algn="tl" rotWithShape="0">
-              <a:prstClr val="black">
-                <a:alpha val="15000"/>
-              </a:prstClr>
-            </a:outerShdw>
-          </a:effectLst>
-        </p:spPr>
-        <p:style>
-          <a:lnRef idx="2">
-            <a:schemeClr val="accent1">
-              <a:shade val="50000"/>
-            </a:schemeClr>
-          </a:lnRef>
-          <a:fillRef idx="1">
-            <a:schemeClr val="accent1"/>
-          </a:fillRef>
-          <a:effectRef idx="0">
-            <a:schemeClr val="accent1"/>
-          </a:effectRef>
-          <a:fontRef idx="minor">
-            <a:schemeClr val="lt1"/>
-          </a:fontRef>
-        </p:style>
-        <p:txBody>
-          <a:bodyPr lIns="109728" tIns="72000" rIns="108000" bIns="72000" rtlCol="0" anchor="ctr"/>
-          <a:lstStyle/>
-          <a:p>
-            <a:r>
-              <a:rPr lang="nl-NL" sz="1000" b="1" noProof="0" dirty="0">
-                <a:solidFill>
-                  <a:schemeClr val="accent1"/>
-                </a:solidFill>
-              </a:rPr>
-              <a:t>@@</a:t>
-            </a:r>
-          </a:p>
-        </p:txBody>
-      </p:sp>
-      <p:sp>
-        <p:nvSpPr>
-          <p:cNvPr id="40" name="TextBox 39">
-            <a:extLst>
-              <a:ext uri="{FF2B5EF4-FFF2-40B4-BE49-F238E27FC236}">
-                <a16:creationId xmlns:a16="http://schemas.microsoft.com/office/drawing/2014/main" id="{BB76C2DB-1877-788E-DC88-4A4AF6641028}"/>
-              </a:ext>
-            </a:extLst>
-          </p:cNvPr>
-          <p:cNvSpPr txBox="1"/>
-          <p:nvPr/>
-        </p:nvSpPr>
-        <p:spPr>
-          <a:xfrm>
-            <a:off x="11186130" y="4921755"/>
-            <a:ext cx="991126" cy="250518"/>
-          </a:xfrm>
-          <a:prstGeom prst="rect">
-            <a:avLst/>
-          </a:prstGeom>
-          <a:noFill/>
-        </p:spPr>
-        <p:txBody>
-          <a:bodyPr wrap="none" lIns="90000" rtlCol="0" anchor="t">
-            <a:spAutoFit/>
-          </a:bodyPr>
-          <a:lstStyle/>
-          <a:p>
-            <a:pPr algn="r">
-              <a:lnSpc>
-                <a:spcPct val="113000"/>
-              </a:lnSpc>
-            </a:pPr>
-            <a:r>
-              <a:rPr lang="en-US" sz="1000" b="1" dirty="0" err="1">
-                <a:solidFill>
-                  <a:schemeClr val="tx2"/>
-                </a:solidFill>
-                <a:latin typeface="Sigsterren" pitchFamily="2" charset="0"/>
-              </a:rPr>
-              <a:t>HHHHH</a:t>
-            </a:r>
-            <a:r>
-              <a:rPr lang="en-US" sz="1000" b="1" dirty="0">
-                <a:solidFill>
-                  <a:schemeClr val="tx2"/>
-                </a:solidFill>
-                <a:latin typeface="Sigsterren" pitchFamily="2" charset="0"/>
-              </a:rPr>
-              <a:t> </a:t>
-            </a:r>
-            <a:r>
-              <a:rPr lang="en-US" sz="1000" b="1" dirty="0">
-                <a:solidFill>
-                  <a:schemeClr val="tx2"/>
-                </a:solidFill>
-                <a:latin typeface="Calibri" panose="020F0502020204030204" pitchFamily="34" charset="0"/>
-                <a:cs typeface="Calibri" panose="020F0502020204030204" pitchFamily="34" charset="0"/>
-              </a:rPr>
-              <a:t>(</a:t>
-            </a:r>
-            <a:r>
-              <a:rPr lang="en-US" sz="1000" b="1" dirty="0" err="1">
-                <a:solidFill>
-                  <a:schemeClr val="tx2"/>
-                </a:solidFill>
-                <a:latin typeface="Calibri" panose="020F0502020204030204" pitchFamily="34" charset="0"/>
-                <a:cs typeface="Calibri" panose="020F0502020204030204" pitchFamily="34" charset="0"/>
-              </a:rPr>
-              <a:t>X.X</a:t>
-            </a:r>
-            <a:r>
-              <a:rPr lang="en-US" sz="1000" b="1" dirty="0">
-                <a:solidFill>
-                  <a:schemeClr val="tx2"/>
-                </a:solidFill>
-                <a:latin typeface="Calibri" panose="020F0502020204030204" pitchFamily="34" charset="0"/>
-                <a:cs typeface="Calibri" panose="020F0502020204030204" pitchFamily="34" charset="0"/>
-              </a:rPr>
-              <a:t>)</a:t>
-            </a:r>
-          </a:p>
-        </p:txBody>
-      </p:sp>
-      <p:sp>
-        <p:nvSpPr>
-          <p:cNvPr id="41" name="TextBox 40">
-            <a:extLst>
-              <a:ext uri="{FF2B5EF4-FFF2-40B4-BE49-F238E27FC236}">
-                <a16:creationId xmlns:a16="http://schemas.microsoft.com/office/drawing/2014/main" id="{5F1E2848-E3BE-739A-464A-13901B3DA94E}"/>
-              </a:ext>
-            </a:extLst>
-          </p:cNvPr>
-          <p:cNvSpPr txBox="1"/>
-          <p:nvPr/>
-        </p:nvSpPr>
-        <p:spPr>
-          <a:xfrm>
-            <a:off x="11186130" y="4502992"/>
-            <a:ext cx="991126" cy="250518"/>
-          </a:xfrm>
-          <a:prstGeom prst="rect">
-            <a:avLst/>
-          </a:prstGeom>
-          <a:noFill/>
-        </p:spPr>
-        <p:txBody>
-          <a:bodyPr wrap="none" lIns="90000" rtlCol="0" anchor="t">
-            <a:spAutoFit/>
-          </a:bodyPr>
-          <a:lstStyle/>
-          <a:p>
-            <a:pPr algn="r">
-              <a:lnSpc>
-                <a:spcPct val="113000"/>
-              </a:lnSpc>
-            </a:pPr>
-            <a:r>
-              <a:rPr lang="en-US" sz="1000" b="1" dirty="0" err="1">
-                <a:solidFill>
-                  <a:schemeClr val="tx2"/>
-                </a:solidFill>
-                <a:latin typeface="Sigsterren" pitchFamily="2" charset="0"/>
-              </a:rPr>
-              <a:t>HHHHH</a:t>
-            </a:r>
-            <a:r>
-              <a:rPr lang="en-US" sz="1000" b="1" dirty="0">
-                <a:solidFill>
-                  <a:schemeClr val="tx2"/>
-                </a:solidFill>
-                <a:latin typeface="Sigsterren" pitchFamily="2" charset="0"/>
-              </a:rPr>
-              <a:t> </a:t>
-            </a:r>
-            <a:r>
-              <a:rPr lang="en-US" sz="1000" b="1" dirty="0">
-                <a:solidFill>
-                  <a:schemeClr val="tx2"/>
-                </a:solidFill>
-                <a:latin typeface="Calibri" panose="020F0502020204030204" pitchFamily="34" charset="0"/>
-                <a:cs typeface="Calibri" panose="020F0502020204030204" pitchFamily="34" charset="0"/>
-              </a:rPr>
-              <a:t>(</a:t>
-            </a:r>
-            <a:r>
-              <a:rPr lang="en-US" sz="1000" b="1" dirty="0" err="1">
-                <a:solidFill>
-                  <a:schemeClr val="tx2"/>
-                </a:solidFill>
-                <a:latin typeface="Calibri" panose="020F0502020204030204" pitchFamily="34" charset="0"/>
-                <a:cs typeface="Calibri" panose="020F0502020204030204" pitchFamily="34" charset="0"/>
-              </a:rPr>
-              <a:t>X.X</a:t>
-            </a:r>
-            <a:r>
-              <a:rPr lang="en-US" sz="1000" b="1" dirty="0">
-                <a:solidFill>
-                  <a:schemeClr val="tx2"/>
-                </a:solidFill>
-                <a:latin typeface="Calibri" panose="020F0502020204030204" pitchFamily="34" charset="0"/>
-                <a:cs typeface="Calibri" panose="020F0502020204030204" pitchFamily="34" charset="0"/>
-              </a:rPr>
-              <a:t>)</a:t>
-            </a:r>
-          </a:p>
-        </p:txBody>
-      </p:sp>
-      <p:sp>
-        <p:nvSpPr>
-          <p:cNvPr id="44" name="TextBox 43">
-            <a:extLst>
-              <a:ext uri="{FF2B5EF4-FFF2-40B4-BE49-F238E27FC236}">
-                <a16:creationId xmlns:a16="http://schemas.microsoft.com/office/drawing/2014/main" id="{E3001FE0-86C6-A42C-B3F0-E12C9A11E258}"/>
-              </a:ext>
-            </a:extLst>
-          </p:cNvPr>
-          <p:cNvSpPr txBox="1"/>
-          <p:nvPr/>
-        </p:nvSpPr>
-        <p:spPr>
-          <a:xfrm>
-            <a:off x="11186130" y="5759281"/>
-            <a:ext cx="991126" cy="250518"/>
-          </a:xfrm>
-          <a:prstGeom prst="rect">
-            <a:avLst/>
-          </a:prstGeom>
-          <a:noFill/>
-        </p:spPr>
-        <p:txBody>
-          <a:bodyPr wrap="none" lIns="90000" rtlCol="0" anchor="t">
-            <a:spAutoFit/>
-          </a:bodyPr>
-          <a:lstStyle/>
-          <a:p>
-            <a:pPr algn="r">
-              <a:lnSpc>
-                <a:spcPct val="113000"/>
-              </a:lnSpc>
-            </a:pPr>
-            <a:r>
-              <a:rPr lang="en-US" sz="1000" b="1" dirty="0" err="1">
-                <a:solidFill>
-                  <a:schemeClr val="tx2"/>
-                </a:solidFill>
-                <a:latin typeface="Sigsterren" pitchFamily="2" charset="0"/>
-              </a:rPr>
-              <a:t>HHHHH</a:t>
-            </a:r>
-            <a:r>
-              <a:rPr lang="en-US" sz="1000" b="1" dirty="0">
-                <a:solidFill>
-                  <a:schemeClr val="tx2"/>
-                </a:solidFill>
-                <a:latin typeface="Sigsterren" pitchFamily="2" charset="0"/>
-              </a:rPr>
-              <a:t> </a:t>
-            </a:r>
-            <a:r>
-              <a:rPr lang="en-US" sz="1000" b="1" dirty="0">
-                <a:solidFill>
-                  <a:schemeClr val="tx2"/>
-                </a:solidFill>
-                <a:latin typeface="Calibri" panose="020F0502020204030204" pitchFamily="34" charset="0"/>
-                <a:cs typeface="Calibri" panose="020F0502020204030204" pitchFamily="34" charset="0"/>
-              </a:rPr>
-              <a:t>(</a:t>
-            </a:r>
-            <a:r>
-              <a:rPr lang="en-US" sz="1000" b="1" dirty="0" err="1">
-                <a:solidFill>
-                  <a:schemeClr val="tx2"/>
-                </a:solidFill>
-                <a:latin typeface="Calibri" panose="020F0502020204030204" pitchFamily="34" charset="0"/>
-                <a:cs typeface="Calibri" panose="020F0502020204030204" pitchFamily="34" charset="0"/>
-              </a:rPr>
-              <a:t>X.X</a:t>
-            </a:r>
-            <a:r>
-              <a:rPr lang="en-US" sz="1000" b="1" dirty="0">
-                <a:solidFill>
-                  <a:schemeClr val="tx2"/>
-                </a:solidFill>
-                <a:latin typeface="Calibri" panose="020F0502020204030204" pitchFamily="34" charset="0"/>
-                <a:cs typeface="Calibri" panose="020F0502020204030204" pitchFamily="34" charset="0"/>
-              </a:rPr>
-              <a:t>)</a:t>
-            </a:r>
-          </a:p>
-        </p:txBody>
-      </p:sp>
-      <p:sp>
-        <p:nvSpPr>
-          <p:cNvPr id="45" name="TextBox 44">
-            <a:extLst>
-              <a:ext uri="{FF2B5EF4-FFF2-40B4-BE49-F238E27FC236}">
-                <a16:creationId xmlns:a16="http://schemas.microsoft.com/office/drawing/2014/main" id="{AD24E266-72AC-E9A5-8874-6CF0F66B6FF8}"/>
-              </a:ext>
-            </a:extLst>
-          </p:cNvPr>
-          <p:cNvSpPr txBox="1"/>
-          <p:nvPr/>
-        </p:nvSpPr>
-        <p:spPr>
-          <a:xfrm>
-            <a:off x="11186130" y="5340518"/>
-            <a:ext cx="991126" cy="250518"/>
-          </a:xfrm>
-          <a:prstGeom prst="rect">
-            <a:avLst/>
-          </a:prstGeom>
-          <a:noFill/>
-        </p:spPr>
-        <p:txBody>
-          <a:bodyPr wrap="none" lIns="90000" rtlCol="0" anchor="t">
-            <a:spAutoFit/>
-          </a:bodyPr>
-          <a:lstStyle/>
-          <a:p>
-            <a:pPr algn="r">
-              <a:lnSpc>
-                <a:spcPct val="113000"/>
-              </a:lnSpc>
-            </a:pPr>
-            <a:r>
-              <a:rPr lang="en-US" sz="1000" b="1" dirty="0" err="1">
-                <a:solidFill>
-                  <a:schemeClr val="tx2"/>
-                </a:solidFill>
-                <a:latin typeface="Sigsterren" pitchFamily="2" charset="0"/>
-              </a:rPr>
-              <a:t>HHHHH</a:t>
-            </a:r>
-            <a:r>
-              <a:rPr lang="en-US" sz="1000" b="1" dirty="0">
-                <a:solidFill>
-                  <a:schemeClr val="tx2"/>
-                </a:solidFill>
-                <a:latin typeface="Sigsterren" pitchFamily="2" charset="0"/>
-              </a:rPr>
-              <a:t> </a:t>
-            </a:r>
-            <a:r>
-              <a:rPr lang="en-US" sz="1000" b="1" dirty="0">
-                <a:solidFill>
-                  <a:schemeClr val="tx2"/>
-                </a:solidFill>
-                <a:latin typeface="Calibri" panose="020F0502020204030204" pitchFamily="34" charset="0"/>
-                <a:cs typeface="Calibri" panose="020F0502020204030204" pitchFamily="34" charset="0"/>
-              </a:rPr>
-              <a:t>(</a:t>
-            </a:r>
-            <a:r>
-              <a:rPr lang="en-US" sz="1000" b="1" dirty="0" err="1">
-                <a:solidFill>
-                  <a:schemeClr val="tx2"/>
-                </a:solidFill>
-                <a:latin typeface="Calibri" panose="020F0502020204030204" pitchFamily="34" charset="0"/>
-                <a:cs typeface="Calibri" panose="020F0502020204030204" pitchFamily="34" charset="0"/>
-              </a:rPr>
-              <a:t>X.X</a:t>
-            </a:r>
-            <a:r>
-              <a:rPr lang="en-US" sz="1000" b="1" dirty="0">
-                <a:solidFill>
-                  <a:schemeClr val="tx2"/>
-                </a:solidFill>
-                <a:latin typeface="Calibri" panose="020F0502020204030204" pitchFamily="34" charset="0"/>
-                <a:cs typeface="Calibri" panose="020F0502020204030204" pitchFamily="34" charset="0"/>
-              </a:rPr>
-              <a:t>)</a:t>
-            </a:r>
-          </a:p>
-        </p:txBody>
-      </p:sp>
-      <p:sp>
-        <p:nvSpPr>
-          <p:cNvPr id="42" name="TextBox 41">
-            <a:extLst>
-              <a:ext uri="{FF2B5EF4-FFF2-40B4-BE49-F238E27FC236}">
-                <a16:creationId xmlns:a16="http://schemas.microsoft.com/office/drawing/2014/main" id="{D546E0E8-6C73-C139-70FE-9B139D1299AB}"/>
-              </a:ext>
-            </a:extLst>
-          </p:cNvPr>
-          <p:cNvSpPr txBox="1"/>
-          <p:nvPr/>
-        </p:nvSpPr>
-        <p:spPr>
-          <a:xfrm>
-            <a:off x="11186130" y="4084229"/>
-            <a:ext cx="991126" cy="250518"/>
-          </a:xfrm>
-          <a:prstGeom prst="rect">
-            <a:avLst/>
-          </a:prstGeom>
-          <a:noFill/>
-        </p:spPr>
-        <p:txBody>
-          <a:bodyPr wrap="none" lIns="90000" rtlCol="0" anchor="t">
-            <a:spAutoFit/>
-          </a:bodyPr>
-          <a:lstStyle/>
-          <a:p>
-            <a:pPr algn="r">
-              <a:lnSpc>
-                <a:spcPct val="113000"/>
-              </a:lnSpc>
-            </a:pPr>
-            <a:r>
-              <a:rPr lang="en-US" sz="1000" b="1" dirty="0" err="1">
-                <a:solidFill>
-                  <a:schemeClr val="tx2"/>
-                </a:solidFill>
-                <a:latin typeface="Sigsterren" pitchFamily="2" charset="0"/>
-              </a:rPr>
-              <a:t>HHHHH</a:t>
-            </a:r>
-            <a:r>
-              <a:rPr lang="en-US" sz="1000" b="1" dirty="0">
-                <a:solidFill>
-                  <a:schemeClr val="tx2"/>
-                </a:solidFill>
-                <a:latin typeface="Sigsterren" pitchFamily="2" charset="0"/>
-              </a:rPr>
-              <a:t> </a:t>
-            </a:r>
-            <a:r>
-              <a:rPr lang="en-US" sz="1000" b="1" dirty="0">
-                <a:solidFill>
-                  <a:schemeClr val="tx2"/>
-                </a:solidFill>
-                <a:latin typeface="Calibri" panose="020F0502020204030204" pitchFamily="34" charset="0"/>
-                <a:cs typeface="Calibri" panose="020F0502020204030204" pitchFamily="34" charset="0"/>
-              </a:rPr>
-              <a:t>(</a:t>
-            </a:r>
-            <a:r>
-              <a:rPr lang="en-US" sz="1000" b="1" dirty="0" err="1">
-                <a:solidFill>
-                  <a:schemeClr val="tx2"/>
-                </a:solidFill>
-                <a:latin typeface="Calibri" panose="020F0502020204030204" pitchFamily="34" charset="0"/>
-                <a:cs typeface="Calibri" panose="020F0502020204030204" pitchFamily="34" charset="0"/>
-              </a:rPr>
-              <a:t>X.X</a:t>
-            </a:r>
-            <a:r>
-              <a:rPr lang="en-US" sz="1000" b="1" dirty="0">
-                <a:solidFill>
-                  <a:schemeClr val="tx2"/>
-                </a:solidFill>
-                <a:latin typeface="Calibri" panose="020F0502020204030204" pitchFamily="34" charset="0"/>
-                <a:cs typeface="Calibri" panose="020F0502020204030204" pitchFamily="34" charset="0"/>
-              </a:rPr>
-              <a:t>)</a:t>
-            </a:r>
-          </a:p>
-        </p:txBody>
-      </p:sp>
-      <p:sp>
-        <p:nvSpPr>
-          <p:cNvPr id="43" name="TextBox 42">
-            <a:extLst>
-              <a:ext uri="{FF2B5EF4-FFF2-40B4-BE49-F238E27FC236}">
-                <a16:creationId xmlns:a16="http://schemas.microsoft.com/office/drawing/2014/main" id="{EA47BA20-DFCA-D693-AE9A-6445666EECF2}"/>
-              </a:ext>
-            </a:extLst>
-          </p:cNvPr>
-          <p:cNvSpPr txBox="1"/>
-          <p:nvPr/>
-        </p:nvSpPr>
-        <p:spPr>
-          <a:xfrm>
-            <a:off x="11186130" y="3665466"/>
-            <a:ext cx="991126" cy="250518"/>
-          </a:xfrm>
-          <a:prstGeom prst="rect">
-            <a:avLst/>
-          </a:prstGeom>
-          <a:noFill/>
-        </p:spPr>
-        <p:txBody>
-          <a:bodyPr wrap="none" lIns="90000" rtlCol="0" anchor="t">
-            <a:spAutoFit/>
-          </a:bodyPr>
-          <a:lstStyle/>
-          <a:p>
-            <a:pPr algn="r">
-              <a:lnSpc>
-                <a:spcPct val="113000"/>
-              </a:lnSpc>
-            </a:pPr>
-            <a:r>
-              <a:rPr lang="en-US" sz="1000" b="1" dirty="0" err="1">
-                <a:solidFill>
-                  <a:schemeClr val="tx2"/>
-                </a:solidFill>
-                <a:latin typeface="Sigsterren" pitchFamily="2" charset="0"/>
-              </a:rPr>
-              <a:t>HHHHH</a:t>
-            </a:r>
-            <a:r>
-              <a:rPr lang="en-US" sz="1000" b="1" dirty="0">
-                <a:solidFill>
-                  <a:schemeClr val="tx2"/>
-                </a:solidFill>
-                <a:latin typeface="Sigsterren" pitchFamily="2" charset="0"/>
-              </a:rPr>
-              <a:t> </a:t>
-            </a:r>
-            <a:r>
-              <a:rPr lang="en-US" sz="1000" b="1" dirty="0">
-                <a:solidFill>
-                  <a:schemeClr val="tx2"/>
-                </a:solidFill>
-                <a:latin typeface="Calibri" panose="020F0502020204030204" pitchFamily="34" charset="0"/>
-                <a:cs typeface="Calibri" panose="020F0502020204030204" pitchFamily="34" charset="0"/>
-              </a:rPr>
-              <a:t>(</a:t>
-            </a:r>
-            <a:r>
-              <a:rPr lang="en-US" sz="1000" b="1" dirty="0" err="1">
-                <a:solidFill>
-                  <a:schemeClr val="tx2"/>
-                </a:solidFill>
-                <a:latin typeface="Calibri" panose="020F0502020204030204" pitchFamily="34" charset="0"/>
-                <a:cs typeface="Calibri" panose="020F0502020204030204" pitchFamily="34" charset="0"/>
-              </a:rPr>
-              <a:t>X.X</a:t>
-            </a:r>
-            <a:r>
-              <a:rPr lang="en-US" sz="1000" b="1" dirty="0">
-                <a:solidFill>
-                  <a:schemeClr val="tx2"/>
-                </a:solidFill>
-                <a:latin typeface="Calibri" panose="020F0502020204030204" pitchFamily="34" charset="0"/>
-                <a:cs typeface="Calibri" panose="020F0502020204030204" pitchFamily="34" charset="0"/>
-              </a:rPr>
-              <a:t>)</a:t>
-            </a:r>
-          </a:p>
-        </p:txBody>
-      </p:sp>
-      <p:sp>
-        <p:nvSpPr>
-          <p:cNvPr id="60" name="Triangle 59">
-            <a:extLst>
-              <a:ext uri="{FF2B5EF4-FFF2-40B4-BE49-F238E27FC236}">
-                <a16:creationId xmlns:a16="http://schemas.microsoft.com/office/drawing/2014/main" id="{F95464F5-7D1F-48C9-9EEF-CDB9C2AF2E96}"/>
-              </a:ext>
-            </a:extLst>
-          </p:cNvPr>
-          <p:cNvSpPr/>
-          <p:nvPr/>
-        </p:nvSpPr>
-        <p:spPr>
-          <a:xfrm rot="5400000">
-            <a:off x="11223517" y="97630"/>
-            <a:ext cx="113704" cy="91353"/>
-          </a:xfrm>
-          <a:prstGeom prst="triangle">
-            <a:avLst/>
-          </a:prstGeom>
-          <a:solidFill>
-            <a:schemeClr val="tx2"/>
-          </a:solidFill>
-          <a:ln>
-            <a:noFill/>
-          </a:ln>
-        </p:spPr>
-        <p:style>
-          <a:lnRef idx="2">
-            <a:schemeClr val="accent1">
-              <a:shade val="50000"/>
-            </a:schemeClr>
-          </a:lnRef>
-          <a:fillRef idx="1">
-            <a:schemeClr val="accent1"/>
-          </a:fillRef>
-          <a:effectRef idx="0">
-            <a:schemeClr val="accent1"/>
-          </a:effectRef>
-          <a:fontRef idx="minor">
-            <a:schemeClr val="lt1"/>
-          </a:fontRef>
-        </p:style>
-        <p:txBody>
-          <a:bodyPr lIns="108000" tIns="72000" rIns="108000" bIns="72000" rtlCol="0" anchor="ctr"/>
-          <a:lstStyle/>
-          <a:p>
-            <a:pPr algn="ctr"/>
-            <a:endParaRPr lang="en-US" sz="1600">
-              <a:solidFill>
-                <a:schemeClr val="bg1"/>
-              </a:solidFill>
-            </a:endParaRPr>
-          </a:p>
-        </p:txBody>
-      </p:sp>
-      <p:pic>
-        <p:nvPicPr>
-          <p:cNvPr id="61" name="Picture 60">
-            <a:extLst>
-              <a:ext uri="{FF2B5EF4-FFF2-40B4-BE49-F238E27FC236}">
-                <a16:creationId xmlns:a16="http://schemas.microsoft.com/office/drawing/2014/main" id="{7BC24C15-E233-6ACF-1FEA-8EAE97B74826}"/>
-              </a:ext>
-            </a:extLst>
-          </p:cNvPr>
-          <p:cNvPicPr>
-            <a:picLocks noChangeAspect="1"/>
-          </p:cNvPicPr>
-          <p:nvPr/>
-        </p:nvPicPr>
-        <p:blipFill>
-          <a:blip r:embed="rId2"/>
-          <a:stretch>
-            <a:fillRect/>
-          </a:stretch>
-        </p:blipFill>
-        <p:spPr>
-          <a:xfrm>
-            <a:off x="10267839" y="52613"/>
-            <a:ext cx="203103" cy="172639"/>
-          </a:xfrm>
-          <a:prstGeom prst="rect">
-            <a:avLst/>
-          </a:prstGeom>
-        </p:spPr>
-      </p:pic>
-      <p:sp>
-        <p:nvSpPr>
-          <p:cNvPr id="62" name="TextBox 61">
-            <a:extLst>
-              <a:ext uri="{FF2B5EF4-FFF2-40B4-BE49-F238E27FC236}">
-                <a16:creationId xmlns:a16="http://schemas.microsoft.com/office/drawing/2014/main" id="{1E7B750E-8A6C-EC7F-4178-D2F44A3E057E}"/>
-              </a:ext>
-            </a:extLst>
-          </p:cNvPr>
-          <p:cNvSpPr txBox="1"/>
-          <p:nvPr/>
-        </p:nvSpPr>
-        <p:spPr>
-          <a:xfrm>
-            <a:off x="10385792" y="10898"/>
-            <a:ext cx="869297" cy="264816"/>
-          </a:xfrm>
-          <a:prstGeom prst="rect">
-            <a:avLst/>
-          </a:prstGeom>
-          <a:noFill/>
-        </p:spPr>
-        <p:txBody>
-          <a:bodyPr wrap="none" lIns="90000" rtlCol="0" anchor="t">
-            <a:spAutoFit/>
-          </a:bodyPr>
-          <a:lstStyle/>
-          <a:p>
-            <a:pPr algn="r">
-              <a:lnSpc>
-                <a:spcPct val="113000"/>
-              </a:lnSpc>
-            </a:pPr>
-            <a:r>
-              <a:rPr lang="nl-NL" sz="1050" b="1" dirty="0" err="1">
-                <a:solidFill>
-                  <a:schemeClr val="bg1">
-                    <a:lumMod val="75000"/>
-                  </a:schemeClr>
-                </a:solidFill>
-              </a:rPr>
-              <a:t>DDMMYYYY</a:t>
-            </a:r>
-            <a:endParaRPr lang="nl-NL" sz="1050" b="1" noProof="0" dirty="0">
-              <a:solidFill>
-                <a:schemeClr val="bg1">
-                  <a:lumMod val="75000"/>
-                </a:schemeClr>
-              </a:solidFill>
-            </a:endParaRPr>
-          </a:p>
-        </p:txBody>
-      </p:sp>
-      <p:sp>
-        <p:nvSpPr>
-          <p:cNvPr id="63" name="TextBox 62">
-            <a:extLst>
-              <a:ext uri="{FF2B5EF4-FFF2-40B4-BE49-F238E27FC236}">
-                <a16:creationId xmlns:a16="http://schemas.microsoft.com/office/drawing/2014/main" id="{D1AB6851-33F7-6EC5-7B7B-CB66A34240F5}"/>
-              </a:ext>
-            </a:extLst>
-          </p:cNvPr>
-          <p:cNvSpPr txBox="1"/>
-          <p:nvPr/>
-        </p:nvSpPr>
-        <p:spPr>
-          <a:xfrm>
-            <a:off x="11305651" y="10898"/>
-            <a:ext cx="869297" cy="264816"/>
-          </a:xfrm>
-          <a:prstGeom prst="rect">
-            <a:avLst/>
-          </a:prstGeom>
-          <a:noFill/>
-        </p:spPr>
-        <p:txBody>
-          <a:bodyPr wrap="none" lIns="90000" rtlCol="0" anchor="t">
-            <a:spAutoFit/>
-          </a:bodyPr>
-          <a:lstStyle/>
-          <a:p>
-            <a:pPr>
-              <a:lnSpc>
-                <a:spcPct val="113000"/>
-              </a:lnSpc>
-            </a:pPr>
-            <a:r>
-              <a:rPr lang="nl-NL" sz="1050" b="1" dirty="0" err="1">
-                <a:solidFill>
-                  <a:schemeClr val="tx2"/>
-                </a:solidFill>
-              </a:rPr>
-              <a:t>DDMMYYYY</a:t>
-            </a:r>
-            <a:endParaRPr lang="nl-NL" sz="1050" b="1" noProof="0" dirty="0">
-              <a:solidFill>
-                <a:schemeClr val="tx2"/>
-              </a:solidFill>
-            </a:endParaRPr>
-          </a:p>
-        </p:txBody>
-      </p:sp>
-      <p:grpSp>
-        <p:nvGrpSpPr>
-          <p:cNvPr id="64" name="Group 63">
-            <a:extLst>
-              <a:ext uri="{FF2B5EF4-FFF2-40B4-BE49-F238E27FC236}">
-                <a16:creationId xmlns:a16="http://schemas.microsoft.com/office/drawing/2014/main" id="{52F634C2-37CE-010F-8B92-6E5760B28860}"/>
-              </a:ext>
-            </a:extLst>
-          </p:cNvPr>
-          <p:cNvGrpSpPr>
-            <a:grpSpLocks noChangeAspect="1"/>
-          </p:cNvGrpSpPr>
-          <p:nvPr/>
-        </p:nvGrpSpPr>
-        <p:grpSpPr>
-          <a:xfrm>
-            <a:off x="-392105" y="2517185"/>
-            <a:ext cx="98115" cy="92576"/>
-            <a:chOff x="-331054" y="2564812"/>
-            <a:chExt cx="141517" cy="133528"/>
-          </a:xfrm>
-          <a:solidFill>
-            <a:srgbClr val="57C968"/>
-          </a:solidFill>
-        </p:grpSpPr>
-        <p:sp>
-          <p:nvSpPr>
-            <p:cNvPr id="65" name="Freeform 64">
-              <a:extLst>
-                <a:ext uri="{FF2B5EF4-FFF2-40B4-BE49-F238E27FC236}">
-                  <a16:creationId xmlns:a16="http://schemas.microsoft.com/office/drawing/2014/main" id="{49B5B708-A7B2-47A0-02A6-B9C8274E353D}"/>
-                </a:ext>
-              </a:extLst>
-            </p:cNvPr>
-            <p:cNvSpPr/>
-            <p:nvPr/>
-          </p:nvSpPr>
-          <p:spPr>
-            <a:xfrm>
-              <a:off x="-331054" y="2564812"/>
-              <a:ext cx="141517" cy="82436"/>
-            </a:xfrm>
-            <a:custGeom>
-              <a:avLst/>
-              <a:gdLst>
-                <a:gd name="connsiteX0" fmla="*/ 70759 w 141517"/>
-                <a:gd name="connsiteY0" fmla="*/ 0 h 82436"/>
-                <a:gd name="connsiteX1" fmla="*/ 141517 w 141517"/>
-                <a:gd name="connsiteY1" fmla="*/ 82436 h 82436"/>
-                <a:gd name="connsiteX2" fmla="*/ 111805 w 141517"/>
-                <a:gd name="connsiteY2" fmla="*/ 82436 h 82436"/>
-                <a:gd name="connsiteX3" fmla="*/ 70759 w 141517"/>
-                <a:gd name="connsiteY3" fmla="*/ 34616 h 82436"/>
-                <a:gd name="connsiteX4" fmla="*/ 29713 w 141517"/>
-                <a:gd name="connsiteY4" fmla="*/ 82436 h 82436"/>
-                <a:gd name="connsiteX5" fmla="*/ 0 w 141517"/>
-                <a:gd name="connsiteY5" fmla="*/ 82436 h 82436"/>
-              </a:gdLst>
-              <a:ahLst/>
-              <a:cxnLst>
-                <a:cxn ang="0">
-                  <a:pos x="connsiteX0" y="connsiteY0"/>
-                </a:cxn>
-                <a:cxn ang="0">
-                  <a:pos x="connsiteX1" y="connsiteY1"/>
-                </a:cxn>
-                <a:cxn ang="0">
-                  <a:pos x="connsiteX2" y="connsiteY2"/>
-                </a:cxn>
-                <a:cxn ang="0">
-                  <a:pos x="connsiteX3" y="connsiteY3"/>
-                </a:cxn>
-                <a:cxn ang="0">
-                  <a:pos x="connsiteX4" y="connsiteY4"/>
-                </a:cxn>
-                <a:cxn ang="0">
-                  <a:pos x="connsiteX5" y="connsiteY5"/>
-                </a:cxn>
-              </a:cxnLst>
-              <a:rect l="l" t="t" r="r" b="b"/>
-              <a:pathLst>
-                <a:path w="141517" h="82436">
-                  <a:moveTo>
-                    <a:pt x="70759" y="0"/>
-                  </a:moveTo>
-                  <a:lnTo>
-                    <a:pt x="141517" y="82436"/>
-                  </a:lnTo>
-                  <a:lnTo>
-                    <a:pt x="111805" y="82436"/>
-                  </a:lnTo>
-                  <a:lnTo>
-                    <a:pt x="70759" y="34616"/>
-                  </a:lnTo>
-                  <a:lnTo>
-                    <a:pt x="29713" y="82436"/>
-                  </a:lnTo>
-                  <a:lnTo>
-                    <a:pt x="0" y="82436"/>
-                  </a:lnTo>
-                  <a:close/>
-                </a:path>
-              </a:pathLst>
-            </a:custGeom>
-            <a:grpFill/>
-            <a:ln>
-              <a:noFill/>
-            </a:ln>
-          </p:spPr>
-          <p:style>
-            <a:lnRef idx="2">
-              <a:schemeClr val="accent1">
-                <a:shade val="50000"/>
-              </a:schemeClr>
-            </a:lnRef>
-            <a:fillRef idx="1">
-              <a:schemeClr val="accent1"/>
-            </a:fillRef>
-            <a:effectRef idx="0">
-              <a:schemeClr val="accent1"/>
-            </a:effectRef>
-            <a:fontRef idx="minor">
-              <a:schemeClr val="lt1"/>
-            </a:fontRef>
-          </p:style>
-          <p:txBody>
-            <a:bodyPr wrap="square" lIns="108000" tIns="72000" rIns="108000" bIns="72000" rtlCol="0" anchor="ctr">
-              <a:noAutofit/>
-            </a:bodyPr>
-            <a:lstStyle/>
-            <a:p>
-              <a:pPr algn="ctr"/>
-              <a:endParaRPr lang="en-US" sz="1600" err="1">
-                <a:solidFill>
-                  <a:schemeClr val="bg1"/>
-                </a:solidFill>
-              </a:endParaRPr>
-            </a:p>
-          </p:txBody>
-        </p:sp>
-        <p:sp>
-          <p:nvSpPr>
-            <p:cNvPr id="66" name="Triangle 65">
-              <a:extLst>
-                <a:ext uri="{FF2B5EF4-FFF2-40B4-BE49-F238E27FC236}">
-                  <a16:creationId xmlns:a16="http://schemas.microsoft.com/office/drawing/2014/main" id="{15016D72-64E2-50BC-91E8-D69B0359C8DE}"/>
-                </a:ext>
-              </a:extLst>
-            </p:cNvPr>
-            <p:cNvSpPr/>
-            <p:nvPr/>
-          </p:nvSpPr>
-          <p:spPr>
-            <a:xfrm>
-              <a:off x="-331054" y="2615904"/>
-              <a:ext cx="141517" cy="82436"/>
-            </a:xfrm>
-            <a:prstGeom prst="triangle">
-              <a:avLst/>
-            </a:prstGeom>
-            <a:grpFill/>
-            <a:ln>
-              <a:noFill/>
-            </a:ln>
-          </p:spPr>
-          <p:style>
-            <a:lnRef idx="2">
-              <a:schemeClr val="accent1">
-                <a:shade val="50000"/>
-              </a:schemeClr>
-            </a:lnRef>
-            <a:fillRef idx="1">
-              <a:schemeClr val="accent1"/>
-            </a:fillRef>
-            <a:effectRef idx="0">
-              <a:schemeClr val="accent1"/>
-            </a:effectRef>
-            <a:fontRef idx="minor">
-              <a:schemeClr val="lt1"/>
-            </a:fontRef>
-          </p:style>
-          <p:txBody>
-            <a:bodyPr lIns="108000" tIns="72000" rIns="108000" bIns="72000" rtlCol="0" anchor="ctr"/>
-            <a:lstStyle/>
-            <a:p>
-              <a:pPr algn="ctr"/>
-              <a:endParaRPr lang="en-US" sz="1600" err="1">
-                <a:solidFill>
-                  <a:schemeClr val="bg1"/>
-                </a:solidFill>
-              </a:endParaRPr>
-            </a:p>
-          </p:txBody>
-        </p:sp>
-      </p:grpSp>
-      <p:grpSp>
-        <p:nvGrpSpPr>
-          <p:cNvPr id="67" name="Group 66">
-            <a:extLst>
-              <a:ext uri="{FF2B5EF4-FFF2-40B4-BE49-F238E27FC236}">
-                <a16:creationId xmlns:a16="http://schemas.microsoft.com/office/drawing/2014/main" id="{FD64E9BF-05EB-6130-A85F-FF06B8B22AC2}"/>
-              </a:ext>
-            </a:extLst>
-          </p:cNvPr>
-          <p:cNvGrpSpPr>
-            <a:grpSpLocks noChangeAspect="1"/>
-          </p:cNvGrpSpPr>
-          <p:nvPr/>
-        </p:nvGrpSpPr>
-        <p:grpSpPr>
-          <a:xfrm rot="10800000">
-            <a:off x="-392106" y="2948284"/>
-            <a:ext cx="98115" cy="92576"/>
-            <a:chOff x="-331054" y="2564812"/>
-            <a:chExt cx="141517" cy="133528"/>
-          </a:xfrm>
-          <a:solidFill>
-            <a:srgbClr val="FFC000"/>
-          </a:solidFill>
-        </p:grpSpPr>
-        <p:sp>
-          <p:nvSpPr>
-            <p:cNvPr id="68" name="Freeform 67">
-              <a:extLst>
-                <a:ext uri="{FF2B5EF4-FFF2-40B4-BE49-F238E27FC236}">
-                  <a16:creationId xmlns:a16="http://schemas.microsoft.com/office/drawing/2014/main" id="{46FEA5A0-621C-D9C8-7568-3EA3F81AD086}"/>
-                </a:ext>
-              </a:extLst>
-            </p:cNvPr>
-            <p:cNvSpPr/>
-            <p:nvPr/>
-          </p:nvSpPr>
-          <p:spPr>
-            <a:xfrm>
-              <a:off x="-331054" y="2564812"/>
-              <a:ext cx="141517" cy="82436"/>
-            </a:xfrm>
-            <a:custGeom>
-              <a:avLst/>
-              <a:gdLst>
-                <a:gd name="connsiteX0" fmla="*/ 70759 w 141517"/>
-                <a:gd name="connsiteY0" fmla="*/ 0 h 82436"/>
-                <a:gd name="connsiteX1" fmla="*/ 141517 w 141517"/>
-                <a:gd name="connsiteY1" fmla="*/ 82436 h 82436"/>
-                <a:gd name="connsiteX2" fmla="*/ 111805 w 141517"/>
-                <a:gd name="connsiteY2" fmla="*/ 82436 h 82436"/>
-                <a:gd name="connsiteX3" fmla="*/ 70759 w 141517"/>
-                <a:gd name="connsiteY3" fmla="*/ 34616 h 82436"/>
-                <a:gd name="connsiteX4" fmla="*/ 29713 w 141517"/>
-                <a:gd name="connsiteY4" fmla="*/ 82436 h 82436"/>
-                <a:gd name="connsiteX5" fmla="*/ 0 w 141517"/>
-                <a:gd name="connsiteY5" fmla="*/ 82436 h 82436"/>
-              </a:gdLst>
-              <a:ahLst/>
-              <a:cxnLst>
-                <a:cxn ang="0">
-                  <a:pos x="connsiteX0" y="connsiteY0"/>
-                </a:cxn>
-                <a:cxn ang="0">
-                  <a:pos x="connsiteX1" y="connsiteY1"/>
-                </a:cxn>
-                <a:cxn ang="0">
-                  <a:pos x="connsiteX2" y="connsiteY2"/>
-                </a:cxn>
-                <a:cxn ang="0">
-                  <a:pos x="connsiteX3" y="connsiteY3"/>
-                </a:cxn>
-                <a:cxn ang="0">
-                  <a:pos x="connsiteX4" y="connsiteY4"/>
-                </a:cxn>
-                <a:cxn ang="0">
-                  <a:pos x="connsiteX5" y="connsiteY5"/>
-                </a:cxn>
-              </a:cxnLst>
-              <a:rect l="l" t="t" r="r" b="b"/>
-              <a:pathLst>
-                <a:path w="141517" h="82436">
-                  <a:moveTo>
-                    <a:pt x="70759" y="0"/>
-                  </a:moveTo>
-                  <a:lnTo>
-                    <a:pt x="141517" y="82436"/>
-                  </a:lnTo>
-                  <a:lnTo>
-                    <a:pt x="111805" y="82436"/>
-                  </a:lnTo>
-                  <a:lnTo>
-                    <a:pt x="70759" y="34616"/>
-                  </a:lnTo>
-                  <a:lnTo>
-                    <a:pt x="29713" y="82436"/>
-                  </a:lnTo>
-                  <a:lnTo>
-                    <a:pt x="0" y="82436"/>
-                  </a:lnTo>
-                  <a:close/>
-                </a:path>
-              </a:pathLst>
-            </a:custGeom>
-            <a:grpFill/>
-            <a:ln>
-              <a:noFill/>
-            </a:ln>
-          </p:spPr>
-          <p:style>
-            <a:lnRef idx="2">
-              <a:schemeClr val="accent1">
-                <a:shade val="50000"/>
-              </a:schemeClr>
-            </a:lnRef>
-            <a:fillRef idx="1">
-              <a:schemeClr val="accent1"/>
-            </a:fillRef>
-            <a:effectRef idx="0">
-              <a:schemeClr val="accent1"/>
-            </a:effectRef>
-            <a:fontRef idx="minor">
-              <a:schemeClr val="lt1"/>
-            </a:fontRef>
-          </p:style>
-          <p:txBody>
-            <a:bodyPr wrap="square" lIns="108000" tIns="72000" rIns="108000" bIns="72000" rtlCol="0" anchor="ctr">
-              <a:noAutofit/>
-            </a:bodyPr>
-            <a:lstStyle/>
-            <a:p>
-              <a:pPr algn="ctr"/>
-              <a:endParaRPr lang="en-US" sz="1600" err="1">
-                <a:solidFill>
-                  <a:schemeClr val="bg1"/>
-                </a:solidFill>
-              </a:endParaRPr>
-            </a:p>
-          </p:txBody>
-        </p:sp>
-        <p:sp>
-          <p:nvSpPr>
-            <p:cNvPr id="69" name="Triangle 68">
-              <a:extLst>
-                <a:ext uri="{FF2B5EF4-FFF2-40B4-BE49-F238E27FC236}">
-                  <a16:creationId xmlns:a16="http://schemas.microsoft.com/office/drawing/2014/main" id="{69BA4EAB-B7EE-8FF8-F8E7-3F662C974ABA}"/>
-                </a:ext>
-              </a:extLst>
-            </p:cNvPr>
-            <p:cNvSpPr/>
-            <p:nvPr/>
-          </p:nvSpPr>
-          <p:spPr>
-            <a:xfrm>
-              <a:off x="-331054" y="2615904"/>
-              <a:ext cx="141517" cy="82436"/>
-            </a:xfrm>
-            <a:prstGeom prst="triangle">
-              <a:avLst/>
-            </a:prstGeom>
-            <a:grpFill/>
-            <a:ln>
-              <a:noFill/>
-            </a:ln>
-          </p:spPr>
-          <p:style>
-            <a:lnRef idx="2">
-              <a:schemeClr val="accent1">
-                <a:shade val="50000"/>
-              </a:schemeClr>
-            </a:lnRef>
-            <a:fillRef idx="1">
-              <a:schemeClr val="accent1"/>
-            </a:fillRef>
-            <a:effectRef idx="0">
-              <a:schemeClr val="accent1"/>
-            </a:effectRef>
-            <a:fontRef idx="minor">
-              <a:schemeClr val="lt1"/>
-            </a:fontRef>
-          </p:style>
-          <p:txBody>
-            <a:bodyPr lIns="108000" tIns="72000" rIns="108000" bIns="72000" rtlCol="0" anchor="ctr"/>
-            <a:lstStyle/>
-            <a:p>
-              <a:pPr algn="ctr"/>
-              <a:endParaRPr lang="en-US" sz="1600" err="1">
-                <a:solidFill>
-                  <a:schemeClr val="bg1"/>
-                </a:solidFill>
-              </a:endParaRPr>
-            </a:p>
-          </p:txBody>
-        </p:sp>
-      </p:grpSp>
-      <p:sp>
-        <p:nvSpPr>
-          <p:cNvPr id="72" name="TextBox 71">
-            <a:extLst>
-              <a:ext uri="{FF2B5EF4-FFF2-40B4-BE49-F238E27FC236}">
-                <a16:creationId xmlns:a16="http://schemas.microsoft.com/office/drawing/2014/main" id="{A83488C0-0263-83DB-D546-0A98087E0898}"/>
-              </a:ext>
-            </a:extLst>
-          </p:cNvPr>
-          <p:cNvSpPr txBox="1"/>
-          <p:nvPr/>
-        </p:nvSpPr>
-        <p:spPr>
-          <a:xfrm>
-            <a:off x="9777184" y="3305030"/>
-            <a:ext cx="579667" cy="322332"/>
-          </a:xfrm>
-          <a:prstGeom prst="rect">
-            <a:avLst/>
-          </a:prstGeom>
-          <a:noFill/>
-        </p:spPr>
-        <p:txBody>
-          <a:bodyPr wrap="none" lIns="90000" rtlCol="0" anchor="t">
-            <a:spAutoFit/>
-          </a:bodyPr>
-          <a:lstStyle/>
-          <a:p>
-            <a:pPr algn="l">
-              <a:lnSpc>
-                <a:spcPct val="113000"/>
-              </a:lnSpc>
-            </a:pPr>
-            <a:r>
-              <a:rPr lang="en-US" sz="1400" b="1" dirty="0">
-                <a:solidFill>
-                  <a:schemeClr val="tx2"/>
-                </a:solidFill>
-              </a:rPr>
-              <a:t>Team</a:t>
-            </a:r>
-          </a:p>
-        </p:txBody>
-      </p:sp>
-      <p:sp>
-        <p:nvSpPr>
-          <p:cNvPr id="2" name="TextBox 1">
-            <a:extLst>
-              <a:ext uri="{FF2B5EF4-FFF2-40B4-BE49-F238E27FC236}">
-                <a16:creationId xmlns:a16="http://schemas.microsoft.com/office/drawing/2014/main" id="{85703D95-EA94-DA5F-AF1C-A4FB16A72007}"/>
-              </a:ext>
-            </a:extLst>
-          </p:cNvPr>
-          <p:cNvSpPr txBox="1"/>
-          <p:nvPr/>
-        </p:nvSpPr>
-        <p:spPr>
-          <a:xfrm>
-            <a:off x="5667804" y="-487693"/>
-            <a:ext cx="3555738" cy="355225"/>
-          </a:xfrm>
-          <a:prstGeom prst="rect">
-            <a:avLst/>
-          </a:prstGeom>
-          <a:noFill/>
-        </p:spPr>
-        <p:txBody>
-          <a:bodyPr wrap="none" lIns="90000" rtlCol="0" anchor="t">
-            <a:spAutoFit/>
-          </a:bodyPr>
-          <a:lstStyle/>
-          <a:p>
-            <a:pPr algn="l">
-              <a:lnSpc>
-                <a:spcPct val="113000"/>
-              </a:lnSpc>
-            </a:pPr>
-            <a:r>
-              <a:rPr lang="en-US" sz="1600" dirty="0">
-                <a:solidFill>
-                  <a:schemeClr val="tx2"/>
-                </a:solidFill>
-              </a:rPr>
-              <a:t>INTERVAL_</a:t>
-            </a:r>
-            <a:r>
-              <a:rPr lang="en-US" sz="1600">
-                <a:solidFill>
-                  <a:schemeClr val="tx2"/>
-                </a:solidFill>
-              </a:rPr>
-              <a:t>PORTFOLIO_qw:</a:t>
-            </a:r>
-            <a:r>
-              <a:rPr lang="en-US" sz="1600" dirty="0">
-                <a:solidFill>
-                  <a:schemeClr val="tx2"/>
-                </a:solidFill>
-              </a:rPr>
-              <a:t>0.56:3.5:9.57</a:t>
-            </a:r>
-          </a:p>
-        </p:txBody>
-      </p:sp>
-      <p:pic>
-        <p:nvPicPr>
-          <p:cNvPr id="12" name="Graphic 11">
-            <a:extLst>
-              <a:ext uri="{FF2B5EF4-FFF2-40B4-BE49-F238E27FC236}">
-                <a16:creationId xmlns:a16="http://schemas.microsoft.com/office/drawing/2014/main" id="{C5717CE4-4A43-AD91-1D83-D8A9D83A84C4}"/>
-              </a:ext>
-            </a:extLst>
-          </p:cNvPr>
-          <p:cNvPicPr>
-            <a:picLocks noChangeAspect="1"/>
-          </p:cNvPicPr>
-          <p:nvPr/>
-        </p:nvPicPr>
-        <p:blipFill>
-          <a:blip r:embed="rId3">
-            <a:extLst>
-              <a:ext uri="{96DAC541-7B7A-43D3-8B79-37D633B846F1}">
-                <asvg:svgBlip xmlns:asvg="http://schemas.microsoft.com/office/drawing/2016/SVG/main" r:embed="rId4"/>
-              </a:ext>
-            </a:extLst>
-          </a:blip>
-          <a:stretch>
-            <a:fillRect/>
-          </a:stretch>
-        </p:blipFill>
-        <p:spPr>
-          <a:xfrm>
-            <a:off x="8838256" y="6071736"/>
-            <a:ext cx="371130" cy="206558"/>
-          </a:xfrm>
-          <a:prstGeom prst="rect">
-            <a:avLst/>
-          </a:prstGeom>
-        </p:spPr>
-      </p:pic>
-      <p:sp>
-        <p:nvSpPr>
-          <p:cNvPr id="4" name="TextBox 3">
-            <a:extLst>
-              <a:ext uri="{FF2B5EF4-FFF2-40B4-BE49-F238E27FC236}">
-                <a16:creationId xmlns:a16="http://schemas.microsoft.com/office/drawing/2014/main" id="{464ABFFC-AD64-4547-1CA1-ACE9043FC327}"/>
-              </a:ext>
-            </a:extLst>
-          </p:cNvPr>
-          <p:cNvSpPr txBox="1"/>
-          <p:nvPr/>
-        </p:nvSpPr>
-        <p:spPr>
-          <a:xfrm>
-            <a:off x="5789382" y="-826903"/>
-            <a:ext cx="3998167" cy="355162"/>
-          </a:xfrm>
-          <a:prstGeom prst="rect">
-            <a:avLst/>
-          </a:prstGeom>
-          <a:noFill/>
-        </p:spPr>
-        <p:txBody>
-          <a:bodyPr wrap="none" lIns="90000" rtlCol="0" anchor="t">
-            <a:spAutoFit/>
-          </a:bodyPr>
-          <a:lstStyle/>
-          <a:p>
-            <a:pPr algn="l">
-              <a:lnSpc>
-                <a:spcPct val="113000"/>
-              </a:lnSpc>
-            </a:pPr>
-            <a:r>
-              <a:rPr lang="en-US" sz="1600" dirty="0" err="1">
-                <a:solidFill>
-                  <a:schemeClr val="tx2"/>
-                </a:solidFill>
-              </a:rPr>
-              <a:t>INTERVAL_PORTFOLIO</a:t>
-            </a:r>
-            <a:r>
-              <a:rPr lang="en-US" sz="1600" dirty="0">
-                <a:solidFill>
-                  <a:schemeClr val="tx2"/>
-                </a:solidFill>
-              </a:rPr>
-              <a:t>_@@MAINTAINABILITY</a:t>
-            </a:r>
-          </a:p>
-        </p:txBody>
-      </p:sp>
-      <p:sp>
-        <p:nvSpPr>
-          <p:cNvPr id="11" name="Rectangle 10">
-            <a:extLst>
-              <a:ext uri="{FF2B5EF4-FFF2-40B4-BE49-F238E27FC236}">
-                <a16:creationId xmlns:a16="http://schemas.microsoft.com/office/drawing/2014/main" id="{3DDEE85E-749D-1E72-0838-0C16CD9596A0}"/>
-              </a:ext>
-            </a:extLst>
-          </p:cNvPr>
-          <p:cNvSpPr/>
-          <p:nvPr/>
-        </p:nvSpPr>
-        <p:spPr>
-          <a:xfrm>
-            <a:off x="585262" y="3344322"/>
-            <a:ext cx="2868134" cy="2520777"/>
-          </a:xfrm>
-          <a:prstGeom prst="rect">
-            <a:avLst/>
-          </a:prstGeom>
-          <a:solidFill>
-            <a:srgbClr val="F0089F"/>
-          </a:solidFill>
-          <a:ln>
-            <a:noFill/>
-          </a:ln>
-        </p:spPr>
-        <p:style>
-          <a:lnRef idx="2">
-            <a:schemeClr val="accent1">
-              <a:shade val="50000"/>
-            </a:schemeClr>
-          </a:lnRef>
-          <a:fillRef idx="1">
-            <a:schemeClr val="accent1"/>
-          </a:fillRef>
-          <a:effectRef idx="0">
-            <a:schemeClr val="accent1"/>
-          </a:effectRef>
-          <a:fontRef idx="minor">
-            <a:schemeClr val="lt1"/>
-          </a:fontRef>
-        </p:style>
-        <p:txBody>
-          <a:bodyPr lIns="108000" tIns="72000" rIns="108000" bIns="72000" rtlCol="0" anchor="ctr"/>
-          <a:lstStyle/>
-          <a:p>
-            <a:pPr algn="ctr"/>
-            <a:r>
-              <a:rPr lang="en-US" sz="1600" dirty="0" err="1">
-                <a:solidFill>
-                  <a:schemeClr val="bg1"/>
-                </a:solidFill>
-              </a:rPr>
-              <a:t>INTERVAL_PORTFOLIO_MAINTAINABILITY</a:t>
-            </a:r>
-            <a:endParaRPr lang="en-US" sz="1600" dirty="0">
-              <a:solidFill>
-                <a:schemeClr val="bg1"/>
-              </a:solidFill>
-            </a:endParaRPr>
-          </a:p>
-        </p:txBody>
-      </p:sp>
-      <p:sp>
-        <p:nvSpPr>
-          <p:cNvPr id="10" name="Rectangle 9">
-            <a:extLst>
-              <a:ext uri="{FF2B5EF4-FFF2-40B4-BE49-F238E27FC236}">
-                <a16:creationId xmlns:a16="http://schemas.microsoft.com/office/drawing/2014/main" id="{264C34DE-AF1B-8752-48D8-A7EEFCAB8ABF}"/>
-              </a:ext>
-            </a:extLst>
-          </p:cNvPr>
-          <p:cNvSpPr/>
-          <p:nvPr/>
-        </p:nvSpPr>
-        <p:spPr>
-          <a:xfrm>
-            <a:off x="3775684" y="3357089"/>
-            <a:ext cx="2868134" cy="2520777"/>
-          </a:xfrm>
-          <a:prstGeom prst="rect">
-            <a:avLst/>
-          </a:prstGeom>
-          <a:solidFill>
-            <a:srgbClr val="F0089F"/>
-          </a:solidFill>
-          <a:ln>
-            <a:noFill/>
-          </a:ln>
-        </p:spPr>
-        <p:style>
-          <a:lnRef idx="2">
-            <a:schemeClr val="accent1">
-              <a:shade val="50000"/>
-            </a:schemeClr>
-          </a:lnRef>
-          <a:fillRef idx="1">
-            <a:schemeClr val="accent1"/>
-          </a:fillRef>
-          <a:effectRef idx="0">
-            <a:schemeClr val="accent1"/>
-          </a:effectRef>
-          <a:fontRef idx="minor">
-            <a:schemeClr val="lt1"/>
-          </a:fontRef>
-        </p:style>
-        <p:txBody>
-          <a:bodyPr lIns="108000" tIns="72000" rIns="108000" bIns="72000" rtlCol="0" anchor="ctr"/>
-          <a:lstStyle/>
-          <a:p>
-            <a:pPr algn="ctr"/>
-            <a:r>
-              <a:rPr lang="en-US" sz="1600" dirty="0" err="1">
-                <a:solidFill>
-                  <a:schemeClr val="bg1"/>
-                </a:solidFill>
-              </a:rPr>
-              <a:t>INTERVAL_PORTFOLIO_MAINTAINABILITY</a:t>
-            </a:r>
-            <a:endParaRPr lang="en-US" sz="1600" dirty="0">
-              <a:solidFill>
-                <a:schemeClr val="bg1"/>
-              </a:solidFill>
-            </a:endParaRPr>
-          </a:p>
-        </p:txBody>
-      </p:sp>
-      <p:sp>
-        <p:nvSpPr>
-          <p:cNvPr id="32" name="TextBox 31">
-            <a:extLst>
-              <a:ext uri="{FF2B5EF4-FFF2-40B4-BE49-F238E27FC236}">
-                <a16:creationId xmlns:a16="http://schemas.microsoft.com/office/drawing/2014/main" id="{3E347E3B-F844-75E6-CCCC-1977398B9D6D}"/>
-              </a:ext>
-            </a:extLst>
-          </p:cNvPr>
-          <p:cNvSpPr txBox="1"/>
-          <p:nvPr/>
-        </p:nvSpPr>
-        <p:spPr>
-          <a:xfrm>
-            <a:off x="2643466" y="6054740"/>
-            <a:ext cx="1276460" cy="223844"/>
-          </a:xfrm>
-          <a:prstGeom prst="rect">
-            <a:avLst/>
-          </a:prstGeom>
-          <a:noFill/>
-        </p:spPr>
-        <p:txBody>
-          <a:bodyPr wrap="none" lIns="90000" rtlCol="0" anchor="t">
-            <a:spAutoFit/>
-          </a:bodyPr>
-          <a:lstStyle/>
-          <a:p>
-            <a:pPr algn="l">
-              <a:lnSpc>
-                <a:spcPct val="113000"/>
-              </a:lnSpc>
-            </a:pPr>
-            <a:r>
-              <a:rPr lang="en-US" sz="800" dirty="0">
-                <a:solidFill>
-                  <a:schemeClr val="accent3"/>
-                </a:solidFill>
-              </a:rPr>
-              <a:t>Systems grouped by </a:t>
-            </a:r>
-            <a:r>
-              <a:rPr lang="en-US" sz="800" b="1" dirty="0">
-                <a:solidFill>
-                  <a:schemeClr val="accent3"/>
-                </a:solidFill>
-              </a:rPr>
-              <a:t>Team</a:t>
-            </a:r>
-          </a:p>
-        </p:txBody>
-      </p:sp>
-      <p:grpSp>
-        <p:nvGrpSpPr>
-          <p:cNvPr id="34" name="Group 33">
-            <a:extLst>
-              <a:ext uri="{FF2B5EF4-FFF2-40B4-BE49-F238E27FC236}">
-                <a16:creationId xmlns:a16="http://schemas.microsoft.com/office/drawing/2014/main" id="{5CB1EDFE-623F-8D30-7B55-AE002AE90293}"/>
-              </a:ext>
-            </a:extLst>
-          </p:cNvPr>
-          <p:cNvGrpSpPr/>
-          <p:nvPr/>
-        </p:nvGrpSpPr>
-        <p:grpSpPr>
-          <a:xfrm>
-            <a:off x="516802" y="6117354"/>
-            <a:ext cx="300732" cy="98617"/>
-            <a:chOff x="586253" y="6116391"/>
-            <a:chExt cx="300732" cy="98617"/>
-          </a:xfrm>
-        </p:grpSpPr>
-        <p:sp>
-          <p:nvSpPr>
-            <p:cNvPr id="46" name="TextBox 45">
-              <a:extLst>
-                <a:ext uri="{FF2B5EF4-FFF2-40B4-BE49-F238E27FC236}">
-                  <a16:creationId xmlns:a16="http://schemas.microsoft.com/office/drawing/2014/main" id="{B3DBAE68-D1D2-081B-CF6A-521378EA57C7}"/>
-                </a:ext>
-              </a:extLst>
-            </p:cNvPr>
-            <p:cNvSpPr txBox="1"/>
-            <p:nvPr/>
-          </p:nvSpPr>
-          <p:spPr>
-            <a:xfrm>
-              <a:off x="710655" y="6116391"/>
-              <a:ext cx="176330" cy="98617"/>
-            </a:xfrm>
-            <a:prstGeom prst="rect">
-              <a:avLst/>
-            </a:prstGeom>
-            <a:noFill/>
-          </p:spPr>
-          <p:txBody>
-            <a:bodyPr wrap="none" lIns="0" tIns="0" rIns="0" bIns="0" rtlCol="0" anchor="t">
-              <a:spAutoFit/>
-            </a:bodyPr>
-            <a:lstStyle/>
-            <a:p>
-              <a:pPr algn="l">
-                <a:lnSpc>
-                  <a:spcPct val="113000"/>
-                </a:lnSpc>
-              </a:pPr>
-              <a:r>
-                <a:rPr lang="en-US" sz="600" dirty="0">
-                  <a:solidFill>
-                    <a:schemeClr val="tx2"/>
-                  </a:solidFill>
-                </a:rPr>
-                <a:t>1 star</a:t>
-              </a:r>
-            </a:p>
-          </p:txBody>
-        </p:sp>
-        <p:sp>
-          <p:nvSpPr>
-            <p:cNvPr id="47" name="Rounded Rectangle 46">
-              <a:extLst>
-                <a:ext uri="{FF2B5EF4-FFF2-40B4-BE49-F238E27FC236}">
-                  <a16:creationId xmlns:a16="http://schemas.microsoft.com/office/drawing/2014/main" id="{328EC574-E78F-8044-BA2E-8B48B28DBE26}"/>
-                </a:ext>
-              </a:extLst>
-            </p:cNvPr>
-            <p:cNvSpPr>
-              <a:spLocks noChangeAspect="1"/>
-            </p:cNvSpPr>
-            <p:nvPr/>
-          </p:nvSpPr>
-          <p:spPr>
-            <a:xfrm>
-              <a:off x="586253" y="6119980"/>
-              <a:ext cx="89812" cy="91440"/>
-            </a:xfrm>
-            <a:prstGeom prst="roundRect">
-              <a:avLst/>
-            </a:prstGeom>
-            <a:solidFill>
-              <a:srgbClr val="C04035"/>
-            </a:solidFill>
-            <a:ln>
-              <a:noFill/>
-            </a:ln>
-          </p:spPr>
-          <p:style>
-            <a:lnRef idx="2">
-              <a:schemeClr val="accent1">
-                <a:shade val="50000"/>
-              </a:schemeClr>
-            </a:lnRef>
-            <a:fillRef idx="1">
-              <a:schemeClr val="accent1"/>
-            </a:fillRef>
-            <a:effectRef idx="0">
-              <a:schemeClr val="accent1"/>
-            </a:effectRef>
-            <a:fontRef idx="minor">
-              <a:schemeClr val="lt1"/>
-            </a:fontRef>
-          </p:style>
-          <p:txBody>
-            <a:bodyPr lIns="108000" tIns="72000" rIns="108000" bIns="72000" rtlCol="0" anchor="ctr"/>
-            <a:lstStyle/>
-            <a:p>
-              <a:pPr algn="ctr"/>
-              <a:endParaRPr lang="en-US" sz="1600" dirty="0" err="1">
-                <a:solidFill>
-                  <a:schemeClr val="bg1"/>
-                </a:solidFill>
-              </a:endParaRPr>
-            </a:p>
-          </p:txBody>
-        </p:sp>
-      </p:grpSp>
-      <p:grpSp>
-        <p:nvGrpSpPr>
-          <p:cNvPr id="48" name="Group 47">
-            <a:extLst>
-              <a:ext uri="{FF2B5EF4-FFF2-40B4-BE49-F238E27FC236}">
-                <a16:creationId xmlns:a16="http://schemas.microsoft.com/office/drawing/2014/main" id="{9F1D3490-FA8F-7954-0352-7DB63D7E18BC}"/>
-              </a:ext>
-            </a:extLst>
-          </p:cNvPr>
-          <p:cNvGrpSpPr/>
-          <p:nvPr/>
-        </p:nvGrpSpPr>
-        <p:grpSpPr>
-          <a:xfrm>
-            <a:off x="934179" y="6117354"/>
-            <a:ext cx="331190" cy="98617"/>
-            <a:chOff x="961765" y="6117353"/>
-            <a:chExt cx="331190" cy="98617"/>
-          </a:xfrm>
-        </p:grpSpPr>
-        <p:sp>
-          <p:nvSpPr>
-            <p:cNvPr id="49" name="TextBox 48">
-              <a:extLst>
-                <a:ext uri="{FF2B5EF4-FFF2-40B4-BE49-F238E27FC236}">
-                  <a16:creationId xmlns:a16="http://schemas.microsoft.com/office/drawing/2014/main" id="{ED1B98BE-5862-78A7-A16D-D55979BD2588}"/>
-                </a:ext>
-              </a:extLst>
-            </p:cNvPr>
-            <p:cNvSpPr txBox="1"/>
-            <p:nvPr/>
-          </p:nvSpPr>
-          <p:spPr>
-            <a:xfrm>
-              <a:off x="1086167" y="6117353"/>
-              <a:ext cx="206788" cy="98617"/>
-            </a:xfrm>
-            <a:prstGeom prst="rect">
-              <a:avLst/>
-            </a:prstGeom>
-            <a:noFill/>
-          </p:spPr>
-          <p:txBody>
-            <a:bodyPr wrap="none" lIns="0" tIns="0" rIns="0" bIns="0" rtlCol="0" anchor="t">
-              <a:spAutoFit/>
-            </a:bodyPr>
-            <a:lstStyle/>
-            <a:p>
-              <a:pPr algn="l">
-                <a:lnSpc>
-                  <a:spcPct val="113000"/>
-                </a:lnSpc>
-              </a:pPr>
-              <a:r>
-                <a:rPr lang="en-US" sz="600" dirty="0">
-                  <a:solidFill>
-                    <a:schemeClr val="tx2"/>
-                  </a:solidFill>
-                </a:rPr>
-                <a:t>2 stars</a:t>
-              </a:r>
-            </a:p>
-          </p:txBody>
-        </p:sp>
-        <p:sp>
-          <p:nvSpPr>
-            <p:cNvPr id="50" name="Rounded Rectangle 49">
-              <a:extLst>
-                <a:ext uri="{FF2B5EF4-FFF2-40B4-BE49-F238E27FC236}">
-                  <a16:creationId xmlns:a16="http://schemas.microsoft.com/office/drawing/2014/main" id="{A1E198CB-8705-DB0E-00C5-75FAFBB56603}"/>
-                </a:ext>
-              </a:extLst>
-            </p:cNvPr>
-            <p:cNvSpPr>
-              <a:spLocks noChangeAspect="1"/>
-            </p:cNvSpPr>
-            <p:nvPr/>
-          </p:nvSpPr>
-          <p:spPr>
-            <a:xfrm>
-              <a:off x="961765" y="6120942"/>
-              <a:ext cx="89812" cy="91440"/>
-            </a:xfrm>
-            <a:prstGeom prst="roundRect">
-              <a:avLst/>
-            </a:prstGeom>
-            <a:solidFill>
-              <a:srgbClr val="EF9819"/>
-            </a:solidFill>
-            <a:ln>
-              <a:noFill/>
-            </a:ln>
-          </p:spPr>
-          <p:style>
-            <a:lnRef idx="2">
-              <a:schemeClr val="accent1">
-                <a:shade val="50000"/>
-              </a:schemeClr>
-            </a:lnRef>
-            <a:fillRef idx="1">
-              <a:schemeClr val="accent1"/>
-            </a:fillRef>
-            <a:effectRef idx="0">
-              <a:schemeClr val="accent1"/>
-            </a:effectRef>
-            <a:fontRef idx="minor">
-              <a:schemeClr val="lt1"/>
-            </a:fontRef>
-          </p:style>
-          <p:txBody>
-            <a:bodyPr lIns="108000" tIns="72000" rIns="108000" bIns="72000" rtlCol="0" anchor="ctr"/>
-            <a:lstStyle/>
-            <a:p>
-              <a:pPr algn="ctr"/>
-              <a:endParaRPr lang="en-US" sz="1600" dirty="0" err="1">
-                <a:solidFill>
-                  <a:schemeClr val="bg1"/>
-                </a:solidFill>
-              </a:endParaRPr>
-            </a:p>
-          </p:txBody>
-        </p:sp>
-      </p:grpSp>
-      <p:grpSp>
-        <p:nvGrpSpPr>
-          <p:cNvPr id="51" name="Group 50">
-            <a:extLst>
-              <a:ext uri="{FF2B5EF4-FFF2-40B4-BE49-F238E27FC236}">
-                <a16:creationId xmlns:a16="http://schemas.microsoft.com/office/drawing/2014/main" id="{626224BD-BED3-FBA2-19F0-308173CC3B5A}"/>
-              </a:ext>
-            </a:extLst>
-          </p:cNvPr>
-          <p:cNvGrpSpPr/>
-          <p:nvPr/>
-        </p:nvGrpSpPr>
-        <p:grpSpPr>
-          <a:xfrm>
-            <a:off x="1382015" y="6117354"/>
-            <a:ext cx="331190" cy="98617"/>
-            <a:chOff x="1114165" y="6269753"/>
-            <a:chExt cx="331190" cy="98617"/>
-          </a:xfrm>
-        </p:grpSpPr>
-        <p:sp>
-          <p:nvSpPr>
-            <p:cNvPr id="52" name="TextBox 51">
-              <a:extLst>
-                <a:ext uri="{FF2B5EF4-FFF2-40B4-BE49-F238E27FC236}">
-                  <a16:creationId xmlns:a16="http://schemas.microsoft.com/office/drawing/2014/main" id="{13437346-ADF3-3560-E351-127363E48C68}"/>
-                </a:ext>
-              </a:extLst>
-            </p:cNvPr>
-            <p:cNvSpPr txBox="1"/>
-            <p:nvPr/>
-          </p:nvSpPr>
-          <p:spPr>
-            <a:xfrm>
-              <a:off x="1238567" y="6269753"/>
-              <a:ext cx="206788" cy="98617"/>
-            </a:xfrm>
-            <a:prstGeom prst="rect">
-              <a:avLst/>
-            </a:prstGeom>
-            <a:noFill/>
-          </p:spPr>
-          <p:txBody>
-            <a:bodyPr wrap="none" lIns="0" tIns="0" rIns="0" bIns="0" rtlCol="0" anchor="t">
-              <a:spAutoFit/>
-            </a:bodyPr>
-            <a:lstStyle/>
-            <a:p>
-              <a:pPr algn="l">
-                <a:lnSpc>
-                  <a:spcPct val="113000"/>
-                </a:lnSpc>
-              </a:pPr>
-              <a:r>
-                <a:rPr lang="en-US" sz="600" dirty="0">
-                  <a:solidFill>
-                    <a:schemeClr val="tx2"/>
-                  </a:solidFill>
-                </a:rPr>
-                <a:t>3 stars</a:t>
-              </a:r>
-            </a:p>
-          </p:txBody>
-        </p:sp>
-        <p:sp>
-          <p:nvSpPr>
-            <p:cNvPr id="53" name="Rounded Rectangle 52">
-              <a:extLst>
-                <a:ext uri="{FF2B5EF4-FFF2-40B4-BE49-F238E27FC236}">
-                  <a16:creationId xmlns:a16="http://schemas.microsoft.com/office/drawing/2014/main" id="{38EE49E1-F720-7778-8EDA-F38779E75A68}"/>
-                </a:ext>
-              </a:extLst>
-            </p:cNvPr>
-            <p:cNvSpPr>
-              <a:spLocks noChangeAspect="1"/>
-            </p:cNvSpPr>
-            <p:nvPr/>
-          </p:nvSpPr>
-          <p:spPr>
-            <a:xfrm>
-              <a:off x="1114165" y="6273342"/>
-              <a:ext cx="89812" cy="91440"/>
-            </a:xfrm>
-            <a:prstGeom prst="roundRect">
-              <a:avLst/>
-            </a:prstGeom>
-            <a:solidFill>
-              <a:srgbClr val="F9C640"/>
-            </a:solidFill>
-            <a:ln>
-              <a:noFill/>
-            </a:ln>
-          </p:spPr>
-          <p:style>
-            <a:lnRef idx="2">
-              <a:schemeClr val="accent1">
-                <a:shade val="50000"/>
-              </a:schemeClr>
-            </a:lnRef>
-            <a:fillRef idx="1">
-              <a:schemeClr val="accent1"/>
-            </a:fillRef>
-            <a:effectRef idx="0">
-              <a:schemeClr val="accent1"/>
-            </a:effectRef>
-            <a:fontRef idx="minor">
-              <a:schemeClr val="lt1"/>
-            </a:fontRef>
-          </p:style>
-          <p:txBody>
-            <a:bodyPr lIns="108000" tIns="72000" rIns="108000" bIns="72000" rtlCol="0" anchor="ctr"/>
-            <a:lstStyle/>
-            <a:p>
-              <a:pPr algn="ctr"/>
-              <a:endParaRPr lang="en-US" sz="1600" dirty="0" err="1">
-                <a:solidFill>
-                  <a:schemeClr val="bg1"/>
-                </a:solidFill>
-              </a:endParaRPr>
-            </a:p>
-          </p:txBody>
-        </p:sp>
-      </p:grpSp>
-      <p:grpSp>
-        <p:nvGrpSpPr>
-          <p:cNvPr id="54" name="Group 53">
-            <a:extLst>
-              <a:ext uri="{FF2B5EF4-FFF2-40B4-BE49-F238E27FC236}">
-                <a16:creationId xmlns:a16="http://schemas.microsoft.com/office/drawing/2014/main" id="{FE48961E-8009-1070-84DE-443A8CDBC52E}"/>
-              </a:ext>
-            </a:extLst>
-          </p:cNvPr>
-          <p:cNvGrpSpPr/>
-          <p:nvPr/>
-        </p:nvGrpSpPr>
-        <p:grpSpPr>
-          <a:xfrm>
-            <a:off x="1829851" y="6117354"/>
-            <a:ext cx="331190" cy="98617"/>
-            <a:chOff x="1114165" y="6269753"/>
-            <a:chExt cx="331190" cy="98617"/>
-          </a:xfrm>
-        </p:grpSpPr>
-        <p:sp>
-          <p:nvSpPr>
-            <p:cNvPr id="55" name="TextBox 54">
-              <a:extLst>
-                <a:ext uri="{FF2B5EF4-FFF2-40B4-BE49-F238E27FC236}">
-                  <a16:creationId xmlns:a16="http://schemas.microsoft.com/office/drawing/2014/main" id="{E195E0A5-EB16-76D8-58F0-395F49F97362}"/>
-                </a:ext>
-              </a:extLst>
-            </p:cNvPr>
-            <p:cNvSpPr txBox="1"/>
-            <p:nvPr/>
-          </p:nvSpPr>
-          <p:spPr>
-            <a:xfrm>
-              <a:off x="1238567" y="6269753"/>
-              <a:ext cx="206788" cy="98617"/>
-            </a:xfrm>
-            <a:prstGeom prst="rect">
-              <a:avLst/>
-            </a:prstGeom>
-            <a:noFill/>
-          </p:spPr>
-          <p:txBody>
-            <a:bodyPr wrap="none" lIns="0" tIns="0" rIns="0" bIns="0" rtlCol="0" anchor="t">
-              <a:spAutoFit/>
-            </a:bodyPr>
-            <a:lstStyle/>
-            <a:p>
-              <a:pPr algn="l">
-                <a:lnSpc>
-                  <a:spcPct val="113000"/>
-                </a:lnSpc>
-              </a:pPr>
-              <a:r>
-                <a:rPr lang="en-US" sz="600" dirty="0">
-                  <a:solidFill>
-                    <a:schemeClr val="tx2"/>
-                  </a:solidFill>
-                </a:rPr>
-                <a:t>4 stars</a:t>
-              </a:r>
-            </a:p>
-          </p:txBody>
-        </p:sp>
-        <p:sp>
-          <p:nvSpPr>
-            <p:cNvPr id="56" name="Rounded Rectangle 55">
-              <a:extLst>
-                <a:ext uri="{FF2B5EF4-FFF2-40B4-BE49-F238E27FC236}">
-                  <a16:creationId xmlns:a16="http://schemas.microsoft.com/office/drawing/2014/main" id="{B4EE619C-EEB7-4D93-A61C-01220CA0BCCF}"/>
-                </a:ext>
-              </a:extLst>
-            </p:cNvPr>
-            <p:cNvSpPr>
-              <a:spLocks noChangeAspect="1"/>
-            </p:cNvSpPr>
-            <p:nvPr/>
-          </p:nvSpPr>
-          <p:spPr>
-            <a:xfrm>
-              <a:off x="1114165" y="6273342"/>
-              <a:ext cx="89812" cy="91440"/>
-            </a:xfrm>
-            <a:prstGeom prst="roundRect">
-              <a:avLst/>
-            </a:prstGeom>
-            <a:solidFill>
-              <a:srgbClr val="57C968"/>
-            </a:solidFill>
-            <a:ln>
-              <a:noFill/>
-            </a:ln>
-          </p:spPr>
-          <p:style>
-            <a:lnRef idx="2">
-              <a:schemeClr val="accent1">
-                <a:shade val="50000"/>
-              </a:schemeClr>
-            </a:lnRef>
-            <a:fillRef idx="1">
-              <a:schemeClr val="accent1"/>
-            </a:fillRef>
-            <a:effectRef idx="0">
-              <a:schemeClr val="accent1"/>
-            </a:effectRef>
-            <a:fontRef idx="minor">
-              <a:schemeClr val="lt1"/>
-            </a:fontRef>
-          </p:style>
-          <p:txBody>
-            <a:bodyPr lIns="108000" tIns="72000" rIns="108000" bIns="72000" rtlCol="0" anchor="ctr"/>
-            <a:lstStyle/>
-            <a:p>
-              <a:pPr algn="ctr"/>
-              <a:endParaRPr lang="en-US" sz="1600" dirty="0" err="1">
-                <a:solidFill>
-                  <a:schemeClr val="bg1"/>
-                </a:solidFill>
-              </a:endParaRPr>
-            </a:p>
-          </p:txBody>
-        </p:sp>
-      </p:grpSp>
-      <p:grpSp>
-        <p:nvGrpSpPr>
-          <p:cNvPr id="57" name="Group 56">
-            <a:extLst>
-              <a:ext uri="{FF2B5EF4-FFF2-40B4-BE49-F238E27FC236}">
-                <a16:creationId xmlns:a16="http://schemas.microsoft.com/office/drawing/2014/main" id="{2EDC7945-DD39-8058-EF47-510ECD5A65A7}"/>
-              </a:ext>
-            </a:extLst>
-          </p:cNvPr>
-          <p:cNvGrpSpPr/>
-          <p:nvPr/>
-        </p:nvGrpSpPr>
-        <p:grpSpPr>
-          <a:xfrm>
-            <a:off x="2277686" y="6117354"/>
-            <a:ext cx="331190" cy="98617"/>
-            <a:chOff x="1114165" y="6269753"/>
-            <a:chExt cx="331190" cy="98617"/>
-          </a:xfrm>
-        </p:grpSpPr>
-        <p:sp>
-          <p:nvSpPr>
-            <p:cNvPr id="58" name="TextBox 57">
-              <a:extLst>
-                <a:ext uri="{FF2B5EF4-FFF2-40B4-BE49-F238E27FC236}">
-                  <a16:creationId xmlns:a16="http://schemas.microsoft.com/office/drawing/2014/main" id="{8A8B6428-BA2B-C93F-5A6C-95AA61670EDE}"/>
-                </a:ext>
-              </a:extLst>
-            </p:cNvPr>
-            <p:cNvSpPr txBox="1"/>
-            <p:nvPr/>
-          </p:nvSpPr>
-          <p:spPr>
-            <a:xfrm>
-              <a:off x="1238567" y="6269753"/>
-              <a:ext cx="206788" cy="98617"/>
-            </a:xfrm>
-            <a:prstGeom prst="rect">
-              <a:avLst/>
-            </a:prstGeom>
-            <a:noFill/>
-          </p:spPr>
-          <p:txBody>
-            <a:bodyPr wrap="none" lIns="0" tIns="0" rIns="0" bIns="0" rtlCol="0" anchor="t">
-              <a:spAutoFit/>
-            </a:bodyPr>
-            <a:lstStyle/>
-            <a:p>
-              <a:pPr algn="l">
-                <a:lnSpc>
-                  <a:spcPct val="113000"/>
-                </a:lnSpc>
-              </a:pPr>
-              <a:r>
-                <a:rPr lang="en-US" sz="600" dirty="0">
-                  <a:solidFill>
-                    <a:schemeClr val="tx2"/>
-                  </a:solidFill>
-                </a:rPr>
-                <a:t>5 stars</a:t>
-              </a:r>
-            </a:p>
-          </p:txBody>
-        </p:sp>
-        <p:sp>
-          <p:nvSpPr>
-            <p:cNvPr id="59" name="Rounded Rectangle 58">
-              <a:extLst>
-                <a:ext uri="{FF2B5EF4-FFF2-40B4-BE49-F238E27FC236}">
-                  <a16:creationId xmlns:a16="http://schemas.microsoft.com/office/drawing/2014/main" id="{B09C3AA7-472A-A3DA-5CEC-409BF10772C5}"/>
-                </a:ext>
-              </a:extLst>
-            </p:cNvPr>
-            <p:cNvSpPr>
-              <a:spLocks noChangeAspect="1"/>
-            </p:cNvSpPr>
-            <p:nvPr/>
-          </p:nvSpPr>
-          <p:spPr>
-            <a:xfrm>
-              <a:off x="1114165" y="6273342"/>
-              <a:ext cx="89812" cy="91440"/>
-            </a:xfrm>
-            <a:prstGeom prst="roundRect">
-              <a:avLst/>
-            </a:prstGeom>
-            <a:solidFill>
-              <a:srgbClr val="2C963F"/>
-            </a:solidFill>
-            <a:ln>
-              <a:noFill/>
-            </a:ln>
-          </p:spPr>
-          <p:style>
-            <a:lnRef idx="2">
-              <a:schemeClr val="accent1">
-                <a:shade val="50000"/>
-              </a:schemeClr>
-            </a:lnRef>
-            <a:fillRef idx="1">
-              <a:schemeClr val="accent1"/>
-            </a:fillRef>
-            <a:effectRef idx="0">
-              <a:schemeClr val="accent1"/>
-            </a:effectRef>
-            <a:fontRef idx="minor">
-              <a:schemeClr val="lt1"/>
-            </a:fontRef>
-          </p:style>
-          <p:txBody>
-            <a:bodyPr lIns="108000" tIns="72000" rIns="108000" bIns="72000" rtlCol="0" anchor="ctr"/>
-            <a:lstStyle/>
-            <a:p>
-              <a:pPr algn="ctr"/>
-              <a:endParaRPr lang="en-US" sz="1600" dirty="0" err="1">
-                <a:solidFill>
-                  <a:schemeClr val="bg1"/>
-                </a:solidFill>
-              </a:endParaRPr>
-            </a:p>
-          </p:txBody>
-        </p:sp>
-      </p:grpSp>
-    </p:spTree>
-    <p:extLst>
-      <p:ext uri="{BB962C8B-B14F-4D97-AF65-F5344CB8AC3E}">
-        <p14:creationId xmlns:p14="http://schemas.microsoft.com/office/powerpoint/2010/main" val="3150479009"/>
-      </p:ext>
-    </p:extLst>
-  </p:cSld>
-  <p:clrMapOvr>
-    <a:masterClrMapping/>
-  </p:clrMapOvr>
-</p:sld>
-</file>
-
-<file path=ppt/slides/slide5.xml><?xml version="1.0" encoding="utf-8"?>
 <p:sld xmlns:a="http://schemas.openxmlformats.org/drawingml/2006/main" xmlns:r="http://schemas.openxmlformats.org/officeDocument/2006/relationships" xmlns:p="http://schemas.openxmlformats.org/presentationml/2006/main">
   <p:cSld>
     <p:spTree>

</xml_diff>

<commit_message>
Adding Architecture Quality ratings
</commit_message>
<xml_diff>
--- a/src/report_generator/presets/templates/sigrid-template.pptx
+++ b/src/report_generator/presets/templates/sigrid-template.pptx
@@ -5,10 +5,10 @@
     <p:sldMasterId id="2147483648" r:id="rId4"/>
   </p:sldMasterIdLst>
   <p:notesMasterIdLst>
-    <p:notesMasterId r:id="rId21"/>
+    <p:notesMasterId r:id="rId22"/>
   </p:notesMasterIdLst>
   <p:handoutMasterIdLst>
-    <p:handoutMasterId r:id="rId22"/>
+    <p:handoutMasterId r:id="rId23"/>
   </p:handoutMasterIdLst>
   <p:sldIdLst>
     <p:sldId id="561" r:id="rId5"/>
@@ -24,9 +24,10 @@
     <p:sldId id="601" r:id="rId15"/>
     <p:sldId id="10725" r:id="rId16"/>
     <p:sldId id="10721" r:id="rId17"/>
-    <p:sldId id="10726" r:id="rId18"/>
-    <p:sldId id="10723" r:id="rId19"/>
-    <p:sldId id="597" r:id="rId20"/>
+    <p:sldId id="10727" r:id="rId18"/>
+    <p:sldId id="10726" r:id="rId19"/>
+    <p:sldId id="10723" r:id="rId20"/>
+    <p:sldId id="597" r:id="rId21"/>
   </p:sldIdLst>
   <p:sldSz cx="12192000" cy="6858000"/>
   <p:notesSz cx="6858000" cy="9144000"/>
@@ -226,7 +227,7 @@
                 </a:outerShdw>
               </a:effectLst>
             </c:spPr>
-            <c:extLst xmlns:lc="http://schemas.openxmlformats.org/drawingml/2006/lockedCanvas" xmlns:comp="http://schemas.openxmlformats.org/drawingml/2006/compatibility" xmlns:we="http://schemas.microsoft.com/office/webextensions/webextension/2010/11" xmlns:wetp="http://schemas.microsoft.com/office/webextensions/taskpanes/2010/11" xmlns:w16cid="http://schemas.microsoft.com/office/word/2016/wordml/cid" xmlns:w16se="http://schemas.microsoft.com/office/word/2015/wordml/symex" xmlns:wps="http://schemas.microsoft.com/office/word/2010/wordprocessingShape" xmlns:b="http://schemas.openxmlformats.org/officeDocument/2006/bibliography" xmlns:odgm="http://opendope.org/SmartArt/DataHierarchy" xmlns:odi="http://opendope.org/components" xmlns:oda="http://opendope.org/answers" xmlns:odq="http://opendope.org/questions" xmlns:odc="http://opendope.org/conditions" xmlns:odx="http://opendope.org/xpaths" xmlns:cppr="http://schemas.microsoft.com/office/2006/coverPageProps" xmlns:pvml="urn:schemas-microsoft-com:office:powerpoint" xmlns:w10="urn:schemas-microsoft-com:office:word" xmlns:v="urn:schemas-microsoft-com:vml" xmlns:o="urn:schemas-microsoft-com:office:office" xmlns:xvml="urn:schemas-microsoft-com:office:excel" xmlns:dsp="http://schemas.microsoft.com/office/drawing/2008/diagram" xmlns:xdr="http://schemas.openxmlformats.org/drawingml/2006/spreadsheetDrawing" xmlns:pic="http://schemas.openxmlformats.org/drawingml/2006/picture" xmlns:dgm="http://schemas.openxmlformats.org/drawingml/2006/diagram" xmlns:c14="http://schemas.microsoft.com/office/drawing/2007/8/2/chart" xmlns:cdr="http://schemas.openxmlformats.org/drawingml/2006/chartDrawing" xmlns:wne="http://schemas.microsoft.com/office/word/2006/wordml" xmlns:sl="http://schemas.openxmlformats.org/schemaLibrary/2006/main" xmlns:mc="http://schemas.openxmlformats.org/markup-compatibility/2006" xmlns:wp14="http://schemas.microsoft.com/office/word/2010/wordprocessingDrawing" xmlns:wp="http://schemas.openxmlformats.org/drawingml/2006/wordprocessingDrawing" xmlns:m="http://schemas.openxmlformats.org/officeDocument/2006/math" xmlns:w14="http://schemas.microsoft.com/office/word/2010/wordml" xmlns:w15="http://schemas.microsoft.com/office/word/2012/wordml" xmlns:w="http://schemas.openxmlformats.org/wordprocessingml/2006/main">
+            <c:extLst xmlns:w="http://schemas.openxmlformats.org/wordprocessingml/2006/main" xmlns:w15="http://schemas.microsoft.com/office/word/2012/wordml" xmlns:w14="http://schemas.microsoft.com/office/word/2010/wordml" xmlns:m="http://schemas.openxmlformats.org/officeDocument/2006/math" xmlns:wp="http://schemas.openxmlformats.org/drawingml/2006/wordprocessingDrawing" xmlns:wp14="http://schemas.microsoft.com/office/word/2010/wordprocessingDrawing" xmlns:mc="http://schemas.openxmlformats.org/markup-compatibility/2006" xmlns:sl="http://schemas.openxmlformats.org/schemaLibrary/2006/main" xmlns:wne="http://schemas.microsoft.com/office/word/2006/wordml" xmlns:cdr="http://schemas.openxmlformats.org/drawingml/2006/chartDrawing" xmlns:c14="http://schemas.microsoft.com/office/drawing/2007/8/2/chart" xmlns:dgm="http://schemas.openxmlformats.org/drawingml/2006/diagram" xmlns:pic="http://schemas.openxmlformats.org/drawingml/2006/picture" xmlns:xdr="http://schemas.openxmlformats.org/drawingml/2006/spreadsheetDrawing" xmlns:dsp="http://schemas.microsoft.com/office/drawing/2008/diagram" xmlns:xvml="urn:schemas-microsoft-com:office:excel" xmlns:o="urn:schemas-microsoft-com:office:office" xmlns:v="urn:schemas-microsoft-com:vml" xmlns:w10="urn:schemas-microsoft-com:office:word" xmlns:pvml="urn:schemas-microsoft-com:office:powerpoint" xmlns:cppr="http://schemas.microsoft.com/office/2006/coverPageProps" xmlns:odx="http://opendope.org/xpaths" xmlns:odc="http://opendope.org/conditions" xmlns:odq="http://opendope.org/questions" xmlns:oda="http://opendope.org/answers" xmlns:odi="http://opendope.org/components" xmlns:odgm="http://opendope.org/SmartArt/DataHierarchy" xmlns:b="http://schemas.openxmlformats.org/officeDocument/2006/bibliography" xmlns:wps="http://schemas.microsoft.com/office/word/2010/wordprocessingShape" xmlns:w16se="http://schemas.microsoft.com/office/word/2015/wordml/symex" xmlns:w16cid="http://schemas.microsoft.com/office/word/2016/wordml/cid" xmlns:wetp="http://schemas.microsoft.com/office/webextensions/taskpanes/2010/11" xmlns:we="http://schemas.microsoft.com/office/webextensions/webextension/2010/11" xmlns:comp="http://schemas.openxmlformats.org/drawingml/2006/compatibility" xmlns:lc="http://schemas.openxmlformats.org/drawingml/2006/lockedCanvas">
               <c:ext xmlns:c16="http://schemas.microsoft.com/office/drawing/2014/chart" uri="{C3380CC4-5D6E-409C-BE32-E72D297353CC}">
                 <c16:uniqueId val="{00000001-6147-E74A-AA7B-5531F0E4EE0C}"/>
               </c:ext>
@@ -255,7 +256,7 @@
               </c:numCache>
             </c:numRef>
           </c:val>
-          <c:extLst xmlns:lc="http://schemas.openxmlformats.org/drawingml/2006/lockedCanvas" xmlns:comp="http://schemas.openxmlformats.org/drawingml/2006/compatibility" xmlns:we="http://schemas.microsoft.com/office/webextensions/webextension/2010/11" xmlns:wetp="http://schemas.microsoft.com/office/webextensions/taskpanes/2010/11" xmlns:w16cid="http://schemas.microsoft.com/office/word/2016/wordml/cid" xmlns:w16se="http://schemas.microsoft.com/office/word/2015/wordml/symex" xmlns:wps="http://schemas.microsoft.com/office/word/2010/wordprocessingShape" xmlns:b="http://schemas.openxmlformats.org/officeDocument/2006/bibliography" xmlns:odgm="http://opendope.org/SmartArt/DataHierarchy" xmlns:odi="http://opendope.org/components" xmlns:oda="http://opendope.org/answers" xmlns:odq="http://opendope.org/questions" xmlns:odc="http://opendope.org/conditions" xmlns:odx="http://opendope.org/xpaths" xmlns:cppr="http://schemas.microsoft.com/office/2006/coverPageProps" xmlns:pvml="urn:schemas-microsoft-com:office:powerpoint" xmlns:w10="urn:schemas-microsoft-com:office:word" xmlns:v="urn:schemas-microsoft-com:vml" xmlns:o="urn:schemas-microsoft-com:office:office" xmlns:xvml="urn:schemas-microsoft-com:office:excel" xmlns:dsp="http://schemas.microsoft.com/office/drawing/2008/diagram" xmlns:xdr="http://schemas.openxmlformats.org/drawingml/2006/spreadsheetDrawing" xmlns:pic="http://schemas.openxmlformats.org/drawingml/2006/picture" xmlns:dgm="http://schemas.openxmlformats.org/drawingml/2006/diagram" xmlns:c14="http://schemas.microsoft.com/office/drawing/2007/8/2/chart" xmlns:cdr="http://schemas.openxmlformats.org/drawingml/2006/chartDrawing" xmlns:wne="http://schemas.microsoft.com/office/word/2006/wordml" xmlns:sl="http://schemas.openxmlformats.org/schemaLibrary/2006/main" xmlns:mc="http://schemas.openxmlformats.org/markup-compatibility/2006" xmlns:wp14="http://schemas.microsoft.com/office/word/2010/wordprocessingDrawing" xmlns:wp="http://schemas.openxmlformats.org/drawingml/2006/wordprocessingDrawing" xmlns:m="http://schemas.openxmlformats.org/officeDocument/2006/math" xmlns:w14="http://schemas.microsoft.com/office/word/2010/wordml" xmlns:w15="http://schemas.microsoft.com/office/word/2012/wordml" xmlns:w="http://schemas.openxmlformats.org/wordprocessingml/2006/main">
+          <c:extLst xmlns:w="http://schemas.openxmlformats.org/wordprocessingml/2006/main" xmlns:w15="http://schemas.microsoft.com/office/word/2012/wordml" xmlns:w14="http://schemas.microsoft.com/office/word/2010/wordml" xmlns:m="http://schemas.openxmlformats.org/officeDocument/2006/math" xmlns:wp="http://schemas.openxmlformats.org/drawingml/2006/wordprocessingDrawing" xmlns:wp14="http://schemas.microsoft.com/office/word/2010/wordprocessingDrawing" xmlns:mc="http://schemas.openxmlformats.org/markup-compatibility/2006" xmlns:sl="http://schemas.openxmlformats.org/schemaLibrary/2006/main" xmlns:wne="http://schemas.microsoft.com/office/word/2006/wordml" xmlns:cdr="http://schemas.openxmlformats.org/drawingml/2006/chartDrawing" xmlns:c14="http://schemas.microsoft.com/office/drawing/2007/8/2/chart" xmlns:dgm="http://schemas.openxmlformats.org/drawingml/2006/diagram" xmlns:pic="http://schemas.openxmlformats.org/drawingml/2006/picture" xmlns:xdr="http://schemas.openxmlformats.org/drawingml/2006/spreadsheetDrawing" xmlns:dsp="http://schemas.microsoft.com/office/drawing/2008/diagram" xmlns:xvml="urn:schemas-microsoft-com:office:excel" xmlns:o="urn:schemas-microsoft-com:office:office" xmlns:v="urn:schemas-microsoft-com:vml" xmlns:w10="urn:schemas-microsoft-com:office:word" xmlns:pvml="urn:schemas-microsoft-com:office:powerpoint" xmlns:cppr="http://schemas.microsoft.com/office/2006/coverPageProps" xmlns:odx="http://opendope.org/xpaths" xmlns:odc="http://opendope.org/conditions" xmlns:odq="http://opendope.org/questions" xmlns:oda="http://opendope.org/answers" xmlns:odi="http://opendope.org/components" xmlns:odgm="http://opendope.org/SmartArt/DataHierarchy" xmlns:b="http://schemas.openxmlformats.org/officeDocument/2006/bibliography" xmlns:wps="http://schemas.microsoft.com/office/word/2010/wordprocessingShape" xmlns:w16se="http://schemas.microsoft.com/office/word/2015/wordml/symex" xmlns:w16cid="http://schemas.microsoft.com/office/word/2016/wordml/cid" xmlns:wetp="http://schemas.microsoft.com/office/webextensions/taskpanes/2010/11" xmlns:we="http://schemas.microsoft.com/office/webextensions/webextension/2010/11" xmlns:comp="http://schemas.openxmlformats.org/drawingml/2006/compatibility" xmlns:lc="http://schemas.openxmlformats.org/drawingml/2006/lockedCanvas">
             <c:ext xmlns:c16="http://schemas.microsoft.com/office/drawing/2014/chart" uri="{C3380CC4-5D6E-409C-BE32-E72D297353CC}">
               <c16:uniqueId val="{00000002-6147-E74A-AA7B-5531F0E4EE0C}"/>
             </c:ext>
@@ -571,7 +572,7 @@
     </c:plotArea>
     <c:plotVisOnly val="1"/>
     <c:dispBlanksAs val="gap"/>
-    <c:extLst xmlns:lc="http://schemas.openxmlformats.org/drawingml/2006/lockedCanvas" xmlns:comp="http://schemas.openxmlformats.org/drawingml/2006/compatibility" xmlns:we="http://schemas.microsoft.com/office/webextensions/webextension/2010/11" xmlns:wetp="http://schemas.microsoft.com/office/webextensions/taskpanes/2010/11" xmlns:w16cid="http://schemas.microsoft.com/office/word/2016/wordml/cid" xmlns:w16se="http://schemas.microsoft.com/office/word/2015/wordml/symex" xmlns:wps="http://schemas.microsoft.com/office/word/2010/wordprocessingShape" xmlns:b="http://schemas.openxmlformats.org/officeDocument/2006/bibliography" xmlns:odgm="http://opendope.org/SmartArt/DataHierarchy" xmlns:odi="http://opendope.org/components" xmlns:oda="http://opendope.org/answers" xmlns:odq="http://opendope.org/questions" xmlns:odc="http://opendope.org/conditions" xmlns:odx="http://opendope.org/xpaths" xmlns:cppr="http://schemas.microsoft.com/office/2006/coverPageProps" xmlns:pvml="urn:schemas-microsoft-com:office:powerpoint" xmlns:w10="urn:schemas-microsoft-com:office:word" xmlns:v="urn:schemas-microsoft-com:vml" xmlns:o="urn:schemas-microsoft-com:office:office" xmlns:xvml="urn:schemas-microsoft-com:office:excel" xmlns:dsp="http://schemas.microsoft.com/office/drawing/2008/diagram" xmlns:xdr="http://schemas.openxmlformats.org/drawingml/2006/spreadsheetDrawing" xmlns:pic="http://schemas.openxmlformats.org/drawingml/2006/picture" xmlns:dgm="http://schemas.openxmlformats.org/drawingml/2006/diagram" xmlns:c14="http://schemas.microsoft.com/office/drawing/2007/8/2/chart" xmlns:cdr="http://schemas.openxmlformats.org/drawingml/2006/chartDrawing" xmlns:wne="http://schemas.microsoft.com/office/word/2006/wordml" xmlns:sl="http://schemas.openxmlformats.org/schemaLibrary/2006/main" xmlns:mc="http://schemas.openxmlformats.org/markup-compatibility/2006" xmlns:wp14="http://schemas.microsoft.com/office/word/2010/wordprocessingDrawing" xmlns:wp="http://schemas.openxmlformats.org/drawingml/2006/wordprocessingDrawing" xmlns:m="http://schemas.openxmlformats.org/officeDocument/2006/math" xmlns:w14="http://schemas.microsoft.com/office/word/2010/wordml" xmlns:w15="http://schemas.microsoft.com/office/word/2012/wordml" xmlns:w="http://schemas.openxmlformats.org/wordprocessingml/2006/main">
+    <c:extLst xmlns:w="http://schemas.openxmlformats.org/wordprocessingml/2006/main" xmlns:w15="http://schemas.microsoft.com/office/word/2012/wordml" xmlns:w14="http://schemas.microsoft.com/office/word/2010/wordml" xmlns:m="http://schemas.openxmlformats.org/officeDocument/2006/math" xmlns:wp="http://schemas.openxmlformats.org/drawingml/2006/wordprocessingDrawing" xmlns:wp14="http://schemas.microsoft.com/office/word/2010/wordprocessingDrawing" xmlns:mc="http://schemas.openxmlformats.org/markup-compatibility/2006" xmlns:sl="http://schemas.openxmlformats.org/schemaLibrary/2006/main" xmlns:wne="http://schemas.microsoft.com/office/word/2006/wordml" xmlns:cdr="http://schemas.openxmlformats.org/drawingml/2006/chartDrawing" xmlns:c14="http://schemas.microsoft.com/office/drawing/2007/8/2/chart" xmlns:dgm="http://schemas.openxmlformats.org/drawingml/2006/diagram" xmlns:pic="http://schemas.openxmlformats.org/drawingml/2006/picture" xmlns:xdr="http://schemas.openxmlformats.org/drawingml/2006/spreadsheetDrawing" xmlns:dsp="http://schemas.microsoft.com/office/drawing/2008/diagram" xmlns:xvml="urn:schemas-microsoft-com:office:excel" xmlns:o="urn:schemas-microsoft-com:office:office" xmlns:v="urn:schemas-microsoft-com:vml" xmlns:w10="urn:schemas-microsoft-com:office:word" xmlns:pvml="urn:schemas-microsoft-com:office:powerpoint" xmlns:cppr="http://schemas.microsoft.com/office/2006/coverPageProps" xmlns:odx="http://opendope.org/xpaths" xmlns:odc="http://opendope.org/conditions" xmlns:odq="http://opendope.org/questions" xmlns:oda="http://opendope.org/answers" xmlns:odi="http://opendope.org/components" xmlns:odgm="http://opendope.org/SmartArt/DataHierarchy" xmlns:b="http://schemas.openxmlformats.org/officeDocument/2006/bibliography" xmlns:wps="http://schemas.microsoft.com/office/word/2010/wordprocessingShape" xmlns:w16se="http://schemas.microsoft.com/office/word/2015/wordml/symex" xmlns:w16cid="http://schemas.microsoft.com/office/word/2016/wordml/cid" xmlns:wetp="http://schemas.microsoft.com/office/webextensions/taskpanes/2010/11" xmlns:we="http://schemas.microsoft.com/office/webextensions/webextension/2010/11" xmlns:comp="http://schemas.openxmlformats.org/drawingml/2006/compatibility" xmlns:lc="http://schemas.openxmlformats.org/drawingml/2006/lockedCanvas">
       <c:ext xmlns:c16r3="http://schemas.microsoft.com/office/drawing/2017/03/chart" uri="{56B9EC1D-385E-4148-901F-78D8002777C0}">
         <c16r3:dataDisplayOptions16>
           <c16r3:dispNaAsBlank val="1"/>
@@ -674,7 +675,7 @@
                 </a:outerShdw>
               </a:effectLst>
             </c:spPr>
-            <c:extLst xmlns:w="http://schemas.openxmlformats.org/wordprocessingml/2006/main" xmlns:w15="http://schemas.microsoft.com/office/word/2012/wordml" xmlns:w14="http://schemas.microsoft.com/office/word/2010/wordml" xmlns:m="http://schemas.openxmlformats.org/officeDocument/2006/math" xmlns:wp="http://schemas.openxmlformats.org/drawingml/2006/wordprocessingDrawing" xmlns:wp14="http://schemas.microsoft.com/office/word/2010/wordprocessingDrawing" xmlns:mc="http://schemas.openxmlformats.org/markup-compatibility/2006" xmlns:sl="http://schemas.openxmlformats.org/schemaLibrary/2006/main" xmlns:wne="http://schemas.microsoft.com/office/word/2006/wordml" xmlns:cdr="http://schemas.openxmlformats.org/drawingml/2006/chartDrawing" xmlns:c14="http://schemas.microsoft.com/office/drawing/2007/8/2/chart" xmlns:dgm="http://schemas.openxmlformats.org/drawingml/2006/diagram" xmlns:pic="http://schemas.openxmlformats.org/drawingml/2006/picture" xmlns:xdr="http://schemas.openxmlformats.org/drawingml/2006/spreadsheetDrawing" xmlns:dsp="http://schemas.microsoft.com/office/drawing/2008/diagram" xmlns:xvml="urn:schemas-microsoft-com:office:excel" xmlns:o="urn:schemas-microsoft-com:office:office" xmlns:v="urn:schemas-microsoft-com:vml" xmlns:w10="urn:schemas-microsoft-com:office:word" xmlns:pvml="urn:schemas-microsoft-com:office:powerpoint" xmlns:cppr="http://schemas.microsoft.com/office/2006/coverPageProps" xmlns:odx="http://opendope.org/xpaths" xmlns:odc="http://opendope.org/conditions" xmlns:odq="http://opendope.org/questions" xmlns:oda="http://opendope.org/answers" xmlns:odi="http://opendope.org/components" xmlns:odgm="http://opendope.org/SmartArt/DataHierarchy" xmlns:b="http://schemas.openxmlformats.org/officeDocument/2006/bibliography" xmlns:wps="http://schemas.microsoft.com/office/word/2010/wordprocessingShape" xmlns:w16se="http://schemas.microsoft.com/office/word/2015/wordml/symex" xmlns:w16cid="http://schemas.microsoft.com/office/word/2016/wordml/cid" xmlns:wetp="http://schemas.microsoft.com/office/webextensions/taskpanes/2010/11" xmlns:we="http://schemas.microsoft.com/office/webextensions/webextension/2010/11" xmlns:comp="http://schemas.openxmlformats.org/drawingml/2006/compatibility" xmlns:lc="http://schemas.openxmlformats.org/drawingml/2006/lockedCanvas">
+            <c:extLst xmlns:lc="http://schemas.openxmlformats.org/drawingml/2006/lockedCanvas" xmlns:comp="http://schemas.openxmlformats.org/drawingml/2006/compatibility" xmlns:we="http://schemas.microsoft.com/office/webextensions/webextension/2010/11" xmlns:wetp="http://schemas.microsoft.com/office/webextensions/taskpanes/2010/11" xmlns:w16cid="http://schemas.microsoft.com/office/word/2016/wordml/cid" xmlns:w16se="http://schemas.microsoft.com/office/word/2015/wordml/symex" xmlns:wps="http://schemas.microsoft.com/office/word/2010/wordprocessingShape" xmlns:b="http://schemas.openxmlformats.org/officeDocument/2006/bibliography" xmlns:odgm="http://opendope.org/SmartArt/DataHierarchy" xmlns:odi="http://opendope.org/components" xmlns:oda="http://opendope.org/answers" xmlns:odq="http://opendope.org/questions" xmlns:odc="http://opendope.org/conditions" xmlns:odx="http://opendope.org/xpaths" xmlns:cppr="http://schemas.microsoft.com/office/2006/coverPageProps" xmlns:pvml="urn:schemas-microsoft-com:office:powerpoint" xmlns:w10="urn:schemas-microsoft-com:office:word" xmlns:v="urn:schemas-microsoft-com:vml" xmlns:o="urn:schemas-microsoft-com:office:office" xmlns:xvml="urn:schemas-microsoft-com:office:excel" xmlns:dsp="http://schemas.microsoft.com/office/drawing/2008/diagram" xmlns:xdr="http://schemas.openxmlformats.org/drawingml/2006/spreadsheetDrawing" xmlns:pic="http://schemas.openxmlformats.org/drawingml/2006/picture" xmlns:dgm="http://schemas.openxmlformats.org/drawingml/2006/diagram" xmlns:c14="http://schemas.microsoft.com/office/drawing/2007/8/2/chart" xmlns:cdr="http://schemas.openxmlformats.org/drawingml/2006/chartDrawing" xmlns:wne="http://schemas.microsoft.com/office/word/2006/wordml" xmlns:sl="http://schemas.openxmlformats.org/schemaLibrary/2006/main" xmlns:mc="http://schemas.openxmlformats.org/markup-compatibility/2006" xmlns:wp14="http://schemas.microsoft.com/office/word/2010/wordprocessingDrawing" xmlns:wp="http://schemas.openxmlformats.org/drawingml/2006/wordprocessingDrawing" xmlns:m="http://schemas.openxmlformats.org/officeDocument/2006/math" xmlns:w14="http://schemas.microsoft.com/office/word/2010/wordml" xmlns:w15="http://schemas.microsoft.com/office/word/2012/wordml" xmlns:w="http://schemas.openxmlformats.org/wordprocessingml/2006/main">
               <c:ext xmlns:c16="http://schemas.microsoft.com/office/drawing/2014/chart" uri="{C3380CC4-5D6E-409C-BE32-E72D297353CC}">
                 <c16:uniqueId val="{00000001-6147-E74A-AA7B-5531F0E4EE0C}"/>
               </c:ext>
@@ -757,7 +758,7 @@
               </c:numCache>
             </c:numRef>
           </c:val>
-          <c:extLst xmlns:w="http://schemas.openxmlformats.org/wordprocessingml/2006/main" xmlns:w15="http://schemas.microsoft.com/office/word/2012/wordml" xmlns:w14="http://schemas.microsoft.com/office/word/2010/wordml" xmlns:m="http://schemas.openxmlformats.org/officeDocument/2006/math" xmlns:wp="http://schemas.openxmlformats.org/drawingml/2006/wordprocessingDrawing" xmlns:wp14="http://schemas.microsoft.com/office/word/2010/wordprocessingDrawing" xmlns:mc="http://schemas.openxmlformats.org/markup-compatibility/2006" xmlns:sl="http://schemas.openxmlformats.org/schemaLibrary/2006/main" xmlns:wne="http://schemas.microsoft.com/office/word/2006/wordml" xmlns:cdr="http://schemas.openxmlformats.org/drawingml/2006/chartDrawing" xmlns:c14="http://schemas.microsoft.com/office/drawing/2007/8/2/chart" xmlns:dgm="http://schemas.openxmlformats.org/drawingml/2006/diagram" xmlns:pic="http://schemas.openxmlformats.org/drawingml/2006/picture" xmlns:xdr="http://schemas.openxmlformats.org/drawingml/2006/spreadsheetDrawing" xmlns:dsp="http://schemas.microsoft.com/office/drawing/2008/diagram" xmlns:xvml="urn:schemas-microsoft-com:office:excel" xmlns:o="urn:schemas-microsoft-com:office:office" xmlns:v="urn:schemas-microsoft-com:vml" xmlns:w10="urn:schemas-microsoft-com:office:word" xmlns:pvml="urn:schemas-microsoft-com:office:powerpoint" xmlns:cppr="http://schemas.microsoft.com/office/2006/coverPageProps" xmlns:odx="http://opendope.org/xpaths" xmlns:odc="http://opendope.org/conditions" xmlns:odq="http://opendope.org/questions" xmlns:oda="http://opendope.org/answers" xmlns:odi="http://opendope.org/components" xmlns:odgm="http://opendope.org/SmartArt/DataHierarchy" xmlns:b="http://schemas.openxmlformats.org/officeDocument/2006/bibliography" xmlns:wps="http://schemas.microsoft.com/office/word/2010/wordprocessingShape" xmlns:w16se="http://schemas.microsoft.com/office/word/2015/wordml/symex" xmlns:w16cid="http://schemas.microsoft.com/office/word/2016/wordml/cid" xmlns:wetp="http://schemas.microsoft.com/office/webextensions/taskpanes/2010/11" xmlns:we="http://schemas.microsoft.com/office/webextensions/webextension/2010/11" xmlns:comp="http://schemas.openxmlformats.org/drawingml/2006/compatibility" xmlns:lc="http://schemas.openxmlformats.org/drawingml/2006/lockedCanvas">
+          <c:extLst xmlns:lc="http://schemas.openxmlformats.org/drawingml/2006/lockedCanvas" xmlns:comp="http://schemas.openxmlformats.org/drawingml/2006/compatibility" xmlns:we="http://schemas.microsoft.com/office/webextensions/webextension/2010/11" xmlns:wetp="http://schemas.microsoft.com/office/webextensions/taskpanes/2010/11" xmlns:w16cid="http://schemas.microsoft.com/office/word/2016/wordml/cid" xmlns:w16se="http://schemas.microsoft.com/office/word/2015/wordml/symex" xmlns:wps="http://schemas.microsoft.com/office/word/2010/wordprocessingShape" xmlns:b="http://schemas.openxmlformats.org/officeDocument/2006/bibliography" xmlns:odgm="http://opendope.org/SmartArt/DataHierarchy" xmlns:odi="http://opendope.org/components" xmlns:oda="http://opendope.org/answers" xmlns:odq="http://opendope.org/questions" xmlns:odc="http://opendope.org/conditions" xmlns:odx="http://opendope.org/xpaths" xmlns:cppr="http://schemas.microsoft.com/office/2006/coverPageProps" xmlns:pvml="urn:schemas-microsoft-com:office:powerpoint" xmlns:w10="urn:schemas-microsoft-com:office:word" xmlns:v="urn:schemas-microsoft-com:vml" xmlns:o="urn:schemas-microsoft-com:office:office" xmlns:xvml="urn:schemas-microsoft-com:office:excel" xmlns:dsp="http://schemas.microsoft.com/office/drawing/2008/diagram" xmlns:xdr="http://schemas.openxmlformats.org/drawingml/2006/spreadsheetDrawing" xmlns:pic="http://schemas.openxmlformats.org/drawingml/2006/picture" xmlns:dgm="http://schemas.openxmlformats.org/drawingml/2006/diagram" xmlns:c14="http://schemas.microsoft.com/office/drawing/2007/8/2/chart" xmlns:cdr="http://schemas.openxmlformats.org/drawingml/2006/chartDrawing" xmlns:wne="http://schemas.microsoft.com/office/word/2006/wordml" xmlns:sl="http://schemas.openxmlformats.org/schemaLibrary/2006/main" xmlns:mc="http://schemas.openxmlformats.org/markup-compatibility/2006" xmlns:wp14="http://schemas.microsoft.com/office/word/2010/wordprocessingDrawing" xmlns:wp="http://schemas.openxmlformats.org/drawingml/2006/wordprocessingDrawing" xmlns:m="http://schemas.openxmlformats.org/officeDocument/2006/math" xmlns:w14="http://schemas.microsoft.com/office/word/2010/wordml" xmlns:w15="http://schemas.microsoft.com/office/word/2012/wordml" xmlns:w="http://schemas.openxmlformats.org/wordprocessingml/2006/main">
             <c:ext xmlns:c16="http://schemas.microsoft.com/office/drawing/2014/chart" uri="{C3380CC4-5D6E-409C-BE32-E72D297353CC}">
               <c16:uniqueId val="{00000002-6147-E74A-AA7B-5531F0E4EE0C}"/>
             </c:ext>
@@ -1319,7 +1320,7 @@
     </c:plotArea>
     <c:plotVisOnly val="1"/>
     <c:dispBlanksAs val="gap"/>
-    <c:extLst xmlns:w="http://schemas.openxmlformats.org/wordprocessingml/2006/main" xmlns:w15="http://schemas.microsoft.com/office/word/2012/wordml" xmlns:w14="http://schemas.microsoft.com/office/word/2010/wordml" xmlns:m="http://schemas.openxmlformats.org/officeDocument/2006/math" xmlns:wp="http://schemas.openxmlformats.org/drawingml/2006/wordprocessingDrawing" xmlns:wp14="http://schemas.microsoft.com/office/word/2010/wordprocessingDrawing" xmlns:mc="http://schemas.openxmlformats.org/markup-compatibility/2006" xmlns:sl="http://schemas.openxmlformats.org/schemaLibrary/2006/main" xmlns:wne="http://schemas.microsoft.com/office/word/2006/wordml" xmlns:cdr="http://schemas.openxmlformats.org/drawingml/2006/chartDrawing" xmlns:c14="http://schemas.microsoft.com/office/drawing/2007/8/2/chart" xmlns:dgm="http://schemas.openxmlformats.org/drawingml/2006/diagram" xmlns:pic="http://schemas.openxmlformats.org/drawingml/2006/picture" xmlns:xdr="http://schemas.openxmlformats.org/drawingml/2006/spreadsheetDrawing" xmlns:dsp="http://schemas.microsoft.com/office/drawing/2008/diagram" xmlns:xvml="urn:schemas-microsoft-com:office:excel" xmlns:o="urn:schemas-microsoft-com:office:office" xmlns:v="urn:schemas-microsoft-com:vml" xmlns:w10="urn:schemas-microsoft-com:office:word" xmlns:pvml="urn:schemas-microsoft-com:office:powerpoint" xmlns:cppr="http://schemas.microsoft.com/office/2006/coverPageProps" xmlns:odx="http://opendope.org/xpaths" xmlns:odc="http://opendope.org/conditions" xmlns:odq="http://opendope.org/questions" xmlns:oda="http://opendope.org/answers" xmlns:odi="http://opendope.org/components" xmlns:odgm="http://opendope.org/SmartArt/DataHierarchy" xmlns:b="http://schemas.openxmlformats.org/officeDocument/2006/bibliography" xmlns:wps="http://schemas.microsoft.com/office/word/2010/wordprocessingShape" xmlns:w16se="http://schemas.microsoft.com/office/word/2015/wordml/symex" xmlns:w16cid="http://schemas.microsoft.com/office/word/2016/wordml/cid" xmlns:wetp="http://schemas.microsoft.com/office/webextensions/taskpanes/2010/11" xmlns:we="http://schemas.microsoft.com/office/webextensions/webextension/2010/11" xmlns:comp="http://schemas.openxmlformats.org/drawingml/2006/compatibility" xmlns:lc="http://schemas.openxmlformats.org/drawingml/2006/lockedCanvas">
+    <c:extLst xmlns:lc="http://schemas.openxmlformats.org/drawingml/2006/lockedCanvas" xmlns:comp="http://schemas.openxmlformats.org/drawingml/2006/compatibility" xmlns:we="http://schemas.microsoft.com/office/webextensions/webextension/2010/11" xmlns:wetp="http://schemas.microsoft.com/office/webextensions/taskpanes/2010/11" xmlns:w16cid="http://schemas.microsoft.com/office/word/2016/wordml/cid" xmlns:w16se="http://schemas.microsoft.com/office/word/2015/wordml/symex" xmlns:wps="http://schemas.microsoft.com/office/word/2010/wordprocessingShape" xmlns:b="http://schemas.openxmlformats.org/officeDocument/2006/bibliography" xmlns:odgm="http://opendope.org/SmartArt/DataHierarchy" xmlns:odi="http://opendope.org/components" xmlns:oda="http://opendope.org/answers" xmlns:odq="http://opendope.org/questions" xmlns:odc="http://opendope.org/conditions" xmlns:odx="http://opendope.org/xpaths" xmlns:cppr="http://schemas.microsoft.com/office/2006/coverPageProps" xmlns:pvml="urn:schemas-microsoft-com:office:powerpoint" xmlns:w10="urn:schemas-microsoft-com:office:word" xmlns:v="urn:schemas-microsoft-com:vml" xmlns:o="urn:schemas-microsoft-com:office:office" xmlns:xvml="urn:schemas-microsoft-com:office:excel" xmlns:dsp="http://schemas.microsoft.com/office/drawing/2008/diagram" xmlns:xdr="http://schemas.openxmlformats.org/drawingml/2006/spreadsheetDrawing" xmlns:pic="http://schemas.openxmlformats.org/drawingml/2006/picture" xmlns:dgm="http://schemas.openxmlformats.org/drawingml/2006/diagram" xmlns:c14="http://schemas.microsoft.com/office/drawing/2007/8/2/chart" xmlns:cdr="http://schemas.openxmlformats.org/drawingml/2006/chartDrawing" xmlns:wne="http://schemas.microsoft.com/office/word/2006/wordml" xmlns:sl="http://schemas.openxmlformats.org/schemaLibrary/2006/main" xmlns:mc="http://schemas.openxmlformats.org/markup-compatibility/2006" xmlns:wp14="http://schemas.microsoft.com/office/word/2010/wordprocessingDrawing" xmlns:wp="http://schemas.openxmlformats.org/drawingml/2006/wordprocessingDrawing" xmlns:m="http://schemas.openxmlformats.org/officeDocument/2006/math" xmlns:w14="http://schemas.microsoft.com/office/word/2010/wordml" xmlns:w15="http://schemas.microsoft.com/office/word/2012/wordml" xmlns:w="http://schemas.openxmlformats.org/wordprocessingml/2006/main">
       <c:ext xmlns:c16r3="http://schemas.microsoft.com/office/drawing/2017/03/chart" uri="{56B9EC1D-385E-4148-901F-78D8002777C0}">
         <c16r3:dataDisplayOptions16>
           <c16r3:dispNaAsBlank val="1"/>
@@ -1422,7 +1423,7 @@
                 </a:outerShdw>
               </a:effectLst>
             </c:spPr>
-            <c:extLst xmlns:lc="http://schemas.openxmlformats.org/drawingml/2006/lockedCanvas" xmlns:comp="http://schemas.openxmlformats.org/drawingml/2006/compatibility" xmlns:we="http://schemas.microsoft.com/office/webextensions/webextension/2010/11" xmlns:wetp="http://schemas.microsoft.com/office/webextensions/taskpanes/2010/11" xmlns:w16cid="http://schemas.microsoft.com/office/word/2016/wordml/cid" xmlns:w16se="http://schemas.microsoft.com/office/word/2015/wordml/symex" xmlns:wps="http://schemas.microsoft.com/office/word/2010/wordprocessingShape" xmlns:b="http://schemas.openxmlformats.org/officeDocument/2006/bibliography" xmlns:odgm="http://opendope.org/SmartArt/DataHierarchy" xmlns:odi="http://opendope.org/components" xmlns:oda="http://opendope.org/answers" xmlns:odq="http://opendope.org/questions" xmlns:odc="http://opendope.org/conditions" xmlns:odx="http://opendope.org/xpaths" xmlns:cppr="http://schemas.microsoft.com/office/2006/coverPageProps" xmlns:pvml="urn:schemas-microsoft-com:office:powerpoint" xmlns:w10="urn:schemas-microsoft-com:office:word" xmlns:v="urn:schemas-microsoft-com:vml" xmlns:o="urn:schemas-microsoft-com:office:office" xmlns:xvml="urn:schemas-microsoft-com:office:excel" xmlns:dsp="http://schemas.microsoft.com/office/drawing/2008/diagram" xmlns:xdr="http://schemas.openxmlformats.org/drawingml/2006/spreadsheetDrawing" xmlns:pic="http://schemas.openxmlformats.org/drawingml/2006/picture" xmlns:dgm="http://schemas.openxmlformats.org/drawingml/2006/diagram" xmlns:c14="http://schemas.microsoft.com/office/drawing/2007/8/2/chart" xmlns:cdr="http://schemas.openxmlformats.org/drawingml/2006/chartDrawing" xmlns:wne="http://schemas.microsoft.com/office/word/2006/wordml" xmlns:sl="http://schemas.openxmlformats.org/schemaLibrary/2006/main" xmlns:mc="http://schemas.openxmlformats.org/markup-compatibility/2006" xmlns:wp14="http://schemas.microsoft.com/office/word/2010/wordprocessingDrawing" xmlns:wp="http://schemas.openxmlformats.org/drawingml/2006/wordprocessingDrawing" xmlns:m="http://schemas.openxmlformats.org/officeDocument/2006/math" xmlns:w14="http://schemas.microsoft.com/office/word/2010/wordml" xmlns:w15="http://schemas.microsoft.com/office/word/2012/wordml" xmlns:w="http://schemas.openxmlformats.org/wordprocessingml/2006/main">
+            <c:extLst xmlns:w="http://schemas.openxmlformats.org/wordprocessingml/2006/main" xmlns:w15="http://schemas.microsoft.com/office/word/2012/wordml" xmlns:w14="http://schemas.microsoft.com/office/word/2010/wordml" xmlns:m="http://schemas.openxmlformats.org/officeDocument/2006/math" xmlns:wp="http://schemas.openxmlformats.org/drawingml/2006/wordprocessingDrawing" xmlns:wp14="http://schemas.microsoft.com/office/word/2010/wordprocessingDrawing" xmlns:mc="http://schemas.openxmlformats.org/markup-compatibility/2006" xmlns:sl="http://schemas.openxmlformats.org/schemaLibrary/2006/main" xmlns:wne="http://schemas.microsoft.com/office/word/2006/wordml" xmlns:cdr="http://schemas.openxmlformats.org/drawingml/2006/chartDrawing" xmlns:c14="http://schemas.microsoft.com/office/drawing/2007/8/2/chart" xmlns:dgm="http://schemas.openxmlformats.org/drawingml/2006/diagram" xmlns:pic="http://schemas.openxmlformats.org/drawingml/2006/picture" xmlns:xdr="http://schemas.openxmlformats.org/drawingml/2006/spreadsheetDrawing" xmlns:dsp="http://schemas.microsoft.com/office/drawing/2008/diagram" xmlns:xvml="urn:schemas-microsoft-com:office:excel" xmlns:o="urn:schemas-microsoft-com:office:office" xmlns:v="urn:schemas-microsoft-com:vml" xmlns:w10="urn:schemas-microsoft-com:office:word" xmlns:pvml="urn:schemas-microsoft-com:office:powerpoint" xmlns:cppr="http://schemas.microsoft.com/office/2006/coverPageProps" xmlns:odx="http://opendope.org/xpaths" xmlns:odc="http://opendope.org/conditions" xmlns:odq="http://opendope.org/questions" xmlns:oda="http://opendope.org/answers" xmlns:odi="http://opendope.org/components" xmlns:odgm="http://opendope.org/SmartArt/DataHierarchy" xmlns:b="http://schemas.openxmlformats.org/officeDocument/2006/bibliography" xmlns:wps="http://schemas.microsoft.com/office/word/2010/wordprocessingShape" xmlns:w16se="http://schemas.microsoft.com/office/word/2015/wordml/symex" xmlns:w16cid="http://schemas.microsoft.com/office/word/2016/wordml/cid" xmlns:wetp="http://schemas.microsoft.com/office/webextensions/taskpanes/2010/11" xmlns:we="http://schemas.microsoft.com/office/webextensions/webextension/2010/11" xmlns:comp="http://schemas.openxmlformats.org/drawingml/2006/compatibility" xmlns:lc="http://schemas.openxmlformats.org/drawingml/2006/lockedCanvas">
               <c:ext xmlns:c16="http://schemas.microsoft.com/office/drawing/2014/chart" uri="{C3380CC4-5D6E-409C-BE32-E72D297353CC}">
                 <c16:uniqueId val="{00000001-6147-E74A-AA7B-5531F0E4EE0C}"/>
               </c:ext>
@@ -1505,7 +1506,7 @@
               </c:numCache>
             </c:numRef>
           </c:val>
-          <c:extLst xmlns:lc="http://schemas.openxmlformats.org/drawingml/2006/lockedCanvas" xmlns:comp="http://schemas.openxmlformats.org/drawingml/2006/compatibility" xmlns:we="http://schemas.microsoft.com/office/webextensions/webextension/2010/11" xmlns:wetp="http://schemas.microsoft.com/office/webextensions/taskpanes/2010/11" xmlns:w16cid="http://schemas.microsoft.com/office/word/2016/wordml/cid" xmlns:w16se="http://schemas.microsoft.com/office/word/2015/wordml/symex" xmlns:wps="http://schemas.microsoft.com/office/word/2010/wordprocessingShape" xmlns:b="http://schemas.openxmlformats.org/officeDocument/2006/bibliography" xmlns:odgm="http://opendope.org/SmartArt/DataHierarchy" xmlns:odi="http://opendope.org/components" xmlns:oda="http://opendope.org/answers" xmlns:odq="http://opendope.org/questions" xmlns:odc="http://opendope.org/conditions" xmlns:odx="http://opendope.org/xpaths" xmlns:cppr="http://schemas.microsoft.com/office/2006/coverPageProps" xmlns:pvml="urn:schemas-microsoft-com:office:powerpoint" xmlns:w10="urn:schemas-microsoft-com:office:word" xmlns:v="urn:schemas-microsoft-com:vml" xmlns:o="urn:schemas-microsoft-com:office:office" xmlns:xvml="urn:schemas-microsoft-com:office:excel" xmlns:dsp="http://schemas.microsoft.com/office/drawing/2008/diagram" xmlns:xdr="http://schemas.openxmlformats.org/drawingml/2006/spreadsheetDrawing" xmlns:pic="http://schemas.openxmlformats.org/drawingml/2006/picture" xmlns:dgm="http://schemas.openxmlformats.org/drawingml/2006/diagram" xmlns:c14="http://schemas.microsoft.com/office/drawing/2007/8/2/chart" xmlns:cdr="http://schemas.openxmlformats.org/drawingml/2006/chartDrawing" xmlns:wne="http://schemas.microsoft.com/office/word/2006/wordml" xmlns:sl="http://schemas.openxmlformats.org/schemaLibrary/2006/main" xmlns:mc="http://schemas.openxmlformats.org/markup-compatibility/2006" xmlns:wp14="http://schemas.microsoft.com/office/word/2010/wordprocessingDrawing" xmlns:wp="http://schemas.openxmlformats.org/drawingml/2006/wordprocessingDrawing" xmlns:m="http://schemas.openxmlformats.org/officeDocument/2006/math" xmlns:w14="http://schemas.microsoft.com/office/word/2010/wordml" xmlns:w15="http://schemas.microsoft.com/office/word/2012/wordml" xmlns:w="http://schemas.openxmlformats.org/wordprocessingml/2006/main">
+          <c:extLst xmlns:w="http://schemas.openxmlformats.org/wordprocessingml/2006/main" xmlns:w15="http://schemas.microsoft.com/office/word/2012/wordml" xmlns:w14="http://schemas.microsoft.com/office/word/2010/wordml" xmlns:m="http://schemas.openxmlformats.org/officeDocument/2006/math" xmlns:wp="http://schemas.openxmlformats.org/drawingml/2006/wordprocessingDrawing" xmlns:wp14="http://schemas.microsoft.com/office/word/2010/wordprocessingDrawing" xmlns:mc="http://schemas.openxmlformats.org/markup-compatibility/2006" xmlns:sl="http://schemas.openxmlformats.org/schemaLibrary/2006/main" xmlns:wne="http://schemas.microsoft.com/office/word/2006/wordml" xmlns:cdr="http://schemas.openxmlformats.org/drawingml/2006/chartDrawing" xmlns:c14="http://schemas.microsoft.com/office/drawing/2007/8/2/chart" xmlns:dgm="http://schemas.openxmlformats.org/drawingml/2006/diagram" xmlns:pic="http://schemas.openxmlformats.org/drawingml/2006/picture" xmlns:xdr="http://schemas.openxmlformats.org/drawingml/2006/spreadsheetDrawing" xmlns:dsp="http://schemas.microsoft.com/office/drawing/2008/diagram" xmlns:xvml="urn:schemas-microsoft-com:office:excel" xmlns:o="urn:schemas-microsoft-com:office:office" xmlns:v="urn:schemas-microsoft-com:vml" xmlns:w10="urn:schemas-microsoft-com:office:word" xmlns:pvml="urn:schemas-microsoft-com:office:powerpoint" xmlns:cppr="http://schemas.microsoft.com/office/2006/coverPageProps" xmlns:odx="http://opendope.org/xpaths" xmlns:odc="http://opendope.org/conditions" xmlns:odq="http://opendope.org/questions" xmlns:oda="http://opendope.org/answers" xmlns:odi="http://opendope.org/components" xmlns:odgm="http://opendope.org/SmartArt/DataHierarchy" xmlns:b="http://schemas.openxmlformats.org/officeDocument/2006/bibliography" xmlns:wps="http://schemas.microsoft.com/office/word/2010/wordprocessingShape" xmlns:w16se="http://schemas.microsoft.com/office/word/2015/wordml/symex" xmlns:w16cid="http://schemas.microsoft.com/office/word/2016/wordml/cid" xmlns:wetp="http://schemas.microsoft.com/office/webextensions/taskpanes/2010/11" xmlns:we="http://schemas.microsoft.com/office/webextensions/webextension/2010/11" xmlns:comp="http://schemas.openxmlformats.org/drawingml/2006/compatibility" xmlns:lc="http://schemas.openxmlformats.org/drawingml/2006/lockedCanvas">
             <c:ext xmlns:c16="http://schemas.microsoft.com/office/drawing/2014/chart" uri="{C3380CC4-5D6E-409C-BE32-E72D297353CC}">
               <c16:uniqueId val="{00000002-6147-E74A-AA7B-5531F0E4EE0C}"/>
             </c:ext>
@@ -2067,7 +2068,7 @@
     </c:plotArea>
     <c:plotVisOnly val="1"/>
     <c:dispBlanksAs val="gap"/>
-    <c:extLst xmlns:lc="http://schemas.openxmlformats.org/drawingml/2006/lockedCanvas" xmlns:comp="http://schemas.openxmlformats.org/drawingml/2006/compatibility" xmlns:we="http://schemas.microsoft.com/office/webextensions/webextension/2010/11" xmlns:wetp="http://schemas.microsoft.com/office/webextensions/taskpanes/2010/11" xmlns:w16cid="http://schemas.microsoft.com/office/word/2016/wordml/cid" xmlns:w16se="http://schemas.microsoft.com/office/word/2015/wordml/symex" xmlns:wps="http://schemas.microsoft.com/office/word/2010/wordprocessingShape" xmlns:b="http://schemas.openxmlformats.org/officeDocument/2006/bibliography" xmlns:odgm="http://opendope.org/SmartArt/DataHierarchy" xmlns:odi="http://opendope.org/components" xmlns:oda="http://opendope.org/answers" xmlns:odq="http://opendope.org/questions" xmlns:odc="http://opendope.org/conditions" xmlns:odx="http://opendope.org/xpaths" xmlns:cppr="http://schemas.microsoft.com/office/2006/coverPageProps" xmlns:pvml="urn:schemas-microsoft-com:office:powerpoint" xmlns:w10="urn:schemas-microsoft-com:office:word" xmlns:v="urn:schemas-microsoft-com:vml" xmlns:o="urn:schemas-microsoft-com:office:office" xmlns:xvml="urn:schemas-microsoft-com:office:excel" xmlns:dsp="http://schemas.microsoft.com/office/drawing/2008/diagram" xmlns:xdr="http://schemas.openxmlformats.org/drawingml/2006/spreadsheetDrawing" xmlns:pic="http://schemas.openxmlformats.org/drawingml/2006/picture" xmlns:dgm="http://schemas.openxmlformats.org/drawingml/2006/diagram" xmlns:c14="http://schemas.microsoft.com/office/drawing/2007/8/2/chart" xmlns:cdr="http://schemas.openxmlformats.org/drawingml/2006/chartDrawing" xmlns:wne="http://schemas.microsoft.com/office/word/2006/wordml" xmlns:sl="http://schemas.openxmlformats.org/schemaLibrary/2006/main" xmlns:mc="http://schemas.openxmlformats.org/markup-compatibility/2006" xmlns:wp14="http://schemas.microsoft.com/office/word/2010/wordprocessingDrawing" xmlns:wp="http://schemas.openxmlformats.org/drawingml/2006/wordprocessingDrawing" xmlns:m="http://schemas.openxmlformats.org/officeDocument/2006/math" xmlns:w14="http://schemas.microsoft.com/office/word/2010/wordml" xmlns:w15="http://schemas.microsoft.com/office/word/2012/wordml" xmlns:w="http://schemas.openxmlformats.org/wordprocessingml/2006/main">
+    <c:extLst xmlns:w="http://schemas.openxmlformats.org/wordprocessingml/2006/main" xmlns:w15="http://schemas.microsoft.com/office/word/2012/wordml" xmlns:w14="http://schemas.microsoft.com/office/word/2010/wordml" xmlns:m="http://schemas.openxmlformats.org/officeDocument/2006/math" xmlns:wp="http://schemas.openxmlformats.org/drawingml/2006/wordprocessingDrawing" xmlns:wp14="http://schemas.microsoft.com/office/word/2010/wordprocessingDrawing" xmlns:mc="http://schemas.openxmlformats.org/markup-compatibility/2006" xmlns:sl="http://schemas.openxmlformats.org/schemaLibrary/2006/main" xmlns:wne="http://schemas.microsoft.com/office/word/2006/wordml" xmlns:cdr="http://schemas.openxmlformats.org/drawingml/2006/chartDrawing" xmlns:c14="http://schemas.microsoft.com/office/drawing/2007/8/2/chart" xmlns:dgm="http://schemas.openxmlformats.org/drawingml/2006/diagram" xmlns:pic="http://schemas.openxmlformats.org/drawingml/2006/picture" xmlns:xdr="http://schemas.openxmlformats.org/drawingml/2006/spreadsheetDrawing" xmlns:dsp="http://schemas.microsoft.com/office/drawing/2008/diagram" xmlns:xvml="urn:schemas-microsoft-com:office:excel" xmlns:o="urn:schemas-microsoft-com:office:office" xmlns:v="urn:schemas-microsoft-com:vml" xmlns:w10="urn:schemas-microsoft-com:office:word" xmlns:pvml="urn:schemas-microsoft-com:office:powerpoint" xmlns:cppr="http://schemas.microsoft.com/office/2006/coverPageProps" xmlns:odx="http://opendope.org/xpaths" xmlns:odc="http://opendope.org/conditions" xmlns:odq="http://opendope.org/questions" xmlns:oda="http://opendope.org/answers" xmlns:odi="http://opendope.org/components" xmlns:odgm="http://opendope.org/SmartArt/DataHierarchy" xmlns:b="http://schemas.openxmlformats.org/officeDocument/2006/bibliography" xmlns:wps="http://schemas.microsoft.com/office/word/2010/wordprocessingShape" xmlns:w16se="http://schemas.microsoft.com/office/word/2015/wordml/symex" xmlns:w16cid="http://schemas.microsoft.com/office/word/2016/wordml/cid" xmlns:wetp="http://schemas.microsoft.com/office/webextensions/taskpanes/2010/11" xmlns:we="http://schemas.microsoft.com/office/webextensions/webextension/2010/11" xmlns:comp="http://schemas.openxmlformats.org/drawingml/2006/compatibility" xmlns:lc="http://schemas.openxmlformats.org/drawingml/2006/lockedCanvas">
       <c:ext xmlns:c16r3="http://schemas.microsoft.com/office/drawing/2017/03/chart" uri="{56B9EC1D-385E-4148-901F-78D8002777C0}">
         <c16r3:dataDisplayOptions16>
           <c16r3:dispNaAsBlank val="1"/>
@@ -2170,7 +2171,7 @@
                 </a:outerShdw>
               </a:effectLst>
             </c:spPr>
-            <c:extLst xmlns:w="http://schemas.openxmlformats.org/wordprocessingml/2006/main" xmlns:w15="http://schemas.microsoft.com/office/word/2012/wordml" xmlns:w14="http://schemas.microsoft.com/office/word/2010/wordml" xmlns:m="http://schemas.openxmlformats.org/officeDocument/2006/math" xmlns:wp="http://schemas.openxmlformats.org/drawingml/2006/wordprocessingDrawing" xmlns:wp14="http://schemas.microsoft.com/office/word/2010/wordprocessingDrawing" xmlns:mc="http://schemas.openxmlformats.org/markup-compatibility/2006" xmlns:sl="http://schemas.openxmlformats.org/schemaLibrary/2006/main" xmlns:wne="http://schemas.microsoft.com/office/word/2006/wordml" xmlns:cdr="http://schemas.openxmlformats.org/drawingml/2006/chartDrawing" xmlns:c14="http://schemas.microsoft.com/office/drawing/2007/8/2/chart" xmlns:dgm="http://schemas.openxmlformats.org/drawingml/2006/diagram" xmlns:pic="http://schemas.openxmlformats.org/drawingml/2006/picture" xmlns:xdr="http://schemas.openxmlformats.org/drawingml/2006/spreadsheetDrawing" xmlns:dsp="http://schemas.microsoft.com/office/drawing/2008/diagram" xmlns:xvml="urn:schemas-microsoft-com:office:excel" xmlns:o="urn:schemas-microsoft-com:office:office" xmlns:v="urn:schemas-microsoft-com:vml" xmlns:w10="urn:schemas-microsoft-com:office:word" xmlns:pvml="urn:schemas-microsoft-com:office:powerpoint" xmlns:cppr="http://schemas.microsoft.com/office/2006/coverPageProps" xmlns:odx="http://opendope.org/xpaths" xmlns:odc="http://opendope.org/conditions" xmlns:odq="http://opendope.org/questions" xmlns:oda="http://opendope.org/answers" xmlns:odi="http://opendope.org/components" xmlns:odgm="http://opendope.org/SmartArt/DataHierarchy" xmlns:b="http://schemas.openxmlformats.org/officeDocument/2006/bibliography" xmlns:wps="http://schemas.microsoft.com/office/word/2010/wordprocessingShape" xmlns:w16se="http://schemas.microsoft.com/office/word/2015/wordml/symex" xmlns:w16cid="http://schemas.microsoft.com/office/word/2016/wordml/cid" xmlns:wetp="http://schemas.microsoft.com/office/webextensions/taskpanes/2010/11" xmlns:we="http://schemas.microsoft.com/office/webextensions/webextension/2010/11" xmlns:comp="http://schemas.openxmlformats.org/drawingml/2006/compatibility" xmlns:lc="http://schemas.openxmlformats.org/drawingml/2006/lockedCanvas">
+            <c:extLst xmlns:lc="http://schemas.openxmlformats.org/drawingml/2006/lockedCanvas" xmlns:comp="http://schemas.openxmlformats.org/drawingml/2006/compatibility" xmlns:we="http://schemas.microsoft.com/office/webextensions/webextension/2010/11" xmlns:wetp="http://schemas.microsoft.com/office/webextensions/taskpanes/2010/11" xmlns:w16cid="http://schemas.microsoft.com/office/word/2016/wordml/cid" xmlns:w16se="http://schemas.microsoft.com/office/word/2015/wordml/symex" xmlns:wps="http://schemas.microsoft.com/office/word/2010/wordprocessingShape" xmlns:b="http://schemas.openxmlformats.org/officeDocument/2006/bibliography" xmlns:odgm="http://opendope.org/SmartArt/DataHierarchy" xmlns:odi="http://opendope.org/components" xmlns:oda="http://opendope.org/answers" xmlns:odq="http://opendope.org/questions" xmlns:odc="http://opendope.org/conditions" xmlns:odx="http://opendope.org/xpaths" xmlns:cppr="http://schemas.microsoft.com/office/2006/coverPageProps" xmlns:pvml="urn:schemas-microsoft-com:office:powerpoint" xmlns:w10="urn:schemas-microsoft-com:office:word" xmlns:v="urn:schemas-microsoft-com:vml" xmlns:o="urn:schemas-microsoft-com:office:office" xmlns:xvml="urn:schemas-microsoft-com:office:excel" xmlns:dsp="http://schemas.microsoft.com/office/drawing/2008/diagram" xmlns:xdr="http://schemas.openxmlformats.org/drawingml/2006/spreadsheetDrawing" xmlns:pic="http://schemas.openxmlformats.org/drawingml/2006/picture" xmlns:dgm="http://schemas.openxmlformats.org/drawingml/2006/diagram" xmlns:c14="http://schemas.microsoft.com/office/drawing/2007/8/2/chart" xmlns:cdr="http://schemas.openxmlformats.org/drawingml/2006/chartDrawing" xmlns:wne="http://schemas.microsoft.com/office/word/2006/wordml" xmlns:sl="http://schemas.openxmlformats.org/schemaLibrary/2006/main" xmlns:mc="http://schemas.openxmlformats.org/markup-compatibility/2006" xmlns:wp14="http://schemas.microsoft.com/office/word/2010/wordprocessingDrawing" xmlns:wp="http://schemas.openxmlformats.org/drawingml/2006/wordprocessingDrawing" xmlns:m="http://schemas.openxmlformats.org/officeDocument/2006/math" xmlns:w14="http://schemas.microsoft.com/office/word/2010/wordml" xmlns:w15="http://schemas.microsoft.com/office/word/2012/wordml" xmlns:w="http://schemas.openxmlformats.org/wordprocessingml/2006/main">
               <c:ext xmlns:c16="http://schemas.microsoft.com/office/drawing/2014/chart" uri="{C3380CC4-5D6E-409C-BE32-E72D297353CC}">
                 <c16:uniqueId val="{00000001-6147-E74A-AA7B-5531F0E4EE0C}"/>
               </c:ext>
@@ -2265,7 +2266,7 @@
               </c:numCache>
             </c:numRef>
           </c:val>
-          <c:extLst xmlns:w="http://schemas.openxmlformats.org/wordprocessingml/2006/main" xmlns:w15="http://schemas.microsoft.com/office/word/2012/wordml" xmlns:w14="http://schemas.microsoft.com/office/word/2010/wordml" xmlns:m="http://schemas.openxmlformats.org/officeDocument/2006/math" xmlns:wp="http://schemas.openxmlformats.org/drawingml/2006/wordprocessingDrawing" xmlns:wp14="http://schemas.microsoft.com/office/word/2010/wordprocessingDrawing" xmlns:mc="http://schemas.openxmlformats.org/markup-compatibility/2006" xmlns:sl="http://schemas.openxmlformats.org/schemaLibrary/2006/main" xmlns:wne="http://schemas.microsoft.com/office/word/2006/wordml" xmlns:cdr="http://schemas.openxmlformats.org/drawingml/2006/chartDrawing" xmlns:c14="http://schemas.microsoft.com/office/drawing/2007/8/2/chart" xmlns:dgm="http://schemas.openxmlformats.org/drawingml/2006/diagram" xmlns:pic="http://schemas.openxmlformats.org/drawingml/2006/picture" xmlns:xdr="http://schemas.openxmlformats.org/drawingml/2006/spreadsheetDrawing" xmlns:dsp="http://schemas.microsoft.com/office/drawing/2008/diagram" xmlns:xvml="urn:schemas-microsoft-com:office:excel" xmlns:o="urn:schemas-microsoft-com:office:office" xmlns:v="urn:schemas-microsoft-com:vml" xmlns:w10="urn:schemas-microsoft-com:office:word" xmlns:pvml="urn:schemas-microsoft-com:office:powerpoint" xmlns:cppr="http://schemas.microsoft.com/office/2006/coverPageProps" xmlns:odx="http://opendope.org/xpaths" xmlns:odc="http://opendope.org/conditions" xmlns:odq="http://opendope.org/questions" xmlns:oda="http://opendope.org/answers" xmlns:odi="http://opendope.org/components" xmlns:odgm="http://opendope.org/SmartArt/DataHierarchy" xmlns:b="http://schemas.openxmlformats.org/officeDocument/2006/bibliography" xmlns:wps="http://schemas.microsoft.com/office/word/2010/wordprocessingShape" xmlns:w16se="http://schemas.microsoft.com/office/word/2015/wordml/symex" xmlns:w16cid="http://schemas.microsoft.com/office/word/2016/wordml/cid" xmlns:wetp="http://schemas.microsoft.com/office/webextensions/taskpanes/2010/11" xmlns:we="http://schemas.microsoft.com/office/webextensions/webextension/2010/11" xmlns:comp="http://schemas.openxmlformats.org/drawingml/2006/compatibility" xmlns:lc="http://schemas.openxmlformats.org/drawingml/2006/lockedCanvas">
+          <c:extLst xmlns:lc="http://schemas.openxmlformats.org/drawingml/2006/lockedCanvas" xmlns:comp="http://schemas.openxmlformats.org/drawingml/2006/compatibility" xmlns:we="http://schemas.microsoft.com/office/webextensions/webextension/2010/11" xmlns:wetp="http://schemas.microsoft.com/office/webextensions/taskpanes/2010/11" xmlns:w16cid="http://schemas.microsoft.com/office/word/2016/wordml/cid" xmlns:w16se="http://schemas.microsoft.com/office/word/2015/wordml/symex" xmlns:wps="http://schemas.microsoft.com/office/word/2010/wordprocessingShape" xmlns:b="http://schemas.openxmlformats.org/officeDocument/2006/bibliography" xmlns:odgm="http://opendope.org/SmartArt/DataHierarchy" xmlns:odi="http://opendope.org/components" xmlns:oda="http://opendope.org/answers" xmlns:odq="http://opendope.org/questions" xmlns:odc="http://opendope.org/conditions" xmlns:odx="http://opendope.org/xpaths" xmlns:cppr="http://schemas.microsoft.com/office/2006/coverPageProps" xmlns:pvml="urn:schemas-microsoft-com:office:powerpoint" xmlns:w10="urn:schemas-microsoft-com:office:word" xmlns:v="urn:schemas-microsoft-com:vml" xmlns:o="urn:schemas-microsoft-com:office:office" xmlns:xvml="urn:schemas-microsoft-com:office:excel" xmlns:dsp="http://schemas.microsoft.com/office/drawing/2008/diagram" xmlns:xdr="http://schemas.openxmlformats.org/drawingml/2006/spreadsheetDrawing" xmlns:pic="http://schemas.openxmlformats.org/drawingml/2006/picture" xmlns:dgm="http://schemas.openxmlformats.org/drawingml/2006/diagram" xmlns:c14="http://schemas.microsoft.com/office/drawing/2007/8/2/chart" xmlns:cdr="http://schemas.openxmlformats.org/drawingml/2006/chartDrawing" xmlns:wne="http://schemas.microsoft.com/office/word/2006/wordml" xmlns:sl="http://schemas.openxmlformats.org/schemaLibrary/2006/main" xmlns:mc="http://schemas.openxmlformats.org/markup-compatibility/2006" xmlns:wp14="http://schemas.microsoft.com/office/word/2010/wordprocessingDrawing" xmlns:wp="http://schemas.openxmlformats.org/drawingml/2006/wordprocessingDrawing" xmlns:m="http://schemas.openxmlformats.org/officeDocument/2006/math" xmlns:w14="http://schemas.microsoft.com/office/word/2010/wordml" xmlns:w15="http://schemas.microsoft.com/office/word/2012/wordml" xmlns:w="http://schemas.openxmlformats.org/wordprocessingml/2006/main">
             <c:ext xmlns:c16="http://schemas.microsoft.com/office/drawing/2014/chart" uri="{C3380CC4-5D6E-409C-BE32-E72D297353CC}">
               <c16:uniqueId val="{00000002-6147-E74A-AA7B-5531F0E4EE0C}"/>
             </c:ext>
@@ -2875,7 +2876,7 @@
     </c:plotArea>
     <c:plotVisOnly val="1"/>
     <c:dispBlanksAs val="gap"/>
-    <c:extLst xmlns:w="http://schemas.openxmlformats.org/wordprocessingml/2006/main" xmlns:w15="http://schemas.microsoft.com/office/word/2012/wordml" xmlns:w14="http://schemas.microsoft.com/office/word/2010/wordml" xmlns:m="http://schemas.openxmlformats.org/officeDocument/2006/math" xmlns:wp="http://schemas.openxmlformats.org/drawingml/2006/wordprocessingDrawing" xmlns:wp14="http://schemas.microsoft.com/office/word/2010/wordprocessingDrawing" xmlns:mc="http://schemas.openxmlformats.org/markup-compatibility/2006" xmlns:sl="http://schemas.openxmlformats.org/schemaLibrary/2006/main" xmlns:wne="http://schemas.microsoft.com/office/word/2006/wordml" xmlns:cdr="http://schemas.openxmlformats.org/drawingml/2006/chartDrawing" xmlns:c14="http://schemas.microsoft.com/office/drawing/2007/8/2/chart" xmlns:dgm="http://schemas.openxmlformats.org/drawingml/2006/diagram" xmlns:pic="http://schemas.openxmlformats.org/drawingml/2006/picture" xmlns:xdr="http://schemas.openxmlformats.org/drawingml/2006/spreadsheetDrawing" xmlns:dsp="http://schemas.microsoft.com/office/drawing/2008/diagram" xmlns:xvml="urn:schemas-microsoft-com:office:excel" xmlns:o="urn:schemas-microsoft-com:office:office" xmlns:v="urn:schemas-microsoft-com:vml" xmlns:w10="urn:schemas-microsoft-com:office:word" xmlns:pvml="urn:schemas-microsoft-com:office:powerpoint" xmlns:cppr="http://schemas.microsoft.com/office/2006/coverPageProps" xmlns:odx="http://opendope.org/xpaths" xmlns:odc="http://opendope.org/conditions" xmlns:odq="http://opendope.org/questions" xmlns:oda="http://opendope.org/answers" xmlns:odi="http://opendope.org/components" xmlns:odgm="http://opendope.org/SmartArt/DataHierarchy" xmlns:b="http://schemas.openxmlformats.org/officeDocument/2006/bibliography" xmlns:wps="http://schemas.microsoft.com/office/word/2010/wordprocessingShape" xmlns:w16se="http://schemas.microsoft.com/office/word/2015/wordml/symex" xmlns:w16cid="http://schemas.microsoft.com/office/word/2016/wordml/cid" xmlns:wetp="http://schemas.microsoft.com/office/webextensions/taskpanes/2010/11" xmlns:we="http://schemas.microsoft.com/office/webextensions/webextension/2010/11" xmlns:comp="http://schemas.openxmlformats.org/drawingml/2006/compatibility" xmlns:lc="http://schemas.openxmlformats.org/drawingml/2006/lockedCanvas">
+    <c:extLst xmlns:lc="http://schemas.openxmlformats.org/drawingml/2006/lockedCanvas" xmlns:comp="http://schemas.openxmlformats.org/drawingml/2006/compatibility" xmlns:we="http://schemas.microsoft.com/office/webextensions/webextension/2010/11" xmlns:wetp="http://schemas.microsoft.com/office/webextensions/taskpanes/2010/11" xmlns:w16cid="http://schemas.microsoft.com/office/word/2016/wordml/cid" xmlns:w16se="http://schemas.microsoft.com/office/word/2015/wordml/symex" xmlns:wps="http://schemas.microsoft.com/office/word/2010/wordprocessingShape" xmlns:b="http://schemas.openxmlformats.org/officeDocument/2006/bibliography" xmlns:odgm="http://opendope.org/SmartArt/DataHierarchy" xmlns:odi="http://opendope.org/components" xmlns:oda="http://opendope.org/answers" xmlns:odq="http://opendope.org/questions" xmlns:odc="http://opendope.org/conditions" xmlns:odx="http://opendope.org/xpaths" xmlns:cppr="http://schemas.microsoft.com/office/2006/coverPageProps" xmlns:pvml="urn:schemas-microsoft-com:office:powerpoint" xmlns:w10="urn:schemas-microsoft-com:office:word" xmlns:v="urn:schemas-microsoft-com:vml" xmlns:o="urn:schemas-microsoft-com:office:office" xmlns:xvml="urn:schemas-microsoft-com:office:excel" xmlns:dsp="http://schemas.microsoft.com/office/drawing/2008/diagram" xmlns:xdr="http://schemas.openxmlformats.org/drawingml/2006/spreadsheetDrawing" xmlns:pic="http://schemas.openxmlformats.org/drawingml/2006/picture" xmlns:dgm="http://schemas.openxmlformats.org/drawingml/2006/diagram" xmlns:c14="http://schemas.microsoft.com/office/drawing/2007/8/2/chart" xmlns:cdr="http://schemas.openxmlformats.org/drawingml/2006/chartDrawing" xmlns:wne="http://schemas.microsoft.com/office/word/2006/wordml" xmlns:sl="http://schemas.openxmlformats.org/schemaLibrary/2006/main" xmlns:mc="http://schemas.openxmlformats.org/markup-compatibility/2006" xmlns:wp14="http://schemas.microsoft.com/office/word/2010/wordprocessingDrawing" xmlns:wp="http://schemas.openxmlformats.org/drawingml/2006/wordprocessingDrawing" xmlns:m="http://schemas.openxmlformats.org/officeDocument/2006/math" xmlns:w14="http://schemas.microsoft.com/office/word/2010/wordml" xmlns:w15="http://schemas.microsoft.com/office/word/2012/wordml" xmlns:w="http://schemas.openxmlformats.org/wordprocessingml/2006/main">
       <c:ext xmlns:c16r3="http://schemas.microsoft.com/office/drawing/2017/03/chart" uri="{56B9EC1D-385E-4148-901F-78D8002777C0}">
         <c16r3:dataDisplayOptions16>
           <c16r3:dispNaAsBlank val="1"/>
@@ -2978,7 +2979,7 @@
                 </a:outerShdw>
               </a:effectLst>
             </c:spPr>
-            <c:extLst xmlns:w="http://schemas.openxmlformats.org/wordprocessingml/2006/main" xmlns:w15="http://schemas.microsoft.com/office/word/2012/wordml" xmlns:w14="http://schemas.microsoft.com/office/word/2010/wordml" xmlns:m="http://schemas.openxmlformats.org/officeDocument/2006/math" xmlns:wp="http://schemas.openxmlformats.org/drawingml/2006/wordprocessingDrawing" xmlns:wp14="http://schemas.microsoft.com/office/word/2010/wordprocessingDrawing" xmlns:mc="http://schemas.openxmlformats.org/markup-compatibility/2006" xmlns:sl="http://schemas.openxmlformats.org/schemaLibrary/2006/main" xmlns:wne="http://schemas.microsoft.com/office/word/2006/wordml" xmlns:cdr="http://schemas.openxmlformats.org/drawingml/2006/chartDrawing" xmlns:c14="http://schemas.microsoft.com/office/drawing/2007/8/2/chart" xmlns:dgm="http://schemas.openxmlformats.org/drawingml/2006/diagram" xmlns:pic="http://schemas.openxmlformats.org/drawingml/2006/picture" xmlns:xdr="http://schemas.openxmlformats.org/drawingml/2006/spreadsheetDrawing" xmlns:dsp="http://schemas.microsoft.com/office/drawing/2008/diagram" xmlns:xvml="urn:schemas-microsoft-com:office:excel" xmlns:o="urn:schemas-microsoft-com:office:office" xmlns:v="urn:schemas-microsoft-com:vml" xmlns:w10="urn:schemas-microsoft-com:office:word" xmlns:pvml="urn:schemas-microsoft-com:office:powerpoint" xmlns:cppr="http://schemas.microsoft.com/office/2006/coverPageProps" xmlns:odx="http://opendope.org/xpaths" xmlns:odc="http://opendope.org/conditions" xmlns:odq="http://opendope.org/questions" xmlns:oda="http://opendope.org/answers" xmlns:odi="http://opendope.org/components" xmlns:odgm="http://opendope.org/SmartArt/DataHierarchy" xmlns:b="http://schemas.openxmlformats.org/officeDocument/2006/bibliography" xmlns:wps="http://schemas.microsoft.com/office/word/2010/wordprocessingShape" xmlns:w16se="http://schemas.microsoft.com/office/word/2015/wordml/symex" xmlns:w16cid="http://schemas.microsoft.com/office/word/2016/wordml/cid" xmlns:wetp="http://schemas.microsoft.com/office/webextensions/taskpanes/2010/11" xmlns:we="http://schemas.microsoft.com/office/webextensions/webextension/2010/11" xmlns:comp="http://schemas.openxmlformats.org/drawingml/2006/compatibility" xmlns:lc="http://schemas.openxmlformats.org/drawingml/2006/lockedCanvas">
+            <c:extLst xmlns:lc="http://schemas.openxmlformats.org/drawingml/2006/lockedCanvas" xmlns:comp="http://schemas.openxmlformats.org/drawingml/2006/compatibility" xmlns:we="http://schemas.microsoft.com/office/webextensions/webextension/2010/11" xmlns:wetp="http://schemas.microsoft.com/office/webextensions/taskpanes/2010/11" xmlns:w16cid="http://schemas.microsoft.com/office/word/2016/wordml/cid" xmlns:w16se="http://schemas.microsoft.com/office/word/2015/wordml/symex" xmlns:wps="http://schemas.microsoft.com/office/word/2010/wordprocessingShape" xmlns:b="http://schemas.openxmlformats.org/officeDocument/2006/bibliography" xmlns:odgm="http://opendope.org/SmartArt/DataHierarchy" xmlns:odi="http://opendope.org/components" xmlns:oda="http://opendope.org/answers" xmlns:odq="http://opendope.org/questions" xmlns:odc="http://opendope.org/conditions" xmlns:odx="http://opendope.org/xpaths" xmlns:cppr="http://schemas.microsoft.com/office/2006/coverPageProps" xmlns:pvml="urn:schemas-microsoft-com:office:powerpoint" xmlns:w10="urn:schemas-microsoft-com:office:word" xmlns:v="urn:schemas-microsoft-com:vml" xmlns:o="urn:schemas-microsoft-com:office:office" xmlns:xvml="urn:schemas-microsoft-com:office:excel" xmlns:dsp="http://schemas.microsoft.com/office/drawing/2008/diagram" xmlns:xdr="http://schemas.openxmlformats.org/drawingml/2006/spreadsheetDrawing" xmlns:pic="http://schemas.openxmlformats.org/drawingml/2006/picture" xmlns:dgm="http://schemas.openxmlformats.org/drawingml/2006/diagram" xmlns:c14="http://schemas.microsoft.com/office/drawing/2007/8/2/chart" xmlns:cdr="http://schemas.openxmlformats.org/drawingml/2006/chartDrawing" xmlns:wne="http://schemas.microsoft.com/office/word/2006/wordml" xmlns:sl="http://schemas.openxmlformats.org/schemaLibrary/2006/main" xmlns:mc="http://schemas.openxmlformats.org/markup-compatibility/2006" xmlns:wp14="http://schemas.microsoft.com/office/word/2010/wordprocessingDrawing" xmlns:wp="http://schemas.openxmlformats.org/drawingml/2006/wordprocessingDrawing" xmlns:m="http://schemas.openxmlformats.org/officeDocument/2006/math" xmlns:w14="http://schemas.microsoft.com/office/word/2010/wordml" xmlns:w15="http://schemas.microsoft.com/office/word/2012/wordml" xmlns:w="http://schemas.openxmlformats.org/wordprocessingml/2006/main">
               <c:ext xmlns:c16="http://schemas.microsoft.com/office/drawing/2014/chart" uri="{C3380CC4-5D6E-409C-BE32-E72D297353CC}">
                 <c16:uniqueId val="{00000001-6147-E74A-AA7B-5531F0E4EE0C}"/>
               </c:ext>
@@ -3073,7 +3074,7 @@
               </c:numCache>
             </c:numRef>
           </c:val>
-          <c:extLst xmlns:w="http://schemas.openxmlformats.org/wordprocessingml/2006/main" xmlns:w15="http://schemas.microsoft.com/office/word/2012/wordml" xmlns:w14="http://schemas.microsoft.com/office/word/2010/wordml" xmlns:m="http://schemas.openxmlformats.org/officeDocument/2006/math" xmlns:wp="http://schemas.openxmlformats.org/drawingml/2006/wordprocessingDrawing" xmlns:wp14="http://schemas.microsoft.com/office/word/2010/wordprocessingDrawing" xmlns:mc="http://schemas.openxmlformats.org/markup-compatibility/2006" xmlns:sl="http://schemas.openxmlformats.org/schemaLibrary/2006/main" xmlns:wne="http://schemas.microsoft.com/office/word/2006/wordml" xmlns:cdr="http://schemas.openxmlformats.org/drawingml/2006/chartDrawing" xmlns:c14="http://schemas.microsoft.com/office/drawing/2007/8/2/chart" xmlns:dgm="http://schemas.openxmlformats.org/drawingml/2006/diagram" xmlns:pic="http://schemas.openxmlformats.org/drawingml/2006/picture" xmlns:xdr="http://schemas.openxmlformats.org/drawingml/2006/spreadsheetDrawing" xmlns:dsp="http://schemas.microsoft.com/office/drawing/2008/diagram" xmlns:xvml="urn:schemas-microsoft-com:office:excel" xmlns:o="urn:schemas-microsoft-com:office:office" xmlns:v="urn:schemas-microsoft-com:vml" xmlns:w10="urn:schemas-microsoft-com:office:word" xmlns:pvml="urn:schemas-microsoft-com:office:powerpoint" xmlns:cppr="http://schemas.microsoft.com/office/2006/coverPageProps" xmlns:odx="http://opendope.org/xpaths" xmlns:odc="http://opendope.org/conditions" xmlns:odq="http://opendope.org/questions" xmlns:oda="http://opendope.org/answers" xmlns:odi="http://opendope.org/components" xmlns:odgm="http://opendope.org/SmartArt/DataHierarchy" xmlns:b="http://schemas.openxmlformats.org/officeDocument/2006/bibliography" xmlns:wps="http://schemas.microsoft.com/office/word/2010/wordprocessingShape" xmlns:w16se="http://schemas.microsoft.com/office/word/2015/wordml/symex" xmlns:w16cid="http://schemas.microsoft.com/office/word/2016/wordml/cid" xmlns:wetp="http://schemas.microsoft.com/office/webextensions/taskpanes/2010/11" xmlns:we="http://schemas.microsoft.com/office/webextensions/webextension/2010/11" xmlns:comp="http://schemas.openxmlformats.org/drawingml/2006/compatibility" xmlns:lc="http://schemas.openxmlformats.org/drawingml/2006/lockedCanvas">
+          <c:extLst xmlns:lc="http://schemas.openxmlformats.org/drawingml/2006/lockedCanvas" xmlns:comp="http://schemas.openxmlformats.org/drawingml/2006/compatibility" xmlns:we="http://schemas.microsoft.com/office/webextensions/webextension/2010/11" xmlns:wetp="http://schemas.microsoft.com/office/webextensions/taskpanes/2010/11" xmlns:w16cid="http://schemas.microsoft.com/office/word/2016/wordml/cid" xmlns:w16se="http://schemas.microsoft.com/office/word/2015/wordml/symex" xmlns:wps="http://schemas.microsoft.com/office/word/2010/wordprocessingShape" xmlns:b="http://schemas.openxmlformats.org/officeDocument/2006/bibliography" xmlns:odgm="http://opendope.org/SmartArt/DataHierarchy" xmlns:odi="http://opendope.org/components" xmlns:oda="http://opendope.org/answers" xmlns:odq="http://opendope.org/questions" xmlns:odc="http://opendope.org/conditions" xmlns:odx="http://opendope.org/xpaths" xmlns:cppr="http://schemas.microsoft.com/office/2006/coverPageProps" xmlns:pvml="urn:schemas-microsoft-com:office:powerpoint" xmlns:w10="urn:schemas-microsoft-com:office:word" xmlns:v="urn:schemas-microsoft-com:vml" xmlns:o="urn:schemas-microsoft-com:office:office" xmlns:xvml="urn:schemas-microsoft-com:office:excel" xmlns:dsp="http://schemas.microsoft.com/office/drawing/2008/diagram" xmlns:xdr="http://schemas.openxmlformats.org/drawingml/2006/spreadsheetDrawing" xmlns:pic="http://schemas.openxmlformats.org/drawingml/2006/picture" xmlns:dgm="http://schemas.openxmlformats.org/drawingml/2006/diagram" xmlns:c14="http://schemas.microsoft.com/office/drawing/2007/8/2/chart" xmlns:cdr="http://schemas.openxmlformats.org/drawingml/2006/chartDrawing" xmlns:wne="http://schemas.microsoft.com/office/word/2006/wordml" xmlns:sl="http://schemas.openxmlformats.org/schemaLibrary/2006/main" xmlns:mc="http://schemas.openxmlformats.org/markup-compatibility/2006" xmlns:wp14="http://schemas.microsoft.com/office/word/2010/wordprocessingDrawing" xmlns:wp="http://schemas.openxmlformats.org/drawingml/2006/wordprocessingDrawing" xmlns:m="http://schemas.openxmlformats.org/officeDocument/2006/math" xmlns:w14="http://schemas.microsoft.com/office/word/2010/wordml" xmlns:w15="http://schemas.microsoft.com/office/word/2012/wordml" xmlns:w="http://schemas.openxmlformats.org/wordprocessingml/2006/main">
             <c:ext xmlns:c16="http://schemas.microsoft.com/office/drawing/2014/chart" uri="{C3380CC4-5D6E-409C-BE32-E72D297353CC}">
               <c16:uniqueId val="{00000002-6147-E74A-AA7B-5531F0E4EE0C}"/>
             </c:ext>
@@ -3683,7 +3684,7 @@
     </c:plotArea>
     <c:plotVisOnly val="1"/>
     <c:dispBlanksAs val="gap"/>
-    <c:extLst xmlns:w="http://schemas.openxmlformats.org/wordprocessingml/2006/main" xmlns:w15="http://schemas.microsoft.com/office/word/2012/wordml" xmlns:w14="http://schemas.microsoft.com/office/word/2010/wordml" xmlns:m="http://schemas.openxmlformats.org/officeDocument/2006/math" xmlns:wp="http://schemas.openxmlformats.org/drawingml/2006/wordprocessingDrawing" xmlns:wp14="http://schemas.microsoft.com/office/word/2010/wordprocessingDrawing" xmlns:mc="http://schemas.openxmlformats.org/markup-compatibility/2006" xmlns:sl="http://schemas.openxmlformats.org/schemaLibrary/2006/main" xmlns:wne="http://schemas.microsoft.com/office/word/2006/wordml" xmlns:cdr="http://schemas.openxmlformats.org/drawingml/2006/chartDrawing" xmlns:c14="http://schemas.microsoft.com/office/drawing/2007/8/2/chart" xmlns:dgm="http://schemas.openxmlformats.org/drawingml/2006/diagram" xmlns:pic="http://schemas.openxmlformats.org/drawingml/2006/picture" xmlns:xdr="http://schemas.openxmlformats.org/drawingml/2006/spreadsheetDrawing" xmlns:dsp="http://schemas.microsoft.com/office/drawing/2008/diagram" xmlns:xvml="urn:schemas-microsoft-com:office:excel" xmlns:o="urn:schemas-microsoft-com:office:office" xmlns:v="urn:schemas-microsoft-com:vml" xmlns:w10="urn:schemas-microsoft-com:office:word" xmlns:pvml="urn:schemas-microsoft-com:office:powerpoint" xmlns:cppr="http://schemas.microsoft.com/office/2006/coverPageProps" xmlns:odx="http://opendope.org/xpaths" xmlns:odc="http://opendope.org/conditions" xmlns:odq="http://opendope.org/questions" xmlns:oda="http://opendope.org/answers" xmlns:odi="http://opendope.org/components" xmlns:odgm="http://opendope.org/SmartArt/DataHierarchy" xmlns:b="http://schemas.openxmlformats.org/officeDocument/2006/bibliography" xmlns:wps="http://schemas.microsoft.com/office/word/2010/wordprocessingShape" xmlns:w16se="http://schemas.microsoft.com/office/word/2015/wordml/symex" xmlns:w16cid="http://schemas.microsoft.com/office/word/2016/wordml/cid" xmlns:wetp="http://schemas.microsoft.com/office/webextensions/taskpanes/2010/11" xmlns:we="http://schemas.microsoft.com/office/webextensions/webextension/2010/11" xmlns:comp="http://schemas.openxmlformats.org/drawingml/2006/compatibility" xmlns:lc="http://schemas.openxmlformats.org/drawingml/2006/lockedCanvas">
+    <c:extLst xmlns:lc="http://schemas.openxmlformats.org/drawingml/2006/lockedCanvas" xmlns:comp="http://schemas.openxmlformats.org/drawingml/2006/compatibility" xmlns:we="http://schemas.microsoft.com/office/webextensions/webextension/2010/11" xmlns:wetp="http://schemas.microsoft.com/office/webextensions/taskpanes/2010/11" xmlns:w16cid="http://schemas.microsoft.com/office/word/2016/wordml/cid" xmlns:w16se="http://schemas.microsoft.com/office/word/2015/wordml/symex" xmlns:wps="http://schemas.microsoft.com/office/word/2010/wordprocessingShape" xmlns:b="http://schemas.openxmlformats.org/officeDocument/2006/bibliography" xmlns:odgm="http://opendope.org/SmartArt/DataHierarchy" xmlns:odi="http://opendope.org/components" xmlns:oda="http://opendope.org/answers" xmlns:odq="http://opendope.org/questions" xmlns:odc="http://opendope.org/conditions" xmlns:odx="http://opendope.org/xpaths" xmlns:cppr="http://schemas.microsoft.com/office/2006/coverPageProps" xmlns:pvml="urn:schemas-microsoft-com:office:powerpoint" xmlns:w10="urn:schemas-microsoft-com:office:word" xmlns:v="urn:schemas-microsoft-com:vml" xmlns:o="urn:schemas-microsoft-com:office:office" xmlns:xvml="urn:schemas-microsoft-com:office:excel" xmlns:dsp="http://schemas.microsoft.com/office/drawing/2008/diagram" xmlns:xdr="http://schemas.openxmlformats.org/drawingml/2006/spreadsheetDrawing" xmlns:pic="http://schemas.openxmlformats.org/drawingml/2006/picture" xmlns:dgm="http://schemas.openxmlformats.org/drawingml/2006/diagram" xmlns:c14="http://schemas.microsoft.com/office/drawing/2007/8/2/chart" xmlns:cdr="http://schemas.openxmlformats.org/drawingml/2006/chartDrawing" xmlns:wne="http://schemas.microsoft.com/office/word/2006/wordml" xmlns:sl="http://schemas.openxmlformats.org/schemaLibrary/2006/main" xmlns:mc="http://schemas.openxmlformats.org/markup-compatibility/2006" xmlns:wp14="http://schemas.microsoft.com/office/word/2010/wordprocessingDrawing" xmlns:wp="http://schemas.openxmlformats.org/drawingml/2006/wordprocessingDrawing" xmlns:m="http://schemas.openxmlformats.org/officeDocument/2006/math" xmlns:w14="http://schemas.microsoft.com/office/word/2010/wordml" xmlns:w15="http://schemas.microsoft.com/office/word/2012/wordml" xmlns:w="http://schemas.openxmlformats.org/wordprocessingml/2006/main">
       <c:ext xmlns:c16r3="http://schemas.microsoft.com/office/drawing/2017/03/chart" uri="{56B9EC1D-385E-4148-901F-78D8002777C0}">
         <c16r3:dataDisplayOptions16>
           <c16r3:dispNaAsBlank val="1"/>
@@ -3786,7 +3787,7 @@
                 </a:outerShdw>
               </a:effectLst>
             </c:spPr>
-            <c:extLst xmlns:lc="http://schemas.openxmlformats.org/drawingml/2006/lockedCanvas" xmlns:comp="http://schemas.openxmlformats.org/drawingml/2006/compatibility" xmlns:we="http://schemas.microsoft.com/office/webextensions/webextension/2010/11" xmlns:wetp="http://schemas.microsoft.com/office/webextensions/taskpanes/2010/11" xmlns:w16cid="http://schemas.microsoft.com/office/word/2016/wordml/cid" xmlns:w16se="http://schemas.microsoft.com/office/word/2015/wordml/symex" xmlns:wps="http://schemas.microsoft.com/office/word/2010/wordprocessingShape" xmlns:b="http://schemas.openxmlformats.org/officeDocument/2006/bibliography" xmlns:odgm="http://opendope.org/SmartArt/DataHierarchy" xmlns:odi="http://opendope.org/components" xmlns:oda="http://opendope.org/answers" xmlns:odq="http://opendope.org/questions" xmlns:odc="http://opendope.org/conditions" xmlns:odx="http://opendope.org/xpaths" xmlns:cppr="http://schemas.microsoft.com/office/2006/coverPageProps" xmlns:pvml="urn:schemas-microsoft-com:office:powerpoint" xmlns:w10="urn:schemas-microsoft-com:office:word" xmlns:v="urn:schemas-microsoft-com:vml" xmlns:o="urn:schemas-microsoft-com:office:office" xmlns:xvml="urn:schemas-microsoft-com:office:excel" xmlns:dsp="http://schemas.microsoft.com/office/drawing/2008/diagram" xmlns:xdr="http://schemas.openxmlformats.org/drawingml/2006/spreadsheetDrawing" xmlns:pic="http://schemas.openxmlformats.org/drawingml/2006/picture" xmlns:dgm="http://schemas.openxmlformats.org/drawingml/2006/diagram" xmlns:c14="http://schemas.microsoft.com/office/drawing/2007/8/2/chart" xmlns:cdr="http://schemas.openxmlformats.org/drawingml/2006/chartDrawing" xmlns:wne="http://schemas.microsoft.com/office/word/2006/wordml" xmlns:sl="http://schemas.openxmlformats.org/schemaLibrary/2006/main" xmlns:mc="http://schemas.openxmlformats.org/markup-compatibility/2006" xmlns:wp14="http://schemas.microsoft.com/office/word/2010/wordprocessingDrawing" xmlns:wp="http://schemas.openxmlformats.org/drawingml/2006/wordprocessingDrawing" xmlns:m="http://schemas.openxmlformats.org/officeDocument/2006/math" xmlns:w14="http://schemas.microsoft.com/office/word/2010/wordml" xmlns:w15="http://schemas.microsoft.com/office/word/2012/wordml" xmlns:w="http://schemas.openxmlformats.org/wordprocessingml/2006/main">
+            <c:extLst xmlns:w="http://schemas.openxmlformats.org/wordprocessingml/2006/main" xmlns:w15="http://schemas.microsoft.com/office/word/2012/wordml" xmlns:w14="http://schemas.microsoft.com/office/word/2010/wordml" xmlns:m="http://schemas.openxmlformats.org/officeDocument/2006/math" xmlns:wp="http://schemas.openxmlformats.org/drawingml/2006/wordprocessingDrawing" xmlns:wp14="http://schemas.microsoft.com/office/word/2010/wordprocessingDrawing" xmlns:mc="http://schemas.openxmlformats.org/markup-compatibility/2006" xmlns:sl="http://schemas.openxmlformats.org/schemaLibrary/2006/main" xmlns:wne="http://schemas.microsoft.com/office/word/2006/wordml" xmlns:cdr="http://schemas.openxmlformats.org/drawingml/2006/chartDrawing" xmlns:c14="http://schemas.microsoft.com/office/drawing/2007/8/2/chart" xmlns:dgm="http://schemas.openxmlformats.org/drawingml/2006/diagram" xmlns:pic="http://schemas.openxmlformats.org/drawingml/2006/picture" xmlns:xdr="http://schemas.openxmlformats.org/drawingml/2006/spreadsheetDrawing" xmlns:dsp="http://schemas.microsoft.com/office/drawing/2008/diagram" xmlns:xvml="urn:schemas-microsoft-com:office:excel" xmlns:o="urn:schemas-microsoft-com:office:office" xmlns:v="urn:schemas-microsoft-com:vml" xmlns:w10="urn:schemas-microsoft-com:office:word" xmlns:pvml="urn:schemas-microsoft-com:office:powerpoint" xmlns:cppr="http://schemas.microsoft.com/office/2006/coverPageProps" xmlns:odx="http://opendope.org/xpaths" xmlns:odc="http://opendope.org/conditions" xmlns:odq="http://opendope.org/questions" xmlns:oda="http://opendope.org/answers" xmlns:odi="http://opendope.org/components" xmlns:odgm="http://opendope.org/SmartArt/DataHierarchy" xmlns:b="http://schemas.openxmlformats.org/officeDocument/2006/bibliography" xmlns:wps="http://schemas.microsoft.com/office/word/2010/wordprocessingShape" xmlns:w16se="http://schemas.microsoft.com/office/word/2015/wordml/symex" xmlns:w16cid="http://schemas.microsoft.com/office/word/2016/wordml/cid" xmlns:wetp="http://schemas.microsoft.com/office/webextensions/taskpanes/2010/11" xmlns:we="http://schemas.microsoft.com/office/webextensions/webextension/2010/11" xmlns:comp="http://schemas.openxmlformats.org/drawingml/2006/compatibility" xmlns:lc="http://schemas.openxmlformats.org/drawingml/2006/lockedCanvas">
               <c:ext xmlns:c16="http://schemas.microsoft.com/office/drawing/2014/chart" uri="{C3380CC4-5D6E-409C-BE32-E72D297353CC}">
                 <c16:uniqueId val="{00000001-6147-E74A-AA7B-5531F0E4EE0C}"/>
               </c:ext>
@@ -3881,7 +3882,7 @@
               </c:numCache>
             </c:numRef>
           </c:val>
-          <c:extLst xmlns:lc="http://schemas.openxmlformats.org/drawingml/2006/lockedCanvas" xmlns:comp="http://schemas.openxmlformats.org/drawingml/2006/compatibility" xmlns:we="http://schemas.microsoft.com/office/webextensions/webextension/2010/11" xmlns:wetp="http://schemas.microsoft.com/office/webextensions/taskpanes/2010/11" xmlns:w16cid="http://schemas.microsoft.com/office/word/2016/wordml/cid" xmlns:w16se="http://schemas.microsoft.com/office/word/2015/wordml/symex" xmlns:wps="http://schemas.microsoft.com/office/word/2010/wordprocessingShape" xmlns:b="http://schemas.openxmlformats.org/officeDocument/2006/bibliography" xmlns:odgm="http://opendope.org/SmartArt/DataHierarchy" xmlns:odi="http://opendope.org/components" xmlns:oda="http://opendope.org/answers" xmlns:odq="http://opendope.org/questions" xmlns:odc="http://opendope.org/conditions" xmlns:odx="http://opendope.org/xpaths" xmlns:cppr="http://schemas.microsoft.com/office/2006/coverPageProps" xmlns:pvml="urn:schemas-microsoft-com:office:powerpoint" xmlns:w10="urn:schemas-microsoft-com:office:word" xmlns:v="urn:schemas-microsoft-com:vml" xmlns:o="urn:schemas-microsoft-com:office:office" xmlns:xvml="urn:schemas-microsoft-com:office:excel" xmlns:dsp="http://schemas.microsoft.com/office/drawing/2008/diagram" xmlns:xdr="http://schemas.openxmlformats.org/drawingml/2006/spreadsheetDrawing" xmlns:pic="http://schemas.openxmlformats.org/drawingml/2006/picture" xmlns:dgm="http://schemas.openxmlformats.org/drawingml/2006/diagram" xmlns:c14="http://schemas.microsoft.com/office/drawing/2007/8/2/chart" xmlns:cdr="http://schemas.openxmlformats.org/drawingml/2006/chartDrawing" xmlns:wne="http://schemas.microsoft.com/office/word/2006/wordml" xmlns:sl="http://schemas.openxmlformats.org/schemaLibrary/2006/main" xmlns:mc="http://schemas.openxmlformats.org/markup-compatibility/2006" xmlns:wp14="http://schemas.microsoft.com/office/word/2010/wordprocessingDrawing" xmlns:wp="http://schemas.openxmlformats.org/drawingml/2006/wordprocessingDrawing" xmlns:m="http://schemas.openxmlformats.org/officeDocument/2006/math" xmlns:w14="http://schemas.microsoft.com/office/word/2010/wordml" xmlns:w15="http://schemas.microsoft.com/office/word/2012/wordml" xmlns:w="http://schemas.openxmlformats.org/wordprocessingml/2006/main">
+          <c:extLst xmlns:w="http://schemas.openxmlformats.org/wordprocessingml/2006/main" xmlns:w15="http://schemas.microsoft.com/office/word/2012/wordml" xmlns:w14="http://schemas.microsoft.com/office/word/2010/wordml" xmlns:m="http://schemas.openxmlformats.org/officeDocument/2006/math" xmlns:wp="http://schemas.openxmlformats.org/drawingml/2006/wordprocessingDrawing" xmlns:wp14="http://schemas.microsoft.com/office/word/2010/wordprocessingDrawing" xmlns:mc="http://schemas.openxmlformats.org/markup-compatibility/2006" xmlns:sl="http://schemas.openxmlformats.org/schemaLibrary/2006/main" xmlns:wne="http://schemas.microsoft.com/office/word/2006/wordml" xmlns:cdr="http://schemas.openxmlformats.org/drawingml/2006/chartDrawing" xmlns:c14="http://schemas.microsoft.com/office/drawing/2007/8/2/chart" xmlns:dgm="http://schemas.openxmlformats.org/drawingml/2006/diagram" xmlns:pic="http://schemas.openxmlformats.org/drawingml/2006/picture" xmlns:xdr="http://schemas.openxmlformats.org/drawingml/2006/spreadsheetDrawing" xmlns:dsp="http://schemas.microsoft.com/office/drawing/2008/diagram" xmlns:xvml="urn:schemas-microsoft-com:office:excel" xmlns:o="urn:schemas-microsoft-com:office:office" xmlns:v="urn:schemas-microsoft-com:vml" xmlns:w10="urn:schemas-microsoft-com:office:word" xmlns:pvml="urn:schemas-microsoft-com:office:powerpoint" xmlns:cppr="http://schemas.microsoft.com/office/2006/coverPageProps" xmlns:odx="http://opendope.org/xpaths" xmlns:odc="http://opendope.org/conditions" xmlns:odq="http://opendope.org/questions" xmlns:oda="http://opendope.org/answers" xmlns:odi="http://opendope.org/components" xmlns:odgm="http://opendope.org/SmartArt/DataHierarchy" xmlns:b="http://schemas.openxmlformats.org/officeDocument/2006/bibliography" xmlns:wps="http://schemas.microsoft.com/office/word/2010/wordprocessingShape" xmlns:w16se="http://schemas.microsoft.com/office/word/2015/wordml/symex" xmlns:w16cid="http://schemas.microsoft.com/office/word/2016/wordml/cid" xmlns:wetp="http://schemas.microsoft.com/office/webextensions/taskpanes/2010/11" xmlns:we="http://schemas.microsoft.com/office/webextensions/webextension/2010/11" xmlns:comp="http://schemas.openxmlformats.org/drawingml/2006/compatibility" xmlns:lc="http://schemas.openxmlformats.org/drawingml/2006/lockedCanvas">
             <c:ext xmlns:c16="http://schemas.microsoft.com/office/drawing/2014/chart" uri="{C3380CC4-5D6E-409C-BE32-E72D297353CC}">
               <c16:uniqueId val="{00000002-6147-E74A-AA7B-5531F0E4EE0C}"/>
             </c:ext>
@@ -4491,7 +4492,7 @@
     </c:plotArea>
     <c:plotVisOnly val="1"/>
     <c:dispBlanksAs val="gap"/>
-    <c:extLst xmlns:lc="http://schemas.openxmlformats.org/drawingml/2006/lockedCanvas" xmlns:comp="http://schemas.openxmlformats.org/drawingml/2006/compatibility" xmlns:we="http://schemas.microsoft.com/office/webextensions/webextension/2010/11" xmlns:wetp="http://schemas.microsoft.com/office/webextensions/taskpanes/2010/11" xmlns:w16cid="http://schemas.microsoft.com/office/word/2016/wordml/cid" xmlns:w16se="http://schemas.microsoft.com/office/word/2015/wordml/symex" xmlns:wps="http://schemas.microsoft.com/office/word/2010/wordprocessingShape" xmlns:b="http://schemas.openxmlformats.org/officeDocument/2006/bibliography" xmlns:odgm="http://opendope.org/SmartArt/DataHierarchy" xmlns:odi="http://opendope.org/components" xmlns:oda="http://opendope.org/answers" xmlns:odq="http://opendope.org/questions" xmlns:odc="http://opendope.org/conditions" xmlns:odx="http://opendope.org/xpaths" xmlns:cppr="http://schemas.microsoft.com/office/2006/coverPageProps" xmlns:pvml="urn:schemas-microsoft-com:office:powerpoint" xmlns:w10="urn:schemas-microsoft-com:office:word" xmlns:v="urn:schemas-microsoft-com:vml" xmlns:o="urn:schemas-microsoft-com:office:office" xmlns:xvml="urn:schemas-microsoft-com:office:excel" xmlns:dsp="http://schemas.microsoft.com/office/drawing/2008/diagram" xmlns:xdr="http://schemas.openxmlformats.org/drawingml/2006/spreadsheetDrawing" xmlns:pic="http://schemas.openxmlformats.org/drawingml/2006/picture" xmlns:dgm="http://schemas.openxmlformats.org/drawingml/2006/diagram" xmlns:c14="http://schemas.microsoft.com/office/drawing/2007/8/2/chart" xmlns:cdr="http://schemas.openxmlformats.org/drawingml/2006/chartDrawing" xmlns:wne="http://schemas.microsoft.com/office/word/2006/wordml" xmlns:sl="http://schemas.openxmlformats.org/schemaLibrary/2006/main" xmlns:mc="http://schemas.openxmlformats.org/markup-compatibility/2006" xmlns:wp14="http://schemas.microsoft.com/office/word/2010/wordprocessingDrawing" xmlns:wp="http://schemas.openxmlformats.org/drawingml/2006/wordprocessingDrawing" xmlns:m="http://schemas.openxmlformats.org/officeDocument/2006/math" xmlns:w14="http://schemas.microsoft.com/office/word/2010/wordml" xmlns:w15="http://schemas.microsoft.com/office/word/2012/wordml" xmlns:w="http://schemas.openxmlformats.org/wordprocessingml/2006/main">
+    <c:extLst xmlns:w="http://schemas.openxmlformats.org/wordprocessingml/2006/main" xmlns:w15="http://schemas.microsoft.com/office/word/2012/wordml" xmlns:w14="http://schemas.microsoft.com/office/word/2010/wordml" xmlns:m="http://schemas.openxmlformats.org/officeDocument/2006/math" xmlns:wp="http://schemas.openxmlformats.org/drawingml/2006/wordprocessingDrawing" xmlns:wp14="http://schemas.microsoft.com/office/word/2010/wordprocessingDrawing" xmlns:mc="http://schemas.openxmlformats.org/markup-compatibility/2006" xmlns:sl="http://schemas.openxmlformats.org/schemaLibrary/2006/main" xmlns:wne="http://schemas.microsoft.com/office/word/2006/wordml" xmlns:cdr="http://schemas.openxmlformats.org/drawingml/2006/chartDrawing" xmlns:c14="http://schemas.microsoft.com/office/drawing/2007/8/2/chart" xmlns:dgm="http://schemas.openxmlformats.org/drawingml/2006/diagram" xmlns:pic="http://schemas.openxmlformats.org/drawingml/2006/picture" xmlns:xdr="http://schemas.openxmlformats.org/drawingml/2006/spreadsheetDrawing" xmlns:dsp="http://schemas.microsoft.com/office/drawing/2008/diagram" xmlns:xvml="urn:schemas-microsoft-com:office:excel" xmlns:o="urn:schemas-microsoft-com:office:office" xmlns:v="urn:schemas-microsoft-com:vml" xmlns:w10="urn:schemas-microsoft-com:office:word" xmlns:pvml="urn:schemas-microsoft-com:office:powerpoint" xmlns:cppr="http://schemas.microsoft.com/office/2006/coverPageProps" xmlns:odx="http://opendope.org/xpaths" xmlns:odc="http://opendope.org/conditions" xmlns:odq="http://opendope.org/questions" xmlns:oda="http://opendope.org/answers" xmlns:odi="http://opendope.org/components" xmlns:odgm="http://opendope.org/SmartArt/DataHierarchy" xmlns:b="http://schemas.openxmlformats.org/officeDocument/2006/bibliography" xmlns:wps="http://schemas.microsoft.com/office/word/2010/wordprocessingShape" xmlns:w16se="http://schemas.microsoft.com/office/word/2015/wordml/symex" xmlns:w16cid="http://schemas.microsoft.com/office/word/2016/wordml/cid" xmlns:wetp="http://schemas.microsoft.com/office/webextensions/taskpanes/2010/11" xmlns:we="http://schemas.microsoft.com/office/webextensions/webextension/2010/11" xmlns:comp="http://schemas.openxmlformats.org/drawingml/2006/compatibility" xmlns:lc="http://schemas.openxmlformats.org/drawingml/2006/lockedCanvas">
       <c:ext xmlns:c16r3="http://schemas.microsoft.com/office/drawing/2017/03/chart" uri="{56B9EC1D-385E-4148-901F-78D8002777C0}">
         <c16r3:dataDisplayOptions16>
           <c16r3:dispNaAsBlank val="1"/>
@@ -4594,7 +4595,7 @@
                 </a:outerShdw>
               </a:effectLst>
             </c:spPr>
-            <c:extLst xmlns:lc="http://schemas.openxmlformats.org/drawingml/2006/lockedCanvas" xmlns:comp="http://schemas.openxmlformats.org/drawingml/2006/compatibility" xmlns:we="http://schemas.microsoft.com/office/webextensions/webextension/2010/11" xmlns:wetp="http://schemas.microsoft.com/office/webextensions/taskpanes/2010/11" xmlns:w16cid="http://schemas.microsoft.com/office/word/2016/wordml/cid" xmlns:w16se="http://schemas.microsoft.com/office/word/2015/wordml/symex" xmlns:wps="http://schemas.microsoft.com/office/word/2010/wordprocessingShape" xmlns:b="http://schemas.openxmlformats.org/officeDocument/2006/bibliography" xmlns:odgm="http://opendope.org/SmartArt/DataHierarchy" xmlns:odi="http://opendope.org/components" xmlns:oda="http://opendope.org/answers" xmlns:odq="http://opendope.org/questions" xmlns:odc="http://opendope.org/conditions" xmlns:odx="http://opendope.org/xpaths" xmlns:cppr="http://schemas.microsoft.com/office/2006/coverPageProps" xmlns:pvml="urn:schemas-microsoft-com:office:powerpoint" xmlns:w10="urn:schemas-microsoft-com:office:word" xmlns:v="urn:schemas-microsoft-com:vml" xmlns:o="urn:schemas-microsoft-com:office:office" xmlns:xvml="urn:schemas-microsoft-com:office:excel" xmlns:dsp="http://schemas.microsoft.com/office/drawing/2008/diagram" xmlns:xdr="http://schemas.openxmlformats.org/drawingml/2006/spreadsheetDrawing" xmlns:pic="http://schemas.openxmlformats.org/drawingml/2006/picture" xmlns:dgm="http://schemas.openxmlformats.org/drawingml/2006/diagram" xmlns:c14="http://schemas.microsoft.com/office/drawing/2007/8/2/chart" xmlns:cdr="http://schemas.openxmlformats.org/drawingml/2006/chartDrawing" xmlns:wne="http://schemas.microsoft.com/office/word/2006/wordml" xmlns:sl="http://schemas.openxmlformats.org/schemaLibrary/2006/main" xmlns:mc="http://schemas.openxmlformats.org/markup-compatibility/2006" xmlns:wp14="http://schemas.microsoft.com/office/word/2010/wordprocessingDrawing" xmlns:wp="http://schemas.openxmlformats.org/drawingml/2006/wordprocessingDrawing" xmlns:m="http://schemas.openxmlformats.org/officeDocument/2006/math" xmlns:w14="http://schemas.microsoft.com/office/word/2010/wordml" xmlns:w15="http://schemas.microsoft.com/office/word/2012/wordml" xmlns:w="http://schemas.openxmlformats.org/wordprocessingml/2006/main">
+            <c:extLst xmlns:w="http://schemas.openxmlformats.org/wordprocessingml/2006/main" xmlns:w15="http://schemas.microsoft.com/office/word/2012/wordml" xmlns:w14="http://schemas.microsoft.com/office/word/2010/wordml" xmlns:m="http://schemas.openxmlformats.org/officeDocument/2006/math" xmlns:wp="http://schemas.openxmlformats.org/drawingml/2006/wordprocessingDrawing" xmlns:wp14="http://schemas.microsoft.com/office/word/2010/wordprocessingDrawing" xmlns:mc="http://schemas.openxmlformats.org/markup-compatibility/2006" xmlns:sl="http://schemas.openxmlformats.org/schemaLibrary/2006/main" xmlns:wne="http://schemas.microsoft.com/office/word/2006/wordml" xmlns:cdr="http://schemas.openxmlformats.org/drawingml/2006/chartDrawing" xmlns:c14="http://schemas.microsoft.com/office/drawing/2007/8/2/chart" xmlns:dgm="http://schemas.openxmlformats.org/drawingml/2006/diagram" xmlns:pic="http://schemas.openxmlformats.org/drawingml/2006/picture" xmlns:xdr="http://schemas.openxmlformats.org/drawingml/2006/spreadsheetDrawing" xmlns:dsp="http://schemas.microsoft.com/office/drawing/2008/diagram" xmlns:xvml="urn:schemas-microsoft-com:office:excel" xmlns:o="urn:schemas-microsoft-com:office:office" xmlns:v="urn:schemas-microsoft-com:vml" xmlns:w10="urn:schemas-microsoft-com:office:word" xmlns:pvml="urn:schemas-microsoft-com:office:powerpoint" xmlns:cppr="http://schemas.microsoft.com/office/2006/coverPageProps" xmlns:odx="http://opendope.org/xpaths" xmlns:odc="http://opendope.org/conditions" xmlns:odq="http://opendope.org/questions" xmlns:oda="http://opendope.org/answers" xmlns:odi="http://opendope.org/components" xmlns:odgm="http://opendope.org/SmartArt/DataHierarchy" xmlns:b="http://schemas.openxmlformats.org/officeDocument/2006/bibliography" xmlns:wps="http://schemas.microsoft.com/office/word/2010/wordprocessingShape" xmlns:w16se="http://schemas.microsoft.com/office/word/2015/wordml/symex" xmlns:w16cid="http://schemas.microsoft.com/office/word/2016/wordml/cid" xmlns:wetp="http://schemas.microsoft.com/office/webextensions/taskpanes/2010/11" xmlns:we="http://schemas.microsoft.com/office/webextensions/webextension/2010/11" xmlns:comp="http://schemas.openxmlformats.org/drawingml/2006/compatibility" xmlns:lc="http://schemas.openxmlformats.org/drawingml/2006/lockedCanvas">
               <c:ext xmlns:c16="http://schemas.microsoft.com/office/drawing/2014/chart" uri="{C3380CC4-5D6E-409C-BE32-E72D297353CC}">
                 <c16:uniqueId val="{00000001-6147-E74A-AA7B-5531F0E4EE0C}"/>
               </c:ext>
@@ -4689,7 +4690,7 @@
               </c:numCache>
             </c:numRef>
           </c:val>
-          <c:extLst xmlns:lc="http://schemas.openxmlformats.org/drawingml/2006/lockedCanvas" xmlns:comp="http://schemas.openxmlformats.org/drawingml/2006/compatibility" xmlns:we="http://schemas.microsoft.com/office/webextensions/webextension/2010/11" xmlns:wetp="http://schemas.microsoft.com/office/webextensions/taskpanes/2010/11" xmlns:w16cid="http://schemas.microsoft.com/office/word/2016/wordml/cid" xmlns:w16se="http://schemas.microsoft.com/office/word/2015/wordml/symex" xmlns:wps="http://schemas.microsoft.com/office/word/2010/wordprocessingShape" xmlns:b="http://schemas.openxmlformats.org/officeDocument/2006/bibliography" xmlns:odgm="http://opendope.org/SmartArt/DataHierarchy" xmlns:odi="http://opendope.org/components" xmlns:oda="http://opendope.org/answers" xmlns:odq="http://opendope.org/questions" xmlns:odc="http://opendope.org/conditions" xmlns:odx="http://opendope.org/xpaths" xmlns:cppr="http://schemas.microsoft.com/office/2006/coverPageProps" xmlns:pvml="urn:schemas-microsoft-com:office:powerpoint" xmlns:w10="urn:schemas-microsoft-com:office:word" xmlns:v="urn:schemas-microsoft-com:vml" xmlns:o="urn:schemas-microsoft-com:office:office" xmlns:xvml="urn:schemas-microsoft-com:office:excel" xmlns:dsp="http://schemas.microsoft.com/office/drawing/2008/diagram" xmlns:xdr="http://schemas.openxmlformats.org/drawingml/2006/spreadsheetDrawing" xmlns:pic="http://schemas.openxmlformats.org/drawingml/2006/picture" xmlns:dgm="http://schemas.openxmlformats.org/drawingml/2006/diagram" xmlns:c14="http://schemas.microsoft.com/office/drawing/2007/8/2/chart" xmlns:cdr="http://schemas.openxmlformats.org/drawingml/2006/chartDrawing" xmlns:wne="http://schemas.microsoft.com/office/word/2006/wordml" xmlns:sl="http://schemas.openxmlformats.org/schemaLibrary/2006/main" xmlns:mc="http://schemas.openxmlformats.org/markup-compatibility/2006" xmlns:wp14="http://schemas.microsoft.com/office/word/2010/wordprocessingDrawing" xmlns:wp="http://schemas.openxmlformats.org/drawingml/2006/wordprocessingDrawing" xmlns:m="http://schemas.openxmlformats.org/officeDocument/2006/math" xmlns:w14="http://schemas.microsoft.com/office/word/2010/wordml" xmlns:w15="http://schemas.microsoft.com/office/word/2012/wordml" xmlns:w="http://schemas.openxmlformats.org/wordprocessingml/2006/main">
+          <c:extLst xmlns:w="http://schemas.openxmlformats.org/wordprocessingml/2006/main" xmlns:w15="http://schemas.microsoft.com/office/word/2012/wordml" xmlns:w14="http://schemas.microsoft.com/office/word/2010/wordml" xmlns:m="http://schemas.openxmlformats.org/officeDocument/2006/math" xmlns:wp="http://schemas.openxmlformats.org/drawingml/2006/wordprocessingDrawing" xmlns:wp14="http://schemas.microsoft.com/office/word/2010/wordprocessingDrawing" xmlns:mc="http://schemas.openxmlformats.org/markup-compatibility/2006" xmlns:sl="http://schemas.openxmlformats.org/schemaLibrary/2006/main" xmlns:wne="http://schemas.microsoft.com/office/word/2006/wordml" xmlns:cdr="http://schemas.openxmlformats.org/drawingml/2006/chartDrawing" xmlns:c14="http://schemas.microsoft.com/office/drawing/2007/8/2/chart" xmlns:dgm="http://schemas.openxmlformats.org/drawingml/2006/diagram" xmlns:pic="http://schemas.openxmlformats.org/drawingml/2006/picture" xmlns:xdr="http://schemas.openxmlformats.org/drawingml/2006/spreadsheetDrawing" xmlns:dsp="http://schemas.microsoft.com/office/drawing/2008/diagram" xmlns:xvml="urn:schemas-microsoft-com:office:excel" xmlns:o="urn:schemas-microsoft-com:office:office" xmlns:v="urn:schemas-microsoft-com:vml" xmlns:w10="urn:schemas-microsoft-com:office:word" xmlns:pvml="urn:schemas-microsoft-com:office:powerpoint" xmlns:cppr="http://schemas.microsoft.com/office/2006/coverPageProps" xmlns:odx="http://opendope.org/xpaths" xmlns:odc="http://opendope.org/conditions" xmlns:odq="http://opendope.org/questions" xmlns:oda="http://opendope.org/answers" xmlns:odi="http://opendope.org/components" xmlns:odgm="http://opendope.org/SmartArt/DataHierarchy" xmlns:b="http://schemas.openxmlformats.org/officeDocument/2006/bibliography" xmlns:wps="http://schemas.microsoft.com/office/word/2010/wordprocessingShape" xmlns:w16se="http://schemas.microsoft.com/office/word/2015/wordml/symex" xmlns:w16cid="http://schemas.microsoft.com/office/word/2016/wordml/cid" xmlns:wetp="http://schemas.microsoft.com/office/webextensions/taskpanes/2010/11" xmlns:we="http://schemas.microsoft.com/office/webextensions/webextension/2010/11" xmlns:comp="http://schemas.openxmlformats.org/drawingml/2006/compatibility" xmlns:lc="http://schemas.openxmlformats.org/drawingml/2006/lockedCanvas">
             <c:ext xmlns:c16="http://schemas.microsoft.com/office/drawing/2014/chart" uri="{C3380CC4-5D6E-409C-BE32-E72D297353CC}">
               <c16:uniqueId val="{00000002-6147-E74A-AA7B-5531F0E4EE0C}"/>
             </c:ext>
@@ -5299,7 +5300,7 @@
     </c:plotArea>
     <c:plotVisOnly val="1"/>
     <c:dispBlanksAs val="gap"/>
-    <c:extLst xmlns:lc="http://schemas.openxmlformats.org/drawingml/2006/lockedCanvas" xmlns:comp="http://schemas.openxmlformats.org/drawingml/2006/compatibility" xmlns:we="http://schemas.microsoft.com/office/webextensions/webextension/2010/11" xmlns:wetp="http://schemas.microsoft.com/office/webextensions/taskpanes/2010/11" xmlns:w16cid="http://schemas.microsoft.com/office/word/2016/wordml/cid" xmlns:w16se="http://schemas.microsoft.com/office/word/2015/wordml/symex" xmlns:wps="http://schemas.microsoft.com/office/word/2010/wordprocessingShape" xmlns:b="http://schemas.openxmlformats.org/officeDocument/2006/bibliography" xmlns:odgm="http://opendope.org/SmartArt/DataHierarchy" xmlns:odi="http://opendope.org/components" xmlns:oda="http://opendope.org/answers" xmlns:odq="http://opendope.org/questions" xmlns:odc="http://opendope.org/conditions" xmlns:odx="http://opendope.org/xpaths" xmlns:cppr="http://schemas.microsoft.com/office/2006/coverPageProps" xmlns:pvml="urn:schemas-microsoft-com:office:powerpoint" xmlns:w10="urn:schemas-microsoft-com:office:word" xmlns:v="urn:schemas-microsoft-com:vml" xmlns:o="urn:schemas-microsoft-com:office:office" xmlns:xvml="urn:schemas-microsoft-com:office:excel" xmlns:dsp="http://schemas.microsoft.com/office/drawing/2008/diagram" xmlns:xdr="http://schemas.openxmlformats.org/drawingml/2006/spreadsheetDrawing" xmlns:pic="http://schemas.openxmlformats.org/drawingml/2006/picture" xmlns:dgm="http://schemas.openxmlformats.org/drawingml/2006/diagram" xmlns:c14="http://schemas.microsoft.com/office/drawing/2007/8/2/chart" xmlns:cdr="http://schemas.openxmlformats.org/drawingml/2006/chartDrawing" xmlns:wne="http://schemas.microsoft.com/office/word/2006/wordml" xmlns:sl="http://schemas.openxmlformats.org/schemaLibrary/2006/main" xmlns:mc="http://schemas.openxmlformats.org/markup-compatibility/2006" xmlns:wp14="http://schemas.microsoft.com/office/word/2010/wordprocessingDrawing" xmlns:wp="http://schemas.openxmlformats.org/drawingml/2006/wordprocessingDrawing" xmlns:m="http://schemas.openxmlformats.org/officeDocument/2006/math" xmlns:w14="http://schemas.microsoft.com/office/word/2010/wordml" xmlns:w15="http://schemas.microsoft.com/office/word/2012/wordml" xmlns:w="http://schemas.openxmlformats.org/wordprocessingml/2006/main">
+    <c:extLst xmlns:w="http://schemas.openxmlformats.org/wordprocessingml/2006/main" xmlns:w15="http://schemas.microsoft.com/office/word/2012/wordml" xmlns:w14="http://schemas.microsoft.com/office/word/2010/wordml" xmlns:m="http://schemas.openxmlformats.org/officeDocument/2006/math" xmlns:wp="http://schemas.openxmlformats.org/drawingml/2006/wordprocessingDrawing" xmlns:wp14="http://schemas.microsoft.com/office/word/2010/wordprocessingDrawing" xmlns:mc="http://schemas.openxmlformats.org/markup-compatibility/2006" xmlns:sl="http://schemas.openxmlformats.org/schemaLibrary/2006/main" xmlns:wne="http://schemas.microsoft.com/office/word/2006/wordml" xmlns:cdr="http://schemas.openxmlformats.org/drawingml/2006/chartDrawing" xmlns:c14="http://schemas.microsoft.com/office/drawing/2007/8/2/chart" xmlns:dgm="http://schemas.openxmlformats.org/drawingml/2006/diagram" xmlns:pic="http://schemas.openxmlformats.org/drawingml/2006/picture" xmlns:xdr="http://schemas.openxmlformats.org/drawingml/2006/spreadsheetDrawing" xmlns:dsp="http://schemas.microsoft.com/office/drawing/2008/diagram" xmlns:xvml="urn:schemas-microsoft-com:office:excel" xmlns:o="urn:schemas-microsoft-com:office:office" xmlns:v="urn:schemas-microsoft-com:vml" xmlns:w10="urn:schemas-microsoft-com:office:word" xmlns:pvml="urn:schemas-microsoft-com:office:powerpoint" xmlns:cppr="http://schemas.microsoft.com/office/2006/coverPageProps" xmlns:odx="http://opendope.org/xpaths" xmlns:odc="http://opendope.org/conditions" xmlns:odq="http://opendope.org/questions" xmlns:oda="http://opendope.org/answers" xmlns:odi="http://opendope.org/components" xmlns:odgm="http://opendope.org/SmartArt/DataHierarchy" xmlns:b="http://schemas.openxmlformats.org/officeDocument/2006/bibliography" xmlns:wps="http://schemas.microsoft.com/office/word/2010/wordprocessingShape" xmlns:w16se="http://schemas.microsoft.com/office/word/2015/wordml/symex" xmlns:w16cid="http://schemas.microsoft.com/office/word/2016/wordml/cid" xmlns:wetp="http://schemas.microsoft.com/office/webextensions/taskpanes/2010/11" xmlns:we="http://schemas.microsoft.com/office/webextensions/webextension/2010/11" xmlns:comp="http://schemas.openxmlformats.org/drawingml/2006/compatibility" xmlns:lc="http://schemas.openxmlformats.org/drawingml/2006/lockedCanvas">
       <c:ext xmlns:c16r3="http://schemas.microsoft.com/office/drawing/2017/03/chart" uri="{56B9EC1D-385E-4148-901F-78D8002777C0}">
         <c16r3:dataDisplayOptions16>
           <c16r3:dispNaAsBlank val="1"/>
@@ -5402,7 +5403,7 @@
                 </a:outerShdw>
               </a:effectLst>
             </c:spPr>
-            <c:extLst xmlns:lc="http://schemas.openxmlformats.org/drawingml/2006/lockedCanvas" xmlns:comp="http://schemas.openxmlformats.org/drawingml/2006/compatibility" xmlns:we="http://schemas.microsoft.com/office/webextensions/webextension/2010/11" xmlns:wetp="http://schemas.microsoft.com/office/webextensions/taskpanes/2010/11" xmlns:w16cid="http://schemas.microsoft.com/office/word/2016/wordml/cid" xmlns:w16se="http://schemas.microsoft.com/office/word/2015/wordml/symex" xmlns:wps="http://schemas.microsoft.com/office/word/2010/wordprocessingShape" xmlns:b="http://schemas.openxmlformats.org/officeDocument/2006/bibliography" xmlns:odgm="http://opendope.org/SmartArt/DataHierarchy" xmlns:odi="http://opendope.org/components" xmlns:oda="http://opendope.org/answers" xmlns:odq="http://opendope.org/questions" xmlns:odc="http://opendope.org/conditions" xmlns:odx="http://opendope.org/xpaths" xmlns:cppr="http://schemas.microsoft.com/office/2006/coverPageProps" xmlns:pvml="urn:schemas-microsoft-com:office:powerpoint" xmlns:w10="urn:schemas-microsoft-com:office:word" xmlns:v="urn:schemas-microsoft-com:vml" xmlns:o="urn:schemas-microsoft-com:office:office" xmlns:xvml="urn:schemas-microsoft-com:office:excel" xmlns:dsp="http://schemas.microsoft.com/office/drawing/2008/diagram" xmlns:xdr="http://schemas.openxmlformats.org/drawingml/2006/spreadsheetDrawing" xmlns:pic="http://schemas.openxmlformats.org/drawingml/2006/picture" xmlns:dgm="http://schemas.openxmlformats.org/drawingml/2006/diagram" xmlns:c14="http://schemas.microsoft.com/office/drawing/2007/8/2/chart" xmlns:cdr="http://schemas.openxmlformats.org/drawingml/2006/chartDrawing" xmlns:wne="http://schemas.microsoft.com/office/word/2006/wordml" xmlns:sl="http://schemas.openxmlformats.org/schemaLibrary/2006/main" xmlns:mc="http://schemas.openxmlformats.org/markup-compatibility/2006" xmlns:wp14="http://schemas.microsoft.com/office/word/2010/wordprocessingDrawing" xmlns:wp="http://schemas.openxmlformats.org/drawingml/2006/wordprocessingDrawing" xmlns:m="http://schemas.openxmlformats.org/officeDocument/2006/math" xmlns:w14="http://schemas.microsoft.com/office/word/2010/wordml" xmlns:w15="http://schemas.microsoft.com/office/word/2012/wordml" xmlns:w="http://schemas.openxmlformats.org/wordprocessingml/2006/main">
+            <c:extLst xmlns:w="http://schemas.openxmlformats.org/wordprocessingml/2006/main" xmlns:w15="http://schemas.microsoft.com/office/word/2012/wordml" xmlns:w14="http://schemas.microsoft.com/office/word/2010/wordml" xmlns:m="http://schemas.openxmlformats.org/officeDocument/2006/math" xmlns:wp="http://schemas.openxmlformats.org/drawingml/2006/wordprocessingDrawing" xmlns:wp14="http://schemas.microsoft.com/office/word/2010/wordprocessingDrawing" xmlns:mc="http://schemas.openxmlformats.org/markup-compatibility/2006" xmlns:sl="http://schemas.openxmlformats.org/schemaLibrary/2006/main" xmlns:wne="http://schemas.microsoft.com/office/word/2006/wordml" xmlns:cdr="http://schemas.openxmlformats.org/drawingml/2006/chartDrawing" xmlns:c14="http://schemas.microsoft.com/office/drawing/2007/8/2/chart" xmlns:dgm="http://schemas.openxmlformats.org/drawingml/2006/diagram" xmlns:pic="http://schemas.openxmlformats.org/drawingml/2006/picture" xmlns:xdr="http://schemas.openxmlformats.org/drawingml/2006/spreadsheetDrawing" xmlns:dsp="http://schemas.microsoft.com/office/drawing/2008/diagram" xmlns:xvml="urn:schemas-microsoft-com:office:excel" xmlns:o="urn:schemas-microsoft-com:office:office" xmlns:v="urn:schemas-microsoft-com:vml" xmlns:w10="urn:schemas-microsoft-com:office:word" xmlns:pvml="urn:schemas-microsoft-com:office:powerpoint" xmlns:cppr="http://schemas.microsoft.com/office/2006/coverPageProps" xmlns:odx="http://opendope.org/xpaths" xmlns:odc="http://opendope.org/conditions" xmlns:odq="http://opendope.org/questions" xmlns:oda="http://opendope.org/answers" xmlns:odi="http://opendope.org/components" xmlns:odgm="http://opendope.org/SmartArt/DataHierarchy" xmlns:b="http://schemas.openxmlformats.org/officeDocument/2006/bibliography" xmlns:wps="http://schemas.microsoft.com/office/word/2010/wordprocessingShape" xmlns:w16se="http://schemas.microsoft.com/office/word/2015/wordml/symex" xmlns:w16cid="http://schemas.microsoft.com/office/word/2016/wordml/cid" xmlns:wetp="http://schemas.microsoft.com/office/webextensions/taskpanes/2010/11" xmlns:we="http://schemas.microsoft.com/office/webextensions/webextension/2010/11" xmlns:comp="http://schemas.openxmlformats.org/drawingml/2006/compatibility" xmlns:lc="http://schemas.openxmlformats.org/drawingml/2006/lockedCanvas">
               <c:ext xmlns:c16="http://schemas.microsoft.com/office/drawing/2014/chart" uri="{C3380CC4-5D6E-409C-BE32-E72D297353CC}">
                 <c16:uniqueId val="{00000001-6147-E74A-AA7B-5531F0E4EE0C}"/>
               </c:ext>
@@ -5497,7 +5498,7 @@
               </c:numCache>
             </c:numRef>
           </c:val>
-          <c:extLst xmlns:lc="http://schemas.openxmlformats.org/drawingml/2006/lockedCanvas" xmlns:comp="http://schemas.openxmlformats.org/drawingml/2006/compatibility" xmlns:we="http://schemas.microsoft.com/office/webextensions/webextension/2010/11" xmlns:wetp="http://schemas.microsoft.com/office/webextensions/taskpanes/2010/11" xmlns:w16cid="http://schemas.microsoft.com/office/word/2016/wordml/cid" xmlns:w16se="http://schemas.microsoft.com/office/word/2015/wordml/symex" xmlns:wps="http://schemas.microsoft.com/office/word/2010/wordprocessingShape" xmlns:b="http://schemas.openxmlformats.org/officeDocument/2006/bibliography" xmlns:odgm="http://opendope.org/SmartArt/DataHierarchy" xmlns:odi="http://opendope.org/components" xmlns:oda="http://opendope.org/answers" xmlns:odq="http://opendope.org/questions" xmlns:odc="http://opendope.org/conditions" xmlns:odx="http://opendope.org/xpaths" xmlns:cppr="http://schemas.microsoft.com/office/2006/coverPageProps" xmlns:pvml="urn:schemas-microsoft-com:office:powerpoint" xmlns:w10="urn:schemas-microsoft-com:office:word" xmlns:v="urn:schemas-microsoft-com:vml" xmlns:o="urn:schemas-microsoft-com:office:office" xmlns:xvml="urn:schemas-microsoft-com:office:excel" xmlns:dsp="http://schemas.microsoft.com/office/drawing/2008/diagram" xmlns:xdr="http://schemas.openxmlformats.org/drawingml/2006/spreadsheetDrawing" xmlns:pic="http://schemas.openxmlformats.org/drawingml/2006/picture" xmlns:dgm="http://schemas.openxmlformats.org/drawingml/2006/diagram" xmlns:c14="http://schemas.microsoft.com/office/drawing/2007/8/2/chart" xmlns:cdr="http://schemas.openxmlformats.org/drawingml/2006/chartDrawing" xmlns:wne="http://schemas.microsoft.com/office/word/2006/wordml" xmlns:sl="http://schemas.openxmlformats.org/schemaLibrary/2006/main" xmlns:mc="http://schemas.openxmlformats.org/markup-compatibility/2006" xmlns:wp14="http://schemas.microsoft.com/office/word/2010/wordprocessingDrawing" xmlns:wp="http://schemas.openxmlformats.org/drawingml/2006/wordprocessingDrawing" xmlns:m="http://schemas.openxmlformats.org/officeDocument/2006/math" xmlns:w14="http://schemas.microsoft.com/office/word/2010/wordml" xmlns:w15="http://schemas.microsoft.com/office/word/2012/wordml" xmlns:w="http://schemas.openxmlformats.org/wordprocessingml/2006/main">
+          <c:extLst xmlns:w="http://schemas.openxmlformats.org/wordprocessingml/2006/main" xmlns:w15="http://schemas.microsoft.com/office/word/2012/wordml" xmlns:w14="http://schemas.microsoft.com/office/word/2010/wordml" xmlns:m="http://schemas.openxmlformats.org/officeDocument/2006/math" xmlns:wp="http://schemas.openxmlformats.org/drawingml/2006/wordprocessingDrawing" xmlns:wp14="http://schemas.microsoft.com/office/word/2010/wordprocessingDrawing" xmlns:mc="http://schemas.openxmlformats.org/markup-compatibility/2006" xmlns:sl="http://schemas.openxmlformats.org/schemaLibrary/2006/main" xmlns:wne="http://schemas.microsoft.com/office/word/2006/wordml" xmlns:cdr="http://schemas.openxmlformats.org/drawingml/2006/chartDrawing" xmlns:c14="http://schemas.microsoft.com/office/drawing/2007/8/2/chart" xmlns:dgm="http://schemas.openxmlformats.org/drawingml/2006/diagram" xmlns:pic="http://schemas.openxmlformats.org/drawingml/2006/picture" xmlns:xdr="http://schemas.openxmlformats.org/drawingml/2006/spreadsheetDrawing" xmlns:dsp="http://schemas.microsoft.com/office/drawing/2008/diagram" xmlns:xvml="urn:schemas-microsoft-com:office:excel" xmlns:o="urn:schemas-microsoft-com:office:office" xmlns:v="urn:schemas-microsoft-com:vml" xmlns:w10="urn:schemas-microsoft-com:office:word" xmlns:pvml="urn:schemas-microsoft-com:office:powerpoint" xmlns:cppr="http://schemas.microsoft.com/office/2006/coverPageProps" xmlns:odx="http://opendope.org/xpaths" xmlns:odc="http://opendope.org/conditions" xmlns:odq="http://opendope.org/questions" xmlns:oda="http://opendope.org/answers" xmlns:odi="http://opendope.org/components" xmlns:odgm="http://opendope.org/SmartArt/DataHierarchy" xmlns:b="http://schemas.openxmlformats.org/officeDocument/2006/bibliography" xmlns:wps="http://schemas.microsoft.com/office/word/2010/wordprocessingShape" xmlns:w16se="http://schemas.microsoft.com/office/word/2015/wordml/symex" xmlns:w16cid="http://schemas.microsoft.com/office/word/2016/wordml/cid" xmlns:wetp="http://schemas.microsoft.com/office/webextensions/taskpanes/2010/11" xmlns:we="http://schemas.microsoft.com/office/webextensions/webextension/2010/11" xmlns:comp="http://schemas.openxmlformats.org/drawingml/2006/compatibility" xmlns:lc="http://schemas.openxmlformats.org/drawingml/2006/lockedCanvas">
             <c:ext xmlns:c16="http://schemas.microsoft.com/office/drawing/2014/chart" uri="{C3380CC4-5D6E-409C-BE32-E72D297353CC}">
               <c16:uniqueId val="{00000002-6147-E74A-AA7B-5531F0E4EE0C}"/>
             </c:ext>
@@ -6107,7 +6108,7 @@
     </c:plotArea>
     <c:plotVisOnly val="1"/>
     <c:dispBlanksAs val="gap"/>
-    <c:extLst xmlns:lc="http://schemas.openxmlformats.org/drawingml/2006/lockedCanvas" xmlns:comp="http://schemas.openxmlformats.org/drawingml/2006/compatibility" xmlns:we="http://schemas.microsoft.com/office/webextensions/webextension/2010/11" xmlns:wetp="http://schemas.microsoft.com/office/webextensions/taskpanes/2010/11" xmlns:w16cid="http://schemas.microsoft.com/office/word/2016/wordml/cid" xmlns:w16se="http://schemas.microsoft.com/office/word/2015/wordml/symex" xmlns:wps="http://schemas.microsoft.com/office/word/2010/wordprocessingShape" xmlns:b="http://schemas.openxmlformats.org/officeDocument/2006/bibliography" xmlns:odgm="http://opendope.org/SmartArt/DataHierarchy" xmlns:odi="http://opendope.org/components" xmlns:oda="http://opendope.org/answers" xmlns:odq="http://opendope.org/questions" xmlns:odc="http://opendope.org/conditions" xmlns:odx="http://opendope.org/xpaths" xmlns:cppr="http://schemas.microsoft.com/office/2006/coverPageProps" xmlns:pvml="urn:schemas-microsoft-com:office:powerpoint" xmlns:w10="urn:schemas-microsoft-com:office:word" xmlns:v="urn:schemas-microsoft-com:vml" xmlns:o="urn:schemas-microsoft-com:office:office" xmlns:xvml="urn:schemas-microsoft-com:office:excel" xmlns:dsp="http://schemas.microsoft.com/office/drawing/2008/diagram" xmlns:xdr="http://schemas.openxmlformats.org/drawingml/2006/spreadsheetDrawing" xmlns:pic="http://schemas.openxmlformats.org/drawingml/2006/picture" xmlns:dgm="http://schemas.openxmlformats.org/drawingml/2006/diagram" xmlns:c14="http://schemas.microsoft.com/office/drawing/2007/8/2/chart" xmlns:cdr="http://schemas.openxmlformats.org/drawingml/2006/chartDrawing" xmlns:wne="http://schemas.microsoft.com/office/word/2006/wordml" xmlns:sl="http://schemas.openxmlformats.org/schemaLibrary/2006/main" xmlns:mc="http://schemas.openxmlformats.org/markup-compatibility/2006" xmlns:wp14="http://schemas.microsoft.com/office/word/2010/wordprocessingDrawing" xmlns:wp="http://schemas.openxmlformats.org/drawingml/2006/wordprocessingDrawing" xmlns:m="http://schemas.openxmlformats.org/officeDocument/2006/math" xmlns:w14="http://schemas.microsoft.com/office/word/2010/wordml" xmlns:w15="http://schemas.microsoft.com/office/word/2012/wordml" xmlns:w="http://schemas.openxmlformats.org/wordprocessingml/2006/main">
+    <c:extLst xmlns:w="http://schemas.openxmlformats.org/wordprocessingml/2006/main" xmlns:w15="http://schemas.microsoft.com/office/word/2012/wordml" xmlns:w14="http://schemas.microsoft.com/office/word/2010/wordml" xmlns:m="http://schemas.openxmlformats.org/officeDocument/2006/math" xmlns:wp="http://schemas.openxmlformats.org/drawingml/2006/wordprocessingDrawing" xmlns:wp14="http://schemas.microsoft.com/office/word/2010/wordprocessingDrawing" xmlns:mc="http://schemas.openxmlformats.org/markup-compatibility/2006" xmlns:sl="http://schemas.openxmlformats.org/schemaLibrary/2006/main" xmlns:wne="http://schemas.microsoft.com/office/word/2006/wordml" xmlns:cdr="http://schemas.openxmlformats.org/drawingml/2006/chartDrawing" xmlns:c14="http://schemas.microsoft.com/office/drawing/2007/8/2/chart" xmlns:dgm="http://schemas.openxmlformats.org/drawingml/2006/diagram" xmlns:pic="http://schemas.openxmlformats.org/drawingml/2006/picture" xmlns:xdr="http://schemas.openxmlformats.org/drawingml/2006/spreadsheetDrawing" xmlns:dsp="http://schemas.microsoft.com/office/drawing/2008/diagram" xmlns:xvml="urn:schemas-microsoft-com:office:excel" xmlns:o="urn:schemas-microsoft-com:office:office" xmlns:v="urn:schemas-microsoft-com:vml" xmlns:w10="urn:schemas-microsoft-com:office:word" xmlns:pvml="urn:schemas-microsoft-com:office:powerpoint" xmlns:cppr="http://schemas.microsoft.com/office/2006/coverPageProps" xmlns:odx="http://opendope.org/xpaths" xmlns:odc="http://opendope.org/conditions" xmlns:odq="http://opendope.org/questions" xmlns:oda="http://opendope.org/answers" xmlns:odi="http://opendope.org/components" xmlns:odgm="http://opendope.org/SmartArt/DataHierarchy" xmlns:b="http://schemas.openxmlformats.org/officeDocument/2006/bibliography" xmlns:wps="http://schemas.microsoft.com/office/word/2010/wordprocessingShape" xmlns:w16se="http://schemas.microsoft.com/office/word/2015/wordml/symex" xmlns:w16cid="http://schemas.microsoft.com/office/word/2016/wordml/cid" xmlns:wetp="http://schemas.microsoft.com/office/webextensions/taskpanes/2010/11" xmlns:we="http://schemas.microsoft.com/office/webextensions/webextension/2010/11" xmlns:comp="http://schemas.openxmlformats.org/drawingml/2006/compatibility" xmlns:lc="http://schemas.openxmlformats.org/drawingml/2006/lockedCanvas">
       <c:ext xmlns:c16r3="http://schemas.microsoft.com/office/drawing/2017/03/chart" uri="{56B9EC1D-385E-4148-901F-78D8002777C0}">
         <c16r3:dataDisplayOptions16>
           <c16r3:dispNaAsBlank val="1"/>
@@ -35668,6 +35669,2781 @@
         <p:cNvPr id="1" name="">
           <a:extLst>
             <a:ext uri="{FF2B5EF4-FFF2-40B4-BE49-F238E27FC236}">
+              <a16:creationId xmlns:a16="http://schemas.microsoft.com/office/drawing/2014/main" id="{C876FA4F-56E0-38D4-2ADF-7F5EB3DFFC86}"/>
+            </a:ext>
+          </a:extLst>
+        </p:cNvPr>
+        <p:cNvGrpSpPr/>
+        <p:nvPr/>
+      </p:nvGrpSpPr>
+      <p:grpSpPr>
+        <a:xfrm>
+          <a:off x="0" y="0"/>
+          <a:ext cx="0" cy="0"/>
+          <a:chOff x="0" y="0"/>
+          <a:chExt cx="0" cy="0"/>
+        </a:xfrm>
+      </p:grpSpPr>
+      <p:sp>
+        <p:nvSpPr>
+          <p:cNvPr id="17" name="Rectangle 16">
+            <a:extLst>
+              <a:ext uri="{FF2B5EF4-FFF2-40B4-BE49-F238E27FC236}">
+                <a16:creationId xmlns:a16="http://schemas.microsoft.com/office/drawing/2014/main" id="{1FAB8F07-6D4B-916A-C1E3-E7E3096D579E}"/>
+              </a:ext>
+            </a:extLst>
+          </p:cNvPr>
+          <p:cNvSpPr/>
+          <p:nvPr/>
+        </p:nvSpPr>
+        <p:spPr>
+          <a:xfrm flipH="1">
+            <a:off x="0" y="1368000"/>
+            <a:ext cx="12192000" cy="1658842"/>
+          </a:xfrm>
+          <a:prstGeom prst="rect">
+            <a:avLst/>
+          </a:prstGeom>
+          <a:gradFill>
+            <a:gsLst>
+              <a:gs pos="0">
+                <a:schemeClr val="bg1"/>
+              </a:gs>
+              <a:gs pos="100000">
+                <a:schemeClr val="bg2"/>
+              </a:gs>
+            </a:gsLst>
+            <a:lin ang="2700000" scaled="0"/>
+          </a:gradFill>
+          <a:ln>
+            <a:noFill/>
+          </a:ln>
+          <a:effectLst>
+            <a:outerShdw blurRad="190500" dist="38100" dir="2700000" algn="tl" rotWithShape="0">
+              <a:prstClr val="black">
+                <a:alpha val="15000"/>
+              </a:prstClr>
+            </a:outerShdw>
+          </a:effectLst>
+        </p:spPr>
+        <p:style>
+          <a:lnRef idx="2">
+            <a:schemeClr val="accent1">
+              <a:shade val="50000"/>
+            </a:schemeClr>
+          </a:lnRef>
+          <a:fillRef idx="1">
+            <a:schemeClr val="accent1"/>
+          </a:fillRef>
+          <a:effectRef idx="0">
+            <a:schemeClr val="accent1"/>
+          </a:effectRef>
+          <a:fontRef idx="minor">
+            <a:schemeClr val="lt1"/>
+          </a:fontRef>
+        </p:style>
+        <p:txBody>
+          <a:bodyPr lIns="731520" tIns="72000" rIns="108000" bIns="72000" rtlCol="0" anchor="ctr"/>
+          <a:lstStyle/>
+          <a:p>
+            <a:endParaRPr lang="nl-NL" sz="1200" b="1" noProof="0" dirty="0">
+              <a:solidFill>
+                <a:schemeClr val="accent1"/>
+              </a:solidFill>
+            </a:endParaRPr>
+          </a:p>
+        </p:txBody>
+      </p:sp>
+      <p:sp>
+        <p:nvSpPr>
+          <p:cNvPr id="3" name="Slide Number Placeholder 2">
+            <a:extLst>
+              <a:ext uri="{FF2B5EF4-FFF2-40B4-BE49-F238E27FC236}">
+                <a16:creationId xmlns:a16="http://schemas.microsoft.com/office/drawing/2014/main" id="{76E08F0F-52CE-A816-71D0-86B4FA3FF4C4}"/>
+              </a:ext>
+            </a:extLst>
+          </p:cNvPr>
+          <p:cNvSpPr>
+            <a:spLocks noGrp="1"/>
+          </p:cNvSpPr>
+          <p:nvPr>
+            <p:ph type="sldNum" sz="quarter" idx="4"/>
+          </p:nvPr>
+        </p:nvSpPr>
+        <p:spPr/>
+        <p:txBody>
+          <a:bodyPr/>
+          <a:lstStyle/>
+          <a:p>
+            <a:fld id="{E242BD21-9B61-2246-BCB1-4BE5E1BEBE1C}" type="slidenum">
+              <a:rPr lang="en-US" smtClean="0"/>
+              <a:pPr/>
+              <a:t>14</a:t>
+            </a:fld>
+            <a:endParaRPr lang="en-US"/>
+          </a:p>
+        </p:txBody>
+      </p:sp>
+      <p:sp>
+        <p:nvSpPr>
+          <p:cNvPr id="7" name="Text Placeholder 6">
+            <a:extLst>
+              <a:ext uri="{FF2B5EF4-FFF2-40B4-BE49-F238E27FC236}">
+                <a16:creationId xmlns:a16="http://schemas.microsoft.com/office/drawing/2014/main" id="{A6B193F2-CE7B-FC39-0466-64F32A0539FF}"/>
+              </a:ext>
+            </a:extLst>
+          </p:cNvPr>
+          <p:cNvSpPr>
+            <a:spLocks noGrp="1"/>
+          </p:cNvSpPr>
+          <p:nvPr>
+            <p:ph type="body" sz="quarter" idx="12"/>
+          </p:nvPr>
+        </p:nvSpPr>
+        <p:spPr/>
+        <p:txBody>
+          <a:bodyPr/>
+          <a:lstStyle/>
+          <a:p>
+            <a:r>
+              <a:rPr lang="en-US" dirty="0"/>
+              <a:t>Findings – </a:t>
+            </a:r>
+            <a:r>
+              <a:rPr lang="en-US" dirty="0">
+                <a:solidFill>
+                  <a:schemeClr val="accent3"/>
+                </a:solidFill>
+              </a:rPr>
+              <a:t>Architecture</a:t>
+            </a:r>
+          </a:p>
+        </p:txBody>
+      </p:sp>
+      <p:sp>
+        <p:nvSpPr>
+          <p:cNvPr id="6" name="Title 5">
+            <a:extLst>
+              <a:ext uri="{FF2B5EF4-FFF2-40B4-BE49-F238E27FC236}">
+                <a16:creationId xmlns:a16="http://schemas.microsoft.com/office/drawing/2014/main" id="{3813AE8D-2181-6973-DFF7-DE2DCBC4BB07}"/>
+              </a:ext>
+            </a:extLst>
+          </p:cNvPr>
+          <p:cNvSpPr>
+            <a:spLocks noGrp="1"/>
+          </p:cNvSpPr>
+          <p:nvPr>
+            <p:ph type="title"/>
+          </p:nvPr>
+        </p:nvSpPr>
+        <p:spPr/>
+        <p:txBody>
+          <a:bodyPr/>
+          <a:lstStyle/>
+          <a:p>
+            <a:r>
+              <a:rPr lang="en-US" noProof="0" dirty="0"/>
+              <a:t>@@</a:t>
+            </a:r>
+          </a:p>
+        </p:txBody>
+      </p:sp>
+      <p:sp>
+        <p:nvSpPr>
+          <p:cNvPr id="8" name="Content Placeholder 7">
+            <a:extLst>
+              <a:ext uri="{FF2B5EF4-FFF2-40B4-BE49-F238E27FC236}">
+                <a16:creationId xmlns:a16="http://schemas.microsoft.com/office/drawing/2014/main" id="{0DBED7E5-EA80-DACD-B5DD-5B2AFC67C3AF}"/>
+              </a:ext>
+            </a:extLst>
+          </p:cNvPr>
+          <p:cNvSpPr>
+            <a:spLocks noGrp="1"/>
+          </p:cNvSpPr>
+          <p:nvPr>
+            <p:ph sz="quarter" idx="13"/>
+          </p:nvPr>
+        </p:nvSpPr>
+        <p:spPr>
+          <a:xfrm>
+            <a:off x="514800" y="1368000"/>
+            <a:ext cx="11232000" cy="1658842"/>
+          </a:xfrm>
+        </p:spPr>
+        <p:txBody>
+          <a:bodyPr anchor="ctr"/>
+          <a:lstStyle/>
+          <a:p>
+            <a:pPr marL="0" indent="0">
+              <a:buNone/>
+            </a:pPr>
+            <a:r>
+              <a:rPr lang="en-US" sz="1400" noProof="0" dirty="0"/>
+              <a:t>@@</a:t>
+            </a:r>
+            <a:endParaRPr lang="en-US" sz="1200" noProof="0" dirty="0"/>
+          </a:p>
+        </p:txBody>
+      </p:sp>
+      <p:sp>
+        <p:nvSpPr>
+          <p:cNvPr id="9" name="Rounded Rectangle 8">
+            <a:extLst>
+              <a:ext uri="{FF2B5EF4-FFF2-40B4-BE49-F238E27FC236}">
+                <a16:creationId xmlns:a16="http://schemas.microsoft.com/office/drawing/2014/main" id="{BF0C5160-5E71-1D75-1843-505E782ADE9E}"/>
+              </a:ext>
+            </a:extLst>
+          </p:cNvPr>
+          <p:cNvSpPr/>
+          <p:nvPr/>
+        </p:nvSpPr>
+        <p:spPr>
+          <a:xfrm>
+            <a:off x="-270313" y="3154680"/>
+            <a:ext cx="9725209" cy="3163320"/>
+          </a:xfrm>
+          <a:prstGeom prst="roundRect">
+            <a:avLst>
+              <a:gd name="adj" fmla="val 3161"/>
+            </a:avLst>
+          </a:prstGeom>
+          <a:solidFill>
+            <a:schemeClr val="bg1"/>
+          </a:solidFill>
+          <a:ln>
+            <a:noFill/>
+          </a:ln>
+          <a:effectLst>
+            <a:outerShdw blurRad="190500" dist="38100" dir="2700000" algn="tl" rotWithShape="0">
+              <a:prstClr val="black">
+                <a:alpha val="15000"/>
+              </a:prstClr>
+            </a:outerShdw>
+          </a:effectLst>
+        </p:spPr>
+        <p:style>
+          <a:lnRef idx="2">
+            <a:schemeClr val="accent1">
+              <a:shade val="50000"/>
+            </a:schemeClr>
+          </a:lnRef>
+          <a:fillRef idx="1">
+            <a:schemeClr val="accent1"/>
+          </a:fillRef>
+          <a:effectRef idx="0">
+            <a:schemeClr val="accent1"/>
+          </a:effectRef>
+          <a:fontRef idx="minor">
+            <a:schemeClr val="lt1"/>
+          </a:fontRef>
+        </p:style>
+        <p:txBody>
+          <a:bodyPr lIns="731520" tIns="72000" rIns="108000" bIns="72000" rtlCol="0" anchor="ctr"/>
+          <a:lstStyle/>
+          <a:p>
+            <a:endParaRPr lang="nl-NL" sz="1200" b="1" noProof="0" dirty="0">
+              <a:solidFill>
+                <a:schemeClr val="accent1"/>
+              </a:solidFill>
+            </a:endParaRPr>
+          </a:p>
+        </p:txBody>
+      </p:sp>
+      <p:sp>
+        <p:nvSpPr>
+          <p:cNvPr id="16" name="Rounded Rectangle 15">
+            <a:extLst>
+              <a:ext uri="{FF2B5EF4-FFF2-40B4-BE49-F238E27FC236}">
+                <a16:creationId xmlns:a16="http://schemas.microsoft.com/office/drawing/2014/main" id="{5FD1D7D0-E508-4E54-4F9E-1F87491FCD21}"/>
+              </a:ext>
+            </a:extLst>
+          </p:cNvPr>
+          <p:cNvSpPr/>
+          <p:nvPr/>
+        </p:nvSpPr>
+        <p:spPr>
+          <a:xfrm flipH="1">
+            <a:off x="9619488" y="3154680"/>
+            <a:ext cx="2724912" cy="3163320"/>
+          </a:xfrm>
+          <a:prstGeom prst="roundRect">
+            <a:avLst>
+              <a:gd name="adj" fmla="val 4851"/>
+            </a:avLst>
+          </a:prstGeom>
+          <a:gradFill>
+            <a:gsLst>
+              <a:gs pos="0">
+                <a:schemeClr val="bg1"/>
+              </a:gs>
+              <a:gs pos="100000">
+                <a:schemeClr val="bg2"/>
+              </a:gs>
+            </a:gsLst>
+            <a:lin ang="2700000" scaled="0"/>
+          </a:gradFill>
+          <a:ln>
+            <a:noFill/>
+          </a:ln>
+          <a:effectLst>
+            <a:outerShdw blurRad="190500" dist="38100" dir="2700000" algn="tl" rotWithShape="0">
+              <a:prstClr val="black">
+                <a:alpha val="15000"/>
+              </a:prstClr>
+            </a:outerShdw>
+          </a:effectLst>
+        </p:spPr>
+        <p:style>
+          <a:lnRef idx="2">
+            <a:schemeClr val="accent1">
+              <a:shade val="50000"/>
+            </a:schemeClr>
+          </a:lnRef>
+          <a:fillRef idx="1">
+            <a:schemeClr val="accent1"/>
+          </a:fillRef>
+          <a:effectRef idx="0">
+            <a:schemeClr val="accent1"/>
+          </a:effectRef>
+          <a:fontRef idx="minor">
+            <a:schemeClr val="lt1"/>
+          </a:fontRef>
+        </p:style>
+        <p:txBody>
+          <a:bodyPr lIns="731520" tIns="72000" rIns="108000" bIns="72000" rtlCol="0" anchor="ctr"/>
+          <a:lstStyle/>
+          <a:p>
+            <a:endParaRPr lang="nl-NL" sz="1200" b="1" noProof="0" dirty="0">
+              <a:solidFill>
+                <a:schemeClr val="accent1"/>
+              </a:solidFill>
+            </a:endParaRPr>
+          </a:p>
+        </p:txBody>
+      </p:sp>
+      <p:sp>
+        <p:nvSpPr>
+          <p:cNvPr id="28" name="TextBox 27">
+            <a:extLst>
+              <a:ext uri="{FF2B5EF4-FFF2-40B4-BE49-F238E27FC236}">
+                <a16:creationId xmlns:a16="http://schemas.microsoft.com/office/drawing/2014/main" id="{F8787B23-C3C2-4DC1-FC2E-4E3FDEB0E3DB}"/>
+              </a:ext>
+            </a:extLst>
+          </p:cNvPr>
+          <p:cNvSpPr txBox="1"/>
+          <p:nvPr/>
+        </p:nvSpPr>
+        <p:spPr>
+          <a:xfrm>
+            <a:off x="-1221448" y="4419492"/>
+            <a:ext cx="628847" cy="633443"/>
+          </a:xfrm>
+          <a:prstGeom prst="rect">
+            <a:avLst/>
+          </a:prstGeom>
+          <a:noFill/>
+        </p:spPr>
+        <p:txBody>
+          <a:bodyPr wrap="none" lIns="90000" rtlCol="0" anchor="t">
+            <a:spAutoFit/>
+          </a:bodyPr>
+          <a:lstStyle/>
+          <a:p>
+            <a:pPr algn="l">
+              <a:lnSpc>
+                <a:spcPct val="113000"/>
+              </a:lnSpc>
+            </a:pPr>
+            <a:r>
+              <a:rPr lang="en-US" sz="1600" dirty="0">
+                <a:solidFill>
+                  <a:schemeClr val="tx2"/>
+                </a:solidFill>
+              </a:rPr>
+              <a:t>3.12”</a:t>
+            </a:r>
+          </a:p>
+          <a:p>
+            <a:pPr algn="l">
+              <a:lnSpc>
+                <a:spcPct val="113000"/>
+              </a:lnSpc>
+            </a:pPr>
+            <a:r>
+              <a:rPr lang="en-US" sz="1600" dirty="0">
+                <a:solidFill>
+                  <a:schemeClr val="tx2"/>
+                </a:solidFill>
+              </a:rPr>
+              <a:t>9.57"</a:t>
+            </a:r>
+          </a:p>
+        </p:txBody>
+      </p:sp>
+      <p:sp>
+        <p:nvSpPr>
+          <p:cNvPr id="35" name="Rounded Rectangle 34">
+            <a:extLst>
+              <a:ext uri="{FF2B5EF4-FFF2-40B4-BE49-F238E27FC236}">
+                <a16:creationId xmlns:a16="http://schemas.microsoft.com/office/drawing/2014/main" id="{5D6C4DB3-A694-6654-C46A-6A30201BAC24}"/>
+              </a:ext>
+            </a:extLst>
+          </p:cNvPr>
+          <p:cNvSpPr/>
+          <p:nvPr/>
+        </p:nvSpPr>
+        <p:spPr>
+          <a:xfrm>
+            <a:off x="9777184" y="4883651"/>
+            <a:ext cx="2573808" cy="326727"/>
+          </a:xfrm>
+          <a:prstGeom prst="roundRect">
+            <a:avLst>
+              <a:gd name="adj" fmla="val 31904"/>
+            </a:avLst>
+          </a:prstGeom>
+          <a:gradFill>
+            <a:gsLst>
+              <a:gs pos="0">
+                <a:srgbClr val="57C968"/>
+              </a:gs>
+              <a:gs pos="25000">
+                <a:schemeClr val="bg2"/>
+              </a:gs>
+            </a:gsLst>
+            <a:lin ang="2700000" scaled="0"/>
+          </a:gradFill>
+          <a:ln>
+            <a:noFill/>
+          </a:ln>
+          <a:effectLst>
+            <a:outerShdw blurRad="190500" dist="38100" dir="2700000" algn="tl" rotWithShape="0">
+              <a:prstClr val="black">
+                <a:alpha val="15000"/>
+              </a:prstClr>
+            </a:outerShdw>
+          </a:effectLst>
+        </p:spPr>
+        <p:style>
+          <a:lnRef idx="2">
+            <a:schemeClr val="accent1">
+              <a:shade val="50000"/>
+            </a:schemeClr>
+          </a:lnRef>
+          <a:fillRef idx="1">
+            <a:schemeClr val="accent1"/>
+          </a:fillRef>
+          <a:effectRef idx="0">
+            <a:schemeClr val="accent1"/>
+          </a:effectRef>
+          <a:fontRef idx="minor">
+            <a:schemeClr val="lt1"/>
+          </a:fontRef>
+        </p:style>
+        <p:txBody>
+          <a:bodyPr lIns="109728" tIns="72000" rIns="108000" bIns="72000" rtlCol="0" anchor="ctr"/>
+          <a:lstStyle/>
+          <a:p>
+            <a:r>
+              <a:rPr lang="nl-NL" sz="1000" b="1" noProof="0" dirty="0">
+                <a:solidFill>
+                  <a:schemeClr val="accent1"/>
+                </a:solidFill>
+              </a:rPr>
+              <a:t>@@</a:t>
+            </a:r>
+          </a:p>
+        </p:txBody>
+      </p:sp>
+      <p:sp>
+        <p:nvSpPr>
+          <p:cNvPr id="39" name="Rounded Rectangle 38">
+            <a:extLst>
+              <a:ext uri="{FF2B5EF4-FFF2-40B4-BE49-F238E27FC236}">
+                <a16:creationId xmlns:a16="http://schemas.microsoft.com/office/drawing/2014/main" id="{6DC8341F-BE21-35A0-B63A-B7CAA7D8AA78}"/>
+              </a:ext>
+            </a:extLst>
+          </p:cNvPr>
+          <p:cNvSpPr/>
+          <p:nvPr/>
+        </p:nvSpPr>
+        <p:spPr>
+          <a:xfrm>
+            <a:off x="9777184" y="4464888"/>
+            <a:ext cx="2573808" cy="326727"/>
+          </a:xfrm>
+          <a:prstGeom prst="roundRect">
+            <a:avLst>
+              <a:gd name="adj" fmla="val 31904"/>
+            </a:avLst>
+          </a:prstGeom>
+          <a:gradFill>
+            <a:gsLst>
+              <a:gs pos="0">
+                <a:srgbClr val="57C968"/>
+              </a:gs>
+              <a:gs pos="25000">
+                <a:schemeClr val="bg2"/>
+              </a:gs>
+            </a:gsLst>
+            <a:lin ang="2700000" scaled="0"/>
+          </a:gradFill>
+          <a:ln>
+            <a:noFill/>
+          </a:ln>
+          <a:effectLst>
+            <a:outerShdw blurRad="190500" dist="38100" dir="2700000" algn="tl" rotWithShape="0">
+              <a:prstClr val="black">
+                <a:alpha val="15000"/>
+              </a:prstClr>
+            </a:outerShdw>
+          </a:effectLst>
+        </p:spPr>
+        <p:style>
+          <a:lnRef idx="2">
+            <a:schemeClr val="accent1">
+              <a:shade val="50000"/>
+            </a:schemeClr>
+          </a:lnRef>
+          <a:fillRef idx="1">
+            <a:schemeClr val="accent1"/>
+          </a:fillRef>
+          <a:effectRef idx="0">
+            <a:schemeClr val="accent1"/>
+          </a:effectRef>
+          <a:fontRef idx="minor">
+            <a:schemeClr val="lt1"/>
+          </a:fontRef>
+        </p:style>
+        <p:txBody>
+          <a:bodyPr lIns="109728" tIns="72000" rIns="108000" bIns="72000" rtlCol="0" anchor="ctr"/>
+          <a:lstStyle/>
+          <a:p>
+            <a:r>
+              <a:rPr lang="nl-NL" sz="1000" b="1" noProof="0" dirty="0">
+                <a:solidFill>
+                  <a:schemeClr val="accent1"/>
+                </a:solidFill>
+              </a:rPr>
+              <a:t>@@</a:t>
+            </a:r>
+          </a:p>
+        </p:txBody>
+      </p:sp>
+      <p:sp>
+        <p:nvSpPr>
+          <p:cNvPr id="33" name="Rounded Rectangle 32">
+            <a:extLst>
+              <a:ext uri="{FF2B5EF4-FFF2-40B4-BE49-F238E27FC236}">
+                <a16:creationId xmlns:a16="http://schemas.microsoft.com/office/drawing/2014/main" id="{C7FAE859-4F19-CCAA-8231-8F233ACDBF22}"/>
+              </a:ext>
+            </a:extLst>
+          </p:cNvPr>
+          <p:cNvSpPr/>
+          <p:nvPr/>
+        </p:nvSpPr>
+        <p:spPr>
+          <a:xfrm>
+            <a:off x="9777184" y="4046125"/>
+            <a:ext cx="2573808" cy="326727"/>
+          </a:xfrm>
+          <a:prstGeom prst="roundRect">
+            <a:avLst>
+              <a:gd name="adj" fmla="val 31904"/>
+            </a:avLst>
+          </a:prstGeom>
+          <a:gradFill>
+            <a:gsLst>
+              <a:gs pos="0">
+                <a:srgbClr val="F9C640"/>
+              </a:gs>
+              <a:gs pos="25000">
+                <a:schemeClr val="bg2"/>
+              </a:gs>
+            </a:gsLst>
+            <a:lin ang="2700000" scaled="0"/>
+          </a:gradFill>
+          <a:ln>
+            <a:noFill/>
+          </a:ln>
+          <a:effectLst>
+            <a:outerShdw blurRad="190500" dist="38100" dir="2700000" algn="tl" rotWithShape="0">
+              <a:prstClr val="black">
+                <a:alpha val="15000"/>
+              </a:prstClr>
+            </a:outerShdw>
+          </a:effectLst>
+        </p:spPr>
+        <p:style>
+          <a:lnRef idx="2">
+            <a:schemeClr val="accent1">
+              <a:shade val="50000"/>
+            </a:schemeClr>
+          </a:lnRef>
+          <a:fillRef idx="1">
+            <a:schemeClr val="accent1"/>
+          </a:fillRef>
+          <a:effectRef idx="0">
+            <a:schemeClr val="accent1"/>
+          </a:effectRef>
+          <a:fontRef idx="minor">
+            <a:schemeClr val="lt1"/>
+          </a:fontRef>
+        </p:style>
+        <p:txBody>
+          <a:bodyPr lIns="109728" tIns="72000" rIns="108000" bIns="72000" rtlCol="0" anchor="ctr"/>
+          <a:lstStyle/>
+          <a:p>
+            <a:r>
+              <a:rPr lang="nl-NL" sz="1000" b="1" noProof="0" dirty="0">
+                <a:solidFill>
+                  <a:schemeClr val="accent1"/>
+                </a:solidFill>
+              </a:rPr>
+              <a:t>@@</a:t>
+            </a:r>
+          </a:p>
+        </p:txBody>
+      </p:sp>
+      <p:sp>
+        <p:nvSpPr>
+          <p:cNvPr id="38" name="Rounded Rectangle 37">
+            <a:extLst>
+              <a:ext uri="{FF2B5EF4-FFF2-40B4-BE49-F238E27FC236}">
+                <a16:creationId xmlns:a16="http://schemas.microsoft.com/office/drawing/2014/main" id="{1070C8A8-5F70-7685-B7B9-DECC513B03C7}"/>
+              </a:ext>
+            </a:extLst>
+          </p:cNvPr>
+          <p:cNvSpPr/>
+          <p:nvPr/>
+        </p:nvSpPr>
+        <p:spPr>
+          <a:xfrm>
+            <a:off x="9777184" y="3627362"/>
+            <a:ext cx="2573808" cy="326727"/>
+          </a:xfrm>
+          <a:prstGeom prst="roundRect">
+            <a:avLst>
+              <a:gd name="adj" fmla="val 31904"/>
+            </a:avLst>
+          </a:prstGeom>
+          <a:gradFill>
+            <a:gsLst>
+              <a:gs pos="0">
+                <a:srgbClr val="F9C640"/>
+              </a:gs>
+              <a:gs pos="25000">
+                <a:schemeClr val="bg2"/>
+              </a:gs>
+            </a:gsLst>
+            <a:lin ang="2700000" scaled="0"/>
+          </a:gradFill>
+          <a:ln>
+            <a:noFill/>
+          </a:ln>
+          <a:effectLst>
+            <a:outerShdw blurRad="190500" dist="38100" dir="2700000" algn="tl" rotWithShape="0">
+              <a:prstClr val="black">
+                <a:alpha val="15000"/>
+              </a:prstClr>
+            </a:outerShdw>
+          </a:effectLst>
+        </p:spPr>
+        <p:style>
+          <a:lnRef idx="2">
+            <a:schemeClr val="accent1">
+              <a:shade val="50000"/>
+            </a:schemeClr>
+          </a:lnRef>
+          <a:fillRef idx="1">
+            <a:schemeClr val="accent1"/>
+          </a:fillRef>
+          <a:effectRef idx="0">
+            <a:schemeClr val="accent1"/>
+          </a:effectRef>
+          <a:fontRef idx="minor">
+            <a:schemeClr val="lt1"/>
+          </a:fontRef>
+        </p:style>
+        <p:txBody>
+          <a:bodyPr lIns="109728" tIns="72000" rIns="108000" bIns="72000" rtlCol="0" anchor="ctr"/>
+          <a:lstStyle/>
+          <a:p>
+            <a:r>
+              <a:rPr lang="nl-NL" sz="1000" b="1" noProof="0" dirty="0">
+                <a:solidFill>
+                  <a:schemeClr val="accent1"/>
+                </a:solidFill>
+              </a:rPr>
+              <a:t>@@</a:t>
+            </a:r>
+          </a:p>
+        </p:txBody>
+      </p:sp>
+      <p:sp>
+        <p:nvSpPr>
+          <p:cNvPr id="37" name="Rounded Rectangle 36">
+            <a:extLst>
+              <a:ext uri="{FF2B5EF4-FFF2-40B4-BE49-F238E27FC236}">
+                <a16:creationId xmlns:a16="http://schemas.microsoft.com/office/drawing/2014/main" id="{AAC7EC1D-51A2-8BD1-7F7E-89632221EAF7}"/>
+              </a:ext>
+            </a:extLst>
+          </p:cNvPr>
+          <p:cNvSpPr/>
+          <p:nvPr/>
+        </p:nvSpPr>
+        <p:spPr>
+          <a:xfrm>
+            <a:off x="9777184" y="5721177"/>
+            <a:ext cx="2573808" cy="326727"/>
+          </a:xfrm>
+          <a:prstGeom prst="roundRect">
+            <a:avLst>
+              <a:gd name="adj" fmla="val 31904"/>
+            </a:avLst>
+          </a:prstGeom>
+          <a:gradFill>
+            <a:gsLst>
+              <a:gs pos="0">
+                <a:srgbClr val="57C968"/>
+              </a:gs>
+              <a:gs pos="25000">
+                <a:schemeClr val="bg2"/>
+              </a:gs>
+            </a:gsLst>
+            <a:lin ang="2700000" scaled="0"/>
+          </a:gradFill>
+          <a:ln>
+            <a:noFill/>
+          </a:ln>
+          <a:effectLst>
+            <a:outerShdw blurRad="190500" dist="38100" dir="2700000" algn="tl" rotWithShape="0">
+              <a:prstClr val="black">
+                <a:alpha val="15000"/>
+              </a:prstClr>
+            </a:outerShdw>
+          </a:effectLst>
+        </p:spPr>
+        <p:style>
+          <a:lnRef idx="2">
+            <a:schemeClr val="accent1">
+              <a:shade val="50000"/>
+            </a:schemeClr>
+          </a:lnRef>
+          <a:fillRef idx="1">
+            <a:schemeClr val="accent1"/>
+          </a:fillRef>
+          <a:effectRef idx="0">
+            <a:schemeClr val="accent1"/>
+          </a:effectRef>
+          <a:fontRef idx="minor">
+            <a:schemeClr val="lt1"/>
+          </a:fontRef>
+        </p:style>
+        <p:txBody>
+          <a:bodyPr lIns="109728" tIns="72000" rIns="108000" bIns="72000" rtlCol="0" anchor="ctr"/>
+          <a:lstStyle/>
+          <a:p>
+            <a:r>
+              <a:rPr lang="nl-NL" sz="1000" b="1" noProof="0" dirty="0">
+                <a:solidFill>
+                  <a:schemeClr val="accent1"/>
+                </a:solidFill>
+              </a:rPr>
+              <a:t>@@</a:t>
+            </a:r>
+          </a:p>
+        </p:txBody>
+      </p:sp>
+      <p:sp>
+        <p:nvSpPr>
+          <p:cNvPr id="36" name="Rounded Rectangle 35">
+            <a:extLst>
+              <a:ext uri="{FF2B5EF4-FFF2-40B4-BE49-F238E27FC236}">
+                <a16:creationId xmlns:a16="http://schemas.microsoft.com/office/drawing/2014/main" id="{43849591-B68A-EEAB-67F2-23F5BAB43709}"/>
+              </a:ext>
+            </a:extLst>
+          </p:cNvPr>
+          <p:cNvSpPr/>
+          <p:nvPr/>
+        </p:nvSpPr>
+        <p:spPr>
+          <a:xfrm>
+            <a:off x="9777184" y="5302414"/>
+            <a:ext cx="2573808" cy="326727"/>
+          </a:xfrm>
+          <a:prstGeom prst="roundRect">
+            <a:avLst>
+              <a:gd name="adj" fmla="val 31904"/>
+            </a:avLst>
+          </a:prstGeom>
+          <a:gradFill>
+            <a:gsLst>
+              <a:gs pos="0">
+                <a:srgbClr val="57C968"/>
+              </a:gs>
+              <a:gs pos="25000">
+                <a:schemeClr val="bg2"/>
+              </a:gs>
+            </a:gsLst>
+            <a:lin ang="2700000" scaled="0"/>
+          </a:gradFill>
+          <a:ln>
+            <a:noFill/>
+          </a:ln>
+          <a:effectLst>
+            <a:outerShdw blurRad="190500" dist="38100" dir="2700000" algn="tl" rotWithShape="0">
+              <a:prstClr val="black">
+                <a:alpha val="15000"/>
+              </a:prstClr>
+            </a:outerShdw>
+          </a:effectLst>
+        </p:spPr>
+        <p:style>
+          <a:lnRef idx="2">
+            <a:schemeClr val="accent1">
+              <a:shade val="50000"/>
+            </a:schemeClr>
+          </a:lnRef>
+          <a:fillRef idx="1">
+            <a:schemeClr val="accent1"/>
+          </a:fillRef>
+          <a:effectRef idx="0">
+            <a:schemeClr val="accent1"/>
+          </a:effectRef>
+          <a:fontRef idx="minor">
+            <a:schemeClr val="lt1"/>
+          </a:fontRef>
+        </p:style>
+        <p:txBody>
+          <a:bodyPr lIns="109728" tIns="72000" rIns="108000" bIns="72000" rtlCol="0" anchor="ctr"/>
+          <a:lstStyle/>
+          <a:p>
+            <a:r>
+              <a:rPr lang="nl-NL" sz="1000" b="1" noProof="0" dirty="0">
+                <a:solidFill>
+                  <a:schemeClr val="accent1"/>
+                </a:solidFill>
+              </a:rPr>
+              <a:t>@@</a:t>
+            </a:r>
+          </a:p>
+        </p:txBody>
+      </p:sp>
+      <p:sp>
+        <p:nvSpPr>
+          <p:cNvPr id="40" name="TextBox 39">
+            <a:extLst>
+              <a:ext uri="{FF2B5EF4-FFF2-40B4-BE49-F238E27FC236}">
+                <a16:creationId xmlns:a16="http://schemas.microsoft.com/office/drawing/2014/main" id="{3330E64A-029D-BE57-A4F4-11697BEC61F3}"/>
+              </a:ext>
+            </a:extLst>
+          </p:cNvPr>
+          <p:cNvSpPr txBox="1"/>
+          <p:nvPr/>
+        </p:nvSpPr>
+        <p:spPr>
+          <a:xfrm>
+            <a:off x="11186130" y="4921755"/>
+            <a:ext cx="991126" cy="250518"/>
+          </a:xfrm>
+          <a:prstGeom prst="rect">
+            <a:avLst/>
+          </a:prstGeom>
+          <a:noFill/>
+        </p:spPr>
+        <p:txBody>
+          <a:bodyPr wrap="none" lIns="90000" rtlCol="0" anchor="t">
+            <a:spAutoFit/>
+          </a:bodyPr>
+          <a:lstStyle/>
+          <a:p>
+            <a:pPr algn="r">
+              <a:lnSpc>
+                <a:spcPct val="113000"/>
+              </a:lnSpc>
+            </a:pPr>
+            <a:r>
+              <a:rPr lang="en-US" sz="1000" b="1" dirty="0" err="1">
+                <a:solidFill>
+                  <a:schemeClr val="tx2"/>
+                </a:solidFill>
+                <a:latin typeface="Sigsterren" pitchFamily="2" charset="0"/>
+              </a:rPr>
+              <a:t>HHHHH</a:t>
+            </a:r>
+            <a:r>
+              <a:rPr lang="en-US" sz="1000" b="1" dirty="0">
+                <a:solidFill>
+                  <a:schemeClr val="tx2"/>
+                </a:solidFill>
+                <a:latin typeface="Sigsterren" pitchFamily="2" charset="0"/>
+              </a:rPr>
+              <a:t> </a:t>
+            </a:r>
+            <a:r>
+              <a:rPr lang="en-US" sz="1000" b="1" dirty="0">
+                <a:solidFill>
+                  <a:schemeClr val="tx2"/>
+                </a:solidFill>
+                <a:latin typeface="Calibri" panose="020F0502020204030204" pitchFamily="34" charset="0"/>
+                <a:cs typeface="Calibri" panose="020F0502020204030204" pitchFamily="34" charset="0"/>
+              </a:rPr>
+              <a:t>(</a:t>
+            </a:r>
+            <a:r>
+              <a:rPr lang="en-US" sz="1000" b="1" dirty="0" err="1">
+                <a:solidFill>
+                  <a:schemeClr val="tx2"/>
+                </a:solidFill>
+                <a:latin typeface="Calibri" panose="020F0502020204030204" pitchFamily="34" charset="0"/>
+                <a:cs typeface="Calibri" panose="020F0502020204030204" pitchFamily="34" charset="0"/>
+              </a:rPr>
+              <a:t>X.X</a:t>
+            </a:r>
+            <a:r>
+              <a:rPr lang="en-US" sz="1000" b="1" dirty="0">
+                <a:solidFill>
+                  <a:schemeClr val="tx2"/>
+                </a:solidFill>
+                <a:latin typeface="Calibri" panose="020F0502020204030204" pitchFamily="34" charset="0"/>
+                <a:cs typeface="Calibri" panose="020F0502020204030204" pitchFamily="34" charset="0"/>
+              </a:rPr>
+              <a:t>)</a:t>
+            </a:r>
+          </a:p>
+        </p:txBody>
+      </p:sp>
+      <p:sp>
+        <p:nvSpPr>
+          <p:cNvPr id="41" name="TextBox 40">
+            <a:extLst>
+              <a:ext uri="{FF2B5EF4-FFF2-40B4-BE49-F238E27FC236}">
+                <a16:creationId xmlns:a16="http://schemas.microsoft.com/office/drawing/2014/main" id="{7117BF85-BAAA-2D29-537D-299AAEC0D2A5}"/>
+              </a:ext>
+            </a:extLst>
+          </p:cNvPr>
+          <p:cNvSpPr txBox="1"/>
+          <p:nvPr/>
+        </p:nvSpPr>
+        <p:spPr>
+          <a:xfrm>
+            <a:off x="11186130" y="4502992"/>
+            <a:ext cx="991126" cy="250518"/>
+          </a:xfrm>
+          <a:prstGeom prst="rect">
+            <a:avLst/>
+          </a:prstGeom>
+          <a:noFill/>
+        </p:spPr>
+        <p:txBody>
+          <a:bodyPr wrap="none" lIns="90000" rtlCol="0" anchor="t">
+            <a:spAutoFit/>
+          </a:bodyPr>
+          <a:lstStyle/>
+          <a:p>
+            <a:pPr algn="r">
+              <a:lnSpc>
+                <a:spcPct val="113000"/>
+              </a:lnSpc>
+            </a:pPr>
+            <a:r>
+              <a:rPr lang="en-US" sz="1000" b="1" dirty="0" err="1">
+                <a:solidFill>
+                  <a:schemeClr val="tx2"/>
+                </a:solidFill>
+                <a:latin typeface="Sigsterren" pitchFamily="2" charset="0"/>
+              </a:rPr>
+              <a:t>HHHHH</a:t>
+            </a:r>
+            <a:r>
+              <a:rPr lang="en-US" sz="1000" b="1" dirty="0">
+                <a:solidFill>
+                  <a:schemeClr val="tx2"/>
+                </a:solidFill>
+                <a:latin typeface="Sigsterren" pitchFamily="2" charset="0"/>
+              </a:rPr>
+              <a:t> </a:t>
+            </a:r>
+            <a:r>
+              <a:rPr lang="en-US" sz="1000" b="1" dirty="0">
+                <a:solidFill>
+                  <a:schemeClr val="tx2"/>
+                </a:solidFill>
+                <a:latin typeface="Calibri" panose="020F0502020204030204" pitchFamily="34" charset="0"/>
+                <a:cs typeface="Calibri" panose="020F0502020204030204" pitchFamily="34" charset="0"/>
+              </a:rPr>
+              <a:t>(</a:t>
+            </a:r>
+            <a:r>
+              <a:rPr lang="en-US" sz="1000" b="1" dirty="0" err="1">
+                <a:solidFill>
+                  <a:schemeClr val="tx2"/>
+                </a:solidFill>
+                <a:latin typeface="Calibri" panose="020F0502020204030204" pitchFamily="34" charset="0"/>
+                <a:cs typeface="Calibri" panose="020F0502020204030204" pitchFamily="34" charset="0"/>
+              </a:rPr>
+              <a:t>X.X</a:t>
+            </a:r>
+            <a:r>
+              <a:rPr lang="en-US" sz="1000" b="1" dirty="0">
+                <a:solidFill>
+                  <a:schemeClr val="tx2"/>
+                </a:solidFill>
+                <a:latin typeface="Calibri" panose="020F0502020204030204" pitchFamily="34" charset="0"/>
+                <a:cs typeface="Calibri" panose="020F0502020204030204" pitchFamily="34" charset="0"/>
+              </a:rPr>
+              <a:t>)</a:t>
+            </a:r>
+          </a:p>
+        </p:txBody>
+      </p:sp>
+      <p:sp>
+        <p:nvSpPr>
+          <p:cNvPr id="44" name="TextBox 43">
+            <a:extLst>
+              <a:ext uri="{FF2B5EF4-FFF2-40B4-BE49-F238E27FC236}">
+                <a16:creationId xmlns:a16="http://schemas.microsoft.com/office/drawing/2014/main" id="{384E70D7-B616-9354-E43A-19C4E8220C5C}"/>
+              </a:ext>
+            </a:extLst>
+          </p:cNvPr>
+          <p:cNvSpPr txBox="1"/>
+          <p:nvPr/>
+        </p:nvSpPr>
+        <p:spPr>
+          <a:xfrm>
+            <a:off x="11186130" y="5759281"/>
+            <a:ext cx="991126" cy="250518"/>
+          </a:xfrm>
+          <a:prstGeom prst="rect">
+            <a:avLst/>
+          </a:prstGeom>
+          <a:noFill/>
+        </p:spPr>
+        <p:txBody>
+          <a:bodyPr wrap="none" lIns="90000" rtlCol="0" anchor="t">
+            <a:spAutoFit/>
+          </a:bodyPr>
+          <a:lstStyle/>
+          <a:p>
+            <a:pPr algn="r">
+              <a:lnSpc>
+                <a:spcPct val="113000"/>
+              </a:lnSpc>
+            </a:pPr>
+            <a:r>
+              <a:rPr lang="en-US" sz="1000" b="1" dirty="0" err="1">
+                <a:solidFill>
+                  <a:schemeClr val="tx2"/>
+                </a:solidFill>
+                <a:latin typeface="Sigsterren" pitchFamily="2" charset="0"/>
+              </a:rPr>
+              <a:t>HHHHH</a:t>
+            </a:r>
+            <a:r>
+              <a:rPr lang="en-US" sz="1000" b="1" dirty="0">
+                <a:solidFill>
+                  <a:schemeClr val="tx2"/>
+                </a:solidFill>
+                <a:latin typeface="Sigsterren" pitchFamily="2" charset="0"/>
+              </a:rPr>
+              <a:t> </a:t>
+            </a:r>
+            <a:r>
+              <a:rPr lang="en-US" sz="1000" b="1" dirty="0">
+                <a:solidFill>
+                  <a:schemeClr val="tx2"/>
+                </a:solidFill>
+                <a:latin typeface="Calibri" panose="020F0502020204030204" pitchFamily="34" charset="0"/>
+                <a:cs typeface="Calibri" panose="020F0502020204030204" pitchFamily="34" charset="0"/>
+              </a:rPr>
+              <a:t>(</a:t>
+            </a:r>
+            <a:r>
+              <a:rPr lang="en-US" sz="1000" b="1" dirty="0" err="1">
+                <a:solidFill>
+                  <a:schemeClr val="tx2"/>
+                </a:solidFill>
+                <a:latin typeface="Calibri" panose="020F0502020204030204" pitchFamily="34" charset="0"/>
+                <a:cs typeface="Calibri" panose="020F0502020204030204" pitchFamily="34" charset="0"/>
+              </a:rPr>
+              <a:t>X.X</a:t>
+            </a:r>
+            <a:r>
+              <a:rPr lang="en-US" sz="1000" b="1" dirty="0">
+                <a:solidFill>
+                  <a:schemeClr val="tx2"/>
+                </a:solidFill>
+                <a:latin typeface="Calibri" panose="020F0502020204030204" pitchFamily="34" charset="0"/>
+                <a:cs typeface="Calibri" panose="020F0502020204030204" pitchFamily="34" charset="0"/>
+              </a:rPr>
+              <a:t>)</a:t>
+            </a:r>
+          </a:p>
+        </p:txBody>
+      </p:sp>
+      <p:sp>
+        <p:nvSpPr>
+          <p:cNvPr id="45" name="TextBox 44">
+            <a:extLst>
+              <a:ext uri="{FF2B5EF4-FFF2-40B4-BE49-F238E27FC236}">
+                <a16:creationId xmlns:a16="http://schemas.microsoft.com/office/drawing/2014/main" id="{D2FCDF86-1BFE-F1DD-09A6-0DDEAED0EA7A}"/>
+              </a:ext>
+            </a:extLst>
+          </p:cNvPr>
+          <p:cNvSpPr txBox="1"/>
+          <p:nvPr/>
+        </p:nvSpPr>
+        <p:spPr>
+          <a:xfrm>
+            <a:off x="11186130" y="5340518"/>
+            <a:ext cx="991126" cy="250518"/>
+          </a:xfrm>
+          <a:prstGeom prst="rect">
+            <a:avLst/>
+          </a:prstGeom>
+          <a:noFill/>
+        </p:spPr>
+        <p:txBody>
+          <a:bodyPr wrap="none" lIns="90000" rtlCol="0" anchor="t">
+            <a:spAutoFit/>
+          </a:bodyPr>
+          <a:lstStyle/>
+          <a:p>
+            <a:pPr algn="r">
+              <a:lnSpc>
+                <a:spcPct val="113000"/>
+              </a:lnSpc>
+            </a:pPr>
+            <a:r>
+              <a:rPr lang="en-US" sz="1000" b="1" dirty="0" err="1">
+                <a:solidFill>
+                  <a:schemeClr val="tx2"/>
+                </a:solidFill>
+                <a:latin typeface="Sigsterren" pitchFamily="2" charset="0"/>
+              </a:rPr>
+              <a:t>HHHHH</a:t>
+            </a:r>
+            <a:r>
+              <a:rPr lang="en-US" sz="1000" b="1" dirty="0">
+                <a:solidFill>
+                  <a:schemeClr val="tx2"/>
+                </a:solidFill>
+                <a:latin typeface="Sigsterren" pitchFamily="2" charset="0"/>
+              </a:rPr>
+              <a:t> </a:t>
+            </a:r>
+            <a:r>
+              <a:rPr lang="en-US" sz="1000" b="1" dirty="0">
+                <a:solidFill>
+                  <a:schemeClr val="tx2"/>
+                </a:solidFill>
+                <a:latin typeface="Calibri" panose="020F0502020204030204" pitchFamily="34" charset="0"/>
+                <a:cs typeface="Calibri" panose="020F0502020204030204" pitchFamily="34" charset="0"/>
+              </a:rPr>
+              <a:t>(</a:t>
+            </a:r>
+            <a:r>
+              <a:rPr lang="en-US" sz="1000" b="1" dirty="0" err="1">
+                <a:solidFill>
+                  <a:schemeClr val="tx2"/>
+                </a:solidFill>
+                <a:latin typeface="Calibri" panose="020F0502020204030204" pitchFamily="34" charset="0"/>
+                <a:cs typeface="Calibri" panose="020F0502020204030204" pitchFamily="34" charset="0"/>
+              </a:rPr>
+              <a:t>X.X</a:t>
+            </a:r>
+            <a:r>
+              <a:rPr lang="en-US" sz="1000" b="1" dirty="0">
+                <a:solidFill>
+                  <a:schemeClr val="tx2"/>
+                </a:solidFill>
+                <a:latin typeface="Calibri" panose="020F0502020204030204" pitchFamily="34" charset="0"/>
+                <a:cs typeface="Calibri" panose="020F0502020204030204" pitchFamily="34" charset="0"/>
+              </a:rPr>
+              <a:t>)</a:t>
+            </a:r>
+          </a:p>
+        </p:txBody>
+      </p:sp>
+      <p:sp>
+        <p:nvSpPr>
+          <p:cNvPr id="42" name="TextBox 41">
+            <a:extLst>
+              <a:ext uri="{FF2B5EF4-FFF2-40B4-BE49-F238E27FC236}">
+                <a16:creationId xmlns:a16="http://schemas.microsoft.com/office/drawing/2014/main" id="{8B4A05E3-5F07-17A7-A878-E3A1F3F83F36}"/>
+              </a:ext>
+            </a:extLst>
+          </p:cNvPr>
+          <p:cNvSpPr txBox="1"/>
+          <p:nvPr/>
+        </p:nvSpPr>
+        <p:spPr>
+          <a:xfrm>
+            <a:off x="11186130" y="4084229"/>
+            <a:ext cx="991126" cy="250518"/>
+          </a:xfrm>
+          <a:prstGeom prst="rect">
+            <a:avLst/>
+          </a:prstGeom>
+          <a:noFill/>
+        </p:spPr>
+        <p:txBody>
+          <a:bodyPr wrap="none" lIns="90000" rtlCol="0" anchor="t">
+            <a:spAutoFit/>
+          </a:bodyPr>
+          <a:lstStyle/>
+          <a:p>
+            <a:pPr algn="r">
+              <a:lnSpc>
+                <a:spcPct val="113000"/>
+              </a:lnSpc>
+            </a:pPr>
+            <a:r>
+              <a:rPr lang="en-US" sz="1000" b="1" dirty="0" err="1">
+                <a:solidFill>
+                  <a:schemeClr val="tx2"/>
+                </a:solidFill>
+                <a:latin typeface="Sigsterren" pitchFamily="2" charset="0"/>
+              </a:rPr>
+              <a:t>HHHHH</a:t>
+            </a:r>
+            <a:r>
+              <a:rPr lang="en-US" sz="1000" b="1" dirty="0">
+                <a:solidFill>
+                  <a:schemeClr val="tx2"/>
+                </a:solidFill>
+                <a:latin typeface="Sigsterren" pitchFamily="2" charset="0"/>
+              </a:rPr>
+              <a:t> </a:t>
+            </a:r>
+            <a:r>
+              <a:rPr lang="en-US" sz="1000" b="1" dirty="0">
+                <a:solidFill>
+                  <a:schemeClr val="tx2"/>
+                </a:solidFill>
+                <a:latin typeface="Calibri" panose="020F0502020204030204" pitchFamily="34" charset="0"/>
+                <a:cs typeface="Calibri" panose="020F0502020204030204" pitchFamily="34" charset="0"/>
+              </a:rPr>
+              <a:t>(</a:t>
+            </a:r>
+            <a:r>
+              <a:rPr lang="en-US" sz="1000" b="1" dirty="0" err="1">
+                <a:solidFill>
+                  <a:schemeClr val="tx2"/>
+                </a:solidFill>
+                <a:latin typeface="Calibri" panose="020F0502020204030204" pitchFamily="34" charset="0"/>
+                <a:cs typeface="Calibri" panose="020F0502020204030204" pitchFamily="34" charset="0"/>
+              </a:rPr>
+              <a:t>X.X</a:t>
+            </a:r>
+            <a:r>
+              <a:rPr lang="en-US" sz="1000" b="1" dirty="0">
+                <a:solidFill>
+                  <a:schemeClr val="tx2"/>
+                </a:solidFill>
+                <a:latin typeface="Calibri" panose="020F0502020204030204" pitchFamily="34" charset="0"/>
+                <a:cs typeface="Calibri" panose="020F0502020204030204" pitchFamily="34" charset="0"/>
+              </a:rPr>
+              <a:t>)</a:t>
+            </a:r>
+          </a:p>
+        </p:txBody>
+      </p:sp>
+      <p:sp>
+        <p:nvSpPr>
+          <p:cNvPr id="43" name="TextBox 42">
+            <a:extLst>
+              <a:ext uri="{FF2B5EF4-FFF2-40B4-BE49-F238E27FC236}">
+                <a16:creationId xmlns:a16="http://schemas.microsoft.com/office/drawing/2014/main" id="{D3967FA3-FEEE-A226-4B36-FB0C331951E6}"/>
+              </a:ext>
+            </a:extLst>
+          </p:cNvPr>
+          <p:cNvSpPr txBox="1"/>
+          <p:nvPr/>
+        </p:nvSpPr>
+        <p:spPr>
+          <a:xfrm>
+            <a:off x="11186130" y="3665466"/>
+            <a:ext cx="991126" cy="250518"/>
+          </a:xfrm>
+          <a:prstGeom prst="rect">
+            <a:avLst/>
+          </a:prstGeom>
+          <a:noFill/>
+        </p:spPr>
+        <p:txBody>
+          <a:bodyPr wrap="none" lIns="90000" rtlCol="0" anchor="t">
+            <a:spAutoFit/>
+          </a:bodyPr>
+          <a:lstStyle/>
+          <a:p>
+            <a:pPr algn="r">
+              <a:lnSpc>
+                <a:spcPct val="113000"/>
+              </a:lnSpc>
+            </a:pPr>
+            <a:r>
+              <a:rPr lang="en-US" sz="1000" b="1" dirty="0" err="1">
+                <a:solidFill>
+                  <a:schemeClr val="tx2"/>
+                </a:solidFill>
+                <a:latin typeface="Sigsterren" pitchFamily="2" charset="0"/>
+              </a:rPr>
+              <a:t>HHHHH</a:t>
+            </a:r>
+            <a:r>
+              <a:rPr lang="en-US" sz="1000" b="1" dirty="0">
+                <a:solidFill>
+                  <a:schemeClr val="tx2"/>
+                </a:solidFill>
+                <a:latin typeface="Sigsterren" pitchFamily="2" charset="0"/>
+              </a:rPr>
+              <a:t> </a:t>
+            </a:r>
+            <a:r>
+              <a:rPr lang="en-US" sz="1000" b="1" dirty="0">
+                <a:solidFill>
+                  <a:schemeClr val="tx2"/>
+                </a:solidFill>
+                <a:latin typeface="Calibri" panose="020F0502020204030204" pitchFamily="34" charset="0"/>
+                <a:cs typeface="Calibri" panose="020F0502020204030204" pitchFamily="34" charset="0"/>
+              </a:rPr>
+              <a:t>(</a:t>
+            </a:r>
+            <a:r>
+              <a:rPr lang="en-US" sz="1000" b="1" dirty="0" err="1">
+                <a:solidFill>
+                  <a:schemeClr val="tx2"/>
+                </a:solidFill>
+                <a:latin typeface="Calibri" panose="020F0502020204030204" pitchFamily="34" charset="0"/>
+                <a:cs typeface="Calibri" panose="020F0502020204030204" pitchFamily="34" charset="0"/>
+              </a:rPr>
+              <a:t>X.X</a:t>
+            </a:r>
+            <a:r>
+              <a:rPr lang="en-US" sz="1000" b="1" dirty="0">
+                <a:solidFill>
+                  <a:schemeClr val="tx2"/>
+                </a:solidFill>
+                <a:latin typeface="Calibri" panose="020F0502020204030204" pitchFamily="34" charset="0"/>
+                <a:cs typeface="Calibri" panose="020F0502020204030204" pitchFamily="34" charset="0"/>
+              </a:rPr>
+              <a:t>)</a:t>
+            </a:r>
+          </a:p>
+        </p:txBody>
+      </p:sp>
+      <p:sp>
+        <p:nvSpPr>
+          <p:cNvPr id="60" name="Triangle 59">
+            <a:extLst>
+              <a:ext uri="{FF2B5EF4-FFF2-40B4-BE49-F238E27FC236}">
+                <a16:creationId xmlns:a16="http://schemas.microsoft.com/office/drawing/2014/main" id="{C1693B4E-8875-225E-C3BC-7D59AEE0ACF0}"/>
+              </a:ext>
+            </a:extLst>
+          </p:cNvPr>
+          <p:cNvSpPr/>
+          <p:nvPr/>
+        </p:nvSpPr>
+        <p:spPr>
+          <a:xfrm rot="5400000">
+            <a:off x="11223517" y="97630"/>
+            <a:ext cx="113704" cy="91353"/>
+          </a:xfrm>
+          <a:prstGeom prst="triangle">
+            <a:avLst/>
+          </a:prstGeom>
+          <a:solidFill>
+            <a:schemeClr val="tx2"/>
+          </a:solidFill>
+          <a:ln>
+            <a:noFill/>
+          </a:ln>
+        </p:spPr>
+        <p:style>
+          <a:lnRef idx="2">
+            <a:schemeClr val="accent1">
+              <a:shade val="50000"/>
+            </a:schemeClr>
+          </a:lnRef>
+          <a:fillRef idx="1">
+            <a:schemeClr val="accent1"/>
+          </a:fillRef>
+          <a:effectRef idx="0">
+            <a:schemeClr val="accent1"/>
+          </a:effectRef>
+          <a:fontRef idx="minor">
+            <a:schemeClr val="lt1"/>
+          </a:fontRef>
+        </p:style>
+        <p:txBody>
+          <a:bodyPr lIns="108000" tIns="72000" rIns="108000" bIns="72000" rtlCol="0" anchor="ctr"/>
+          <a:lstStyle/>
+          <a:p>
+            <a:pPr algn="ctr"/>
+            <a:endParaRPr lang="en-US" sz="1600">
+              <a:solidFill>
+                <a:schemeClr val="bg1"/>
+              </a:solidFill>
+            </a:endParaRPr>
+          </a:p>
+        </p:txBody>
+      </p:sp>
+      <p:pic>
+        <p:nvPicPr>
+          <p:cNvPr id="61" name="Picture 60">
+            <a:extLst>
+              <a:ext uri="{FF2B5EF4-FFF2-40B4-BE49-F238E27FC236}">
+                <a16:creationId xmlns:a16="http://schemas.microsoft.com/office/drawing/2014/main" id="{06B4C579-A729-7BC8-C3C2-C43674979489}"/>
+              </a:ext>
+            </a:extLst>
+          </p:cNvPr>
+          <p:cNvPicPr>
+            <a:picLocks noChangeAspect="1"/>
+          </p:cNvPicPr>
+          <p:nvPr/>
+        </p:nvPicPr>
+        <p:blipFill>
+          <a:blip r:embed="rId2"/>
+          <a:stretch>
+            <a:fillRect/>
+          </a:stretch>
+        </p:blipFill>
+        <p:spPr>
+          <a:xfrm>
+            <a:off x="10267839" y="52613"/>
+            <a:ext cx="203103" cy="172639"/>
+          </a:xfrm>
+          <a:prstGeom prst="rect">
+            <a:avLst/>
+          </a:prstGeom>
+        </p:spPr>
+      </p:pic>
+      <p:sp>
+        <p:nvSpPr>
+          <p:cNvPr id="62" name="TextBox 61">
+            <a:extLst>
+              <a:ext uri="{FF2B5EF4-FFF2-40B4-BE49-F238E27FC236}">
+                <a16:creationId xmlns:a16="http://schemas.microsoft.com/office/drawing/2014/main" id="{18269E38-D98E-A1A9-849D-FA7CE973A729}"/>
+              </a:ext>
+            </a:extLst>
+          </p:cNvPr>
+          <p:cNvSpPr txBox="1"/>
+          <p:nvPr/>
+        </p:nvSpPr>
+        <p:spPr>
+          <a:xfrm>
+            <a:off x="9145068" y="10898"/>
+            <a:ext cx="2110021" cy="264816"/>
+          </a:xfrm>
+          <a:prstGeom prst="rect">
+            <a:avLst/>
+          </a:prstGeom>
+          <a:noFill/>
+        </p:spPr>
+        <p:txBody>
+          <a:bodyPr wrap="none" lIns="90000" rtlCol="0" anchor="t">
+            <a:spAutoFit/>
+          </a:bodyPr>
+          <a:lstStyle/>
+          <a:p>
+            <a:pPr algn="r">
+              <a:lnSpc>
+                <a:spcPct val="113000"/>
+              </a:lnSpc>
+            </a:pPr>
+            <a:r>
+              <a:rPr lang="nl-NL" sz="1050" b="1" dirty="0" err="1">
+                <a:solidFill>
+                  <a:schemeClr val="bg1">
+                    <a:lumMod val="75000"/>
+                  </a:schemeClr>
+                </a:solidFill>
+              </a:rPr>
+              <a:t>PORTFOLIO_PERIOD_START_DATE</a:t>
+            </a:r>
+            <a:endParaRPr lang="nl-NL" sz="1050" b="1" dirty="0">
+              <a:solidFill>
+                <a:schemeClr val="bg1">
+                  <a:lumMod val="75000"/>
+                </a:schemeClr>
+              </a:solidFill>
+            </a:endParaRPr>
+          </a:p>
+        </p:txBody>
+      </p:sp>
+      <p:sp>
+        <p:nvSpPr>
+          <p:cNvPr id="63" name="TextBox 62">
+            <a:extLst>
+              <a:ext uri="{FF2B5EF4-FFF2-40B4-BE49-F238E27FC236}">
+                <a16:creationId xmlns:a16="http://schemas.microsoft.com/office/drawing/2014/main" id="{842D4281-B725-AADD-7434-A67A1A6008DB}"/>
+              </a:ext>
+            </a:extLst>
+          </p:cNvPr>
+          <p:cNvSpPr txBox="1"/>
+          <p:nvPr/>
+        </p:nvSpPr>
+        <p:spPr>
+          <a:xfrm>
+            <a:off x="11305651" y="10898"/>
+            <a:ext cx="1993003" cy="264816"/>
+          </a:xfrm>
+          <a:prstGeom prst="rect">
+            <a:avLst/>
+          </a:prstGeom>
+          <a:noFill/>
+        </p:spPr>
+        <p:txBody>
+          <a:bodyPr wrap="none" lIns="90000" rtlCol="0" anchor="t">
+            <a:spAutoFit/>
+          </a:bodyPr>
+          <a:lstStyle/>
+          <a:p>
+            <a:pPr>
+              <a:lnSpc>
+                <a:spcPct val="113000"/>
+              </a:lnSpc>
+            </a:pPr>
+            <a:r>
+              <a:rPr lang="nl-NL" sz="1050" b="1" dirty="0" err="1">
+                <a:solidFill>
+                  <a:schemeClr val="tx2"/>
+                </a:solidFill>
+              </a:rPr>
+              <a:t>PORTFOLIO_PERIOD_END_DATE</a:t>
+            </a:r>
+            <a:endParaRPr lang="nl-NL" sz="1050" b="1" dirty="0">
+              <a:solidFill>
+                <a:schemeClr val="tx2"/>
+              </a:solidFill>
+            </a:endParaRPr>
+          </a:p>
+        </p:txBody>
+      </p:sp>
+      <p:grpSp>
+        <p:nvGrpSpPr>
+          <p:cNvPr id="64" name="Group 63">
+            <a:extLst>
+              <a:ext uri="{FF2B5EF4-FFF2-40B4-BE49-F238E27FC236}">
+                <a16:creationId xmlns:a16="http://schemas.microsoft.com/office/drawing/2014/main" id="{7A0448F1-9072-6C0C-66A5-40DE5ABB8FD4}"/>
+              </a:ext>
+            </a:extLst>
+          </p:cNvPr>
+          <p:cNvGrpSpPr>
+            <a:grpSpLocks noChangeAspect="1"/>
+          </p:cNvGrpSpPr>
+          <p:nvPr/>
+        </p:nvGrpSpPr>
+        <p:grpSpPr>
+          <a:xfrm>
+            <a:off x="-392105" y="2517185"/>
+            <a:ext cx="98115" cy="92576"/>
+            <a:chOff x="-331054" y="2564812"/>
+            <a:chExt cx="141517" cy="133528"/>
+          </a:xfrm>
+          <a:solidFill>
+            <a:srgbClr val="57C968"/>
+          </a:solidFill>
+        </p:grpSpPr>
+        <p:sp>
+          <p:nvSpPr>
+            <p:cNvPr id="65" name="Freeform 64">
+              <a:extLst>
+                <a:ext uri="{FF2B5EF4-FFF2-40B4-BE49-F238E27FC236}">
+                  <a16:creationId xmlns:a16="http://schemas.microsoft.com/office/drawing/2014/main" id="{A7BE0DB5-2B07-7D12-87EB-1EA854951E21}"/>
+                </a:ext>
+              </a:extLst>
+            </p:cNvPr>
+            <p:cNvSpPr/>
+            <p:nvPr/>
+          </p:nvSpPr>
+          <p:spPr>
+            <a:xfrm>
+              <a:off x="-331054" y="2564812"/>
+              <a:ext cx="141517" cy="82436"/>
+            </a:xfrm>
+            <a:custGeom>
+              <a:avLst/>
+              <a:gdLst>
+                <a:gd name="connsiteX0" fmla="*/ 70759 w 141517"/>
+                <a:gd name="connsiteY0" fmla="*/ 0 h 82436"/>
+                <a:gd name="connsiteX1" fmla="*/ 141517 w 141517"/>
+                <a:gd name="connsiteY1" fmla="*/ 82436 h 82436"/>
+                <a:gd name="connsiteX2" fmla="*/ 111805 w 141517"/>
+                <a:gd name="connsiteY2" fmla="*/ 82436 h 82436"/>
+                <a:gd name="connsiteX3" fmla="*/ 70759 w 141517"/>
+                <a:gd name="connsiteY3" fmla="*/ 34616 h 82436"/>
+                <a:gd name="connsiteX4" fmla="*/ 29713 w 141517"/>
+                <a:gd name="connsiteY4" fmla="*/ 82436 h 82436"/>
+                <a:gd name="connsiteX5" fmla="*/ 0 w 141517"/>
+                <a:gd name="connsiteY5" fmla="*/ 82436 h 82436"/>
+              </a:gdLst>
+              <a:ahLst/>
+              <a:cxnLst>
+                <a:cxn ang="0">
+                  <a:pos x="connsiteX0" y="connsiteY0"/>
+                </a:cxn>
+                <a:cxn ang="0">
+                  <a:pos x="connsiteX1" y="connsiteY1"/>
+                </a:cxn>
+                <a:cxn ang="0">
+                  <a:pos x="connsiteX2" y="connsiteY2"/>
+                </a:cxn>
+                <a:cxn ang="0">
+                  <a:pos x="connsiteX3" y="connsiteY3"/>
+                </a:cxn>
+                <a:cxn ang="0">
+                  <a:pos x="connsiteX4" y="connsiteY4"/>
+                </a:cxn>
+                <a:cxn ang="0">
+                  <a:pos x="connsiteX5" y="connsiteY5"/>
+                </a:cxn>
+              </a:cxnLst>
+              <a:rect l="l" t="t" r="r" b="b"/>
+              <a:pathLst>
+                <a:path w="141517" h="82436">
+                  <a:moveTo>
+                    <a:pt x="70759" y="0"/>
+                  </a:moveTo>
+                  <a:lnTo>
+                    <a:pt x="141517" y="82436"/>
+                  </a:lnTo>
+                  <a:lnTo>
+                    <a:pt x="111805" y="82436"/>
+                  </a:lnTo>
+                  <a:lnTo>
+                    <a:pt x="70759" y="34616"/>
+                  </a:lnTo>
+                  <a:lnTo>
+                    <a:pt x="29713" y="82436"/>
+                  </a:lnTo>
+                  <a:lnTo>
+                    <a:pt x="0" y="82436"/>
+                  </a:lnTo>
+                  <a:close/>
+                </a:path>
+              </a:pathLst>
+            </a:custGeom>
+            <a:grpFill/>
+            <a:ln>
+              <a:noFill/>
+            </a:ln>
+          </p:spPr>
+          <p:style>
+            <a:lnRef idx="2">
+              <a:schemeClr val="accent1">
+                <a:shade val="50000"/>
+              </a:schemeClr>
+            </a:lnRef>
+            <a:fillRef idx="1">
+              <a:schemeClr val="accent1"/>
+            </a:fillRef>
+            <a:effectRef idx="0">
+              <a:schemeClr val="accent1"/>
+            </a:effectRef>
+            <a:fontRef idx="minor">
+              <a:schemeClr val="lt1"/>
+            </a:fontRef>
+          </p:style>
+          <p:txBody>
+            <a:bodyPr wrap="square" lIns="108000" tIns="72000" rIns="108000" bIns="72000" rtlCol="0" anchor="ctr">
+              <a:noAutofit/>
+            </a:bodyPr>
+            <a:lstStyle/>
+            <a:p>
+              <a:pPr algn="ctr"/>
+              <a:endParaRPr lang="en-US" sz="1600" err="1">
+                <a:solidFill>
+                  <a:schemeClr val="bg1"/>
+                </a:solidFill>
+              </a:endParaRPr>
+            </a:p>
+          </p:txBody>
+        </p:sp>
+        <p:sp>
+          <p:nvSpPr>
+            <p:cNvPr id="66" name="Triangle 65">
+              <a:extLst>
+                <a:ext uri="{FF2B5EF4-FFF2-40B4-BE49-F238E27FC236}">
+                  <a16:creationId xmlns:a16="http://schemas.microsoft.com/office/drawing/2014/main" id="{528E10CF-5539-9E74-A175-FF3487DF89A0}"/>
+                </a:ext>
+              </a:extLst>
+            </p:cNvPr>
+            <p:cNvSpPr/>
+            <p:nvPr/>
+          </p:nvSpPr>
+          <p:spPr>
+            <a:xfrm>
+              <a:off x="-331054" y="2615904"/>
+              <a:ext cx="141517" cy="82436"/>
+            </a:xfrm>
+            <a:prstGeom prst="triangle">
+              <a:avLst/>
+            </a:prstGeom>
+            <a:grpFill/>
+            <a:ln>
+              <a:noFill/>
+            </a:ln>
+          </p:spPr>
+          <p:style>
+            <a:lnRef idx="2">
+              <a:schemeClr val="accent1">
+                <a:shade val="50000"/>
+              </a:schemeClr>
+            </a:lnRef>
+            <a:fillRef idx="1">
+              <a:schemeClr val="accent1"/>
+            </a:fillRef>
+            <a:effectRef idx="0">
+              <a:schemeClr val="accent1"/>
+            </a:effectRef>
+            <a:fontRef idx="minor">
+              <a:schemeClr val="lt1"/>
+            </a:fontRef>
+          </p:style>
+          <p:txBody>
+            <a:bodyPr lIns="108000" tIns="72000" rIns="108000" bIns="72000" rtlCol="0" anchor="ctr"/>
+            <a:lstStyle/>
+            <a:p>
+              <a:pPr algn="ctr"/>
+              <a:endParaRPr lang="en-US" sz="1600" err="1">
+                <a:solidFill>
+                  <a:schemeClr val="bg1"/>
+                </a:solidFill>
+              </a:endParaRPr>
+            </a:p>
+          </p:txBody>
+        </p:sp>
+      </p:grpSp>
+      <p:grpSp>
+        <p:nvGrpSpPr>
+          <p:cNvPr id="67" name="Group 66">
+            <a:extLst>
+              <a:ext uri="{FF2B5EF4-FFF2-40B4-BE49-F238E27FC236}">
+                <a16:creationId xmlns:a16="http://schemas.microsoft.com/office/drawing/2014/main" id="{377AEB37-B31B-0863-1FA0-10CE92E74F36}"/>
+              </a:ext>
+            </a:extLst>
+          </p:cNvPr>
+          <p:cNvGrpSpPr>
+            <a:grpSpLocks noChangeAspect="1"/>
+          </p:cNvGrpSpPr>
+          <p:nvPr/>
+        </p:nvGrpSpPr>
+        <p:grpSpPr>
+          <a:xfrm rot="10800000">
+            <a:off x="-392106" y="2948284"/>
+            <a:ext cx="98115" cy="92576"/>
+            <a:chOff x="-331054" y="2564812"/>
+            <a:chExt cx="141517" cy="133528"/>
+          </a:xfrm>
+          <a:solidFill>
+            <a:srgbClr val="FFC000"/>
+          </a:solidFill>
+        </p:grpSpPr>
+        <p:sp>
+          <p:nvSpPr>
+            <p:cNvPr id="68" name="Freeform 67">
+              <a:extLst>
+                <a:ext uri="{FF2B5EF4-FFF2-40B4-BE49-F238E27FC236}">
+                  <a16:creationId xmlns:a16="http://schemas.microsoft.com/office/drawing/2014/main" id="{54C842EB-ACD9-13E8-3D00-A46BBE4F8CF0}"/>
+                </a:ext>
+              </a:extLst>
+            </p:cNvPr>
+            <p:cNvSpPr/>
+            <p:nvPr/>
+          </p:nvSpPr>
+          <p:spPr>
+            <a:xfrm>
+              <a:off x="-331054" y="2564812"/>
+              <a:ext cx="141517" cy="82436"/>
+            </a:xfrm>
+            <a:custGeom>
+              <a:avLst/>
+              <a:gdLst>
+                <a:gd name="connsiteX0" fmla="*/ 70759 w 141517"/>
+                <a:gd name="connsiteY0" fmla="*/ 0 h 82436"/>
+                <a:gd name="connsiteX1" fmla="*/ 141517 w 141517"/>
+                <a:gd name="connsiteY1" fmla="*/ 82436 h 82436"/>
+                <a:gd name="connsiteX2" fmla="*/ 111805 w 141517"/>
+                <a:gd name="connsiteY2" fmla="*/ 82436 h 82436"/>
+                <a:gd name="connsiteX3" fmla="*/ 70759 w 141517"/>
+                <a:gd name="connsiteY3" fmla="*/ 34616 h 82436"/>
+                <a:gd name="connsiteX4" fmla="*/ 29713 w 141517"/>
+                <a:gd name="connsiteY4" fmla="*/ 82436 h 82436"/>
+                <a:gd name="connsiteX5" fmla="*/ 0 w 141517"/>
+                <a:gd name="connsiteY5" fmla="*/ 82436 h 82436"/>
+              </a:gdLst>
+              <a:ahLst/>
+              <a:cxnLst>
+                <a:cxn ang="0">
+                  <a:pos x="connsiteX0" y="connsiteY0"/>
+                </a:cxn>
+                <a:cxn ang="0">
+                  <a:pos x="connsiteX1" y="connsiteY1"/>
+                </a:cxn>
+                <a:cxn ang="0">
+                  <a:pos x="connsiteX2" y="connsiteY2"/>
+                </a:cxn>
+                <a:cxn ang="0">
+                  <a:pos x="connsiteX3" y="connsiteY3"/>
+                </a:cxn>
+                <a:cxn ang="0">
+                  <a:pos x="connsiteX4" y="connsiteY4"/>
+                </a:cxn>
+                <a:cxn ang="0">
+                  <a:pos x="connsiteX5" y="connsiteY5"/>
+                </a:cxn>
+              </a:cxnLst>
+              <a:rect l="l" t="t" r="r" b="b"/>
+              <a:pathLst>
+                <a:path w="141517" h="82436">
+                  <a:moveTo>
+                    <a:pt x="70759" y="0"/>
+                  </a:moveTo>
+                  <a:lnTo>
+                    <a:pt x="141517" y="82436"/>
+                  </a:lnTo>
+                  <a:lnTo>
+                    <a:pt x="111805" y="82436"/>
+                  </a:lnTo>
+                  <a:lnTo>
+                    <a:pt x="70759" y="34616"/>
+                  </a:lnTo>
+                  <a:lnTo>
+                    <a:pt x="29713" y="82436"/>
+                  </a:lnTo>
+                  <a:lnTo>
+                    <a:pt x="0" y="82436"/>
+                  </a:lnTo>
+                  <a:close/>
+                </a:path>
+              </a:pathLst>
+            </a:custGeom>
+            <a:grpFill/>
+            <a:ln>
+              <a:noFill/>
+            </a:ln>
+          </p:spPr>
+          <p:style>
+            <a:lnRef idx="2">
+              <a:schemeClr val="accent1">
+                <a:shade val="50000"/>
+              </a:schemeClr>
+            </a:lnRef>
+            <a:fillRef idx="1">
+              <a:schemeClr val="accent1"/>
+            </a:fillRef>
+            <a:effectRef idx="0">
+              <a:schemeClr val="accent1"/>
+            </a:effectRef>
+            <a:fontRef idx="minor">
+              <a:schemeClr val="lt1"/>
+            </a:fontRef>
+          </p:style>
+          <p:txBody>
+            <a:bodyPr wrap="square" lIns="108000" tIns="72000" rIns="108000" bIns="72000" rtlCol="0" anchor="ctr">
+              <a:noAutofit/>
+            </a:bodyPr>
+            <a:lstStyle/>
+            <a:p>
+              <a:pPr algn="ctr"/>
+              <a:endParaRPr lang="en-US" sz="1600" err="1">
+                <a:solidFill>
+                  <a:schemeClr val="bg1"/>
+                </a:solidFill>
+              </a:endParaRPr>
+            </a:p>
+          </p:txBody>
+        </p:sp>
+        <p:sp>
+          <p:nvSpPr>
+            <p:cNvPr id="69" name="Triangle 68">
+              <a:extLst>
+                <a:ext uri="{FF2B5EF4-FFF2-40B4-BE49-F238E27FC236}">
+                  <a16:creationId xmlns:a16="http://schemas.microsoft.com/office/drawing/2014/main" id="{15AD5229-C433-7CFC-899F-E2A9748EC122}"/>
+                </a:ext>
+              </a:extLst>
+            </p:cNvPr>
+            <p:cNvSpPr/>
+            <p:nvPr/>
+          </p:nvSpPr>
+          <p:spPr>
+            <a:xfrm>
+              <a:off x="-331054" y="2615904"/>
+              <a:ext cx="141517" cy="82436"/>
+            </a:xfrm>
+            <a:prstGeom prst="triangle">
+              <a:avLst/>
+            </a:prstGeom>
+            <a:grpFill/>
+            <a:ln>
+              <a:noFill/>
+            </a:ln>
+          </p:spPr>
+          <p:style>
+            <a:lnRef idx="2">
+              <a:schemeClr val="accent1">
+                <a:shade val="50000"/>
+              </a:schemeClr>
+            </a:lnRef>
+            <a:fillRef idx="1">
+              <a:schemeClr val="accent1"/>
+            </a:fillRef>
+            <a:effectRef idx="0">
+              <a:schemeClr val="accent1"/>
+            </a:effectRef>
+            <a:fontRef idx="minor">
+              <a:schemeClr val="lt1"/>
+            </a:fontRef>
+          </p:style>
+          <p:txBody>
+            <a:bodyPr lIns="108000" tIns="72000" rIns="108000" bIns="72000" rtlCol="0" anchor="ctr"/>
+            <a:lstStyle/>
+            <a:p>
+              <a:pPr algn="ctr"/>
+              <a:endParaRPr lang="en-US" sz="1600" err="1">
+                <a:solidFill>
+                  <a:schemeClr val="bg1"/>
+                </a:solidFill>
+              </a:endParaRPr>
+            </a:p>
+          </p:txBody>
+        </p:sp>
+      </p:grpSp>
+      <p:sp>
+        <p:nvSpPr>
+          <p:cNvPr id="72" name="TextBox 71">
+            <a:extLst>
+              <a:ext uri="{FF2B5EF4-FFF2-40B4-BE49-F238E27FC236}">
+                <a16:creationId xmlns:a16="http://schemas.microsoft.com/office/drawing/2014/main" id="{4BEB0E91-753E-DE0D-1DF6-13AAA357C45E}"/>
+              </a:ext>
+            </a:extLst>
+          </p:cNvPr>
+          <p:cNvSpPr txBox="1"/>
+          <p:nvPr/>
+        </p:nvSpPr>
+        <p:spPr>
+          <a:xfrm>
+            <a:off x="9777184" y="3305030"/>
+            <a:ext cx="579667" cy="322332"/>
+          </a:xfrm>
+          <a:prstGeom prst="rect">
+            <a:avLst/>
+          </a:prstGeom>
+          <a:noFill/>
+        </p:spPr>
+        <p:txBody>
+          <a:bodyPr wrap="none" lIns="90000" rtlCol="0" anchor="t">
+            <a:spAutoFit/>
+          </a:bodyPr>
+          <a:lstStyle/>
+          <a:p>
+            <a:pPr algn="l">
+              <a:lnSpc>
+                <a:spcPct val="113000"/>
+              </a:lnSpc>
+            </a:pPr>
+            <a:r>
+              <a:rPr lang="en-US" sz="1400" b="1" dirty="0">
+                <a:solidFill>
+                  <a:schemeClr val="tx2"/>
+                </a:solidFill>
+              </a:rPr>
+              <a:t>Team</a:t>
+            </a:r>
+          </a:p>
+        </p:txBody>
+      </p:sp>
+      <p:pic>
+        <p:nvPicPr>
+          <p:cNvPr id="12" name="Graphic 11">
+            <a:extLst>
+              <a:ext uri="{FF2B5EF4-FFF2-40B4-BE49-F238E27FC236}">
+                <a16:creationId xmlns:a16="http://schemas.microsoft.com/office/drawing/2014/main" id="{50529EB5-7D61-96B4-768B-08F6BF3B9D5C}"/>
+              </a:ext>
+            </a:extLst>
+          </p:cNvPr>
+          <p:cNvPicPr>
+            <a:picLocks noChangeAspect="1"/>
+          </p:cNvPicPr>
+          <p:nvPr/>
+        </p:nvPicPr>
+        <p:blipFill>
+          <a:blip r:embed="rId3">
+            <a:extLst>
+              <a:ext uri="{96DAC541-7B7A-43D3-8B79-37D633B846F1}">
+                <asvg:svgBlip xmlns:asvg="http://schemas.microsoft.com/office/drawing/2016/SVG/main" r:embed="rId4"/>
+              </a:ext>
+            </a:extLst>
+          </a:blip>
+          <a:stretch>
+            <a:fillRect/>
+          </a:stretch>
+        </p:blipFill>
+        <p:spPr>
+          <a:xfrm>
+            <a:off x="8838256" y="6071736"/>
+            <a:ext cx="371130" cy="206558"/>
+          </a:xfrm>
+          <a:prstGeom prst="rect">
+            <a:avLst/>
+          </a:prstGeom>
+        </p:spPr>
+      </p:pic>
+      <p:sp>
+        <p:nvSpPr>
+          <p:cNvPr id="11" name="Rectangle 10">
+            <a:extLst>
+              <a:ext uri="{FF2B5EF4-FFF2-40B4-BE49-F238E27FC236}">
+                <a16:creationId xmlns:a16="http://schemas.microsoft.com/office/drawing/2014/main" id="{7FA8CC6E-79D0-779A-4057-FF94D4182B43}"/>
+              </a:ext>
+            </a:extLst>
+          </p:cNvPr>
+          <p:cNvSpPr/>
+          <p:nvPr/>
+        </p:nvSpPr>
+        <p:spPr>
+          <a:xfrm>
+            <a:off x="512064" y="3200400"/>
+            <a:ext cx="8750808" cy="2843784"/>
+          </a:xfrm>
+          <a:prstGeom prst="rect">
+            <a:avLst/>
+          </a:prstGeom>
+          <a:solidFill>
+            <a:srgbClr val="F0089F"/>
+          </a:solidFill>
+          <a:ln>
+            <a:noFill/>
+          </a:ln>
+        </p:spPr>
+        <p:style>
+          <a:lnRef idx="2">
+            <a:schemeClr val="accent1">
+              <a:shade val="50000"/>
+            </a:schemeClr>
+          </a:lnRef>
+          <a:fillRef idx="1">
+            <a:schemeClr val="accent1"/>
+          </a:fillRef>
+          <a:effectRef idx="0">
+            <a:schemeClr val="accent1"/>
+          </a:effectRef>
+          <a:fontRef idx="minor">
+            <a:schemeClr val="lt1"/>
+          </a:fontRef>
+        </p:style>
+        <p:txBody>
+          <a:bodyPr lIns="108000" tIns="72000" rIns="108000" bIns="72000" rtlCol="0" anchor="ctr"/>
+          <a:lstStyle/>
+          <a:p>
+            <a:pPr algn="ctr"/>
+            <a:r>
+              <a:rPr lang="en-US" sz="1600" dirty="0" err="1">
+                <a:solidFill>
+                  <a:schemeClr val="bg1"/>
+                </a:solidFill>
+              </a:rPr>
+              <a:t>PORTFOLIO_PERIOD_ARCHITECTURE</a:t>
+            </a:r>
+            <a:endParaRPr lang="en-US" sz="1600" dirty="0">
+              <a:solidFill>
+                <a:schemeClr val="bg1"/>
+              </a:solidFill>
+            </a:endParaRPr>
+          </a:p>
+        </p:txBody>
+      </p:sp>
+      <p:sp>
+        <p:nvSpPr>
+          <p:cNvPr id="2" name="TextBox 1">
+            <a:extLst>
+              <a:ext uri="{FF2B5EF4-FFF2-40B4-BE49-F238E27FC236}">
+                <a16:creationId xmlns:a16="http://schemas.microsoft.com/office/drawing/2014/main" id="{6E4B93BD-B59A-71C8-4848-15AFF292DD1C}"/>
+              </a:ext>
+            </a:extLst>
+          </p:cNvPr>
+          <p:cNvSpPr txBox="1"/>
+          <p:nvPr/>
+        </p:nvSpPr>
+        <p:spPr>
+          <a:xfrm>
+            <a:off x="2643466" y="6054740"/>
+            <a:ext cx="1276460" cy="223844"/>
+          </a:xfrm>
+          <a:prstGeom prst="rect">
+            <a:avLst/>
+          </a:prstGeom>
+          <a:noFill/>
+        </p:spPr>
+        <p:txBody>
+          <a:bodyPr wrap="none" lIns="90000" rtlCol="0" anchor="t">
+            <a:spAutoFit/>
+          </a:bodyPr>
+          <a:lstStyle/>
+          <a:p>
+            <a:pPr algn="l">
+              <a:lnSpc>
+                <a:spcPct val="113000"/>
+              </a:lnSpc>
+            </a:pPr>
+            <a:r>
+              <a:rPr lang="en-US" sz="800" dirty="0">
+                <a:solidFill>
+                  <a:schemeClr val="accent3"/>
+                </a:solidFill>
+              </a:rPr>
+              <a:t>Systems grouped by </a:t>
+            </a:r>
+            <a:r>
+              <a:rPr lang="en-US" sz="800" b="1" dirty="0">
+                <a:solidFill>
+                  <a:schemeClr val="accent3"/>
+                </a:solidFill>
+              </a:rPr>
+              <a:t>Team</a:t>
+            </a:r>
+          </a:p>
+        </p:txBody>
+      </p:sp>
+      <p:grpSp>
+        <p:nvGrpSpPr>
+          <p:cNvPr id="4" name="Group 3">
+            <a:extLst>
+              <a:ext uri="{FF2B5EF4-FFF2-40B4-BE49-F238E27FC236}">
+                <a16:creationId xmlns:a16="http://schemas.microsoft.com/office/drawing/2014/main" id="{E94BE5A8-50A2-3CB5-EB9F-ECAAAD999D4C}"/>
+              </a:ext>
+            </a:extLst>
+          </p:cNvPr>
+          <p:cNvGrpSpPr/>
+          <p:nvPr/>
+        </p:nvGrpSpPr>
+        <p:grpSpPr>
+          <a:xfrm>
+            <a:off x="516802" y="6117354"/>
+            <a:ext cx="300732" cy="98617"/>
+            <a:chOff x="586253" y="6116391"/>
+            <a:chExt cx="300732" cy="98617"/>
+          </a:xfrm>
+        </p:grpSpPr>
+        <p:sp>
+          <p:nvSpPr>
+            <p:cNvPr id="5" name="TextBox 4">
+              <a:extLst>
+                <a:ext uri="{FF2B5EF4-FFF2-40B4-BE49-F238E27FC236}">
+                  <a16:creationId xmlns:a16="http://schemas.microsoft.com/office/drawing/2014/main" id="{1D242320-FF53-799F-AD12-F1A53454CADD}"/>
+                </a:ext>
+              </a:extLst>
+            </p:cNvPr>
+            <p:cNvSpPr txBox="1"/>
+            <p:nvPr/>
+          </p:nvSpPr>
+          <p:spPr>
+            <a:xfrm>
+              <a:off x="710655" y="6116391"/>
+              <a:ext cx="176330" cy="98617"/>
+            </a:xfrm>
+            <a:prstGeom prst="rect">
+              <a:avLst/>
+            </a:prstGeom>
+            <a:noFill/>
+          </p:spPr>
+          <p:txBody>
+            <a:bodyPr wrap="none" lIns="0" tIns="0" rIns="0" bIns="0" rtlCol="0" anchor="t">
+              <a:spAutoFit/>
+            </a:bodyPr>
+            <a:lstStyle/>
+            <a:p>
+              <a:pPr algn="l">
+                <a:lnSpc>
+                  <a:spcPct val="113000"/>
+                </a:lnSpc>
+              </a:pPr>
+              <a:r>
+                <a:rPr lang="en-US" sz="600" dirty="0">
+                  <a:solidFill>
+                    <a:schemeClr val="tx2"/>
+                  </a:solidFill>
+                </a:rPr>
+                <a:t>1 star</a:t>
+              </a:r>
+            </a:p>
+          </p:txBody>
+        </p:sp>
+        <p:sp>
+          <p:nvSpPr>
+            <p:cNvPr id="13" name="Rounded Rectangle 12">
+              <a:extLst>
+                <a:ext uri="{FF2B5EF4-FFF2-40B4-BE49-F238E27FC236}">
+                  <a16:creationId xmlns:a16="http://schemas.microsoft.com/office/drawing/2014/main" id="{B0FE9ED6-B82B-2268-BCC0-A3C543ECC37E}"/>
+                </a:ext>
+              </a:extLst>
+            </p:cNvPr>
+            <p:cNvSpPr>
+              <a:spLocks noChangeAspect="1"/>
+            </p:cNvSpPr>
+            <p:nvPr/>
+          </p:nvSpPr>
+          <p:spPr>
+            <a:xfrm>
+              <a:off x="586253" y="6119980"/>
+              <a:ext cx="89812" cy="91440"/>
+            </a:xfrm>
+            <a:prstGeom prst="roundRect">
+              <a:avLst/>
+            </a:prstGeom>
+            <a:solidFill>
+              <a:srgbClr val="C04035"/>
+            </a:solidFill>
+            <a:ln>
+              <a:noFill/>
+            </a:ln>
+          </p:spPr>
+          <p:style>
+            <a:lnRef idx="2">
+              <a:schemeClr val="accent1">
+                <a:shade val="50000"/>
+              </a:schemeClr>
+            </a:lnRef>
+            <a:fillRef idx="1">
+              <a:schemeClr val="accent1"/>
+            </a:fillRef>
+            <a:effectRef idx="0">
+              <a:schemeClr val="accent1"/>
+            </a:effectRef>
+            <a:fontRef idx="minor">
+              <a:schemeClr val="lt1"/>
+            </a:fontRef>
+          </p:style>
+          <p:txBody>
+            <a:bodyPr lIns="108000" tIns="72000" rIns="108000" bIns="72000" rtlCol="0" anchor="ctr"/>
+            <a:lstStyle/>
+            <a:p>
+              <a:pPr algn="ctr"/>
+              <a:endParaRPr lang="en-US" sz="1600" dirty="0" err="1">
+                <a:solidFill>
+                  <a:schemeClr val="bg1"/>
+                </a:solidFill>
+              </a:endParaRPr>
+            </a:p>
+          </p:txBody>
+        </p:sp>
+      </p:grpSp>
+      <p:grpSp>
+        <p:nvGrpSpPr>
+          <p:cNvPr id="14" name="Group 13">
+            <a:extLst>
+              <a:ext uri="{FF2B5EF4-FFF2-40B4-BE49-F238E27FC236}">
+                <a16:creationId xmlns:a16="http://schemas.microsoft.com/office/drawing/2014/main" id="{6093FE6B-1978-BDB2-A7E1-C77BFDC63CE6}"/>
+              </a:ext>
+            </a:extLst>
+          </p:cNvPr>
+          <p:cNvGrpSpPr/>
+          <p:nvPr/>
+        </p:nvGrpSpPr>
+        <p:grpSpPr>
+          <a:xfrm>
+            <a:off x="934179" y="6117354"/>
+            <a:ext cx="331190" cy="98617"/>
+            <a:chOff x="961765" y="6117353"/>
+            <a:chExt cx="331190" cy="98617"/>
+          </a:xfrm>
+        </p:grpSpPr>
+        <p:sp>
+          <p:nvSpPr>
+            <p:cNvPr id="15" name="TextBox 14">
+              <a:extLst>
+                <a:ext uri="{FF2B5EF4-FFF2-40B4-BE49-F238E27FC236}">
+                  <a16:creationId xmlns:a16="http://schemas.microsoft.com/office/drawing/2014/main" id="{B889ECD7-4049-C2BC-62DC-5EFCEFFE4820}"/>
+                </a:ext>
+              </a:extLst>
+            </p:cNvPr>
+            <p:cNvSpPr txBox="1"/>
+            <p:nvPr/>
+          </p:nvSpPr>
+          <p:spPr>
+            <a:xfrm>
+              <a:off x="1086167" y="6117353"/>
+              <a:ext cx="206788" cy="98617"/>
+            </a:xfrm>
+            <a:prstGeom prst="rect">
+              <a:avLst/>
+            </a:prstGeom>
+            <a:noFill/>
+          </p:spPr>
+          <p:txBody>
+            <a:bodyPr wrap="none" lIns="0" tIns="0" rIns="0" bIns="0" rtlCol="0" anchor="t">
+              <a:spAutoFit/>
+            </a:bodyPr>
+            <a:lstStyle/>
+            <a:p>
+              <a:pPr algn="l">
+                <a:lnSpc>
+                  <a:spcPct val="113000"/>
+                </a:lnSpc>
+              </a:pPr>
+              <a:r>
+                <a:rPr lang="en-US" sz="600" dirty="0">
+                  <a:solidFill>
+                    <a:schemeClr val="tx2"/>
+                  </a:solidFill>
+                </a:rPr>
+                <a:t>2 stars</a:t>
+              </a:r>
+            </a:p>
+          </p:txBody>
+        </p:sp>
+        <p:sp>
+          <p:nvSpPr>
+            <p:cNvPr id="18" name="Rounded Rectangle 17">
+              <a:extLst>
+                <a:ext uri="{FF2B5EF4-FFF2-40B4-BE49-F238E27FC236}">
+                  <a16:creationId xmlns:a16="http://schemas.microsoft.com/office/drawing/2014/main" id="{3C71F5E1-5F10-DEAB-C5E9-9D1A4015EFBD}"/>
+                </a:ext>
+              </a:extLst>
+            </p:cNvPr>
+            <p:cNvSpPr>
+              <a:spLocks noChangeAspect="1"/>
+            </p:cNvSpPr>
+            <p:nvPr/>
+          </p:nvSpPr>
+          <p:spPr>
+            <a:xfrm>
+              <a:off x="961765" y="6120942"/>
+              <a:ext cx="89812" cy="91440"/>
+            </a:xfrm>
+            <a:prstGeom prst="roundRect">
+              <a:avLst/>
+            </a:prstGeom>
+            <a:solidFill>
+              <a:srgbClr val="EF9819"/>
+            </a:solidFill>
+            <a:ln>
+              <a:noFill/>
+            </a:ln>
+          </p:spPr>
+          <p:style>
+            <a:lnRef idx="2">
+              <a:schemeClr val="accent1">
+                <a:shade val="50000"/>
+              </a:schemeClr>
+            </a:lnRef>
+            <a:fillRef idx="1">
+              <a:schemeClr val="accent1"/>
+            </a:fillRef>
+            <a:effectRef idx="0">
+              <a:schemeClr val="accent1"/>
+            </a:effectRef>
+            <a:fontRef idx="minor">
+              <a:schemeClr val="lt1"/>
+            </a:fontRef>
+          </p:style>
+          <p:txBody>
+            <a:bodyPr lIns="108000" tIns="72000" rIns="108000" bIns="72000" rtlCol="0" anchor="ctr"/>
+            <a:lstStyle/>
+            <a:p>
+              <a:pPr algn="ctr"/>
+              <a:endParaRPr lang="en-US" sz="1600" dirty="0" err="1">
+                <a:solidFill>
+                  <a:schemeClr val="bg1"/>
+                </a:solidFill>
+              </a:endParaRPr>
+            </a:p>
+          </p:txBody>
+        </p:sp>
+      </p:grpSp>
+      <p:grpSp>
+        <p:nvGrpSpPr>
+          <p:cNvPr id="19" name="Group 18">
+            <a:extLst>
+              <a:ext uri="{FF2B5EF4-FFF2-40B4-BE49-F238E27FC236}">
+                <a16:creationId xmlns:a16="http://schemas.microsoft.com/office/drawing/2014/main" id="{3669BCA8-26A4-2D2B-F1E1-0F65BD120BCB}"/>
+              </a:ext>
+            </a:extLst>
+          </p:cNvPr>
+          <p:cNvGrpSpPr/>
+          <p:nvPr/>
+        </p:nvGrpSpPr>
+        <p:grpSpPr>
+          <a:xfrm>
+            <a:off x="1382015" y="6117354"/>
+            <a:ext cx="331190" cy="98617"/>
+            <a:chOff x="1114165" y="6269753"/>
+            <a:chExt cx="331190" cy="98617"/>
+          </a:xfrm>
+        </p:grpSpPr>
+        <p:sp>
+          <p:nvSpPr>
+            <p:cNvPr id="20" name="TextBox 19">
+              <a:extLst>
+                <a:ext uri="{FF2B5EF4-FFF2-40B4-BE49-F238E27FC236}">
+                  <a16:creationId xmlns:a16="http://schemas.microsoft.com/office/drawing/2014/main" id="{2AA2CAC9-D0AF-5C25-7509-7F76A37502B2}"/>
+                </a:ext>
+              </a:extLst>
+            </p:cNvPr>
+            <p:cNvSpPr txBox="1"/>
+            <p:nvPr/>
+          </p:nvSpPr>
+          <p:spPr>
+            <a:xfrm>
+              <a:off x="1238567" y="6269753"/>
+              <a:ext cx="206788" cy="98617"/>
+            </a:xfrm>
+            <a:prstGeom prst="rect">
+              <a:avLst/>
+            </a:prstGeom>
+            <a:noFill/>
+          </p:spPr>
+          <p:txBody>
+            <a:bodyPr wrap="none" lIns="0" tIns="0" rIns="0" bIns="0" rtlCol="0" anchor="t">
+              <a:spAutoFit/>
+            </a:bodyPr>
+            <a:lstStyle/>
+            <a:p>
+              <a:pPr algn="l">
+                <a:lnSpc>
+                  <a:spcPct val="113000"/>
+                </a:lnSpc>
+              </a:pPr>
+              <a:r>
+                <a:rPr lang="en-US" sz="600" dirty="0">
+                  <a:solidFill>
+                    <a:schemeClr val="tx2"/>
+                  </a:solidFill>
+                </a:rPr>
+                <a:t>3 stars</a:t>
+              </a:r>
+            </a:p>
+          </p:txBody>
+        </p:sp>
+        <p:sp>
+          <p:nvSpPr>
+            <p:cNvPr id="21" name="Rounded Rectangle 20">
+              <a:extLst>
+                <a:ext uri="{FF2B5EF4-FFF2-40B4-BE49-F238E27FC236}">
+                  <a16:creationId xmlns:a16="http://schemas.microsoft.com/office/drawing/2014/main" id="{B57FDB8E-6FC9-A84D-B32A-91746C436FB2}"/>
+                </a:ext>
+              </a:extLst>
+            </p:cNvPr>
+            <p:cNvSpPr>
+              <a:spLocks noChangeAspect="1"/>
+            </p:cNvSpPr>
+            <p:nvPr/>
+          </p:nvSpPr>
+          <p:spPr>
+            <a:xfrm>
+              <a:off x="1114165" y="6273342"/>
+              <a:ext cx="89812" cy="91440"/>
+            </a:xfrm>
+            <a:prstGeom prst="roundRect">
+              <a:avLst/>
+            </a:prstGeom>
+            <a:solidFill>
+              <a:srgbClr val="F9C640"/>
+            </a:solidFill>
+            <a:ln>
+              <a:noFill/>
+            </a:ln>
+          </p:spPr>
+          <p:style>
+            <a:lnRef idx="2">
+              <a:schemeClr val="accent1">
+                <a:shade val="50000"/>
+              </a:schemeClr>
+            </a:lnRef>
+            <a:fillRef idx="1">
+              <a:schemeClr val="accent1"/>
+            </a:fillRef>
+            <a:effectRef idx="0">
+              <a:schemeClr val="accent1"/>
+            </a:effectRef>
+            <a:fontRef idx="minor">
+              <a:schemeClr val="lt1"/>
+            </a:fontRef>
+          </p:style>
+          <p:txBody>
+            <a:bodyPr lIns="108000" tIns="72000" rIns="108000" bIns="72000" rtlCol="0" anchor="ctr"/>
+            <a:lstStyle/>
+            <a:p>
+              <a:pPr algn="ctr"/>
+              <a:endParaRPr lang="en-US" sz="1600" dirty="0" err="1">
+                <a:solidFill>
+                  <a:schemeClr val="bg1"/>
+                </a:solidFill>
+              </a:endParaRPr>
+            </a:p>
+          </p:txBody>
+        </p:sp>
+      </p:grpSp>
+      <p:grpSp>
+        <p:nvGrpSpPr>
+          <p:cNvPr id="22" name="Group 21">
+            <a:extLst>
+              <a:ext uri="{FF2B5EF4-FFF2-40B4-BE49-F238E27FC236}">
+                <a16:creationId xmlns:a16="http://schemas.microsoft.com/office/drawing/2014/main" id="{762C6950-8001-E340-ADED-D28E5F7F961E}"/>
+              </a:ext>
+            </a:extLst>
+          </p:cNvPr>
+          <p:cNvGrpSpPr/>
+          <p:nvPr/>
+        </p:nvGrpSpPr>
+        <p:grpSpPr>
+          <a:xfrm>
+            <a:off x="1829851" y="6117354"/>
+            <a:ext cx="331190" cy="98617"/>
+            <a:chOff x="1114165" y="6269753"/>
+            <a:chExt cx="331190" cy="98617"/>
+          </a:xfrm>
+        </p:grpSpPr>
+        <p:sp>
+          <p:nvSpPr>
+            <p:cNvPr id="23" name="TextBox 22">
+              <a:extLst>
+                <a:ext uri="{FF2B5EF4-FFF2-40B4-BE49-F238E27FC236}">
+                  <a16:creationId xmlns:a16="http://schemas.microsoft.com/office/drawing/2014/main" id="{418DA12C-ECBE-3A73-0A59-64820DFAA06E}"/>
+                </a:ext>
+              </a:extLst>
+            </p:cNvPr>
+            <p:cNvSpPr txBox="1"/>
+            <p:nvPr/>
+          </p:nvSpPr>
+          <p:spPr>
+            <a:xfrm>
+              <a:off x="1238567" y="6269753"/>
+              <a:ext cx="206788" cy="98617"/>
+            </a:xfrm>
+            <a:prstGeom prst="rect">
+              <a:avLst/>
+            </a:prstGeom>
+            <a:noFill/>
+          </p:spPr>
+          <p:txBody>
+            <a:bodyPr wrap="none" lIns="0" tIns="0" rIns="0" bIns="0" rtlCol="0" anchor="t">
+              <a:spAutoFit/>
+            </a:bodyPr>
+            <a:lstStyle/>
+            <a:p>
+              <a:pPr algn="l">
+                <a:lnSpc>
+                  <a:spcPct val="113000"/>
+                </a:lnSpc>
+              </a:pPr>
+              <a:r>
+                <a:rPr lang="en-US" sz="600" dirty="0">
+                  <a:solidFill>
+                    <a:schemeClr val="tx2"/>
+                  </a:solidFill>
+                </a:rPr>
+                <a:t>4 stars</a:t>
+              </a:r>
+            </a:p>
+          </p:txBody>
+        </p:sp>
+        <p:sp>
+          <p:nvSpPr>
+            <p:cNvPr id="24" name="Rounded Rectangle 23">
+              <a:extLst>
+                <a:ext uri="{FF2B5EF4-FFF2-40B4-BE49-F238E27FC236}">
+                  <a16:creationId xmlns:a16="http://schemas.microsoft.com/office/drawing/2014/main" id="{D65AD3B7-FEC0-B0E6-33A0-5C13D4D6EB7C}"/>
+                </a:ext>
+              </a:extLst>
+            </p:cNvPr>
+            <p:cNvSpPr>
+              <a:spLocks noChangeAspect="1"/>
+            </p:cNvSpPr>
+            <p:nvPr/>
+          </p:nvSpPr>
+          <p:spPr>
+            <a:xfrm>
+              <a:off x="1114165" y="6273342"/>
+              <a:ext cx="89812" cy="91440"/>
+            </a:xfrm>
+            <a:prstGeom prst="roundRect">
+              <a:avLst/>
+            </a:prstGeom>
+            <a:solidFill>
+              <a:srgbClr val="57C968"/>
+            </a:solidFill>
+            <a:ln>
+              <a:noFill/>
+            </a:ln>
+          </p:spPr>
+          <p:style>
+            <a:lnRef idx="2">
+              <a:schemeClr val="accent1">
+                <a:shade val="50000"/>
+              </a:schemeClr>
+            </a:lnRef>
+            <a:fillRef idx="1">
+              <a:schemeClr val="accent1"/>
+            </a:fillRef>
+            <a:effectRef idx="0">
+              <a:schemeClr val="accent1"/>
+            </a:effectRef>
+            <a:fontRef idx="minor">
+              <a:schemeClr val="lt1"/>
+            </a:fontRef>
+          </p:style>
+          <p:txBody>
+            <a:bodyPr lIns="108000" tIns="72000" rIns="108000" bIns="72000" rtlCol="0" anchor="ctr"/>
+            <a:lstStyle/>
+            <a:p>
+              <a:pPr algn="ctr"/>
+              <a:endParaRPr lang="en-US" sz="1600" dirty="0" err="1">
+                <a:solidFill>
+                  <a:schemeClr val="bg1"/>
+                </a:solidFill>
+              </a:endParaRPr>
+            </a:p>
+          </p:txBody>
+        </p:sp>
+      </p:grpSp>
+      <p:grpSp>
+        <p:nvGrpSpPr>
+          <p:cNvPr id="25" name="Group 24">
+            <a:extLst>
+              <a:ext uri="{FF2B5EF4-FFF2-40B4-BE49-F238E27FC236}">
+                <a16:creationId xmlns:a16="http://schemas.microsoft.com/office/drawing/2014/main" id="{5ED4B644-4825-FB9E-D737-7F6747FF7D17}"/>
+              </a:ext>
+            </a:extLst>
+          </p:cNvPr>
+          <p:cNvGrpSpPr/>
+          <p:nvPr/>
+        </p:nvGrpSpPr>
+        <p:grpSpPr>
+          <a:xfrm>
+            <a:off x="2277686" y="6117354"/>
+            <a:ext cx="331190" cy="98617"/>
+            <a:chOff x="1114165" y="6269753"/>
+            <a:chExt cx="331190" cy="98617"/>
+          </a:xfrm>
+        </p:grpSpPr>
+        <p:sp>
+          <p:nvSpPr>
+            <p:cNvPr id="26" name="TextBox 25">
+              <a:extLst>
+                <a:ext uri="{FF2B5EF4-FFF2-40B4-BE49-F238E27FC236}">
+                  <a16:creationId xmlns:a16="http://schemas.microsoft.com/office/drawing/2014/main" id="{D3C279F1-186D-292C-F3C7-24C382DE4CE3}"/>
+                </a:ext>
+              </a:extLst>
+            </p:cNvPr>
+            <p:cNvSpPr txBox="1"/>
+            <p:nvPr/>
+          </p:nvSpPr>
+          <p:spPr>
+            <a:xfrm>
+              <a:off x="1238567" y="6269753"/>
+              <a:ext cx="206788" cy="98617"/>
+            </a:xfrm>
+            <a:prstGeom prst="rect">
+              <a:avLst/>
+            </a:prstGeom>
+            <a:noFill/>
+          </p:spPr>
+          <p:txBody>
+            <a:bodyPr wrap="none" lIns="0" tIns="0" rIns="0" bIns="0" rtlCol="0" anchor="t">
+              <a:spAutoFit/>
+            </a:bodyPr>
+            <a:lstStyle/>
+            <a:p>
+              <a:pPr algn="l">
+                <a:lnSpc>
+                  <a:spcPct val="113000"/>
+                </a:lnSpc>
+              </a:pPr>
+              <a:r>
+                <a:rPr lang="en-US" sz="600" dirty="0">
+                  <a:solidFill>
+                    <a:schemeClr val="tx2"/>
+                  </a:solidFill>
+                </a:rPr>
+                <a:t>5 stars</a:t>
+              </a:r>
+            </a:p>
+          </p:txBody>
+        </p:sp>
+        <p:sp>
+          <p:nvSpPr>
+            <p:cNvPr id="27" name="Rounded Rectangle 26">
+              <a:extLst>
+                <a:ext uri="{FF2B5EF4-FFF2-40B4-BE49-F238E27FC236}">
+                  <a16:creationId xmlns:a16="http://schemas.microsoft.com/office/drawing/2014/main" id="{DCF5C1D5-2A14-42E2-BD7E-C1FDDC8AE37E}"/>
+                </a:ext>
+              </a:extLst>
+            </p:cNvPr>
+            <p:cNvSpPr>
+              <a:spLocks noChangeAspect="1"/>
+            </p:cNvSpPr>
+            <p:nvPr/>
+          </p:nvSpPr>
+          <p:spPr>
+            <a:xfrm>
+              <a:off x="1114165" y="6273342"/>
+              <a:ext cx="89812" cy="91440"/>
+            </a:xfrm>
+            <a:prstGeom prst="roundRect">
+              <a:avLst/>
+            </a:prstGeom>
+            <a:solidFill>
+              <a:srgbClr val="2C963F"/>
+            </a:solidFill>
+            <a:ln>
+              <a:noFill/>
+            </a:ln>
+          </p:spPr>
+          <p:style>
+            <a:lnRef idx="2">
+              <a:schemeClr val="accent1">
+                <a:shade val="50000"/>
+              </a:schemeClr>
+            </a:lnRef>
+            <a:fillRef idx="1">
+              <a:schemeClr val="accent1"/>
+            </a:fillRef>
+            <a:effectRef idx="0">
+              <a:schemeClr val="accent1"/>
+            </a:effectRef>
+            <a:fontRef idx="minor">
+              <a:schemeClr val="lt1"/>
+            </a:fontRef>
+          </p:style>
+          <p:txBody>
+            <a:bodyPr lIns="108000" tIns="72000" rIns="108000" bIns="72000" rtlCol="0" anchor="ctr"/>
+            <a:lstStyle/>
+            <a:p>
+              <a:pPr algn="ctr"/>
+              <a:endParaRPr lang="en-US" sz="1600" dirty="0" err="1">
+                <a:solidFill>
+                  <a:schemeClr val="bg1"/>
+                </a:solidFill>
+              </a:endParaRPr>
+            </a:p>
+          </p:txBody>
+        </p:sp>
+      </p:grpSp>
+    </p:spTree>
+    <p:extLst>
+      <p:ext uri="{BB962C8B-B14F-4D97-AF65-F5344CB8AC3E}">
+        <p14:creationId xmlns:p14="http://schemas.microsoft.com/office/powerpoint/2010/main" val="480855850"/>
+      </p:ext>
+    </p:extLst>
+  </p:cSld>
+  <p:clrMapOvr>
+    <a:masterClrMapping/>
+  </p:clrMapOvr>
+</p:sld>
+</file>
+
+<file path=ppt/slides/slide15.xml><?xml version="1.0" encoding="utf-8"?>
+<p:sld xmlns:a="http://schemas.openxmlformats.org/drawingml/2006/main" xmlns:r="http://schemas.openxmlformats.org/officeDocument/2006/relationships" xmlns:p="http://schemas.openxmlformats.org/presentationml/2006/main">
+  <p:cSld>
+    <p:spTree>
+      <p:nvGrpSpPr>
+        <p:cNvPr id="1" name="">
+          <a:extLst>
+            <a:ext uri="{FF2B5EF4-FFF2-40B4-BE49-F238E27FC236}">
               <a16:creationId xmlns:a16="http://schemas.microsoft.com/office/drawing/2014/main" id="{E98C0A81-88C5-4527-C0A0-244B124815FB}"/>
             </a:ext>
           </a:extLst>
@@ -35777,7 +38553,7 @@
             <a:fld id="{E242BD21-9B61-2246-BCB1-4BE5E1BEBE1C}" type="slidenum">
               <a:rPr lang="en-US" smtClean="0"/>
               <a:pPr/>
-              <a:t>14</a:t>
+              <a:t>15</a:t>
             </a:fld>
             <a:endParaRPr lang="en-US"/>
           </a:p>
@@ -38435,7 +41211,7 @@
 </p:sld>
 </file>
 
-<file path=ppt/slides/slide15.xml><?xml version="1.0" encoding="utf-8"?>
+<file path=ppt/slides/slide16.xml><?xml version="1.0" encoding="utf-8"?>
 <p:sld xmlns:a="http://schemas.openxmlformats.org/drawingml/2006/main" xmlns:r="http://schemas.openxmlformats.org/officeDocument/2006/relationships" xmlns:p="http://schemas.openxmlformats.org/presentationml/2006/main">
   <p:cSld>
     <p:spTree>
@@ -38552,7 +41328,7 @@
             <a:fld id="{E242BD21-9B61-2246-BCB1-4BE5E1BEBE1C}" type="slidenum">
               <a:rPr lang="en-US" smtClean="0"/>
               <a:pPr/>
-              <a:t>15</a:t>
+              <a:t>16</a:t>
             </a:fld>
             <a:endParaRPr lang="en-US"/>
           </a:p>
@@ -41210,7 +43986,7 @@
 </p:sld>
 </file>
 
-<file path=ppt/slides/slide16.xml><?xml version="1.0" encoding="utf-8"?>
+<file path=ppt/slides/slide17.xml><?xml version="1.0" encoding="utf-8"?>
 <p:sld xmlns:a="http://schemas.openxmlformats.org/drawingml/2006/main" xmlns:r="http://schemas.openxmlformats.org/officeDocument/2006/relationships" xmlns:p="http://schemas.openxmlformats.org/presentationml/2006/main">
   <p:cSld>
     <p:spTree>
@@ -44626,6 +47402,26 @@
 </file>
 
 <file path=customXml/item1.xml><?xml version="1.0" encoding="utf-8"?>
+<?mso-contentType ?>
+<FormTemplates xmlns="http://schemas.microsoft.com/sharepoint/v3/contenttype/forms">
+  <Display>DocumentLibraryForm</Display>
+  <Edit>DocumentLibraryForm</Edit>
+  <New>DocumentLibraryForm</New>
+</FormTemplates>
+</file>
+
+<file path=customXml/item2.xml><?xml version="1.0" encoding="utf-8"?>
+<p:properties xmlns:p="http://schemas.microsoft.com/office/2006/metadata/properties" xmlns:xsi="http://www.w3.org/2001/XMLSchema-instance" xmlns:pc="http://schemas.microsoft.com/office/infopath/2007/PartnerControls">
+  <documentManagement>
+    <lcf76f155ced4ddcb4097134ff3c332f xmlns="fa937df2-abe2-4d38-b5f4-c228acba3827">
+      <Terms xmlns="http://schemas.microsoft.com/office/infopath/2007/PartnerControls"/>
+    </lcf76f155ced4ddcb4097134ff3c332f>
+    <TaxCatchAll xmlns="bc8ba18a-4a58-4ad2-bfc0-6516af8e7dc2" xsi:nil="true"/>
+  </documentManagement>
+</p:properties>
+</file>
+
+<file path=customXml/item3.xml><?xml version="1.0" encoding="utf-8"?>
 <ct:contentTypeSchema xmlns:ct="http://schemas.microsoft.com/office/2006/metadata/contentType" xmlns:ma="http://schemas.microsoft.com/office/2006/metadata/properties/metaAttributes" ct:_="" ma:_="" ma:contentTypeName="Document" ma:contentTypeID="0x010100398B4EB28540854BB4092730D7F67224" ma:contentTypeVersion="13" ma:contentTypeDescription="Create a new document." ma:contentTypeScope="" ma:versionID="07d6997c7358ecc3b6f0d78039f1ac55">
   <xsd:schema xmlns:xsd="http://www.w3.org/2001/XMLSchema" xmlns:xs="http://www.w3.org/2001/XMLSchema" xmlns:p="http://schemas.microsoft.com/office/2006/metadata/properties" xmlns:ns2="fa937df2-abe2-4d38-b5f4-c228acba3827" xmlns:ns3="bc8ba18a-4a58-4ad2-bfc0-6516af8e7dc2" targetNamespace="http://schemas.microsoft.com/office/2006/metadata/properties" ma:root="true" ma:fieldsID="a7d20d2c9a349b6838acf4b79389f2fd" ns2:_="" ns3:_="">
     <xsd:import namespace="fa937df2-abe2-4d38-b5f4-c228acba3827"/>
@@ -44848,41 +47644,10 @@
 </ct:contentTypeSchema>
 </file>
 
-<file path=customXml/item2.xml><?xml version="1.0" encoding="utf-8"?>
-<p:properties xmlns:p="http://schemas.microsoft.com/office/2006/metadata/properties" xmlns:xsi="http://www.w3.org/2001/XMLSchema-instance" xmlns:pc="http://schemas.microsoft.com/office/infopath/2007/PartnerControls">
-  <documentManagement>
-    <lcf76f155ced4ddcb4097134ff3c332f xmlns="fa937df2-abe2-4d38-b5f4-c228acba3827">
-      <Terms xmlns="http://schemas.microsoft.com/office/infopath/2007/PartnerControls"/>
-    </lcf76f155ced4ddcb4097134ff3c332f>
-    <TaxCatchAll xmlns="bc8ba18a-4a58-4ad2-bfc0-6516af8e7dc2" xsi:nil="true"/>
-  </documentManagement>
-</p:properties>
-</file>
-
-<file path=customXml/item3.xml><?xml version="1.0" encoding="utf-8"?>
-<?mso-contentType ?>
-<FormTemplates xmlns="http://schemas.microsoft.com/sharepoint/v3/contenttype/forms">
-  <Display>DocumentLibraryForm</Display>
-  <Edit>DocumentLibraryForm</Edit>
-  <New>DocumentLibraryForm</New>
-</FormTemplates>
-</file>
-
 <file path=customXml/itemProps1.xml><?xml version="1.0" encoding="utf-8"?>
-<ds:datastoreItem xmlns:ds="http://schemas.openxmlformats.org/officeDocument/2006/customXml" ds:itemID="{06E6923A-C221-4753-B75B-BA213EEB7564}">
+<ds:datastoreItem xmlns:ds="http://schemas.openxmlformats.org/officeDocument/2006/customXml" ds:itemID="{570928F0-D7CA-4732-B7F3-1F945720D0AA}">
   <ds:schemaRefs>
-    <ds:schemaRef ds:uri="bc8ba18a-4a58-4ad2-bfc0-6516af8e7dc2"/>
-    <ds:schemaRef ds:uri="fa937df2-abe2-4d38-b5f4-c228acba3827"/>
-    <ds:schemaRef ds:uri="http://purl.org/dc/elements/1.1/"/>
-    <ds:schemaRef ds:uri="http://purl.org/dc/terms/"/>
-    <ds:schemaRef ds:uri="http://schemas.microsoft.com/internal/obd"/>
-    <ds:schemaRef ds:uri="http://schemas.microsoft.com/office/2006/documentManagement/types"/>
-    <ds:schemaRef ds:uri="http://schemas.microsoft.com/office/2006/metadata/contentType"/>
-    <ds:schemaRef ds:uri="http://schemas.microsoft.com/office/2006/metadata/properties"/>
-    <ds:schemaRef ds:uri="http://schemas.microsoft.com/office/2006/metadata/properties/metaAttributes"/>
-    <ds:schemaRef ds:uri="http://schemas.microsoft.com/office/infopath/2007/PartnerControls"/>
-    <ds:schemaRef ds:uri="http://schemas.openxmlformats.org/package/2006/metadata/core-properties"/>
-    <ds:schemaRef ds:uri="http://www.w3.org/2001/XMLSchema"/>
+    <ds:schemaRef ds:uri="http://schemas.microsoft.com/sharepoint/v3/contenttype/forms"/>
   </ds:schemaRefs>
 </ds:datastoreItem>
 </file>
@@ -44905,9 +47670,20 @@
 </file>
 
 <file path=customXml/itemProps3.xml><?xml version="1.0" encoding="utf-8"?>
-<ds:datastoreItem xmlns:ds="http://schemas.openxmlformats.org/officeDocument/2006/customXml" ds:itemID="{570928F0-D7CA-4732-B7F3-1F945720D0AA}">
+<ds:datastoreItem xmlns:ds="http://schemas.openxmlformats.org/officeDocument/2006/customXml" ds:itemID="{06E6923A-C221-4753-B75B-BA213EEB7564}">
   <ds:schemaRefs>
-    <ds:schemaRef ds:uri="http://schemas.microsoft.com/sharepoint/v3/contenttype/forms"/>
+    <ds:schemaRef ds:uri="bc8ba18a-4a58-4ad2-bfc0-6516af8e7dc2"/>
+    <ds:schemaRef ds:uri="fa937df2-abe2-4d38-b5f4-c228acba3827"/>
+    <ds:schemaRef ds:uri="http://purl.org/dc/elements/1.1/"/>
+    <ds:schemaRef ds:uri="http://purl.org/dc/terms/"/>
+    <ds:schemaRef ds:uri="http://schemas.microsoft.com/internal/obd"/>
+    <ds:schemaRef ds:uri="http://schemas.microsoft.com/office/2006/documentManagement/types"/>
+    <ds:schemaRef ds:uri="http://schemas.microsoft.com/office/2006/metadata/contentType"/>
+    <ds:schemaRef ds:uri="http://schemas.microsoft.com/office/2006/metadata/properties"/>
+    <ds:schemaRef ds:uri="http://schemas.microsoft.com/office/2006/metadata/properties/metaAttributes"/>
+    <ds:schemaRef ds:uri="http://schemas.microsoft.com/office/infopath/2007/PartnerControls"/>
+    <ds:schemaRef ds:uri="http://schemas.openxmlformats.org/package/2006/metadata/core-properties"/>
+    <ds:schemaRef ds:uri="http://www.w3.org/2001/XMLSchema"/>
   </ds:schemaRefs>
 </ds:datastoreItem>
 </file>
</xml_diff>

<commit_message>
Setup for maintainability changes treemap
</commit_message>
<xml_diff>
--- a/src/report_generator/presets/templates/sigrid-template.pptx
+++ b/src/report_generator/presets/templates/sigrid-template.pptx
@@ -5,10 +5,10 @@
     <p:sldMasterId id="2147483648" r:id="rId4"/>
   </p:sldMasterIdLst>
   <p:notesMasterIdLst>
-    <p:notesMasterId r:id="rId22"/>
+    <p:notesMasterId r:id="rId23"/>
   </p:notesMasterIdLst>
   <p:handoutMasterIdLst>
-    <p:handoutMasterId r:id="rId23"/>
+    <p:handoutMasterId r:id="rId24"/>
   </p:handoutMasterIdLst>
   <p:sldIdLst>
     <p:sldId id="561" r:id="rId5"/>
@@ -24,10 +24,11 @@
     <p:sldId id="601" r:id="rId15"/>
     <p:sldId id="10725" r:id="rId16"/>
     <p:sldId id="10721" r:id="rId17"/>
-    <p:sldId id="10727" r:id="rId18"/>
-    <p:sldId id="10726" r:id="rId19"/>
-    <p:sldId id="10723" r:id="rId20"/>
-    <p:sldId id="597" r:id="rId21"/>
+    <p:sldId id="10728" r:id="rId18"/>
+    <p:sldId id="10727" r:id="rId19"/>
+    <p:sldId id="10726" r:id="rId20"/>
+    <p:sldId id="10723" r:id="rId21"/>
+    <p:sldId id="597" r:id="rId22"/>
   </p:sldIdLst>
   <p:sldSz cx="12192000" cy="6858000"/>
   <p:notesSz cx="6858000" cy="9144000"/>
@@ -227,7 +228,7 @@
                 </a:outerShdw>
               </a:effectLst>
             </c:spPr>
-            <c:extLst xmlns:w="http://schemas.openxmlformats.org/wordprocessingml/2006/main" xmlns:w15="http://schemas.microsoft.com/office/word/2012/wordml" xmlns:w14="http://schemas.microsoft.com/office/word/2010/wordml" xmlns:m="http://schemas.openxmlformats.org/officeDocument/2006/math" xmlns:wp="http://schemas.openxmlformats.org/drawingml/2006/wordprocessingDrawing" xmlns:wp14="http://schemas.microsoft.com/office/word/2010/wordprocessingDrawing" xmlns:mc="http://schemas.openxmlformats.org/markup-compatibility/2006" xmlns:sl="http://schemas.openxmlformats.org/schemaLibrary/2006/main" xmlns:wne="http://schemas.microsoft.com/office/word/2006/wordml" xmlns:cdr="http://schemas.openxmlformats.org/drawingml/2006/chartDrawing" xmlns:c14="http://schemas.microsoft.com/office/drawing/2007/8/2/chart" xmlns:dgm="http://schemas.openxmlformats.org/drawingml/2006/diagram" xmlns:pic="http://schemas.openxmlformats.org/drawingml/2006/picture" xmlns:xdr="http://schemas.openxmlformats.org/drawingml/2006/spreadsheetDrawing" xmlns:dsp="http://schemas.microsoft.com/office/drawing/2008/diagram" xmlns:xvml="urn:schemas-microsoft-com:office:excel" xmlns:o="urn:schemas-microsoft-com:office:office" xmlns:v="urn:schemas-microsoft-com:vml" xmlns:w10="urn:schemas-microsoft-com:office:word" xmlns:pvml="urn:schemas-microsoft-com:office:powerpoint" xmlns:cppr="http://schemas.microsoft.com/office/2006/coverPageProps" xmlns:odx="http://opendope.org/xpaths" xmlns:odc="http://opendope.org/conditions" xmlns:odq="http://opendope.org/questions" xmlns:oda="http://opendope.org/answers" xmlns:odi="http://opendope.org/components" xmlns:odgm="http://opendope.org/SmartArt/DataHierarchy" xmlns:b="http://schemas.openxmlformats.org/officeDocument/2006/bibliography" xmlns:wps="http://schemas.microsoft.com/office/word/2010/wordprocessingShape" xmlns:w16se="http://schemas.microsoft.com/office/word/2015/wordml/symex" xmlns:w16cid="http://schemas.microsoft.com/office/word/2016/wordml/cid" xmlns:wetp="http://schemas.microsoft.com/office/webextensions/taskpanes/2010/11" xmlns:we="http://schemas.microsoft.com/office/webextensions/webextension/2010/11" xmlns:comp="http://schemas.openxmlformats.org/drawingml/2006/compatibility" xmlns:lc="http://schemas.openxmlformats.org/drawingml/2006/lockedCanvas">
+            <c:extLst xmlns:lc="http://schemas.openxmlformats.org/drawingml/2006/lockedCanvas" xmlns:comp="http://schemas.openxmlformats.org/drawingml/2006/compatibility" xmlns:we="http://schemas.microsoft.com/office/webextensions/webextension/2010/11" xmlns:wetp="http://schemas.microsoft.com/office/webextensions/taskpanes/2010/11" xmlns:w16cid="http://schemas.microsoft.com/office/word/2016/wordml/cid" xmlns:w16se="http://schemas.microsoft.com/office/word/2015/wordml/symex" xmlns:wps="http://schemas.microsoft.com/office/word/2010/wordprocessingShape" xmlns:b="http://schemas.openxmlformats.org/officeDocument/2006/bibliography" xmlns:odgm="http://opendope.org/SmartArt/DataHierarchy" xmlns:odi="http://opendope.org/components" xmlns:oda="http://opendope.org/answers" xmlns:odq="http://opendope.org/questions" xmlns:odc="http://opendope.org/conditions" xmlns:odx="http://opendope.org/xpaths" xmlns:cppr="http://schemas.microsoft.com/office/2006/coverPageProps" xmlns:pvml="urn:schemas-microsoft-com:office:powerpoint" xmlns:w10="urn:schemas-microsoft-com:office:word" xmlns:v="urn:schemas-microsoft-com:vml" xmlns:o="urn:schemas-microsoft-com:office:office" xmlns:xvml="urn:schemas-microsoft-com:office:excel" xmlns:dsp="http://schemas.microsoft.com/office/drawing/2008/diagram" xmlns:xdr="http://schemas.openxmlformats.org/drawingml/2006/spreadsheetDrawing" xmlns:pic="http://schemas.openxmlformats.org/drawingml/2006/picture" xmlns:dgm="http://schemas.openxmlformats.org/drawingml/2006/diagram" xmlns:c14="http://schemas.microsoft.com/office/drawing/2007/8/2/chart" xmlns:cdr="http://schemas.openxmlformats.org/drawingml/2006/chartDrawing" xmlns:wne="http://schemas.microsoft.com/office/word/2006/wordml" xmlns:sl="http://schemas.openxmlformats.org/schemaLibrary/2006/main" xmlns:mc="http://schemas.openxmlformats.org/markup-compatibility/2006" xmlns:wp14="http://schemas.microsoft.com/office/word/2010/wordprocessingDrawing" xmlns:wp="http://schemas.openxmlformats.org/drawingml/2006/wordprocessingDrawing" xmlns:m="http://schemas.openxmlformats.org/officeDocument/2006/math" xmlns:w14="http://schemas.microsoft.com/office/word/2010/wordml" xmlns:w15="http://schemas.microsoft.com/office/word/2012/wordml" xmlns:w="http://schemas.openxmlformats.org/wordprocessingml/2006/main">
               <c:ext xmlns:c16="http://schemas.microsoft.com/office/drawing/2014/chart" uri="{C3380CC4-5D6E-409C-BE32-E72D297353CC}">
                 <c16:uniqueId val="{00000001-6147-E74A-AA7B-5531F0E4EE0C}"/>
               </c:ext>
@@ -256,7 +257,7 @@
               </c:numCache>
             </c:numRef>
           </c:val>
-          <c:extLst xmlns:w="http://schemas.openxmlformats.org/wordprocessingml/2006/main" xmlns:w15="http://schemas.microsoft.com/office/word/2012/wordml" xmlns:w14="http://schemas.microsoft.com/office/word/2010/wordml" xmlns:m="http://schemas.openxmlformats.org/officeDocument/2006/math" xmlns:wp="http://schemas.openxmlformats.org/drawingml/2006/wordprocessingDrawing" xmlns:wp14="http://schemas.microsoft.com/office/word/2010/wordprocessingDrawing" xmlns:mc="http://schemas.openxmlformats.org/markup-compatibility/2006" xmlns:sl="http://schemas.openxmlformats.org/schemaLibrary/2006/main" xmlns:wne="http://schemas.microsoft.com/office/word/2006/wordml" xmlns:cdr="http://schemas.openxmlformats.org/drawingml/2006/chartDrawing" xmlns:c14="http://schemas.microsoft.com/office/drawing/2007/8/2/chart" xmlns:dgm="http://schemas.openxmlformats.org/drawingml/2006/diagram" xmlns:pic="http://schemas.openxmlformats.org/drawingml/2006/picture" xmlns:xdr="http://schemas.openxmlformats.org/drawingml/2006/spreadsheetDrawing" xmlns:dsp="http://schemas.microsoft.com/office/drawing/2008/diagram" xmlns:xvml="urn:schemas-microsoft-com:office:excel" xmlns:o="urn:schemas-microsoft-com:office:office" xmlns:v="urn:schemas-microsoft-com:vml" xmlns:w10="urn:schemas-microsoft-com:office:word" xmlns:pvml="urn:schemas-microsoft-com:office:powerpoint" xmlns:cppr="http://schemas.microsoft.com/office/2006/coverPageProps" xmlns:odx="http://opendope.org/xpaths" xmlns:odc="http://opendope.org/conditions" xmlns:odq="http://opendope.org/questions" xmlns:oda="http://opendope.org/answers" xmlns:odi="http://opendope.org/components" xmlns:odgm="http://opendope.org/SmartArt/DataHierarchy" xmlns:b="http://schemas.openxmlformats.org/officeDocument/2006/bibliography" xmlns:wps="http://schemas.microsoft.com/office/word/2010/wordprocessingShape" xmlns:w16se="http://schemas.microsoft.com/office/word/2015/wordml/symex" xmlns:w16cid="http://schemas.microsoft.com/office/word/2016/wordml/cid" xmlns:wetp="http://schemas.microsoft.com/office/webextensions/taskpanes/2010/11" xmlns:we="http://schemas.microsoft.com/office/webextensions/webextension/2010/11" xmlns:comp="http://schemas.openxmlformats.org/drawingml/2006/compatibility" xmlns:lc="http://schemas.openxmlformats.org/drawingml/2006/lockedCanvas">
+          <c:extLst xmlns:lc="http://schemas.openxmlformats.org/drawingml/2006/lockedCanvas" xmlns:comp="http://schemas.openxmlformats.org/drawingml/2006/compatibility" xmlns:we="http://schemas.microsoft.com/office/webextensions/webextension/2010/11" xmlns:wetp="http://schemas.microsoft.com/office/webextensions/taskpanes/2010/11" xmlns:w16cid="http://schemas.microsoft.com/office/word/2016/wordml/cid" xmlns:w16se="http://schemas.microsoft.com/office/word/2015/wordml/symex" xmlns:wps="http://schemas.microsoft.com/office/word/2010/wordprocessingShape" xmlns:b="http://schemas.openxmlformats.org/officeDocument/2006/bibliography" xmlns:odgm="http://opendope.org/SmartArt/DataHierarchy" xmlns:odi="http://opendope.org/components" xmlns:oda="http://opendope.org/answers" xmlns:odq="http://opendope.org/questions" xmlns:odc="http://opendope.org/conditions" xmlns:odx="http://opendope.org/xpaths" xmlns:cppr="http://schemas.microsoft.com/office/2006/coverPageProps" xmlns:pvml="urn:schemas-microsoft-com:office:powerpoint" xmlns:w10="urn:schemas-microsoft-com:office:word" xmlns:v="urn:schemas-microsoft-com:vml" xmlns:o="urn:schemas-microsoft-com:office:office" xmlns:xvml="urn:schemas-microsoft-com:office:excel" xmlns:dsp="http://schemas.microsoft.com/office/drawing/2008/diagram" xmlns:xdr="http://schemas.openxmlformats.org/drawingml/2006/spreadsheetDrawing" xmlns:pic="http://schemas.openxmlformats.org/drawingml/2006/picture" xmlns:dgm="http://schemas.openxmlformats.org/drawingml/2006/diagram" xmlns:c14="http://schemas.microsoft.com/office/drawing/2007/8/2/chart" xmlns:cdr="http://schemas.openxmlformats.org/drawingml/2006/chartDrawing" xmlns:wne="http://schemas.microsoft.com/office/word/2006/wordml" xmlns:sl="http://schemas.openxmlformats.org/schemaLibrary/2006/main" xmlns:mc="http://schemas.openxmlformats.org/markup-compatibility/2006" xmlns:wp14="http://schemas.microsoft.com/office/word/2010/wordprocessingDrawing" xmlns:wp="http://schemas.openxmlformats.org/drawingml/2006/wordprocessingDrawing" xmlns:m="http://schemas.openxmlformats.org/officeDocument/2006/math" xmlns:w14="http://schemas.microsoft.com/office/word/2010/wordml" xmlns:w15="http://schemas.microsoft.com/office/word/2012/wordml" xmlns:w="http://schemas.openxmlformats.org/wordprocessingml/2006/main">
             <c:ext xmlns:c16="http://schemas.microsoft.com/office/drawing/2014/chart" uri="{C3380CC4-5D6E-409C-BE32-E72D297353CC}">
               <c16:uniqueId val="{00000002-6147-E74A-AA7B-5531F0E4EE0C}"/>
             </c:ext>
@@ -572,7 +573,7 @@
     </c:plotArea>
     <c:plotVisOnly val="1"/>
     <c:dispBlanksAs val="gap"/>
-    <c:extLst xmlns:w="http://schemas.openxmlformats.org/wordprocessingml/2006/main" xmlns:w15="http://schemas.microsoft.com/office/word/2012/wordml" xmlns:w14="http://schemas.microsoft.com/office/word/2010/wordml" xmlns:m="http://schemas.openxmlformats.org/officeDocument/2006/math" xmlns:wp="http://schemas.openxmlformats.org/drawingml/2006/wordprocessingDrawing" xmlns:wp14="http://schemas.microsoft.com/office/word/2010/wordprocessingDrawing" xmlns:mc="http://schemas.openxmlformats.org/markup-compatibility/2006" xmlns:sl="http://schemas.openxmlformats.org/schemaLibrary/2006/main" xmlns:wne="http://schemas.microsoft.com/office/word/2006/wordml" xmlns:cdr="http://schemas.openxmlformats.org/drawingml/2006/chartDrawing" xmlns:c14="http://schemas.microsoft.com/office/drawing/2007/8/2/chart" xmlns:dgm="http://schemas.openxmlformats.org/drawingml/2006/diagram" xmlns:pic="http://schemas.openxmlformats.org/drawingml/2006/picture" xmlns:xdr="http://schemas.openxmlformats.org/drawingml/2006/spreadsheetDrawing" xmlns:dsp="http://schemas.microsoft.com/office/drawing/2008/diagram" xmlns:xvml="urn:schemas-microsoft-com:office:excel" xmlns:o="urn:schemas-microsoft-com:office:office" xmlns:v="urn:schemas-microsoft-com:vml" xmlns:w10="urn:schemas-microsoft-com:office:word" xmlns:pvml="urn:schemas-microsoft-com:office:powerpoint" xmlns:cppr="http://schemas.microsoft.com/office/2006/coverPageProps" xmlns:odx="http://opendope.org/xpaths" xmlns:odc="http://opendope.org/conditions" xmlns:odq="http://opendope.org/questions" xmlns:oda="http://opendope.org/answers" xmlns:odi="http://opendope.org/components" xmlns:odgm="http://opendope.org/SmartArt/DataHierarchy" xmlns:b="http://schemas.openxmlformats.org/officeDocument/2006/bibliography" xmlns:wps="http://schemas.microsoft.com/office/word/2010/wordprocessingShape" xmlns:w16se="http://schemas.microsoft.com/office/word/2015/wordml/symex" xmlns:w16cid="http://schemas.microsoft.com/office/word/2016/wordml/cid" xmlns:wetp="http://schemas.microsoft.com/office/webextensions/taskpanes/2010/11" xmlns:we="http://schemas.microsoft.com/office/webextensions/webextension/2010/11" xmlns:comp="http://schemas.openxmlformats.org/drawingml/2006/compatibility" xmlns:lc="http://schemas.openxmlformats.org/drawingml/2006/lockedCanvas">
+    <c:extLst xmlns:lc="http://schemas.openxmlformats.org/drawingml/2006/lockedCanvas" xmlns:comp="http://schemas.openxmlformats.org/drawingml/2006/compatibility" xmlns:we="http://schemas.microsoft.com/office/webextensions/webextension/2010/11" xmlns:wetp="http://schemas.microsoft.com/office/webextensions/taskpanes/2010/11" xmlns:w16cid="http://schemas.microsoft.com/office/word/2016/wordml/cid" xmlns:w16se="http://schemas.microsoft.com/office/word/2015/wordml/symex" xmlns:wps="http://schemas.microsoft.com/office/word/2010/wordprocessingShape" xmlns:b="http://schemas.openxmlformats.org/officeDocument/2006/bibliography" xmlns:odgm="http://opendope.org/SmartArt/DataHierarchy" xmlns:odi="http://opendope.org/components" xmlns:oda="http://opendope.org/answers" xmlns:odq="http://opendope.org/questions" xmlns:odc="http://opendope.org/conditions" xmlns:odx="http://opendope.org/xpaths" xmlns:cppr="http://schemas.microsoft.com/office/2006/coverPageProps" xmlns:pvml="urn:schemas-microsoft-com:office:powerpoint" xmlns:w10="urn:schemas-microsoft-com:office:word" xmlns:v="urn:schemas-microsoft-com:vml" xmlns:o="urn:schemas-microsoft-com:office:office" xmlns:xvml="urn:schemas-microsoft-com:office:excel" xmlns:dsp="http://schemas.microsoft.com/office/drawing/2008/diagram" xmlns:xdr="http://schemas.openxmlformats.org/drawingml/2006/spreadsheetDrawing" xmlns:pic="http://schemas.openxmlformats.org/drawingml/2006/picture" xmlns:dgm="http://schemas.openxmlformats.org/drawingml/2006/diagram" xmlns:c14="http://schemas.microsoft.com/office/drawing/2007/8/2/chart" xmlns:cdr="http://schemas.openxmlformats.org/drawingml/2006/chartDrawing" xmlns:wne="http://schemas.microsoft.com/office/word/2006/wordml" xmlns:sl="http://schemas.openxmlformats.org/schemaLibrary/2006/main" xmlns:mc="http://schemas.openxmlformats.org/markup-compatibility/2006" xmlns:wp14="http://schemas.microsoft.com/office/word/2010/wordprocessingDrawing" xmlns:wp="http://schemas.openxmlformats.org/drawingml/2006/wordprocessingDrawing" xmlns:m="http://schemas.openxmlformats.org/officeDocument/2006/math" xmlns:w14="http://schemas.microsoft.com/office/word/2010/wordml" xmlns:w15="http://schemas.microsoft.com/office/word/2012/wordml" xmlns:w="http://schemas.openxmlformats.org/wordprocessingml/2006/main">
       <c:ext xmlns:c16r3="http://schemas.microsoft.com/office/drawing/2017/03/chart" uri="{56B9EC1D-385E-4148-901F-78D8002777C0}">
         <c16r3:dataDisplayOptions16>
           <c16r3:dispNaAsBlank val="1"/>
@@ -675,7 +676,7 @@
                 </a:outerShdw>
               </a:effectLst>
             </c:spPr>
-            <c:extLst xmlns:lc="http://schemas.openxmlformats.org/drawingml/2006/lockedCanvas" xmlns:comp="http://schemas.openxmlformats.org/drawingml/2006/compatibility" xmlns:we="http://schemas.microsoft.com/office/webextensions/webextension/2010/11" xmlns:wetp="http://schemas.microsoft.com/office/webextensions/taskpanes/2010/11" xmlns:w16cid="http://schemas.microsoft.com/office/word/2016/wordml/cid" xmlns:w16se="http://schemas.microsoft.com/office/word/2015/wordml/symex" xmlns:wps="http://schemas.microsoft.com/office/word/2010/wordprocessingShape" xmlns:b="http://schemas.openxmlformats.org/officeDocument/2006/bibliography" xmlns:odgm="http://opendope.org/SmartArt/DataHierarchy" xmlns:odi="http://opendope.org/components" xmlns:oda="http://opendope.org/answers" xmlns:odq="http://opendope.org/questions" xmlns:odc="http://opendope.org/conditions" xmlns:odx="http://opendope.org/xpaths" xmlns:cppr="http://schemas.microsoft.com/office/2006/coverPageProps" xmlns:pvml="urn:schemas-microsoft-com:office:powerpoint" xmlns:w10="urn:schemas-microsoft-com:office:word" xmlns:v="urn:schemas-microsoft-com:vml" xmlns:o="urn:schemas-microsoft-com:office:office" xmlns:xvml="urn:schemas-microsoft-com:office:excel" xmlns:dsp="http://schemas.microsoft.com/office/drawing/2008/diagram" xmlns:xdr="http://schemas.openxmlformats.org/drawingml/2006/spreadsheetDrawing" xmlns:pic="http://schemas.openxmlformats.org/drawingml/2006/picture" xmlns:dgm="http://schemas.openxmlformats.org/drawingml/2006/diagram" xmlns:c14="http://schemas.microsoft.com/office/drawing/2007/8/2/chart" xmlns:cdr="http://schemas.openxmlformats.org/drawingml/2006/chartDrawing" xmlns:wne="http://schemas.microsoft.com/office/word/2006/wordml" xmlns:sl="http://schemas.openxmlformats.org/schemaLibrary/2006/main" xmlns:mc="http://schemas.openxmlformats.org/markup-compatibility/2006" xmlns:wp14="http://schemas.microsoft.com/office/word/2010/wordprocessingDrawing" xmlns:wp="http://schemas.openxmlformats.org/drawingml/2006/wordprocessingDrawing" xmlns:m="http://schemas.openxmlformats.org/officeDocument/2006/math" xmlns:w14="http://schemas.microsoft.com/office/word/2010/wordml" xmlns:w15="http://schemas.microsoft.com/office/word/2012/wordml" xmlns:w="http://schemas.openxmlformats.org/wordprocessingml/2006/main">
+            <c:extLst xmlns:w="http://schemas.openxmlformats.org/wordprocessingml/2006/main" xmlns:w15="http://schemas.microsoft.com/office/word/2012/wordml" xmlns:w14="http://schemas.microsoft.com/office/word/2010/wordml" xmlns:m="http://schemas.openxmlformats.org/officeDocument/2006/math" xmlns:wp="http://schemas.openxmlformats.org/drawingml/2006/wordprocessingDrawing" xmlns:wp14="http://schemas.microsoft.com/office/word/2010/wordprocessingDrawing" xmlns:mc="http://schemas.openxmlformats.org/markup-compatibility/2006" xmlns:sl="http://schemas.openxmlformats.org/schemaLibrary/2006/main" xmlns:wne="http://schemas.microsoft.com/office/word/2006/wordml" xmlns:cdr="http://schemas.openxmlformats.org/drawingml/2006/chartDrawing" xmlns:c14="http://schemas.microsoft.com/office/drawing/2007/8/2/chart" xmlns:dgm="http://schemas.openxmlformats.org/drawingml/2006/diagram" xmlns:pic="http://schemas.openxmlformats.org/drawingml/2006/picture" xmlns:xdr="http://schemas.openxmlformats.org/drawingml/2006/spreadsheetDrawing" xmlns:dsp="http://schemas.microsoft.com/office/drawing/2008/diagram" xmlns:xvml="urn:schemas-microsoft-com:office:excel" xmlns:o="urn:schemas-microsoft-com:office:office" xmlns:v="urn:schemas-microsoft-com:vml" xmlns:w10="urn:schemas-microsoft-com:office:word" xmlns:pvml="urn:schemas-microsoft-com:office:powerpoint" xmlns:cppr="http://schemas.microsoft.com/office/2006/coverPageProps" xmlns:odx="http://opendope.org/xpaths" xmlns:odc="http://opendope.org/conditions" xmlns:odq="http://opendope.org/questions" xmlns:oda="http://opendope.org/answers" xmlns:odi="http://opendope.org/components" xmlns:odgm="http://opendope.org/SmartArt/DataHierarchy" xmlns:b="http://schemas.openxmlformats.org/officeDocument/2006/bibliography" xmlns:wps="http://schemas.microsoft.com/office/word/2010/wordprocessingShape" xmlns:w16se="http://schemas.microsoft.com/office/word/2015/wordml/symex" xmlns:w16cid="http://schemas.microsoft.com/office/word/2016/wordml/cid" xmlns:wetp="http://schemas.microsoft.com/office/webextensions/taskpanes/2010/11" xmlns:we="http://schemas.microsoft.com/office/webextensions/webextension/2010/11" xmlns:comp="http://schemas.openxmlformats.org/drawingml/2006/compatibility" xmlns:lc="http://schemas.openxmlformats.org/drawingml/2006/lockedCanvas">
               <c:ext xmlns:c16="http://schemas.microsoft.com/office/drawing/2014/chart" uri="{C3380CC4-5D6E-409C-BE32-E72D297353CC}">
                 <c16:uniqueId val="{00000001-6147-E74A-AA7B-5531F0E4EE0C}"/>
               </c:ext>
@@ -758,7 +759,7 @@
               </c:numCache>
             </c:numRef>
           </c:val>
-          <c:extLst xmlns:lc="http://schemas.openxmlformats.org/drawingml/2006/lockedCanvas" xmlns:comp="http://schemas.openxmlformats.org/drawingml/2006/compatibility" xmlns:we="http://schemas.microsoft.com/office/webextensions/webextension/2010/11" xmlns:wetp="http://schemas.microsoft.com/office/webextensions/taskpanes/2010/11" xmlns:w16cid="http://schemas.microsoft.com/office/word/2016/wordml/cid" xmlns:w16se="http://schemas.microsoft.com/office/word/2015/wordml/symex" xmlns:wps="http://schemas.microsoft.com/office/word/2010/wordprocessingShape" xmlns:b="http://schemas.openxmlformats.org/officeDocument/2006/bibliography" xmlns:odgm="http://opendope.org/SmartArt/DataHierarchy" xmlns:odi="http://opendope.org/components" xmlns:oda="http://opendope.org/answers" xmlns:odq="http://opendope.org/questions" xmlns:odc="http://opendope.org/conditions" xmlns:odx="http://opendope.org/xpaths" xmlns:cppr="http://schemas.microsoft.com/office/2006/coverPageProps" xmlns:pvml="urn:schemas-microsoft-com:office:powerpoint" xmlns:w10="urn:schemas-microsoft-com:office:word" xmlns:v="urn:schemas-microsoft-com:vml" xmlns:o="urn:schemas-microsoft-com:office:office" xmlns:xvml="urn:schemas-microsoft-com:office:excel" xmlns:dsp="http://schemas.microsoft.com/office/drawing/2008/diagram" xmlns:xdr="http://schemas.openxmlformats.org/drawingml/2006/spreadsheetDrawing" xmlns:pic="http://schemas.openxmlformats.org/drawingml/2006/picture" xmlns:dgm="http://schemas.openxmlformats.org/drawingml/2006/diagram" xmlns:c14="http://schemas.microsoft.com/office/drawing/2007/8/2/chart" xmlns:cdr="http://schemas.openxmlformats.org/drawingml/2006/chartDrawing" xmlns:wne="http://schemas.microsoft.com/office/word/2006/wordml" xmlns:sl="http://schemas.openxmlformats.org/schemaLibrary/2006/main" xmlns:mc="http://schemas.openxmlformats.org/markup-compatibility/2006" xmlns:wp14="http://schemas.microsoft.com/office/word/2010/wordprocessingDrawing" xmlns:wp="http://schemas.openxmlformats.org/drawingml/2006/wordprocessingDrawing" xmlns:m="http://schemas.openxmlformats.org/officeDocument/2006/math" xmlns:w14="http://schemas.microsoft.com/office/word/2010/wordml" xmlns:w15="http://schemas.microsoft.com/office/word/2012/wordml" xmlns:w="http://schemas.openxmlformats.org/wordprocessingml/2006/main">
+          <c:extLst xmlns:w="http://schemas.openxmlformats.org/wordprocessingml/2006/main" xmlns:w15="http://schemas.microsoft.com/office/word/2012/wordml" xmlns:w14="http://schemas.microsoft.com/office/word/2010/wordml" xmlns:m="http://schemas.openxmlformats.org/officeDocument/2006/math" xmlns:wp="http://schemas.openxmlformats.org/drawingml/2006/wordprocessingDrawing" xmlns:wp14="http://schemas.microsoft.com/office/word/2010/wordprocessingDrawing" xmlns:mc="http://schemas.openxmlformats.org/markup-compatibility/2006" xmlns:sl="http://schemas.openxmlformats.org/schemaLibrary/2006/main" xmlns:wne="http://schemas.microsoft.com/office/word/2006/wordml" xmlns:cdr="http://schemas.openxmlformats.org/drawingml/2006/chartDrawing" xmlns:c14="http://schemas.microsoft.com/office/drawing/2007/8/2/chart" xmlns:dgm="http://schemas.openxmlformats.org/drawingml/2006/diagram" xmlns:pic="http://schemas.openxmlformats.org/drawingml/2006/picture" xmlns:xdr="http://schemas.openxmlformats.org/drawingml/2006/spreadsheetDrawing" xmlns:dsp="http://schemas.microsoft.com/office/drawing/2008/diagram" xmlns:xvml="urn:schemas-microsoft-com:office:excel" xmlns:o="urn:schemas-microsoft-com:office:office" xmlns:v="urn:schemas-microsoft-com:vml" xmlns:w10="urn:schemas-microsoft-com:office:word" xmlns:pvml="urn:schemas-microsoft-com:office:powerpoint" xmlns:cppr="http://schemas.microsoft.com/office/2006/coverPageProps" xmlns:odx="http://opendope.org/xpaths" xmlns:odc="http://opendope.org/conditions" xmlns:odq="http://opendope.org/questions" xmlns:oda="http://opendope.org/answers" xmlns:odi="http://opendope.org/components" xmlns:odgm="http://opendope.org/SmartArt/DataHierarchy" xmlns:b="http://schemas.openxmlformats.org/officeDocument/2006/bibliography" xmlns:wps="http://schemas.microsoft.com/office/word/2010/wordprocessingShape" xmlns:w16se="http://schemas.microsoft.com/office/word/2015/wordml/symex" xmlns:w16cid="http://schemas.microsoft.com/office/word/2016/wordml/cid" xmlns:wetp="http://schemas.microsoft.com/office/webextensions/taskpanes/2010/11" xmlns:we="http://schemas.microsoft.com/office/webextensions/webextension/2010/11" xmlns:comp="http://schemas.openxmlformats.org/drawingml/2006/compatibility" xmlns:lc="http://schemas.openxmlformats.org/drawingml/2006/lockedCanvas">
             <c:ext xmlns:c16="http://schemas.microsoft.com/office/drawing/2014/chart" uri="{C3380CC4-5D6E-409C-BE32-E72D297353CC}">
               <c16:uniqueId val="{00000002-6147-E74A-AA7B-5531F0E4EE0C}"/>
             </c:ext>
@@ -1320,7 +1321,7 @@
     </c:plotArea>
     <c:plotVisOnly val="1"/>
     <c:dispBlanksAs val="gap"/>
-    <c:extLst xmlns:lc="http://schemas.openxmlformats.org/drawingml/2006/lockedCanvas" xmlns:comp="http://schemas.openxmlformats.org/drawingml/2006/compatibility" xmlns:we="http://schemas.microsoft.com/office/webextensions/webextension/2010/11" xmlns:wetp="http://schemas.microsoft.com/office/webextensions/taskpanes/2010/11" xmlns:w16cid="http://schemas.microsoft.com/office/word/2016/wordml/cid" xmlns:w16se="http://schemas.microsoft.com/office/word/2015/wordml/symex" xmlns:wps="http://schemas.microsoft.com/office/word/2010/wordprocessingShape" xmlns:b="http://schemas.openxmlformats.org/officeDocument/2006/bibliography" xmlns:odgm="http://opendope.org/SmartArt/DataHierarchy" xmlns:odi="http://opendope.org/components" xmlns:oda="http://opendope.org/answers" xmlns:odq="http://opendope.org/questions" xmlns:odc="http://opendope.org/conditions" xmlns:odx="http://opendope.org/xpaths" xmlns:cppr="http://schemas.microsoft.com/office/2006/coverPageProps" xmlns:pvml="urn:schemas-microsoft-com:office:powerpoint" xmlns:w10="urn:schemas-microsoft-com:office:word" xmlns:v="urn:schemas-microsoft-com:vml" xmlns:o="urn:schemas-microsoft-com:office:office" xmlns:xvml="urn:schemas-microsoft-com:office:excel" xmlns:dsp="http://schemas.microsoft.com/office/drawing/2008/diagram" xmlns:xdr="http://schemas.openxmlformats.org/drawingml/2006/spreadsheetDrawing" xmlns:pic="http://schemas.openxmlformats.org/drawingml/2006/picture" xmlns:dgm="http://schemas.openxmlformats.org/drawingml/2006/diagram" xmlns:c14="http://schemas.microsoft.com/office/drawing/2007/8/2/chart" xmlns:cdr="http://schemas.openxmlformats.org/drawingml/2006/chartDrawing" xmlns:wne="http://schemas.microsoft.com/office/word/2006/wordml" xmlns:sl="http://schemas.openxmlformats.org/schemaLibrary/2006/main" xmlns:mc="http://schemas.openxmlformats.org/markup-compatibility/2006" xmlns:wp14="http://schemas.microsoft.com/office/word/2010/wordprocessingDrawing" xmlns:wp="http://schemas.openxmlformats.org/drawingml/2006/wordprocessingDrawing" xmlns:m="http://schemas.openxmlformats.org/officeDocument/2006/math" xmlns:w14="http://schemas.microsoft.com/office/word/2010/wordml" xmlns:w15="http://schemas.microsoft.com/office/word/2012/wordml" xmlns:w="http://schemas.openxmlformats.org/wordprocessingml/2006/main">
+    <c:extLst xmlns:w="http://schemas.openxmlformats.org/wordprocessingml/2006/main" xmlns:w15="http://schemas.microsoft.com/office/word/2012/wordml" xmlns:w14="http://schemas.microsoft.com/office/word/2010/wordml" xmlns:m="http://schemas.openxmlformats.org/officeDocument/2006/math" xmlns:wp="http://schemas.openxmlformats.org/drawingml/2006/wordprocessingDrawing" xmlns:wp14="http://schemas.microsoft.com/office/word/2010/wordprocessingDrawing" xmlns:mc="http://schemas.openxmlformats.org/markup-compatibility/2006" xmlns:sl="http://schemas.openxmlformats.org/schemaLibrary/2006/main" xmlns:wne="http://schemas.microsoft.com/office/word/2006/wordml" xmlns:cdr="http://schemas.openxmlformats.org/drawingml/2006/chartDrawing" xmlns:c14="http://schemas.microsoft.com/office/drawing/2007/8/2/chart" xmlns:dgm="http://schemas.openxmlformats.org/drawingml/2006/diagram" xmlns:pic="http://schemas.openxmlformats.org/drawingml/2006/picture" xmlns:xdr="http://schemas.openxmlformats.org/drawingml/2006/spreadsheetDrawing" xmlns:dsp="http://schemas.microsoft.com/office/drawing/2008/diagram" xmlns:xvml="urn:schemas-microsoft-com:office:excel" xmlns:o="urn:schemas-microsoft-com:office:office" xmlns:v="urn:schemas-microsoft-com:vml" xmlns:w10="urn:schemas-microsoft-com:office:word" xmlns:pvml="urn:schemas-microsoft-com:office:powerpoint" xmlns:cppr="http://schemas.microsoft.com/office/2006/coverPageProps" xmlns:odx="http://opendope.org/xpaths" xmlns:odc="http://opendope.org/conditions" xmlns:odq="http://opendope.org/questions" xmlns:oda="http://opendope.org/answers" xmlns:odi="http://opendope.org/components" xmlns:odgm="http://opendope.org/SmartArt/DataHierarchy" xmlns:b="http://schemas.openxmlformats.org/officeDocument/2006/bibliography" xmlns:wps="http://schemas.microsoft.com/office/word/2010/wordprocessingShape" xmlns:w16se="http://schemas.microsoft.com/office/word/2015/wordml/symex" xmlns:w16cid="http://schemas.microsoft.com/office/word/2016/wordml/cid" xmlns:wetp="http://schemas.microsoft.com/office/webextensions/taskpanes/2010/11" xmlns:we="http://schemas.microsoft.com/office/webextensions/webextension/2010/11" xmlns:comp="http://schemas.openxmlformats.org/drawingml/2006/compatibility" xmlns:lc="http://schemas.openxmlformats.org/drawingml/2006/lockedCanvas">
       <c:ext xmlns:c16r3="http://schemas.microsoft.com/office/drawing/2017/03/chart" uri="{56B9EC1D-385E-4148-901F-78D8002777C0}">
         <c16r3:dataDisplayOptions16>
           <c16r3:dispNaAsBlank val="1"/>
@@ -1423,7 +1424,7 @@
                 </a:outerShdw>
               </a:effectLst>
             </c:spPr>
-            <c:extLst xmlns:w="http://schemas.openxmlformats.org/wordprocessingml/2006/main" xmlns:w15="http://schemas.microsoft.com/office/word/2012/wordml" xmlns:w14="http://schemas.microsoft.com/office/word/2010/wordml" xmlns:m="http://schemas.openxmlformats.org/officeDocument/2006/math" xmlns:wp="http://schemas.openxmlformats.org/drawingml/2006/wordprocessingDrawing" xmlns:wp14="http://schemas.microsoft.com/office/word/2010/wordprocessingDrawing" xmlns:mc="http://schemas.openxmlformats.org/markup-compatibility/2006" xmlns:sl="http://schemas.openxmlformats.org/schemaLibrary/2006/main" xmlns:wne="http://schemas.microsoft.com/office/word/2006/wordml" xmlns:cdr="http://schemas.openxmlformats.org/drawingml/2006/chartDrawing" xmlns:c14="http://schemas.microsoft.com/office/drawing/2007/8/2/chart" xmlns:dgm="http://schemas.openxmlformats.org/drawingml/2006/diagram" xmlns:pic="http://schemas.openxmlformats.org/drawingml/2006/picture" xmlns:xdr="http://schemas.openxmlformats.org/drawingml/2006/spreadsheetDrawing" xmlns:dsp="http://schemas.microsoft.com/office/drawing/2008/diagram" xmlns:xvml="urn:schemas-microsoft-com:office:excel" xmlns:o="urn:schemas-microsoft-com:office:office" xmlns:v="urn:schemas-microsoft-com:vml" xmlns:w10="urn:schemas-microsoft-com:office:word" xmlns:pvml="urn:schemas-microsoft-com:office:powerpoint" xmlns:cppr="http://schemas.microsoft.com/office/2006/coverPageProps" xmlns:odx="http://opendope.org/xpaths" xmlns:odc="http://opendope.org/conditions" xmlns:odq="http://opendope.org/questions" xmlns:oda="http://opendope.org/answers" xmlns:odi="http://opendope.org/components" xmlns:odgm="http://opendope.org/SmartArt/DataHierarchy" xmlns:b="http://schemas.openxmlformats.org/officeDocument/2006/bibliography" xmlns:wps="http://schemas.microsoft.com/office/word/2010/wordprocessingShape" xmlns:w16se="http://schemas.microsoft.com/office/word/2015/wordml/symex" xmlns:w16cid="http://schemas.microsoft.com/office/word/2016/wordml/cid" xmlns:wetp="http://schemas.microsoft.com/office/webextensions/taskpanes/2010/11" xmlns:we="http://schemas.microsoft.com/office/webextensions/webextension/2010/11" xmlns:comp="http://schemas.openxmlformats.org/drawingml/2006/compatibility" xmlns:lc="http://schemas.openxmlformats.org/drawingml/2006/lockedCanvas">
+            <c:extLst xmlns:lc="http://schemas.openxmlformats.org/drawingml/2006/lockedCanvas" xmlns:comp="http://schemas.openxmlformats.org/drawingml/2006/compatibility" xmlns:we="http://schemas.microsoft.com/office/webextensions/webextension/2010/11" xmlns:wetp="http://schemas.microsoft.com/office/webextensions/taskpanes/2010/11" xmlns:w16cid="http://schemas.microsoft.com/office/word/2016/wordml/cid" xmlns:w16se="http://schemas.microsoft.com/office/word/2015/wordml/symex" xmlns:wps="http://schemas.microsoft.com/office/word/2010/wordprocessingShape" xmlns:b="http://schemas.openxmlformats.org/officeDocument/2006/bibliography" xmlns:odgm="http://opendope.org/SmartArt/DataHierarchy" xmlns:odi="http://opendope.org/components" xmlns:oda="http://opendope.org/answers" xmlns:odq="http://opendope.org/questions" xmlns:odc="http://opendope.org/conditions" xmlns:odx="http://opendope.org/xpaths" xmlns:cppr="http://schemas.microsoft.com/office/2006/coverPageProps" xmlns:pvml="urn:schemas-microsoft-com:office:powerpoint" xmlns:w10="urn:schemas-microsoft-com:office:word" xmlns:v="urn:schemas-microsoft-com:vml" xmlns:o="urn:schemas-microsoft-com:office:office" xmlns:xvml="urn:schemas-microsoft-com:office:excel" xmlns:dsp="http://schemas.microsoft.com/office/drawing/2008/diagram" xmlns:xdr="http://schemas.openxmlformats.org/drawingml/2006/spreadsheetDrawing" xmlns:pic="http://schemas.openxmlformats.org/drawingml/2006/picture" xmlns:dgm="http://schemas.openxmlformats.org/drawingml/2006/diagram" xmlns:c14="http://schemas.microsoft.com/office/drawing/2007/8/2/chart" xmlns:cdr="http://schemas.openxmlformats.org/drawingml/2006/chartDrawing" xmlns:wne="http://schemas.microsoft.com/office/word/2006/wordml" xmlns:sl="http://schemas.openxmlformats.org/schemaLibrary/2006/main" xmlns:mc="http://schemas.openxmlformats.org/markup-compatibility/2006" xmlns:wp14="http://schemas.microsoft.com/office/word/2010/wordprocessingDrawing" xmlns:wp="http://schemas.openxmlformats.org/drawingml/2006/wordprocessingDrawing" xmlns:m="http://schemas.openxmlformats.org/officeDocument/2006/math" xmlns:w14="http://schemas.microsoft.com/office/word/2010/wordml" xmlns:w15="http://schemas.microsoft.com/office/word/2012/wordml" xmlns:w="http://schemas.openxmlformats.org/wordprocessingml/2006/main">
               <c:ext xmlns:c16="http://schemas.microsoft.com/office/drawing/2014/chart" uri="{C3380CC4-5D6E-409C-BE32-E72D297353CC}">
                 <c16:uniqueId val="{00000001-6147-E74A-AA7B-5531F0E4EE0C}"/>
               </c:ext>
@@ -1506,7 +1507,7 @@
               </c:numCache>
             </c:numRef>
           </c:val>
-          <c:extLst xmlns:w="http://schemas.openxmlformats.org/wordprocessingml/2006/main" xmlns:w15="http://schemas.microsoft.com/office/word/2012/wordml" xmlns:w14="http://schemas.microsoft.com/office/word/2010/wordml" xmlns:m="http://schemas.openxmlformats.org/officeDocument/2006/math" xmlns:wp="http://schemas.openxmlformats.org/drawingml/2006/wordprocessingDrawing" xmlns:wp14="http://schemas.microsoft.com/office/word/2010/wordprocessingDrawing" xmlns:mc="http://schemas.openxmlformats.org/markup-compatibility/2006" xmlns:sl="http://schemas.openxmlformats.org/schemaLibrary/2006/main" xmlns:wne="http://schemas.microsoft.com/office/word/2006/wordml" xmlns:cdr="http://schemas.openxmlformats.org/drawingml/2006/chartDrawing" xmlns:c14="http://schemas.microsoft.com/office/drawing/2007/8/2/chart" xmlns:dgm="http://schemas.openxmlformats.org/drawingml/2006/diagram" xmlns:pic="http://schemas.openxmlformats.org/drawingml/2006/picture" xmlns:xdr="http://schemas.openxmlformats.org/drawingml/2006/spreadsheetDrawing" xmlns:dsp="http://schemas.microsoft.com/office/drawing/2008/diagram" xmlns:xvml="urn:schemas-microsoft-com:office:excel" xmlns:o="urn:schemas-microsoft-com:office:office" xmlns:v="urn:schemas-microsoft-com:vml" xmlns:w10="urn:schemas-microsoft-com:office:word" xmlns:pvml="urn:schemas-microsoft-com:office:powerpoint" xmlns:cppr="http://schemas.microsoft.com/office/2006/coverPageProps" xmlns:odx="http://opendope.org/xpaths" xmlns:odc="http://opendope.org/conditions" xmlns:odq="http://opendope.org/questions" xmlns:oda="http://opendope.org/answers" xmlns:odi="http://opendope.org/components" xmlns:odgm="http://opendope.org/SmartArt/DataHierarchy" xmlns:b="http://schemas.openxmlformats.org/officeDocument/2006/bibliography" xmlns:wps="http://schemas.microsoft.com/office/word/2010/wordprocessingShape" xmlns:w16se="http://schemas.microsoft.com/office/word/2015/wordml/symex" xmlns:w16cid="http://schemas.microsoft.com/office/word/2016/wordml/cid" xmlns:wetp="http://schemas.microsoft.com/office/webextensions/taskpanes/2010/11" xmlns:we="http://schemas.microsoft.com/office/webextensions/webextension/2010/11" xmlns:comp="http://schemas.openxmlformats.org/drawingml/2006/compatibility" xmlns:lc="http://schemas.openxmlformats.org/drawingml/2006/lockedCanvas">
+          <c:extLst xmlns:lc="http://schemas.openxmlformats.org/drawingml/2006/lockedCanvas" xmlns:comp="http://schemas.openxmlformats.org/drawingml/2006/compatibility" xmlns:we="http://schemas.microsoft.com/office/webextensions/webextension/2010/11" xmlns:wetp="http://schemas.microsoft.com/office/webextensions/taskpanes/2010/11" xmlns:w16cid="http://schemas.microsoft.com/office/word/2016/wordml/cid" xmlns:w16se="http://schemas.microsoft.com/office/word/2015/wordml/symex" xmlns:wps="http://schemas.microsoft.com/office/word/2010/wordprocessingShape" xmlns:b="http://schemas.openxmlformats.org/officeDocument/2006/bibliography" xmlns:odgm="http://opendope.org/SmartArt/DataHierarchy" xmlns:odi="http://opendope.org/components" xmlns:oda="http://opendope.org/answers" xmlns:odq="http://opendope.org/questions" xmlns:odc="http://opendope.org/conditions" xmlns:odx="http://opendope.org/xpaths" xmlns:cppr="http://schemas.microsoft.com/office/2006/coverPageProps" xmlns:pvml="urn:schemas-microsoft-com:office:powerpoint" xmlns:w10="urn:schemas-microsoft-com:office:word" xmlns:v="urn:schemas-microsoft-com:vml" xmlns:o="urn:schemas-microsoft-com:office:office" xmlns:xvml="urn:schemas-microsoft-com:office:excel" xmlns:dsp="http://schemas.microsoft.com/office/drawing/2008/diagram" xmlns:xdr="http://schemas.openxmlformats.org/drawingml/2006/spreadsheetDrawing" xmlns:pic="http://schemas.openxmlformats.org/drawingml/2006/picture" xmlns:dgm="http://schemas.openxmlformats.org/drawingml/2006/diagram" xmlns:c14="http://schemas.microsoft.com/office/drawing/2007/8/2/chart" xmlns:cdr="http://schemas.openxmlformats.org/drawingml/2006/chartDrawing" xmlns:wne="http://schemas.microsoft.com/office/word/2006/wordml" xmlns:sl="http://schemas.openxmlformats.org/schemaLibrary/2006/main" xmlns:mc="http://schemas.openxmlformats.org/markup-compatibility/2006" xmlns:wp14="http://schemas.microsoft.com/office/word/2010/wordprocessingDrawing" xmlns:wp="http://schemas.openxmlformats.org/drawingml/2006/wordprocessingDrawing" xmlns:m="http://schemas.openxmlformats.org/officeDocument/2006/math" xmlns:w14="http://schemas.microsoft.com/office/word/2010/wordml" xmlns:w15="http://schemas.microsoft.com/office/word/2012/wordml" xmlns:w="http://schemas.openxmlformats.org/wordprocessingml/2006/main">
             <c:ext xmlns:c16="http://schemas.microsoft.com/office/drawing/2014/chart" uri="{C3380CC4-5D6E-409C-BE32-E72D297353CC}">
               <c16:uniqueId val="{00000002-6147-E74A-AA7B-5531F0E4EE0C}"/>
             </c:ext>
@@ -2068,7 +2069,7 @@
     </c:plotArea>
     <c:plotVisOnly val="1"/>
     <c:dispBlanksAs val="gap"/>
-    <c:extLst xmlns:w="http://schemas.openxmlformats.org/wordprocessingml/2006/main" xmlns:w15="http://schemas.microsoft.com/office/word/2012/wordml" xmlns:w14="http://schemas.microsoft.com/office/word/2010/wordml" xmlns:m="http://schemas.openxmlformats.org/officeDocument/2006/math" xmlns:wp="http://schemas.openxmlformats.org/drawingml/2006/wordprocessingDrawing" xmlns:wp14="http://schemas.microsoft.com/office/word/2010/wordprocessingDrawing" xmlns:mc="http://schemas.openxmlformats.org/markup-compatibility/2006" xmlns:sl="http://schemas.openxmlformats.org/schemaLibrary/2006/main" xmlns:wne="http://schemas.microsoft.com/office/word/2006/wordml" xmlns:cdr="http://schemas.openxmlformats.org/drawingml/2006/chartDrawing" xmlns:c14="http://schemas.microsoft.com/office/drawing/2007/8/2/chart" xmlns:dgm="http://schemas.openxmlformats.org/drawingml/2006/diagram" xmlns:pic="http://schemas.openxmlformats.org/drawingml/2006/picture" xmlns:xdr="http://schemas.openxmlformats.org/drawingml/2006/spreadsheetDrawing" xmlns:dsp="http://schemas.microsoft.com/office/drawing/2008/diagram" xmlns:xvml="urn:schemas-microsoft-com:office:excel" xmlns:o="urn:schemas-microsoft-com:office:office" xmlns:v="urn:schemas-microsoft-com:vml" xmlns:w10="urn:schemas-microsoft-com:office:word" xmlns:pvml="urn:schemas-microsoft-com:office:powerpoint" xmlns:cppr="http://schemas.microsoft.com/office/2006/coverPageProps" xmlns:odx="http://opendope.org/xpaths" xmlns:odc="http://opendope.org/conditions" xmlns:odq="http://opendope.org/questions" xmlns:oda="http://opendope.org/answers" xmlns:odi="http://opendope.org/components" xmlns:odgm="http://opendope.org/SmartArt/DataHierarchy" xmlns:b="http://schemas.openxmlformats.org/officeDocument/2006/bibliography" xmlns:wps="http://schemas.microsoft.com/office/word/2010/wordprocessingShape" xmlns:w16se="http://schemas.microsoft.com/office/word/2015/wordml/symex" xmlns:w16cid="http://schemas.microsoft.com/office/word/2016/wordml/cid" xmlns:wetp="http://schemas.microsoft.com/office/webextensions/taskpanes/2010/11" xmlns:we="http://schemas.microsoft.com/office/webextensions/webextension/2010/11" xmlns:comp="http://schemas.openxmlformats.org/drawingml/2006/compatibility" xmlns:lc="http://schemas.openxmlformats.org/drawingml/2006/lockedCanvas">
+    <c:extLst xmlns:lc="http://schemas.openxmlformats.org/drawingml/2006/lockedCanvas" xmlns:comp="http://schemas.openxmlformats.org/drawingml/2006/compatibility" xmlns:we="http://schemas.microsoft.com/office/webextensions/webextension/2010/11" xmlns:wetp="http://schemas.microsoft.com/office/webextensions/taskpanes/2010/11" xmlns:w16cid="http://schemas.microsoft.com/office/word/2016/wordml/cid" xmlns:w16se="http://schemas.microsoft.com/office/word/2015/wordml/symex" xmlns:wps="http://schemas.microsoft.com/office/word/2010/wordprocessingShape" xmlns:b="http://schemas.openxmlformats.org/officeDocument/2006/bibliography" xmlns:odgm="http://opendope.org/SmartArt/DataHierarchy" xmlns:odi="http://opendope.org/components" xmlns:oda="http://opendope.org/answers" xmlns:odq="http://opendope.org/questions" xmlns:odc="http://opendope.org/conditions" xmlns:odx="http://opendope.org/xpaths" xmlns:cppr="http://schemas.microsoft.com/office/2006/coverPageProps" xmlns:pvml="urn:schemas-microsoft-com:office:powerpoint" xmlns:w10="urn:schemas-microsoft-com:office:word" xmlns:v="urn:schemas-microsoft-com:vml" xmlns:o="urn:schemas-microsoft-com:office:office" xmlns:xvml="urn:schemas-microsoft-com:office:excel" xmlns:dsp="http://schemas.microsoft.com/office/drawing/2008/diagram" xmlns:xdr="http://schemas.openxmlformats.org/drawingml/2006/spreadsheetDrawing" xmlns:pic="http://schemas.openxmlformats.org/drawingml/2006/picture" xmlns:dgm="http://schemas.openxmlformats.org/drawingml/2006/diagram" xmlns:c14="http://schemas.microsoft.com/office/drawing/2007/8/2/chart" xmlns:cdr="http://schemas.openxmlformats.org/drawingml/2006/chartDrawing" xmlns:wne="http://schemas.microsoft.com/office/word/2006/wordml" xmlns:sl="http://schemas.openxmlformats.org/schemaLibrary/2006/main" xmlns:mc="http://schemas.openxmlformats.org/markup-compatibility/2006" xmlns:wp14="http://schemas.microsoft.com/office/word/2010/wordprocessingDrawing" xmlns:wp="http://schemas.openxmlformats.org/drawingml/2006/wordprocessingDrawing" xmlns:m="http://schemas.openxmlformats.org/officeDocument/2006/math" xmlns:w14="http://schemas.microsoft.com/office/word/2010/wordml" xmlns:w15="http://schemas.microsoft.com/office/word/2012/wordml" xmlns:w="http://schemas.openxmlformats.org/wordprocessingml/2006/main">
       <c:ext xmlns:c16r3="http://schemas.microsoft.com/office/drawing/2017/03/chart" uri="{56B9EC1D-385E-4148-901F-78D8002777C0}">
         <c16r3:dataDisplayOptions16>
           <c16r3:dispNaAsBlank val="1"/>
@@ -2171,7 +2172,7 @@
                 </a:outerShdw>
               </a:effectLst>
             </c:spPr>
-            <c:extLst xmlns:lc="http://schemas.openxmlformats.org/drawingml/2006/lockedCanvas" xmlns:comp="http://schemas.openxmlformats.org/drawingml/2006/compatibility" xmlns:we="http://schemas.microsoft.com/office/webextensions/webextension/2010/11" xmlns:wetp="http://schemas.microsoft.com/office/webextensions/taskpanes/2010/11" xmlns:w16cid="http://schemas.microsoft.com/office/word/2016/wordml/cid" xmlns:w16se="http://schemas.microsoft.com/office/word/2015/wordml/symex" xmlns:wps="http://schemas.microsoft.com/office/word/2010/wordprocessingShape" xmlns:b="http://schemas.openxmlformats.org/officeDocument/2006/bibliography" xmlns:odgm="http://opendope.org/SmartArt/DataHierarchy" xmlns:odi="http://opendope.org/components" xmlns:oda="http://opendope.org/answers" xmlns:odq="http://opendope.org/questions" xmlns:odc="http://opendope.org/conditions" xmlns:odx="http://opendope.org/xpaths" xmlns:cppr="http://schemas.microsoft.com/office/2006/coverPageProps" xmlns:pvml="urn:schemas-microsoft-com:office:powerpoint" xmlns:w10="urn:schemas-microsoft-com:office:word" xmlns:v="urn:schemas-microsoft-com:vml" xmlns:o="urn:schemas-microsoft-com:office:office" xmlns:xvml="urn:schemas-microsoft-com:office:excel" xmlns:dsp="http://schemas.microsoft.com/office/drawing/2008/diagram" xmlns:xdr="http://schemas.openxmlformats.org/drawingml/2006/spreadsheetDrawing" xmlns:pic="http://schemas.openxmlformats.org/drawingml/2006/picture" xmlns:dgm="http://schemas.openxmlformats.org/drawingml/2006/diagram" xmlns:c14="http://schemas.microsoft.com/office/drawing/2007/8/2/chart" xmlns:cdr="http://schemas.openxmlformats.org/drawingml/2006/chartDrawing" xmlns:wne="http://schemas.microsoft.com/office/word/2006/wordml" xmlns:sl="http://schemas.openxmlformats.org/schemaLibrary/2006/main" xmlns:mc="http://schemas.openxmlformats.org/markup-compatibility/2006" xmlns:wp14="http://schemas.microsoft.com/office/word/2010/wordprocessingDrawing" xmlns:wp="http://schemas.openxmlformats.org/drawingml/2006/wordprocessingDrawing" xmlns:m="http://schemas.openxmlformats.org/officeDocument/2006/math" xmlns:w14="http://schemas.microsoft.com/office/word/2010/wordml" xmlns:w15="http://schemas.microsoft.com/office/word/2012/wordml" xmlns:w="http://schemas.openxmlformats.org/wordprocessingml/2006/main">
+            <c:extLst xmlns:w="http://schemas.openxmlformats.org/wordprocessingml/2006/main" xmlns:w15="http://schemas.microsoft.com/office/word/2012/wordml" xmlns:w14="http://schemas.microsoft.com/office/word/2010/wordml" xmlns:m="http://schemas.openxmlformats.org/officeDocument/2006/math" xmlns:wp="http://schemas.openxmlformats.org/drawingml/2006/wordprocessingDrawing" xmlns:wp14="http://schemas.microsoft.com/office/word/2010/wordprocessingDrawing" xmlns:mc="http://schemas.openxmlformats.org/markup-compatibility/2006" xmlns:sl="http://schemas.openxmlformats.org/schemaLibrary/2006/main" xmlns:wne="http://schemas.microsoft.com/office/word/2006/wordml" xmlns:cdr="http://schemas.openxmlformats.org/drawingml/2006/chartDrawing" xmlns:c14="http://schemas.microsoft.com/office/drawing/2007/8/2/chart" xmlns:dgm="http://schemas.openxmlformats.org/drawingml/2006/diagram" xmlns:pic="http://schemas.openxmlformats.org/drawingml/2006/picture" xmlns:xdr="http://schemas.openxmlformats.org/drawingml/2006/spreadsheetDrawing" xmlns:dsp="http://schemas.microsoft.com/office/drawing/2008/diagram" xmlns:xvml="urn:schemas-microsoft-com:office:excel" xmlns:o="urn:schemas-microsoft-com:office:office" xmlns:v="urn:schemas-microsoft-com:vml" xmlns:w10="urn:schemas-microsoft-com:office:word" xmlns:pvml="urn:schemas-microsoft-com:office:powerpoint" xmlns:cppr="http://schemas.microsoft.com/office/2006/coverPageProps" xmlns:odx="http://opendope.org/xpaths" xmlns:odc="http://opendope.org/conditions" xmlns:odq="http://opendope.org/questions" xmlns:oda="http://opendope.org/answers" xmlns:odi="http://opendope.org/components" xmlns:odgm="http://opendope.org/SmartArt/DataHierarchy" xmlns:b="http://schemas.openxmlformats.org/officeDocument/2006/bibliography" xmlns:wps="http://schemas.microsoft.com/office/word/2010/wordprocessingShape" xmlns:w16se="http://schemas.microsoft.com/office/word/2015/wordml/symex" xmlns:w16cid="http://schemas.microsoft.com/office/word/2016/wordml/cid" xmlns:wetp="http://schemas.microsoft.com/office/webextensions/taskpanes/2010/11" xmlns:we="http://schemas.microsoft.com/office/webextensions/webextension/2010/11" xmlns:comp="http://schemas.openxmlformats.org/drawingml/2006/compatibility" xmlns:lc="http://schemas.openxmlformats.org/drawingml/2006/lockedCanvas">
               <c:ext xmlns:c16="http://schemas.microsoft.com/office/drawing/2014/chart" uri="{C3380CC4-5D6E-409C-BE32-E72D297353CC}">
                 <c16:uniqueId val="{00000001-6147-E74A-AA7B-5531F0E4EE0C}"/>
               </c:ext>
@@ -2266,7 +2267,7 @@
               </c:numCache>
             </c:numRef>
           </c:val>
-          <c:extLst xmlns:lc="http://schemas.openxmlformats.org/drawingml/2006/lockedCanvas" xmlns:comp="http://schemas.openxmlformats.org/drawingml/2006/compatibility" xmlns:we="http://schemas.microsoft.com/office/webextensions/webextension/2010/11" xmlns:wetp="http://schemas.microsoft.com/office/webextensions/taskpanes/2010/11" xmlns:w16cid="http://schemas.microsoft.com/office/word/2016/wordml/cid" xmlns:w16se="http://schemas.microsoft.com/office/word/2015/wordml/symex" xmlns:wps="http://schemas.microsoft.com/office/word/2010/wordprocessingShape" xmlns:b="http://schemas.openxmlformats.org/officeDocument/2006/bibliography" xmlns:odgm="http://opendope.org/SmartArt/DataHierarchy" xmlns:odi="http://opendope.org/components" xmlns:oda="http://opendope.org/answers" xmlns:odq="http://opendope.org/questions" xmlns:odc="http://opendope.org/conditions" xmlns:odx="http://opendope.org/xpaths" xmlns:cppr="http://schemas.microsoft.com/office/2006/coverPageProps" xmlns:pvml="urn:schemas-microsoft-com:office:powerpoint" xmlns:w10="urn:schemas-microsoft-com:office:word" xmlns:v="urn:schemas-microsoft-com:vml" xmlns:o="urn:schemas-microsoft-com:office:office" xmlns:xvml="urn:schemas-microsoft-com:office:excel" xmlns:dsp="http://schemas.microsoft.com/office/drawing/2008/diagram" xmlns:xdr="http://schemas.openxmlformats.org/drawingml/2006/spreadsheetDrawing" xmlns:pic="http://schemas.openxmlformats.org/drawingml/2006/picture" xmlns:dgm="http://schemas.openxmlformats.org/drawingml/2006/diagram" xmlns:c14="http://schemas.microsoft.com/office/drawing/2007/8/2/chart" xmlns:cdr="http://schemas.openxmlformats.org/drawingml/2006/chartDrawing" xmlns:wne="http://schemas.microsoft.com/office/word/2006/wordml" xmlns:sl="http://schemas.openxmlformats.org/schemaLibrary/2006/main" xmlns:mc="http://schemas.openxmlformats.org/markup-compatibility/2006" xmlns:wp14="http://schemas.microsoft.com/office/word/2010/wordprocessingDrawing" xmlns:wp="http://schemas.openxmlformats.org/drawingml/2006/wordprocessingDrawing" xmlns:m="http://schemas.openxmlformats.org/officeDocument/2006/math" xmlns:w14="http://schemas.microsoft.com/office/word/2010/wordml" xmlns:w15="http://schemas.microsoft.com/office/word/2012/wordml" xmlns:w="http://schemas.openxmlformats.org/wordprocessingml/2006/main">
+          <c:extLst xmlns:w="http://schemas.openxmlformats.org/wordprocessingml/2006/main" xmlns:w15="http://schemas.microsoft.com/office/word/2012/wordml" xmlns:w14="http://schemas.microsoft.com/office/word/2010/wordml" xmlns:m="http://schemas.openxmlformats.org/officeDocument/2006/math" xmlns:wp="http://schemas.openxmlformats.org/drawingml/2006/wordprocessingDrawing" xmlns:wp14="http://schemas.microsoft.com/office/word/2010/wordprocessingDrawing" xmlns:mc="http://schemas.openxmlformats.org/markup-compatibility/2006" xmlns:sl="http://schemas.openxmlformats.org/schemaLibrary/2006/main" xmlns:wne="http://schemas.microsoft.com/office/word/2006/wordml" xmlns:cdr="http://schemas.openxmlformats.org/drawingml/2006/chartDrawing" xmlns:c14="http://schemas.microsoft.com/office/drawing/2007/8/2/chart" xmlns:dgm="http://schemas.openxmlformats.org/drawingml/2006/diagram" xmlns:pic="http://schemas.openxmlformats.org/drawingml/2006/picture" xmlns:xdr="http://schemas.openxmlformats.org/drawingml/2006/spreadsheetDrawing" xmlns:dsp="http://schemas.microsoft.com/office/drawing/2008/diagram" xmlns:xvml="urn:schemas-microsoft-com:office:excel" xmlns:o="urn:schemas-microsoft-com:office:office" xmlns:v="urn:schemas-microsoft-com:vml" xmlns:w10="urn:schemas-microsoft-com:office:word" xmlns:pvml="urn:schemas-microsoft-com:office:powerpoint" xmlns:cppr="http://schemas.microsoft.com/office/2006/coverPageProps" xmlns:odx="http://opendope.org/xpaths" xmlns:odc="http://opendope.org/conditions" xmlns:odq="http://opendope.org/questions" xmlns:oda="http://opendope.org/answers" xmlns:odi="http://opendope.org/components" xmlns:odgm="http://opendope.org/SmartArt/DataHierarchy" xmlns:b="http://schemas.openxmlformats.org/officeDocument/2006/bibliography" xmlns:wps="http://schemas.microsoft.com/office/word/2010/wordprocessingShape" xmlns:w16se="http://schemas.microsoft.com/office/word/2015/wordml/symex" xmlns:w16cid="http://schemas.microsoft.com/office/word/2016/wordml/cid" xmlns:wetp="http://schemas.microsoft.com/office/webextensions/taskpanes/2010/11" xmlns:we="http://schemas.microsoft.com/office/webextensions/webextension/2010/11" xmlns:comp="http://schemas.openxmlformats.org/drawingml/2006/compatibility" xmlns:lc="http://schemas.openxmlformats.org/drawingml/2006/lockedCanvas">
             <c:ext xmlns:c16="http://schemas.microsoft.com/office/drawing/2014/chart" uri="{C3380CC4-5D6E-409C-BE32-E72D297353CC}">
               <c16:uniqueId val="{00000002-6147-E74A-AA7B-5531F0E4EE0C}"/>
             </c:ext>
@@ -2876,7 +2877,7 @@
     </c:plotArea>
     <c:plotVisOnly val="1"/>
     <c:dispBlanksAs val="gap"/>
-    <c:extLst xmlns:lc="http://schemas.openxmlformats.org/drawingml/2006/lockedCanvas" xmlns:comp="http://schemas.openxmlformats.org/drawingml/2006/compatibility" xmlns:we="http://schemas.microsoft.com/office/webextensions/webextension/2010/11" xmlns:wetp="http://schemas.microsoft.com/office/webextensions/taskpanes/2010/11" xmlns:w16cid="http://schemas.microsoft.com/office/word/2016/wordml/cid" xmlns:w16se="http://schemas.microsoft.com/office/word/2015/wordml/symex" xmlns:wps="http://schemas.microsoft.com/office/word/2010/wordprocessingShape" xmlns:b="http://schemas.openxmlformats.org/officeDocument/2006/bibliography" xmlns:odgm="http://opendope.org/SmartArt/DataHierarchy" xmlns:odi="http://opendope.org/components" xmlns:oda="http://opendope.org/answers" xmlns:odq="http://opendope.org/questions" xmlns:odc="http://opendope.org/conditions" xmlns:odx="http://opendope.org/xpaths" xmlns:cppr="http://schemas.microsoft.com/office/2006/coverPageProps" xmlns:pvml="urn:schemas-microsoft-com:office:powerpoint" xmlns:w10="urn:schemas-microsoft-com:office:word" xmlns:v="urn:schemas-microsoft-com:vml" xmlns:o="urn:schemas-microsoft-com:office:office" xmlns:xvml="urn:schemas-microsoft-com:office:excel" xmlns:dsp="http://schemas.microsoft.com/office/drawing/2008/diagram" xmlns:xdr="http://schemas.openxmlformats.org/drawingml/2006/spreadsheetDrawing" xmlns:pic="http://schemas.openxmlformats.org/drawingml/2006/picture" xmlns:dgm="http://schemas.openxmlformats.org/drawingml/2006/diagram" xmlns:c14="http://schemas.microsoft.com/office/drawing/2007/8/2/chart" xmlns:cdr="http://schemas.openxmlformats.org/drawingml/2006/chartDrawing" xmlns:wne="http://schemas.microsoft.com/office/word/2006/wordml" xmlns:sl="http://schemas.openxmlformats.org/schemaLibrary/2006/main" xmlns:mc="http://schemas.openxmlformats.org/markup-compatibility/2006" xmlns:wp14="http://schemas.microsoft.com/office/word/2010/wordprocessingDrawing" xmlns:wp="http://schemas.openxmlformats.org/drawingml/2006/wordprocessingDrawing" xmlns:m="http://schemas.openxmlformats.org/officeDocument/2006/math" xmlns:w14="http://schemas.microsoft.com/office/word/2010/wordml" xmlns:w15="http://schemas.microsoft.com/office/word/2012/wordml" xmlns:w="http://schemas.openxmlformats.org/wordprocessingml/2006/main">
+    <c:extLst xmlns:w="http://schemas.openxmlformats.org/wordprocessingml/2006/main" xmlns:w15="http://schemas.microsoft.com/office/word/2012/wordml" xmlns:w14="http://schemas.microsoft.com/office/word/2010/wordml" xmlns:m="http://schemas.openxmlformats.org/officeDocument/2006/math" xmlns:wp="http://schemas.openxmlformats.org/drawingml/2006/wordprocessingDrawing" xmlns:wp14="http://schemas.microsoft.com/office/word/2010/wordprocessingDrawing" xmlns:mc="http://schemas.openxmlformats.org/markup-compatibility/2006" xmlns:sl="http://schemas.openxmlformats.org/schemaLibrary/2006/main" xmlns:wne="http://schemas.microsoft.com/office/word/2006/wordml" xmlns:cdr="http://schemas.openxmlformats.org/drawingml/2006/chartDrawing" xmlns:c14="http://schemas.microsoft.com/office/drawing/2007/8/2/chart" xmlns:dgm="http://schemas.openxmlformats.org/drawingml/2006/diagram" xmlns:pic="http://schemas.openxmlformats.org/drawingml/2006/picture" xmlns:xdr="http://schemas.openxmlformats.org/drawingml/2006/spreadsheetDrawing" xmlns:dsp="http://schemas.microsoft.com/office/drawing/2008/diagram" xmlns:xvml="urn:schemas-microsoft-com:office:excel" xmlns:o="urn:schemas-microsoft-com:office:office" xmlns:v="urn:schemas-microsoft-com:vml" xmlns:w10="urn:schemas-microsoft-com:office:word" xmlns:pvml="urn:schemas-microsoft-com:office:powerpoint" xmlns:cppr="http://schemas.microsoft.com/office/2006/coverPageProps" xmlns:odx="http://opendope.org/xpaths" xmlns:odc="http://opendope.org/conditions" xmlns:odq="http://opendope.org/questions" xmlns:oda="http://opendope.org/answers" xmlns:odi="http://opendope.org/components" xmlns:odgm="http://opendope.org/SmartArt/DataHierarchy" xmlns:b="http://schemas.openxmlformats.org/officeDocument/2006/bibliography" xmlns:wps="http://schemas.microsoft.com/office/word/2010/wordprocessingShape" xmlns:w16se="http://schemas.microsoft.com/office/word/2015/wordml/symex" xmlns:w16cid="http://schemas.microsoft.com/office/word/2016/wordml/cid" xmlns:wetp="http://schemas.microsoft.com/office/webextensions/taskpanes/2010/11" xmlns:we="http://schemas.microsoft.com/office/webextensions/webextension/2010/11" xmlns:comp="http://schemas.openxmlformats.org/drawingml/2006/compatibility" xmlns:lc="http://schemas.openxmlformats.org/drawingml/2006/lockedCanvas">
       <c:ext xmlns:c16r3="http://schemas.microsoft.com/office/drawing/2017/03/chart" uri="{56B9EC1D-385E-4148-901F-78D8002777C0}">
         <c16r3:dataDisplayOptions16>
           <c16r3:dispNaAsBlank val="1"/>
@@ -2979,7 +2980,7 @@
                 </a:outerShdw>
               </a:effectLst>
             </c:spPr>
-            <c:extLst xmlns:lc="http://schemas.openxmlformats.org/drawingml/2006/lockedCanvas" xmlns:comp="http://schemas.openxmlformats.org/drawingml/2006/compatibility" xmlns:we="http://schemas.microsoft.com/office/webextensions/webextension/2010/11" xmlns:wetp="http://schemas.microsoft.com/office/webextensions/taskpanes/2010/11" xmlns:w16cid="http://schemas.microsoft.com/office/word/2016/wordml/cid" xmlns:w16se="http://schemas.microsoft.com/office/word/2015/wordml/symex" xmlns:wps="http://schemas.microsoft.com/office/word/2010/wordprocessingShape" xmlns:b="http://schemas.openxmlformats.org/officeDocument/2006/bibliography" xmlns:odgm="http://opendope.org/SmartArt/DataHierarchy" xmlns:odi="http://opendope.org/components" xmlns:oda="http://opendope.org/answers" xmlns:odq="http://opendope.org/questions" xmlns:odc="http://opendope.org/conditions" xmlns:odx="http://opendope.org/xpaths" xmlns:cppr="http://schemas.microsoft.com/office/2006/coverPageProps" xmlns:pvml="urn:schemas-microsoft-com:office:powerpoint" xmlns:w10="urn:schemas-microsoft-com:office:word" xmlns:v="urn:schemas-microsoft-com:vml" xmlns:o="urn:schemas-microsoft-com:office:office" xmlns:xvml="urn:schemas-microsoft-com:office:excel" xmlns:dsp="http://schemas.microsoft.com/office/drawing/2008/diagram" xmlns:xdr="http://schemas.openxmlformats.org/drawingml/2006/spreadsheetDrawing" xmlns:pic="http://schemas.openxmlformats.org/drawingml/2006/picture" xmlns:dgm="http://schemas.openxmlformats.org/drawingml/2006/diagram" xmlns:c14="http://schemas.microsoft.com/office/drawing/2007/8/2/chart" xmlns:cdr="http://schemas.openxmlformats.org/drawingml/2006/chartDrawing" xmlns:wne="http://schemas.microsoft.com/office/word/2006/wordml" xmlns:sl="http://schemas.openxmlformats.org/schemaLibrary/2006/main" xmlns:mc="http://schemas.openxmlformats.org/markup-compatibility/2006" xmlns:wp14="http://schemas.microsoft.com/office/word/2010/wordprocessingDrawing" xmlns:wp="http://schemas.openxmlformats.org/drawingml/2006/wordprocessingDrawing" xmlns:m="http://schemas.openxmlformats.org/officeDocument/2006/math" xmlns:w14="http://schemas.microsoft.com/office/word/2010/wordml" xmlns:w15="http://schemas.microsoft.com/office/word/2012/wordml" xmlns:w="http://schemas.openxmlformats.org/wordprocessingml/2006/main">
+            <c:extLst xmlns:w="http://schemas.openxmlformats.org/wordprocessingml/2006/main" xmlns:w15="http://schemas.microsoft.com/office/word/2012/wordml" xmlns:w14="http://schemas.microsoft.com/office/word/2010/wordml" xmlns:m="http://schemas.openxmlformats.org/officeDocument/2006/math" xmlns:wp="http://schemas.openxmlformats.org/drawingml/2006/wordprocessingDrawing" xmlns:wp14="http://schemas.microsoft.com/office/word/2010/wordprocessingDrawing" xmlns:mc="http://schemas.openxmlformats.org/markup-compatibility/2006" xmlns:sl="http://schemas.openxmlformats.org/schemaLibrary/2006/main" xmlns:wne="http://schemas.microsoft.com/office/word/2006/wordml" xmlns:cdr="http://schemas.openxmlformats.org/drawingml/2006/chartDrawing" xmlns:c14="http://schemas.microsoft.com/office/drawing/2007/8/2/chart" xmlns:dgm="http://schemas.openxmlformats.org/drawingml/2006/diagram" xmlns:pic="http://schemas.openxmlformats.org/drawingml/2006/picture" xmlns:xdr="http://schemas.openxmlformats.org/drawingml/2006/spreadsheetDrawing" xmlns:dsp="http://schemas.microsoft.com/office/drawing/2008/diagram" xmlns:xvml="urn:schemas-microsoft-com:office:excel" xmlns:o="urn:schemas-microsoft-com:office:office" xmlns:v="urn:schemas-microsoft-com:vml" xmlns:w10="urn:schemas-microsoft-com:office:word" xmlns:pvml="urn:schemas-microsoft-com:office:powerpoint" xmlns:cppr="http://schemas.microsoft.com/office/2006/coverPageProps" xmlns:odx="http://opendope.org/xpaths" xmlns:odc="http://opendope.org/conditions" xmlns:odq="http://opendope.org/questions" xmlns:oda="http://opendope.org/answers" xmlns:odi="http://opendope.org/components" xmlns:odgm="http://opendope.org/SmartArt/DataHierarchy" xmlns:b="http://schemas.openxmlformats.org/officeDocument/2006/bibliography" xmlns:wps="http://schemas.microsoft.com/office/word/2010/wordprocessingShape" xmlns:w16se="http://schemas.microsoft.com/office/word/2015/wordml/symex" xmlns:w16cid="http://schemas.microsoft.com/office/word/2016/wordml/cid" xmlns:wetp="http://schemas.microsoft.com/office/webextensions/taskpanes/2010/11" xmlns:we="http://schemas.microsoft.com/office/webextensions/webextension/2010/11" xmlns:comp="http://schemas.openxmlformats.org/drawingml/2006/compatibility" xmlns:lc="http://schemas.openxmlformats.org/drawingml/2006/lockedCanvas">
               <c:ext xmlns:c16="http://schemas.microsoft.com/office/drawing/2014/chart" uri="{C3380CC4-5D6E-409C-BE32-E72D297353CC}">
                 <c16:uniqueId val="{00000001-6147-E74A-AA7B-5531F0E4EE0C}"/>
               </c:ext>
@@ -3074,7 +3075,7 @@
               </c:numCache>
             </c:numRef>
           </c:val>
-          <c:extLst xmlns:lc="http://schemas.openxmlformats.org/drawingml/2006/lockedCanvas" xmlns:comp="http://schemas.openxmlformats.org/drawingml/2006/compatibility" xmlns:we="http://schemas.microsoft.com/office/webextensions/webextension/2010/11" xmlns:wetp="http://schemas.microsoft.com/office/webextensions/taskpanes/2010/11" xmlns:w16cid="http://schemas.microsoft.com/office/word/2016/wordml/cid" xmlns:w16se="http://schemas.microsoft.com/office/word/2015/wordml/symex" xmlns:wps="http://schemas.microsoft.com/office/word/2010/wordprocessingShape" xmlns:b="http://schemas.openxmlformats.org/officeDocument/2006/bibliography" xmlns:odgm="http://opendope.org/SmartArt/DataHierarchy" xmlns:odi="http://opendope.org/components" xmlns:oda="http://opendope.org/answers" xmlns:odq="http://opendope.org/questions" xmlns:odc="http://opendope.org/conditions" xmlns:odx="http://opendope.org/xpaths" xmlns:cppr="http://schemas.microsoft.com/office/2006/coverPageProps" xmlns:pvml="urn:schemas-microsoft-com:office:powerpoint" xmlns:w10="urn:schemas-microsoft-com:office:word" xmlns:v="urn:schemas-microsoft-com:vml" xmlns:o="urn:schemas-microsoft-com:office:office" xmlns:xvml="urn:schemas-microsoft-com:office:excel" xmlns:dsp="http://schemas.microsoft.com/office/drawing/2008/diagram" xmlns:xdr="http://schemas.openxmlformats.org/drawingml/2006/spreadsheetDrawing" xmlns:pic="http://schemas.openxmlformats.org/drawingml/2006/picture" xmlns:dgm="http://schemas.openxmlformats.org/drawingml/2006/diagram" xmlns:c14="http://schemas.microsoft.com/office/drawing/2007/8/2/chart" xmlns:cdr="http://schemas.openxmlformats.org/drawingml/2006/chartDrawing" xmlns:wne="http://schemas.microsoft.com/office/word/2006/wordml" xmlns:sl="http://schemas.openxmlformats.org/schemaLibrary/2006/main" xmlns:mc="http://schemas.openxmlformats.org/markup-compatibility/2006" xmlns:wp14="http://schemas.microsoft.com/office/word/2010/wordprocessingDrawing" xmlns:wp="http://schemas.openxmlformats.org/drawingml/2006/wordprocessingDrawing" xmlns:m="http://schemas.openxmlformats.org/officeDocument/2006/math" xmlns:w14="http://schemas.microsoft.com/office/word/2010/wordml" xmlns:w15="http://schemas.microsoft.com/office/word/2012/wordml" xmlns:w="http://schemas.openxmlformats.org/wordprocessingml/2006/main">
+          <c:extLst xmlns:w="http://schemas.openxmlformats.org/wordprocessingml/2006/main" xmlns:w15="http://schemas.microsoft.com/office/word/2012/wordml" xmlns:w14="http://schemas.microsoft.com/office/word/2010/wordml" xmlns:m="http://schemas.openxmlformats.org/officeDocument/2006/math" xmlns:wp="http://schemas.openxmlformats.org/drawingml/2006/wordprocessingDrawing" xmlns:wp14="http://schemas.microsoft.com/office/word/2010/wordprocessingDrawing" xmlns:mc="http://schemas.openxmlformats.org/markup-compatibility/2006" xmlns:sl="http://schemas.openxmlformats.org/schemaLibrary/2006/main" xmlns:wne="http://schemas.microsoft.com/office/word/2006/wordml" xmlns:cdr="http://schemas.openxmlformats.org/drawingml/2006/chartDrawing" xmlns:c14="http://schemas.microsoft.com/office/drawing/2007/8/2/chart" xmlns:dgm="http://schemas.openxmlformats.org/drawingml/2006/diagram" xmlns:pic="http://schemas.openxmlformats.org/drawingml/2006/picture" xmlns:xdr="http://schemas.openxmlformats.org/drawingml/2006/spreadsheetDrawing" xmlns:dsp="http://schemas.microsoft.com/office/drawing/2008/diagram" xmlns:xvml="urn:schemas-microsoft-com:office:excel" xmlns:o="urn:schemas-microsoft-com:office:office" xmlns:v="urn:schemas-microsoft-com:vml" xmlns:w10="urn:schemas-microsoft-com:office:word" xmlns:pvml="urn:schemas-microsoft-com:office:powerpoint" xmlns:cppr="http://schemas.microsoft.com/office/2006/coverPageProps" xmlns:odx="http://opendope.org/xpaths" xmlns:odc="http://opendope.org/conditions" xmlns:odq="http://opendope.org/questions" xmlns:oda="http://opendope.org/answers" xmlns:odi="http://opendope.org/components" xmlns:odgm="http://opendope.org/SmartArt/DataHierarchy" xmlns:b="http://schemas.openxmlformats.org/officeDocument/2006/bibliography" xmlns:wps="http://schemas.microsoft.com/office/word/2010/wordprocessingShape" xmlns:w16se="http://schemas.microsoft.com/office/word/2015/wordml/symex" xmlns:w16cid="http://schemas.microsoft.com/office/word/2016/wordml/cid" xmlns:wetp="http://schemas.microsoft.com/office/webextensions/taskpanes/2010/11" xmlns:we="http://schemas.microsoft.com/office/webextensions/webextension/2010/11" xmlns:comp="http://schemas.openxmlformats.org/drawingml/2006/compatibility" xmlns:lc="http://schemas.openxmlformats.org/drawingml/2006/lockedCanvas">
             <c:ext xmlns:c16="http://schemas.microsoft.com/office/drawing/2014/chart" uri="{C3380CC4-5D6E-409C-BE32-E72D297353CC}">
               <c16:uniqueId val="{00000002-6147-E74A-AA7B-5531F0E4EE0C}"/>
             </c:ext>
@@ -3684,7 +3685,7 @@
     </c:plotArea>
     <c:plotVisOnly val="1"/>
     <c:dispBlanksAs val="gap"/>
-    <c:extLst xmlns:lc="http://schemas.openxmlformats.org/drawingml/2006/lockedCanvas" xmlns:comp="http://schemas.openxmlformats.org/drawingml/2006/compatibility" xmlns:we="http://schemas.microsoft.com/office/webextensions/webextension/2010/11" xmlns:wetp="http://schemas.microsoft.com/office/webextensions/taskpanes/2010/11" xmlns:w16cid="http://schemas.microsoft.com/office/word/2016/wordml/cid" xmlns:w16se="http://schemas.microsoft.com/office/word/2015/wordml/symex" xmlns:wps="http://schemas.microsoft.com/office/word/2010/wordprocessingShape" xmlns:b="http://schemas.openxmlformats.org/officeDocument/2006/bibliography" xmlns:odgm="http://opendope.org/SmartArt/DataHierarchy" xmlns:odi="http://opendope.org/components" xmlns:oda="http://opendope.org/answers" xmlns:odq="http://opendope.org/questions" xmlns:odc="http://opendope.org/conditions" xmlns:odx="http://opendope.org/xpaths" xmlns:cppr="http://schemas.microsoft.com/office/2006/coverPageProps" xmlns:pvml="urn:schemas-microsoft-com:office:powerpoint" xmlns:w10="urn:schemas-microsoft-com:office:word" xmlns:v="urn:schemas-microsoft-com:vml" xmlns:o="urn:schemas-microsoft-com:office:office" xmlns:xvml="urn:schemas-microsoft-com:office:excel" xmlns:dsp="http://schemas.microsoft.com/office/drawing/2008/diagram" xmlns:xdr="http://schemas.openxmlformats.org/drawingml/2006/spreadsheetDrawing" xmlns:pic="http://schemas.openxmlformats.org/drawingml/2006/picture" xmlns:dgm="http://schemas.openxmlformats.org/drawingml/2006/diagram" xmlns:c14="http://schemas.microsoft.com/office/drawing/2007/8/2/chart" xmlns:cdr="http://schemas.openxmlformats.org/drawingml/2006/chartDrawing" xmlns:wne="http://schemas.microsoft.com/office/word/2006/wordml" xmlns:sl="http://schemas.openxmlformats.org/schemaLibrary/2006/main" xmlns:mc="http://schemas.openxmlformats.org/markup-compatibility/2006" xmlns:wp14="http://schemas.microsoft.com/office/word/2010/wordprocessingDrawing" xmlns:wp="http://schemas.openxmlformats.org/drawingml/2006/wordprocessingDrawing" xmlns:m="http://schemas.openxmlformats.org/officeDocument/2006/math" xmlns:w14="http://schemas.microsoft.com/office/word/2010/wordml" xmlns:w15="http://schemas.microsoft.com/office/word/2012/wordml" xmlns:w="http://schemas.openxmlformats.org/wordprocessingml/2006/main">
+    <c:extLst xmlns:w="http://schemas.openxmlformats.org/wordprocessingml/2006/main" xmlns:w15="http://schemas.microsoft.com/office/word/2012/wordml" xmlns:w14="http://schemas.microsoft.com/office/word/2010/wordml" xmlns:m="http://schemas.openxmlformats.org/officeDocument/2006/math" xmlns:wp="http://schemas.openxmlformats.org/drawingml/2006/wordprocessingDrawing" xmlns:wp14="http://schemas.microsoft.com/office/word/2010/wordprocessingDrawing" xmlns:mc="http://schemas.openxmlformats.org/markup-compatibility/2006" xmlns:sl="http://schemas.openxmlformats.org/schemaLibrary/2006/main" xmlns:wne="http://schemas.microsoft.com/office/word/2006/wordml" xmlns:cdr="http://schemas.openxmlformats.org/drawingml/2006/chartDrawing" xmlns:c14="http://schemas.microsoft.com/office/drawing/2007/8/2/chart" xmlns:dgm="http://schemas.openxmlformats.org/drawingml/2006/diagram" xmlns:pic="http://schemas.openxmlformats.org/drawingml/2006/picture" xmlns:xdr="http://schemas.openxmlformats.org/drawingml/2006/spreadsheetDrawing" xmlns:dsp="http://schemas.microsoft.com/office/drawing/2008/diagram" xmlns:xvml="urn:schemas-microsoft-com:office:excel" xmlns:o="urn:schemas-microsoft-com:office:office" xmlns:v="urn:schemas-microsoft-com:vml" xmlns:w10="urn:schemas-microsoft-com:office:word" xmlns:pvml="urn:schemas-microsoft-com:office:powerpoint" xmlns:cppr="http://schemas.microsoft.com/office/2006/coverPageProps" xmlns:odx="http://opendope.org/xpaths" xmlns:odc="http://opendope.org/conditions" xmlns:odq="http://opendope.org/questions" xmlns:oda="http://opendope.org/answers" xmlns:odi="http://opendope.org/components" xmlns:odgm="http://opendope.org/SmartArt/DataHierarchy" xmlns:b="http://schemas.openxmlformats.org/officeDocument/2006/bibliography" xmlns:wps="http://schemas.microsoft.com/office/word/2010/wordprocessingShape" xmlns:w16se="http://schemas.microsoft.com/office/word/2015/wordml/symex" xmlns:w16cid="http://schemas.microsoft.com/office/word/2016/wordml/cid" xmlns:wetp="http://schemas.microsoft.com/office/webextensions/taskpanes/2010/11" xmlns:we="http://schemas.microsoft.com/office/webextensions/webextension/2010/11" xmlns:comp="http://schemas.openxmlformats.org/drawingml/2006/compatibility" xmlns:lc="http://schemas.openxmlformats.org/drawingml/2006/lockedCanvas">
       <c:ext xmlns:c16r3="http://schemas.microsoft.com/office/drawing/2017/03/chart" uri="{56B9EC1D-385E-4148-901F-78D8002777C0}">
         <c16r3:dataDisplayOptions16>
           <c16r3:dispNaAsBlank val="1"/>
@@ -3787,7 +3788,7 @@
                 </a:outerShdw>
               </a:effectLst>
             </c:spPr>
-            <c:extLst xmlns:w="http://schemas.openxmlformats.org/wordprocessingml/2006/main" xmlns:w15="http://schemas.microsoft.com/office/word/2012/wordml" xmlns:w14="http://schemas.microsoft.com/office/word/2010/wordml" xmlns:m="http://schemas.openxmlformats.org/officeDocument/2006/math" xmlns:wp="http://schemas.openxmlformats.org/drawingml/2006/wordprocessingDrawing" xmlns:wp14="http://schemas.microsoft.com/office/word/2010/wordprocessingDrawing" xmlns:mc="http://schemas.openxmlformats.org/markup-compatibility/2006" xmlns:sl="http://schemas.openxmlformats.org/schemaLibrary/2006/main" xmlns:wne="http://schemas.microsoft.com/office/word/2006/wordml" xmlns:cdr="http://schemas.openxmlformats.org/drawingml/2006/chartDrawing" xmlns:c14="http://schemas.microsoft.com/office/drawing/2007/8/2/chart" xmlns:dgm="http://schemas.openxmlformats.org/drawingml/2006/diagram" xmlns:pic="http://schemas.openxmlformats.org/drawingml/2006/picture" xmlns:xdr="http://schemas.openxmlformats.org/drawingml/2006/spreadsheetDrawing" xmlns:dsp="http://schemas.microsoft.com/office/drawing/2008/diagram" xmlns:xvml="urn:schemas-microsoft-com:office:excel" xmlns:o="urn:schemas-microsoft-com:office:office" xmlns:v="urn:schemas-microsoft-com:vml" xmlns:w10="urn:schemas-microsoft-com:office:word" xmlns:pvml="urn:schemas-microsoft-com:office:powerpoint" xmlns:cppr="http://schemas.microsoft.com/office/2006/coverPageProps" xmlns:odx="http://opendope.org/xpaths" xmlns:odc="http://opendope.org/conditions" xmlns:odq="http://opendope.org/questions" xmlns:oda="http://opendope.org/answers" xmlns:odi="http://opendope.org/components" xmlns:odgm="http://opendope.org/SmartArt/DataHierarchy" xmlns:b="http://schemas.openxmlformats.org/officeDocument/2006/bibliography" xmlns:wps="http://schemas.microsoft.com/office/word/2010/wordprocessingShape" xmlns:w16se="http://schemas.microsoft.com/office/word/2015/wordml/symex" xmlns:w16cid="http://schemas.microsoft.com/office/word/2016/wordml/cid" xmlns:wetp="http://schemas.microsoft.com/office/webextensions/taskpanes/2010/11" xmlns:we="http://schemas.microsoft.com/office/webextensions/webextension/2010/11" xmlns:comp="http://schemas.openxmlformats.org/drawingml/2006/compatibility" xmlns:lc="http://schemas.openxmlformats.org/drawingml/2006/lockedCanvas">
+            <c:extLst xmlns:lc="http://schemas.openxmlformats.org/drawingml/2006/lockedCanvas" xmlns:comp="http://schemas.openxmlformats.org/drawingml/2006/compatibility" xmlns:we="http://schemas.microsoft.com/office/webextensions/webextension/2010/11" xmlns:wetp="http://schemas.microsoft.com/office/webextensions/taskpanes/2010/11" xmlns:w16cid="http://schemas.microsoft.com/office/word/2016/wordml/cid" xmlns:w16se="http://schemas.microsoft.com/office/word/2015/wordml/symex" xmlns:wps="http://schemas.microsoft.com/office/word/2010/wordprocessingShape" xmlns:b="http://schemas.openxmlformats.org/officeDocument/2006/bibliography" xmlns:odgm="http://opendope.org/SmartArt/DataHierarchy" xmlns:odi="http://opendope.org/components" xmlns:oda="http://opendope.org/answers" xmlns:odq="http://opendope.org/questions" xmlns:odc="http://opendope.org/conditions" xmlns:odx="http://opendope.org/xpaths" xmlns:cppr="http://schemas.microsoft.com/office/2006/coverPageProps" xmlns:pvml="urn:schemas-microsoft-com:office:powerpoint" xmlns:w10="urn:schemas-microsoft-com:office:word" xmlns:v="urn:schemas-microsoft-com:vml" xmlns:o="urn:schemas-microsoft-com:office:office" xmlns:xvml="urn:schemas-microsoft-com:office:excel" xmlns:dsp="http://schemas.microsoft.com/office/drawing/2008/diagram" xmlns:xdr="http://schemas.openxmlformats.org/drawingml/2006/spreadsheetDrawing" xmlns:pic="http://schemas.openxmlformats.org/drawingml/2006/picture" xmlns:dgm="http://schemas.openxmlformats.org/drawingml/2006/diagram" xmlns:c14="http://schemas.microsoft.com/office/drawing/2007/8/2/chart" xmlns:cdr="http://schemas.openxmlformats.org/drawingml/2006/chartDrawing" xmlns:wne="http://schemas.microsoft.com/office/word/2006/wordml" xmlns:sl="http://schemas.openxmlformats.org/schemaLibrary/2006/main" xmlns:mc="http://schemas.openxmlformats.org/markup-compatibility/2006" xmlns:wp14="http://schemas.microsoft.com/office/word/2010/wordprocessingDrawing" xmlns:wp="http://schemas.openxmlformats.org/drawingml/2006/wordprocessingDrawing" xmlns:m="http://schemas.openxmlformats.org/officeDocument/2006/math" xmlns:w14="http://schemas.microsoft.com/office/word/2010/wordml" xmlns:w15="http://schemas.microsoft.com/office/word/2012/wordml" xmlns:w="http://schemas.openxmlformats.org/wordprocessingml/2006/main">
               <c:ext xmlns:c16="http://schemas.microsoft.com/office/drawing/2014/chart" uri="{C3380CC4-5D6E-409C-BE32-E72D297353CC}">
                 <c16:uniqueId val="{00000001-6147-E74A-AA7B-5531F0E4EE0C}"/>
               </c:ext>
@@ -3882,7 +3883,7 @@
               </c:numCache>
             </c:numRef>
           </c:val>
-          <c:extLst xmlns:w="http://schemas.openxmlformats.org/wordprocessingml/2006/main" xmlns:w15="http://schemas.microsoft.com/office/word/2012/wordml" xmlns:w14="http://schemas.microsoft.com/office/word/2010/wordml" xmlns:m="http://schemas.openxmlformats.org/officeDocument/2006/math" xmlns:wp="http://schemas.openxmlformats.org/drawingml/2006/wordprocessingDrawing" xmlns:wp14="http://schemas.microsoft.com/office/word/2010/wordprocessingDrawing" xmlns:mc="http://schemas.openxmlformats.org/markup-compatibility/2006" xmlns:sl="http://schemas.openxmlformats.org/schemaLibrary/2006/main" xmlns:wne="http://schemas.microsoft.com/office/word/2006/wordml" xmlns:cdr="http://schemas.openxmlformats.org/drawingml/2006/chartDrawing" xmlns:c14="http://schemas.microsoft.com/office/drawing/2007/8/2/chart" xmlns:dgm="http://schemas.openxmlformats.org/drawingml/2006/diagram" xmlns:pic="http://schemas.openxmlformats.org/drawingml/2006/picture" xmlns:xdr="http://schemas.openxmlformats.org/drawingml/2006/spreadsheetDrawing" xmlns:dsp="http://schemas.microsoft.com/office/drawing/2008/diagram" xmlns:xvml="urn:schemas-microsoft-com:office:excel" xmlns:o="urn:schemas-microsoft-com:office:office" xmlns:v="urn:schemas-microsoft-com:vml" xmlns:w10="urn:schemas-microsoft-com:office:word" xmlns:pvml="urn:schemas-microsoft-com:office:powerpoint" xmlns:cppr="http://schemas.microsoft.com/office/2006/coverPageProps" xmlns:odx="http://opendope.org/xpaths" xmlns:odc="http://opendope.org/conditions" xmlns:odq="http://opendope.org/questions" xmlns:oda="http://opendope.org/answers" xmlns:odi="http://opendope.org/components" xmlns:odgm="http://opendope.org/SmartArt/DataHierarchy" xmlns:b="http://schemas.openxmlformats.org/officeDocument/2006/bibliography" xmlns:wps="http://schemas.microsoft.com/office/word/2010/wordprocessingShape" xmlns:w16se="http://schemas.microsoft.com/office/word/2015/wordml/symex" xmlns:w16cid="http://schemas.microsoft.com/office/word/2016/wordml/cid" xmlns:wetp="http://schemas.microsoft.com/office/webextensions/taskpanes/2010/11" xmlns:we="http://schemas.microsoft.com/office/webextensions/webextension/2010/11" xmlns:comp="http://schemas.openxmlformats.org/drawingml/2006/compatibility" xmlns:lc="http://schemas.openxmlformats.org/drawingml/2006/lockedCanvas">
+          <c:extLst xmlns:lc="http://schemas.openxmlformats.org/drawingml/2006/lockedCanvas" xmlns:comp="http://schemas.openxmlformats.org/drawingml/2006/compatibility" xmlns:we="http://schemas.microsoft.com/office/webextensions/webextension/2010/11" xmlns:wetp="http://schemas.microsoft.com/office/webextensions/taskpanes/2010/11" xmlns:w16cid="http://schemas.microsoft.com/office/word/2016/wordml/cid" xmlns:w16se="http://schemas.microsoft.com/office/word/2015/wordml/symex" xmlns:wps="http://schemas.microsoft.com/office/word/2010/wordprocessingShape" xmlns:b="http://schemas.openxmlformats.org/officeDocument/2006/bibliography" xmlns:odgm="http://opendope.org/SmartArt/DataHierarchy" xmlns:odi="http://opendope.org/components" xmlns:oda="http://opendope.org/answers" xmlns:odq="http://opendope.org/questions" xmlns:odc="http://opendope.org/conditions" xmlns:odx="http://opendope.org/xpaths" xmlns:cppr="http://schemas.microsoft.com/office/2006/coverPageProps" xmlns:pvml="urn:schemas-microsoft-com:office:powerpoint" xmlns:w10="urn:schemas-microsoft-com:office:word" xmlns:v="urn:schemas-microsoft-com:vml" xmlns:o="urn:schemas-microsoft-com:office:office" xmlns:xvml="urn:schemas-microsoft-com:office:excel" xmlns:dsp="http://schemas.microsoft.com/office/drawing/2008/diagram" xmlns:xdr="http://schemas.openxmlformats.org/drawingml/2006/spreadsheetDrawing" xmlns:pic="http://schemas.openxmlformats.org/drawingml/2006/picture" xmlns:dgm="http://schemas.openxmlformats.org/drawingml/2006/diagram" xmlns:c14="http://schemas.microsoft.com/office/drawing/2007/8/2/chart" xmlns:cdr="http://schemas.openxmlformats.org/drawingml/2006/chartDrawing" xmlns:wne="http://schemas.microsoft.com/office/word/2006/wordml" xmlns:sl="http://schemas.openxmlformats.org/schemaLibrary/2006/main" xmlns:mc="http://schemas.openxmlformats.org/markup-compatibility/2006" xmlns:wp14="http://schemas.microsoft.com/office/word/2010/wordprocessingDrawing" xmlns:wp="http://schemas.openxmlformats.org/drawingml/2006/wordprocessingDrawing" xmlns:m="http://schemas.openxmlformats.org/officeDocument/2006/math" xmlns:w14="http://schemas.microsoft.com/office/word/2010/wordml" xmlns:w15="http://schemas.microsoft.com/office/word/2012/wordml" xmlns:w="http://schemas.openxmlformats.org/wordprocessingml/2006/main">
             <c:ext xmlns:c16="http://schemas.microsoft.com/office/drawing/2014/chart" uri="{C3380CC4-5D6E-409C-BE32-E72D297353CC}">
               <c16:uniqueId val="{00000002-6147-E74A-AA7B-5531F0E4EE0C}"/>
             </c:ext>
@@ -4492,7 +4493,7 @@
     </c:plotArea>
     <c:plotVisOnly val="1"/>
     <c:dispBlanksAs val="gap"/>
-    <c:extLst xmlns:w="http://schemas.openxmlformats.org/wordprocessingml/2006/main" xmlns:w15="http://schemas.microsoft.com/office/word/2012/wordml" xmlns:w14="http://schemas.microsoft.com/office/word/2010/wordml" xmlns:m="http://schemas.openxmlformats.org/officeDocument/2006/math" xmlns:wp="http://schemas.openxmlformats.org/drawingml/2006/wordprocessingDrawing" xmlns:wp14="http://schemas.microsoft.com/office/word/2010/wordprocessingDrawing" xmlns:mc="http://schemas.openxmlformats.org/markup-compatibility/2006" xmlns:sl="http://schemas.openxmlformats.org/schemaLibrary/2006/main" xmlns:wne="http://schemas.microsoft.com/office/word/2006/wordml" xmlns:cdr="http://schemas.openxmlformats.org/drawingml/2006/chartDrawing" xmlns:c14="http://schemas.microsoft.com/office/drawing/2007/8/2/chart" xmlns:dgm="http://schemas.openxmlformats.org/drawingml/2006/diagram" xmlns:pic="http://schemas.openxmlformats.org/drawingml/2006/picture" xmlns:xdr="http://schemas.openxmlformats.org/drawingml/2006/spreadsheetDrawing" xmlns:dsp="http://schemas.microsoft.com/office/drawing/2008/diagram" xmlns:xvml="urn:schemas-microsoft-com:office:excel" xmlns:o="urn:schemas-microsoft-com:office:office" xmlns:v="urn:schemas-microsoft-com:vml" xmlns:w10="urn:schemas-microsoft-com:office:word" xmlns:pvml="urn:schemas-microsoft-com:office:powerpoint" xmlns:cppr="http://schemas.microsoft.com/office/2006/coverPageProps" xmlns:odx="http://opendope.org/xpaths" xmlns:odc="http://opendope.org/conditions" xmlns:odq="http://opendope.org/questions" xmlns:oda="http://opendope.org/answers" xmlns:odi="http://opendope.org/components" xmlns:odgm="http://opendope.org/SmartArt/DataHierarchy" xmlns:b="http://schemas.openxmlformats.org/officeDocument/2006/bibliography" xmlns:wps="http://schemas.microsoft.com/office/word/2010/wordprocessingShape" xmlns:w16se="http://schemas.microsoft.com/office/word/2015/wordml/symex" xmlns:w16cid="http://schemas.microsoft.com/office/word/2016/wordml/cid" xmlns:wetp="http://schemas.microsoft.com/office/webextensions/taskpanes/2010/11" xmlns:we="http://schemas.microsoft.com/office/webextensions/webextension/2010/11" xmlns:comp="http://schemas.openxmlformats.org/drawingml/2006/compatibility" xmlns:lc="http://schemas.openxmlformats.org/drawingml/2006/lockedCanvas">
+    <c:extLst xmlns:lc="http://schemas.openxmlformats.org/drawingml/2006/lockedCanvas" xmlns:comp="http://schemas.openxmlformats.org/drawingml/2006/compatibility" xmlns:we="http://schemas.microsoft.com/office/webextensions/webextension/2010/11" xmlns:wetp="http://schemas.microsoft.com/office/webextensions/taskpanes/2010/11" xmlns:w16cid="http://schemas.microsoft.com/office/word/2016/wordml/cid" xmlns:w16se="http://schemas.microsoft.com/office/word/2015/wordml/symex" xmlns:wps="http://schemas.microsoft.com/office/word/2010/wordprocessingShape" xmlns:b="http://schemas.openxmlformats.org/officeDocument/2006/bibliography" xmlns:odgm="http://opendope.org/SmartArt/DataHierarchy" xmlns:odi="http://opendope.org/components" xmlns:oda="http://opendope.org/answers" xmlns:odq="http://opendope.org/questions" xmlns:odc="http://opendope.org/conditions" xmlns:odx="http://opendope.org/xpaths" xmlns:cppr="http://schemas.microsoft.com/office/2006/coverPageProps" xmlns:pvml="urn:schemas-microsoft-com:office:powerpoint" xmlns:w10="urn:schemas-microsoft-com:office:word" xmlns:v="urn:schemas-microsoft-com:vml" xmlns:o="urn:schemas-microsoft-com:office:office" xmlns:xvml="urn:schemas-microsoft-com:office:excel" xmlns:dsp="http://schemas.microsoft.com/office/drawing/2008/diagram" xmlns:xdr="http://schemas.openxmlformats.org/drawingml/2006/spreadsheetDrawing" xmlns:pic="http://schemas.openxmlformats.org/drawingml/2006/picture" xmlns:dgm="http://schemas.openxmlformats.org/drawingml/2006/diagram" xmlns:c14="http://schemas.microsoft.com/office/drawing/2007/8/2/chart" xmlns:cdr="http://schemas.openxmlformats.org/drawingml/2006/chartDrawing" xmlns:wne="http://schemas.microsoft.com/office/word/2006/wordml" xmlns:sl="http://schemas.openxmlformats.org/schemaLibrary/2006/main" xmlns:mc="http://schemas.openxmlformats.org/markup-compatibility/2006" xmlns:wp14="http://schemas.microsoft.com/office/word/2010/wordprocessingDrawing" xmlns:wp="http://schemas.openxmlformats.org/drawingml/2006/wordprocessingDrawing" xmlns:m="http://schemas.openxmlformats.org/officeDocument/2006/math" xmlns:w14="http://schemas.microsoft.com/office/word/2010/wordml" xmlns:w15="http://schemas.microsoft.com/office/word/2012/wordml" xmlns:w="http://schemas.openxmlformats.org/wordprocessingml/2006/main">
       <c:ext xmlns:c16r3="http://schemas.microsoft.com/office/drawing/2017/03/chart" uri="{56B9EC1D-385E-4148-901F-78D8002777C0}">
         <c16r3:dataDisplayOptions16>
           <c16r3:dispNaAsBlank val="1"/>
@@ -4595,7 +4596,7 @@
                 </a:outerShdw>
               </a:effectLst>
             </c:spPr>
-            <c:extLst xmlns:w="http://schemas.openxmlformats.org/wordprocessingml/2006/main" xmlns:w15="http://schemas.microsoft.com/office/word/2012/wordml" xmlns:w14="http://schemas.microsoft.com/office/word/2010/wordml" xmlns:m="http://schemas.openxmlformats.org/officeDocument/2006/math" xmlns:wp="http://schemas.openxmlformats.org/drawingml/2006/wordprocessingDrawing" xmlns:wp14="http://schemas.microsoft.com/office/word/2010/wordprocessingDrawing" xmlns:mc="http://schemas.openxmlformats.org/markup-compatibility/2006" xmlns:sl="http://schemas.openxmlformats.org/schemaLibrary/2006/main" xmlns:wne="http://schemas.microsoft.com/office/word/2006/wordml" xmlns:cdr="http://schemas.openxmlformats.org/drawingml/2006/chartDrawing" xmlns:c14="http://schemas.microsoft.com/office/drawing/2007/8/2/chart" xmlns:dgm="http://schemas.openxmlformats.org/drawingml/2006/diagram" xmlns:pic="http://schemas.openxmlformats.org/drawingml/2006/picture" xmlns:xdr="http://schemas.openxmlformats.org/drawingml/2006/spreadsheetDrawing" xmlns:dsp="http://schemas.microsoft.com/office/drawing/2008/diagram" xmlns:xvml="urn:schemas-microsoft-com:office:excel" xmlns:o="urn:schemas-microsoft-com:office:office" xmlns:v="urn:schemas-microsoft-com:vml" xmlns:w10="urn:schemas-microsoft-com:office:word" xmlns:pvml="urn:schemas-microsoft-com:office:powerpoint" xmlns:cppr="http://schemas.microsoft.com/office/2006/coverPageProps" xmlns:odx="http://opendope.org/xpaths" xmlns:odc="http://opendope.org/conditions" xmlns:odq="http://opendope.org/questions" xmlns:oda="http://opendope.org/answers" xmlns:odi="http://opendope.org/components" xmlns:odgm="http://opendope.org/SmartArt/DataHierarchy" xmlns:b="http://schemas.openxmlformats.org/officeDocument/2006/bibliography" xmlns:wps="http://schemas.microsoft.com/office/word/2010/wordprocessingShape" xmlns:w16se="http://schemas.microsoft.com/office/word/2015/wordml/symex" xmlns:w16cid="http://schemas.microsoft.com/office/word/2016/wordml/cid" xmlns:wetp="http://schemas.microsoft.com/office/webextensions/taskpanes/2010/11" xmlns:we="http://schemas.microsoft.com/office/webextensions/webextension/2010/11" xmlns:comp="http://schemas.openxmlformats.org/drawingml/2006/compatibility" xmlns:lc="http://schemas.openxmlformats.org/drawingml/2006/lockedCanvas">
+            <c:extLst xmlns:lc="http://schemas.openxmlformats.org/drawingml/2006/lockedCanvas" xmlns:comp="http://schemas.openxmlformats.org/drawingml/2006/compatibility" xmlns:we="http://schemas.microsoft.com/office/webextensions/webextension/2010/11" xmlns:wetp="http://schemas.microsoft.com/office/webextensions/taskpanes/2010/11" xmlns:w16cid="http://schemas.microsoft.com/office/word/2016/wordml/cid" xmlns:w16se="http://schemas.microsoft.com/office/word/2015/wordml/symex" xmlns:wps="http://schemas.microsoft.com/office/word/2010/wordprocessingShape" xmlns:b="http://schemas.openxmlformats.org/officeDocument/2006/bibliography" xmlns:odgm="http://opendope.org/SmartArt/DataHierarchy" xmlns:odi="http://opendope.org/components" xmlns:oda="http://opendope.org/answers" xmlns:odq="http://opendope.org/questions" xmlns:odc="http://opendope.org/conditions" xmlns:odx="http://opendope.org/xpaths" xmlns:cppr="http://schemas.microsoft.com/office/2006/coverPageProps" xmlns:pvml="urn:schemas-microsoft-com:office:powerpoint" xmlns:w10="urn:schemas-microsoft-com:office:word" xmlns:v="urn:schemas-microsoft-com:vml" xmlns:o="urn:schemas-microsoft-com:office:office" xmlns:xvml="urn:schemas-microsoft-com:office:excel" xmlns:dsp="http://schemas.microsoft.com/office/drawing/2008/diagram" xmlns:xdr="http://schemas.openxmlformats.org/drawingml/2006/spreadsheetDrawing" xmlns:pic="http://schemas.openxmlformats.org/drawingml/2006/picture" xmlns:dgm="http://schemas.openxmlformats.org/drawingml/2006/diagram" xmlns:c14="http://schemas.microsoft.com/office/drawing/2007/8/2/chart" xmlns:cdr="http://schemas.openxmlformats.org/drawingml/2006/chartDrawing" xmlns:wne="http://schemas.microsoft.com/office/word/2006/wordml" xmlns:sl="http://schemas.openxmlformats.org/schemaLibrary/2006/main" xmlns:mc="http://schemas.openxmlformats.org/markup-compatibility/2006" xmlns:wp14="http://schemas.microsoft.com/office/word/2010/wordprocessingDrawing" xmlns:wp="http://schemas.openxmlformats.org/drawingml/2006/wordprocessingDrawing" xmlns:m="http://schemas.openxmlformats.org/officeDocument/2006/math" xmlns:w14="http://schemas.microsoft.com/office/word/2010/wordml" xmlns:w15="http://schemas.microsoft.com/office/word/2012/wordml" xmlns:w="http://schemas.openxmlformats.org/wordprocessingml/2006/main">
               <c:ext xmlns:c16="http://schemas.microsoft.com/office/drawing/2014/chart" uri="{C3380CC4-5D6E-409C-BE32-E72D297353CC}">
                 <c16:uniqueId val="{00000001-6147-E74A-AA7B-5531F0E4EE0C}"/>
               </c:ext>
@@ -4690,7 +4691,7 @@
               </c:numCache>
             </c:numRef>
           </c:val>
-          <c:extLst xmlns:w="http://schemas.openxmlformats.org/wordprocessingml/2006/main" xmlns:w15="http://schemas.microsoft.com/office/word/2012/wordml" xmlns:w14="http://schemas.microsoft.com/office/word/2010/wordml" xmlns:m="http://schemas.openxmlformats.org/officeDocument/2006/math" xmlns:wp="http://schemas.openxmlformats.org/drawingml/2006/wordprocessingDrawing" xmlns:wp14="http://schemas.microsoft.com/office/word/2010/wordprocessingDrawing" xmlns:mc="http://schemas.openxmlformats.org/markup-compatibility/2006" xmlns:sl="http://schemas.openxmlformats.org/schemaLibrary/2006/main" xmlns:wne="http://schemas.microsoft.com/office/word/2006/wordml" xmlns:cdr="http://schemas.openxmlformats.org/drawingml/2006/chartDrawing" xmlns:c14="http://schemas.microsoft.com/office/drawing/2007/8/2/chart" xmlns:dgm="http://schemas.openxmlformats.org/drawingml/2006/diagram" xmlns:pic="http://schemas.openxmlformats.org/drawingml/2006/picture" xmlns:xdr="http://schemas.openxmlformats.org/drawingml/2006/spreadsheetDrawing" xmlns:dsp="http://schemas.microsoft.com/office/drawing/2008/diagram" xmlns:xvml="urn:schemas-microsoft-com:office:excel" xmlns:o="urn:schemas-microsoft-com:office:office" xmlns:v="urn:schemas-microsoft-com:vml" xmlns:w10="urn:schemas-microsoft-com:office:word" xmlns:pvml="urn:schemas-microsoft-com:office:powerpoint" xmlns:cppr="http://schemas.microsoft.com/office/2006/coverPageProps" xmlns:odx="http://opendope.org/xpaths" xmlns:odc="http://opendope.org/conditions" xmlns:odq="http://opendope.org/questions" xmlns:oda="http://opendope.org/answers" xmlns:odi="http://opendope.org/components" xmlns:odgm="http://opendope.org/SmartArt/DataHierarchy" xmlns:b="http://schemas.openxmlformats.org/officeDocument/2006/bibliography" xmlns:wps="http://schemas.microsoft.com/office/word/2010/wordprocessingShape" xmlns:w16se="http://schemas.microsoft.com/office/word/2015/wordml/symex" xmlns:w16cid="http://schemas.microsoft.com/office/word/2016/wordml/cid" xmlns:wetp="http://schemas.microsoft.com/office/webextensions/taskpanes/2010/11" xmlns:we="http://schemas.microsoft.com/office/webextensions/webextension/2010/11" xmlns:comp="http://schemas.openxmlformats.org/drawingml/2006/compatibility" xmlns:lc="http://schemas.openxmlformats.org/drawingml/2006/lockedCanvas">
+          <c:extLst xmlns:lc="http://schemas.openxmlformats.org/drawingml/2006/lockedCanvas" xmlns:comp="http://schemas.openxmlformats.org/drawingml/2006/compatibility" xmlns:we="http://schemas.microsoft.com/office/webextensions/webextension/2010/11" xmlns:wetp="http://schemas.microsoft.com/office/webextensions/taskpanes/2010/11" xmlns:w16cid="http://schemas.microsoft.com/office/word/2016/wordml/cid" xmlns:w16se="http://schemas.microsoft.com/office/word/2015/wordml/symex" xmlns:wps="http://schemas.microsoft.com/office/word/2010/wordprocessingShape" xmlns:b="http://schemas.openxmlformats.org/officeDocument/2006/bibliography" xmlns:odgm="http://opendope.org/SmartArt/DataHierarchy" xmlns:odi="http://opendope.org/components" xmlns:oda="http://opendope.org/answers" xmlns:odq="http://opendope.org/questions" xmlns:odc="http://opendope.org/conditions" xmlns:odx="http://opendope.org/xpaths" xmlns:cppr="http://schemas.microsoft.com/office/2006/coverPageProps" xmlns:pvml="urn:schemas-microsoft-com:office:powerpoint" xmlns:w10="urn:schemas-microsoft-com:office:word" xmlns:v="urn:schemas-microsoft-com:vml" xmlns:o="urn:schemas-microsoft-com:office:office" xmlns:xvml="urn:schemas-microsoft-com:office:excel" xmlns:dsp="http://schemas.microsoft.com/office/drawing/2008/diagram" xmlns:xdr="http://schemas.openxmlformats.org/drawingml/2006/spreadsheetDrawing" xmlns:pic="http://schemas.openxmlformats.org/drawingml/2006/picture" xmlns:dgm="http://schemas.openxmlformats.org/drawingml/2006/diagram" xmlns:c14="http://schemas.microsoft.com/office/drawing/2007/8/2/chart" xmlns:cdr="http://schemas.openxmlformats.org/drawingml/2006/chartDrawing" xmlns:wne="http://schemas.microsoft.com/office/word/2006/wordml" xmlns:sl="http://schemas.openxmlformats.org/schemaLibrary/2006/main" xmlns:mc="http://schemas.openxmlformats.org/markup-compatibility/2006" xmlns:wp14="http://schemas.microsoft.com/office/word/2010/wordprocessingDrawing" xmlns:wp="http://schemas.openxmlformats.org/drawingml/2006/wordprocessingDrawing" xmlns:m="http://schemas.openxmlformats.org/officeDocument/2006/math" xmlns:w14="http://schemas.microsoft.com/office/word/2010/wordml" xmlns:w15="http://schemas.microsoft.com/office/word/2012/wordml" xmlns:w="http://schemas.openxmlformats.org/wordprocessingml/2006/main">
             <c:ext xmlns:c16="http://schemas.microsoft.com/office/drawing/2014/chart" uri="{C3380CC4-5D6E-409C-BE32-E72D297353CC}">
               <c16:uniqueId val="{00000002-6147-E74A-AA7B-5531F0E4EE0C}"/>
             </c:ext>
@@ -5300,7 +5301,7 @@
     </c:plotArea>
     <c:plotVisOnly val="1"/>
     <c:dispBlanksAs val="gap"/>
-    <c:extLst xmlns:w="http://schemas.openxmlformats.org/wordprocessingml/2006/main" xmlns:w15="http://schemas.microsoft.com/office/word/2012/wordml" xmlns:w14="http://schemas.microsoft.com/office/word/2010/wordml" xmlns:m="http://schemas.openxmlformats.org/officeDocument/2006/math" xmlns:wp="http://schemas.openxmlformats.org/drawingml/2006/wordprocessingDrawing" xmlns:wp14="http://schemas.microsoft.com/office/word/2010/wordprocessingDrawing" xmlns:mc="http://schemas.openxmlformats.org/markup-compatibility/2006" xmlns:sl="http://schemas.openxmlformats.org/schemaLibrary/2006/main" xmlns:wne="http://schemas.microsoft.com/office/word/2006/wordml" xmlns:cdr="http://schemas.openxmlformats.org/drawingml/2006/chartDrawing" xmlns:c14="http://schemas.microsoft.com/office/drawing/2007/8/2/chart" xmlns:dgm="http://schemas.openxmlformats.org/drawingml/2006/diagram" xmlns:pic="http://schemas.openxmlformats.org/drawingml/2006/picture" xmlns:xdr="http://schemas.openxmlformats.org/drawingml/2006/spreadsheetDrawing" xmlns:dsp="http://schemas.microsoft.com/office/drawing/2008/diagram" xmlns:xvml="urn:schemas-microsoft-com:office:excel" xmlns:o="urn:schemas-microsoft-com:office:office" xmlns:v="urn:schemas-microsoft-com:vml" xmlns:w10="urn:schemas-microsoft-com:office:word" xmlns:pvml="urn:schemas-microsoft-com:office:powerpoint" xmlns:cppr="http://schemas.microsoft.com/office/2006/coverPageProps" xmlns:odx="http://opendope.org/xpaths" xmlns:odc="http://opendope.org/conditions" xmlns:odq="http://opendope.org/questions" xmlns:oda="http://opendope.org/answers" xmlns:odi="http://opendope.org/components" xmlns:odgm="http://opendope.org/SmartArt/DataHierarchy" xmlns:b="http://schemas.openxmlformats.org/officeDocument/2006/bibliography" xmlns:wps="http://schemas.microsoft.com/office/word/2010/wordprocessingShape" xmlns:w16se="http://schemas.microsoft.com/office/word/2015/wordml/symex" xmlns:w16cid="http://schemas.microsoft.com/office/word/2016/wordml/cid" xmlns:wetp="http://schemas.microsoft.com/office/webextensions/taskpanes/2010/11" xmlns:we="http://schemas.microsoft.com/office/webextensions/webextension/2010/11" xmlns:comp="http://schemas.openxmlformats.org/drawingml/2006/compatibility" xmlns:lc="http://schemas.openxmlformats.org/drawingml/2006/lockedCanvas">
+    <c:extLst xmlns:lc="http://schemas.openxmlformats.org/drawingml/2006/lockedCanvas" xmlns:comp="http://schemas.openxmlformats.org/drawingml/2006/compatibility" xmlns:we="http://schemas.microsoft.com/office/webextensions/webextension/2010/11" xmlns:wetp="http://schemas.microsoft.com/office/webextensions/taskpanes/2010/11" xmlns:w16cid="http://schemas.microsoft.com/office/word/2016/wordml/cid" xmlns:w16se="http://schemas.microsoft.com/office/word/2015/wordml/symex" xmlns:wps="http://schemas.microsoft.com/office/word/2010/wordprocessingShape" xmlns:b="http://schemas.openxmlformats.org/officeDocument/2006/bibliography" xmlns:odgm="http://opendope.org/SmartArt/DataHierarchy" xmlns:odi="http://opendope.org/components" xmlns:oda="http://opendope.org/answers" xmlns:odq="http://opendope.org/questions" xmlns:odc="http://opendope.org/conditions" xmlns:odx="http://opendope.org/xpaths" xmlns:cppr="http://schemas.microsoft.com/office/2006/coverPageProps" xmlns:pvml="urn:schemas-microsoft-com:office:powerpoint" xmlns:w10="urn:schemas-microsoft-com:office:word" xmlns:v="urn:schemas-microsoft-com:vml" xmlns:o="urn:schemas-microsoft-com:office:office" xmlns:xvml="urn:schemas-microsoft-com:office:excel" xmlns:dsp="http://schemas.microsoft.com/office/drawing/2008/diagram" xmlns:xdr="http://schemas.openxmlformats.org/drawingml/2006/spreadsheetDrawing" xmlns:pic="http://schemas.openxmlformats.org/drawingml/2006/picture" xmlns:dgm="http://schemas.openxmlformats.org/drawingml/2006/diagram" xmlns:c14="http://schemas.microsoft.com/office/drawing/2007/8/2/chart" xmlns:cdr="http://schemas.openxmlformats.org/drawingml/2006/chartDrawing" xmlns:wne="http://schemas.microsoft.com/office/word/2006/wordml" xmlns:sl="http://schemas.openxmlformats.org/schemaLibrary/2006/main" xmlns:mc="http://schemas.openxmlformats.org/markup-compatibility/2006" xmlns:wp14="http://schemas.microsoft.com/office/word/2010/wordprocessingDrawing" xmlns:wp="http://schemas.openxmlformats.org/drawingml/2006/wordprocessingDrawing" xmlns:m="http://schemas.openxmlformats.org/officeDocument/2006/math" xmlns:w14="http://schemas.microsoft.com/office/word/2010/wordml" xmlns:w15="http://schemas.microsoft.com/office/word/2012/wordml" xmlns:w="http://schemas.openxmlformats.org/wordprocessingml/2006/main">
       <c:ext xmlns:c16r3="http://schemas.microsoft.com/office/drawing/2017/03/chart" uri="{56B9EC1D-385E-4148-901F-78D8002777C0}">
         <c16r3:dataDisplayOptions16>
           <c16r3:dispNaAsBlank val="1"/>
@@ -5403,7 +5404,7 @@
                 </a:outerShdw>
               </a:effectLst>
             </c:spPr>
-            <c:extLst xmlns:w="http://schemas.openxmlformats.org/wordprocessingml/2006/main" xmlns:w15="http://schemas.microsoft.com/office/word/2012/wordml" xmlns:w14="http://schemas.microsoft.com/office/word/2010/wordml" xmlns:m="http://schemas.openxmlformats.org/officeDocument/2006/math" xmlns:wp="http://schemas.openxmlformats.org/drawingml/2006/wordprocessingDrawing" xmlns:wp14="http://schemas.microsoft.com/office/word/2010/wordprocessingDrawing" xmlns:mc="http://schemas.openxmlformats.org/markup-compatibility/2006" xmlns:sl="http://schemas.openxmlformats.org/schemaLibrary/2006/main" xmlns:wne="http://schemas.microsoft.com/office/word/2006/wordml" xmlns:cdr="http://schemas.openxmlformats.org/drawingml/2006/chartDrawing" xmlns:c14="http://schemas.microsoft.com/office/drawing/2007/8/2/chart" xmlns:dgm="http://schemas.openxmlformats.org/drawingml/2006/diagram" xmlns:pic="http://schemas.openxmlformats.org/drawingml/2006/picture" xmlns:xdr="http://schemas.openxmlformats.org/drawingml/2006/spreadsheetDrawing" xmlns:dsp="http://schemas.microsoft.com/office/drawing/2008/diagram" xmlns:xvml="urn:schemas-microsoft-com:office:excel" xmlns:o="urn:schemas-microsoft-com:office:office" xmlns:v="urn:schemas-microsoft-com:vml" xmlns:w10="urn:schemas-microsoft-com:office:word" xmlns:pvml="urn:schemas-microsoft-com:office:powerpoint" xmlns:cppr="http://schemas.microsoft.com/office/2006/coverPageProps" xmlns:odx="http://opendope.org/xpaths" xmlns:odc="http://opendope.org/conditions" xmlns:odq="http://opendope.org/questions" xmlns:oda="http://opendope.org/answers" xmlns:odi="http://opendope.org/components" xmlns:odgm="http://opendope.org/SmartArt/DataHierarchy" xmlns:b="http://schemas.openxmlformats.org/officeDocument/2006/bibliography" xmlns:wps="http://schemas.microsoft.com/office/word/2010/wordprocessingShape" xmlns:w16se="http://schemas.microsoft.com/office/word/2015/wordml/symex" xmlns:w16cid="http://schemas.microsoft.com/office/word/2016/wordml/cid" xmlns:wetp="http://schemas.microsoft.com/office/webextensions/taskpanes/2010/11" xmlns:we="http://schemas.microsoft.com/office/webextensions/webextension/2010/11" xmlns:comp="http://schemas.openxmlformats.org/drawingml/2006/compatibility" xmlns:lc="http://schemas.openxmlformats.org/drawingml/2006/lockedCanvas">
+            <c:extLst xmlns:lc="http://schemas.openxmlformats.org/drawingml/2006/lockedCanvas" xmlns:comp="http://schemas.openxmlformats.org/drawingml/2006/compatibility" xmlns:we="http://schemas.microsoft.com/office/webextensions/webextension/2010/11" xmlns:wetp="http://schemas.microsoft.com/office/webextensions/taskpanes/2010/11" xmlns:w16cid="http://schemas.microsoft.com/office/word/2016/wordml/cid" xmlns:w16se="http://schemas.microsoft.com/office/word/2015/wordml/symex" xmlns:wps="http://schemas.microsoft.com/office/word/2010/wordprocessingShape" xmlns:b="http://schemas.openxmlformats.org/officeDocument/2006/bibliography" xmlns:odgm="http://opendope.org/SmartArt/DataHierarchy" xmlns:odi="http://opendope.org/components" xmlns:oda="http://opendope.org/answers" xmlns:odq="http://opendope.org/questions" xmlns:odc="http://opendope.org/conditions" xmlns:odx="http://opendope.org/xpaths" xmlns:cppr="http://schemas.microsoft.com/office/2006/coverPageProps" xmlns:pvml="urn:schemas-microsoft-com:office:powerpoint" xmlns:w10="urn:schemas-microsoft-com:office:word" xmlns:v="urn:schemas-microsoft-com:vml" xmlns:o="urn:schemas-microsoft-com:office:office" xmlns:xvml="urn:schemas-microsoft-com:office:excel" xmlns:dsp="http://schemas.microsoft.com/office/drawing/2008/diagram" xmlns:xdr="http://schemas.openxmlformats.org/drawingml/2006/spreadsheetDrawing" xmlns:pic="http://schemas.openxmlformats.org/drawingml/2006/picture" xmlns:dgm="http://schemas.openxmlformats.org/drawingml/2006/diagram" xmlns:c14="http://schemas.microsoft.com/office/drawing/2007/8/2/chart" xmlns:cdr="http://schemas.openxmlformats.org/drawingml/2006/chartDrawing" xmlns:wne="http://schemas.microsoft.com/office/word/2006/wordml" xmlns:sl="http://schemas.openxmlformats.org/schemaLibrary/2006/main" xmlns:mc="http://schemas.openxmlformats.org/markup-compatibility/2006" xmlns:wp14="http://schemas.microsoft.com/office/word/2010/wordprocessingDrawing" xmlns:wp="http://schemas.openxmlformats.org/drawingml/2006/wordprocessingDrawing" xmlns:m="http://schemas.openxmlformats.org/officeDocument/2006/math" xmlns:w14="http://schemas.microsoft.com/office/word/2010/wordml" xmlns:w15="http://schemas.microsoft.com/office/word/2012/wordml" xmlns:w="http://schemas.openxmlformats.org/wordprocessingml/2006/main">
               <c:ext xmlns:c16="http://schemas.microsoft.com/office/drawing/2014/chart" uri="{C3380CC4-5D6E-409C-BE32-E72D297353CC}">
                 <c16:uniqueId val="{00000001-6147-E74A-AA7B-5531F0E4EE0C}"/>
               </c:ext>
@@ -5498,7 +5499,7 @@
               </c:numCache>
             </c:numRef>
           </c:val>
-          <c:extLst xmlns:w="http://schemas.openxmlformats.org/wordprocessingml/2006/main" xmlns:w15="http://schemas.microsoft.com/office/word/2012/wordml" xmlns:w14="http://schemas.microsoft.com/office/word/2010/wordml" xmlns:m="http://schemas.openxmlformats.org/officeDocument/2006/math" xmlns:wp="http://schemas.openxmlformats.org/drawingml/2006/wordprocessingDrawing" xmlns:wp14="http://schemas.microsoft.com/office/word/2010/wordprocessingDrawing" xmlns:mc="http://schemas.openxmlformats.org/markup-compatibility/2006" xmlns:sl="http://schemas.openxmlformats.org/schemaLibrary/2006/main" xmlns:wne="http://schemas.microsoft.com/office/word/2006/wordml" xmlns:cdr="http://schemas.openxmlformats.org/drawingml/2006/chartDrawing" xmlns:c14="http://schemas.microsoft.com/office/drawing/2007/8/2/chart" xmlns:dgm="http://schemas.openxmlformats.org/drawingml/2006/diagram" xmlns:pic="http://schemas.openxmlformats.org/drawingml/2006/picture" xmlns:xdr="http://schemas.openxmlformats.org/drawingml/2006/spreadsheetDrawing" xmlns:dsp="http://schemas.microsoft.com/office/drawing/2008/diagram" xmlns:xvml="urn:schemas-microsoft-com:office:excel" xmlns:o="urn:schemas-microsoft-com:office:office" xmlns:v="urn:schemas-microsoft-com:vml" xmlns:w10="urn:schemas-microsoft-com:office:word" xmlns:pvml="urn:schemas-microsoft-com:office:powerpoint" xmlns:cppr="http://schemas.microsoft.com/office/2006/coverPageProps" xmlns:odx="http://opendope.org/xpaths" xmlns:odc="http://opendope.org/conditions" xmlns:odq="http://opendope.org/questions" xmlns:oda="http://opendope.org/answers" xmlns:odi="http://opendope.org/components" xmlns:odgm="http://opendope.org/SmartArt/DataHierarchy" xmlns:b="http://schemas.openxmlformats.org/officeDocument/2006/bibliography" xmlns:wps="http://schemas.microsoft.com/office/word/2010/wordprocessingShape" xmlns:w16se="http://schemas.microsoft.com/office/word/2015/wordml/symex" xmlns:w16cid="http://schemas.microsoft.com/office/word/2016/wordml/cid" xmlns:wetp="http://schemas.microsoft.com/office/webextensions/taskpanes/2010/11" xmlns:we="http://schemas.microsoft.com/office/webextensions/webextension/2010/11" xmlns:comp="http://schemas.openxmlformats.org/drawingml/2006/compatibility" xmlns:lc="http://schemas.openxmlformats.org/drawingml/2006/lockedCanvas">
+          <c:extLst xmlns:lc="http://schemas.openxmlformats.org/drawingml/2006/lockedCanvas" xmlns:comp="http://schemas.openxmlformats.org/drawingml/2006/compatibility" xmlns:we="http://schemas.microsoft.com/office/webextensions/webextension/2010/11" xmlns:wetp="http://schemas.microsoft.com/office/webextensions/taskpanes/2010/11" xmlns:w16cid="http://schemas.microsoft.com/office/word/2016/wordml/cid" xmlns:w16se="http://schemas.microsoft.com/office/word/2015/wordml/symex" xmlns:wps="http://schemas.microsoft.com/office/word/2010/wordprocessingShape" xmlns:b="http://schemas.openxmlformats.org/officeDocument/2006/bibliography" xmlns:odgm="http://opendope.org/SmartArt/DataHierarchy" xmlns:odi="http://opendope.org/components" xmlns:oda="http://opendope.org/answers" xmlns:odq="http://opendope.org/questions" xmlns:odc="http://opendope.org/conditions" xmlns:odx="http://opendope.org/xpaths" xmlns:cppr="http://schemas.microsoft.com/office/2006/coverPageProps" xmlns:pvml="urn:schemas-microsoft-com:office:powerpoint" xmlns:w10="urn:schemas-microsoft-com:office:word" xmlns:v="urn:schemas-microsoft-com:vml" xmlns:o="urn:schemas-microsoft-com:office:office" xmlns:xvml="urn:schemas-microsoft-com:office:excel" xmlns:dsp="http://schemas.microsoft.com/office/drawing/2008/diagram" xmlns:xdr="http://schemas.openxmlformats.org/drawingml/2006/spreadsheetDrawing" xmlns:pic="http://schemas.openxmlformats.org/drawingml/2006/picture" xmlns:dgm="http://schemas.openxmlformats.org/drawingml/2006/diagram" xmlns:c14="http://schemas.microsoft.com/office/drawing/2007/8/2/chart" xmlns:cdr="http://schemas.openxmlformats.org/drawingml/2006/chartDrawing" xmlns:wne="http://schemas.microsoft.com/office/word/2006/wordml" xmlns:sl="http://schemas.openxmlformats.org/schemaLibrary/2006/main" xmlns:mc="http://schemas.openxmlformats.org/markup-compatibility/2006" xmlns:wp14="http://schemas.microsoft.com/office/word/2010/wordprocessingDrawing" xmlns:wp="http://schemas.openxmlformats.org/drawingml/2006/wordprocessingDrawing" xmlns:m="http://schemas.openxmlformats.org/officeDocument/2006/math" xmlns:w14="http://schemas.microsoft.com/office/word/2010/wordml" xmlns:w15="http://schemas.microsoft.com/office/word/2012/wordml" xmlns:w="http://schemas.openxmlformats.org/wordprocessingml/2006/main">
             <c:ext xmlns:c16="http://schemas.microsoft.com/office/drawing/2014/chart" uri="{C3380CC4-5D6E-409C-BE32-E72D297353CC}">
               <c16:uniqueId val="{00000002-6147-E74A-AA7B-5531F0E4EE0C}"/>
             </c:ext>
@@ -6108,7 +6109,7 @@
     </c:plotArea>
     <c:plotVisOnly val="1"/>
     <c:dispBlanksAs val="gap"/>
-    <c:extLst xmlns:w="http://schemas.openxmlformats.org/wordprocessingml/2006/main" xmlns:w15="http://schemas.microsoft.com/office/word/2012/wordml" xmlns:w14="http://schemas.microsoft.com/office/word/2010/wordml" xmlns:m="http://schemas.openxmlformats.org/officeDocument/2006/math" xmlns:wp="http://schemas.openxmlformats.org/drawingml/2006/wordprocessingDrawing" xmlns:wp14="http://schemas.microsoft.com/office/word/2010/wordprocessingDrawing" xmlns:mc="http://schemas.openxmlformats.org/markup-compatibility/2006" xmlns:sl="http://schemas.openxmlformats.org/schemaLibrary/2006/main" xmlns:wne="http://schemas.microsoft.com/office/word/2006/wordml" xmlns:cdr="http://schemas.openxmlformats.org/drawingml/2006/chartDrawing" xmlns:c14="http://schemas.microsoft.com/office/drawing/2007/8/2/chart" xmlns:dgm="http://schemas.openxmlformats.org/drawingml/2006/diagram" xmlns:pic="http://schemas.openxmlformats.org/drawingml/2006/picture" xmlns:xdr="http://schemas.openxmlformats.org/drawingml/2006/spreadsheetDrawing" xmlns:dsp="http://schemas.microsoft.com/office/drawing/2008/diagram" xmlns:xvml="urn:schemas-microsoft-com:office:excel" xmlns:o="urn:schemas-microsoft-com:office:office" xmlns:v="urn:schemas-microsoft-com:vml" xmlns:w10="urn:schemas-microsoft-com:office:word" xmlns:pvml="urn:schemas-microsoft-com:office:powerpoint" xmlns:cppr="http://schemas.microsoft.com/office/2006/coverPageProps" xmlns:odx="http://opendope.org/xpaths" xmlns:odc="http://opendope.org/conditions" xmlns:odq="http://opendope.org/questions" xmlns:oda="http://opendope.org/answers" xmlns:odi="http://opendope.org/components" xmlns:odgm="http://opendope.org/SmartArt/DataHierarchy" xmlns:b="http://schemas.openxmlformats.org/officeDocument/2006/bibliography" xmlns:wps="http://schemas.microsoft.com/office/word/2010/wordprocessingShape" xmlns:w16se="http://schemas.microsoft.com/office/word/2015/wordml/symex" xmlns:w16cid="http://schemas.microsoft.com/office/word/2016/wordml/cid" xmlns:wetp="http://schemas.microsoft.com/office/webextensions/taskpanes/2010/11" xmlns:we="http://schemas.microsoft.com/office/webextensions/webextension/2010/11" xmlns:comp="http://schemas.openxmlformats.org/drawingml/2006/compatibility" xmlns:lc="http://schemas.openxmlformats.org/drawingml/2006/lockedCanvas">
+    <c:extLst xmlns:lc="http://schemas.openxmlformats.org/drawingml/2006/lockedCanvas" xmlns:comp="http://schemas.openxmlformats.org/drawingml/2006/compatibility" xmlns:we="http://schemas.microsoft.com/office/webextensions/webextension/2010/11" xmlns:wetp="http://schemas.microsoft.com/office/webextensions/taskpanes/2010/11" xmlns:w16cid="http://schemas.microsoft.com/office/word/2016/wordml/cid" xmlns:w16se="http://schemas.microsoft.com/office/word/2015/wordml/symex" xmlns:wps="http://schemas.microsoft.com/office/word/2010/wordprocessingShape" xmlns:b="http://schemas.openxmlformats.org/officeDocument/2006/bibliography" xmlns:odgm="http://opendope.org/SmartArt/DataHierarchy" xmlns:odi="http://opendope.org/components" xmlns:oda="http://opendope.org/answers" xmlns:odq="http://opendope.org/questions" xmlns:odc="http://opendope.org/conditions" xmlns:odx="http://opendope.org/xpaths" xmlns:cppr="http://schemas.microsoft.com/office/2006/coverPageProps" xmlns:pvml="urn:schemas-microsoft-com:office:powerpoint" xmlns:w10="urn:schemas-microsoft-com:office:word" xmlns:v="urn:schemas-microsoft-com:vml" xmlns:o="urn:schemas-microsoft-com:office:office" xmlns:xvml="urn:schemas-microsoft-com:office:excel" xmlns:dsp="http://schemas.microsoft.com/office/drawing/2008/diagram" xmlns:xdr="http://schemas.openxmlformats.org/drawingml/2006/spreadsheetDrawing" xmlns:pic="http://schemas.openxmlformats.org/drawingml/2006/picture" xmlns:dgm="http://schemas.openxmlformats.org/drawingml/2006/diagram" xmlns:c14="http://schemas.microsoft.com/office/drawing/2007/8/2/chart" xmlns:cdr="http://schemas.openxmlformats.org/drawingml/2006/chartDrawing" xmlns:wne="http://schemas.microsoft.com/office/word/2006/wordml" xmlns:sl="http://schemas.openxmlformats.org/schemaLibrary/2006/main" xmlns:mc="http://schemas.openxmlformats.org/markup-compatibility/2006" xmlns:wp14="http://schemas.microsoft.com/office/word/2010/wordprocessingDrawing" xmlns:wp="http://schemas.openxmlformats.org/drawingml/2006/wordprocessingDrawing" xmlns:m="http://schemas.openxmlformats.org/officeDocument/2006/math" xmlns:w14="http://schemas.microsoft.com/office/word/2010/wordml" xmlns:w15="http://schemas.microsoft.com/office/word/2012/wordml" xmlns:w="http://schemas.openxmlformats.org/wordprocessingml/2006/main">
       <c:ext xmlns:c16r3="http://schemas.microsoft.com/office/drawing/2017/03/chart" uri="{56B9EC1D-385E-4148-901F-78D8002777C0}">
         <c16r3:dataDisplayOptions16>
           <c16r3:dispNaAsBlank val="1"/>
@@ -10434,7 +10435,7 @@
           <a:p>
             <a:fld id="{C1255C68-584F-174D-BB81-51BF91708794}" type="datetimeFigureOut">
               <a:rPr lang="en-US" smtClean="0"/>
-              <a:t>8/8/25</a:t>
+              <a:t>8/9/25</a:t>
             </a:fld>
             <a:endParaRPr lang="en-US"/>
           </a:p>
@@ -10611,7 +10612,7 @@
           <a:p>
             <a:fld id="{A1EDAAC4-819D-C544-9EA1-C73624CFD70B}" type="datetimeFigureOut">
               <a:rPr lang="en-US" smtClean="0"/>
-              <a:t>8/8/25</a:t>
+              <a:t>8/9/25</a:t>
             </a:fld>
             <a:endParaRPr lang="en-US"/>
           </a:p>
@@ -35669,7 +35670,7 @@
         <p:cNvPr id="1" name="">
           <a:extLst>
             <a:ext uri="{FF2B5EF4-FFF2-40B4-BE49-F238E27FC236}">
-              <a16:creationId xmlns:a16="http://schemas.microsoft.com/office/drawing/2014/main" id="{C876FA4F-56E0-38D4-2ADF-7F5EB3DFFC86}"/>
+              <a16:creationId xmlns:a16="http://schemas.microsoft.com/office/drawing/2014/main" id="{F8879EA7-9E0F-A30A-7773-2366D1DF53C8}"/>
             </a:ext>
           </a:extLst>
         </p:cNvPr>
@@ -35689,7 +35690,7 @@
           <p:cNvPr id="17" name="Rectangle 16">
             <a:extLst>
               <a:ext uri="{FF2B5EF4-FFF2-40B4-BE49-F238E27FC236}">
-                <a16:creationId xmlns:a16="http://schemas.microsoft.com/office/drawing/2014/main" id="{1FAB8F07-6D4B-916A-C1E3-E7E3096D579E}"/>
+                <a16:creationId xmlns:a16="http://schemas.microsoft.com/office/drawing/2014/main" id="{2F15B9C0-1729-89A5-BDBB-D4D9D64F613B}"/>
               </a:ext>
             </a:extLst>
           </p:cNvPr>
@@ -35759,7 +35760,7 @@
           <p:cNvPr id="3" name="Slide Number Placeholder 2">
             <a:extLst>
               <a:ext uri="{FF2B5EF4-FFF2-40B4-BE49-F238E27FC236}">
-                <a16:creationId xmlns:a16="http://schemas.microsoft.com/office/drawing/2014/main" id="{76E08F0F-52CE-A816-71D0-86B4FA3FF4C4}"/>
+                <a16:creationId xmlns:a16="http://schemas.microsoft.com/office/drawing/2014/main" id="{75F35920-DAEA-3B96-C1C4-B1210C24235E}"/>
               </a:ext>
             </a:extLst>
           </p:cNvPr>
@@ -35779,6 +35780,3881 @@
               <a:rPr lang="en-US" smtClean="0"/>
               <a:pPr/>
               <a:t>14</a:t>
+            </a:fld>
+            <a:endParaRPr lang="en-US"/>
+          </a:p>
+        </p:txBody>
+      </p:sp>
+      <p:sp>
+        <p:nvSpPr>
+          <p:cNvPr id="7" name="Text Placeholder 6">
+            <a:extLst>
+              <a:ext uri="{FF2B5EF4-FFF2-40B4-BE49-F238E27FC236}">
+                <a16:creationId xmlns:a16="http://schemas.microsoft.com/office/drawing/2014/main" id="{79840A33-EC3D-5A3B-3E0B-F3C497E5A045}"/>
+              </a:ext>
+            </a:extLst>
+          </p:cNvPr>
+          <p:cNvSpPr>
+            <a:spLocks noGrp="1"/>
+          </p:cNvSpPr>
+          <p:nvPr>
+            <p:ph type="body" sz="quarter" idx="12"/>
+          </p:nvPr>
+        </p:nvSpPr>
+        <p:spPr/>
+        <p:txBody>
+          <a:bodyPr/>
+          <a:lstStyle/>
+          <a:p>
+            <a:r>
+              <a:rPr lang="en-US" dirty="0"/>
+              <a:t>Findings – </a:t>
+            </a:r>
+            <a:r>
+              <a:rPr lang="en-US" dirty="0">
+                <a:solidFill>
+                  <a:schemeClr val="accent3"/>
+                </a:solidFill>
+              </a:rPr>
+              <a:t>Maintainability CHANGE</a:t>
+            </a:r>
+          </a:p>
+        </p:txBody>
+      </p:sp>
+      <p:sp>
+        <p:nvSpPr>
+          <p:cNvPr id="6" name="Title 5">
+            <a:extLst>
+              <a:ext uri="{FF2B5EF4-FFF2-40B4-BE49-F238E27FC236}">
+                <a16:creationId xmlns:a16="http://schemas.microsoft.com/office/drawing/2014/main" id="{9B74B313-6830-DEF8-1148-1BDA2D0AB64E}"/>
+              </a:ext>
+            </a:extLst>
+          </p:cNvPr>
+          <p:cNvSpPr>
+            <a:spLocks noGrp="1"/>
+          </p:cNvSpPr>
+          <p:nvPr>
+            <p:ph type="title"/>
+          </p:nvPr>
+        </p:nvSpPr>
+        <p:spPr/>
+        <p:txBody>
+          <a:bodyPr/>
+          <a:lstStyle/>
+          <a:p>
+            <a:r>
+              <a:rPr lang="en-US" noProof="0" dirty="0"/>
+              <a:t>@@</a:t>
+            </a:r>
+          </a:p>
+        </p:txBody>
+      </p:sp>
+      <p:sp>
+        <p:nvSpPr>
+          <p:cNvPr id="8" name="Content Placeholder 7">
+            <a:extLst>
+              <a:ext uri="{FF2B5EF4-FFF2-40B4-BE49-F238E27FC236}">
+                <a16:creationId xmlns:a16="http://schemas.microsoft.com/office/drawing/2014/main" id="{843685E7-A45E-DF9B-90AE-FE2ACA8DFEC7}"/>
+              </a:ext>
+            </a:extLst>
+          </p:cNvPr>
+          <p:cNvSpPr>
+            <a:spLocks noGrp="1"/>
+          </p:cNvSpPr>
+          <p:nvPr>
+            <p:ph sz="quarter" idx="13"/>
+          </p:nvPr>
+        </p:nvSpPr>
+        <p:spPr>
+          <a:xfrm>
+            <a:off x="514800" y="1368000"/>
+            <a:ext cx="11232000" cy="1658842"/>
+          </a:xfrm>
+        </p:spPr>
+        <p:txBody>
+          <a:bodyPr anchor="ctr"/>
+          <a:lstStyle/>
+          <a:p>
+            <a:pPr marL="0" indent="0">
+              <a:buNone/>
+            </a:pPr>
+            <a:r>
+              <a:rPr lang="en-US" sz="1400" noProof="0" dirty="0"/>
+              <a:t>@@</a:t>
+            </a:r>
+            <a:endParaRPr lang="en-US" sz="1200" noProof="0" dirty="0"/>
+          </a:p>
+        </p:txBody>
+      </p:sp>
+      <p:sp>
+        <p:nvSpPr>
+          <p:cNvPr id="9" name="Rounded Rectangle 8">
+            <a:extLst>
+              <a:ext uri="{FF2B5EF4-FFF2-40B4-BE49-F238E27FC236}">
+                <a16:creationId xmlns:a16="http://schemas.microsoft.com/office/drawing/2014/main" id="{BA1498DF-7C02-B183-B78D-C458BCD32FDC}"/>
+              </a:ext>
+            </a:extLst>
+          </p:cNvPr>
+          <p:cNvSpPr/>
+          <p:nvPr/>
+        </p:nvSpPr>
+        <p:spPr>
+          <a:xfrm>
+            <a:off x="-270313" y="3154680"/>
+            <a:ext cx="9725209" cy="3163320"/>
+          </a:xfrm>
+          <a:prstGeom prst="roundRect">
+            <a:avLst>
+              <a:gd name="adj" fmla="val 3161"/>
+            </a:avLst>
+          </a:prstGeom>
+          <a:solidFill>
+            <a:schemeClr val="bg1"/>
+          </a:solidFill>
+          <a:ln>
+            <a:noFill/>
+          </a:ln>
+          <a:effectLst>
+            <a:outerShdw blurRad="190500" dist="38100" dir="2700000" algn="tl" rotWithShape="0">
+              <a:prstClr val="black">
+                <a:alpha val="15000"/>
+              </a:prstClr>
+            </a:outerShdw>
+          </a:effectLst>
+        </p:spPr>
+        <p:style>
+          <a:lnRef idx="2">
+            <a:schemeClr val="accent1">
+              <a:shade val="50000"/>
+            </a:schemeClr>
+          </a:lnRef>
+          <a:fillRef idx="1">
+            <a:schemeClr val="accent1"/>
+          </a:fillRef>
+          <a:effectRef idx="0">
+            <a:schemeClr val="accent1"/>
+          </a:effectRef>
+          <a:fontRef idx="minor">
+            <a:schemeClr val="lt1"/>
+          </a:fontRef>
+        </p:style>
+        <p:txBody>
+          <a:bodyPr lIns="731520" tIns="72000" rIns="108000" bIns="72000" rtlCol="0" anchor="ctr"/>
+          <a:lstStyle/>
+          <a:p>
+            <a:endParaRPr lang="nl-NL" sz="1200" b="1" noProof="0" dirty="0">
+              <a:solidFill>
+                <a:schemeClr val="accent1"/>
+              </a:solidFill>
+            </a:endParaRPr>
+          </a:p>
+        </p:txBody>
+      </p:sp>
+      <p:sp>
+        <p:nvSpPr>
+          <p:cNvPr id="16" name="Rounded Rectangle 15">
+            <a:extLst>
+              <a:ext uri="{FF2B5EF4-FFF2-40B4-BE49-F238E27FC236}">
+                <a16:creationId xmlns:a16="http://schemas.microsoft.com/office/drawing/2014/main" id="{EC9632B6-F9D1-F384-41B4-528EA345C515}"/>
+              </a:ext>
+            </a:extLst>
+          </p:cNvPr>
+          <p:cNvSpPr/>
+          <p:nvPr/>
+        </p:nvSpPr>
+        <p:spPr>
+          <a:xfrm flipH="1">
+            <a:off x="9619488" y="3154680"/>
+            <a:ext cx="2724912" cy="3163320"/>
+          </a:xfrm>
+          <a:prstGeom prst="roundRect">
+            <a:avLst>
+              <a:gd name="adj" fmla="val 4851"/>
+            </a:avLst>
+          </a:prstGeom>
+          <a:gradFill>
+            <a:gsLst>
+              <a:gs pos="0">
+                <a:schemeClr val="bg1"/>
+              </a:gs>
+              <a:gs pos="100000">
+                <a:schemeClr val="bg2"/>
+              </a:gs>
+            </a:gsLst>
+            <a:lin ang="2700000" scaled="0"/>
+          </a:gradFill>
+          <a:ln>
+            <a:noFill/>
+          </a:ln>
+          <a:effectLst>
+            <a:outerShdw blurRad="190500" dist="38100" dir="2700000" algn="tl" rotWithShape="0">
+              <a:prstClr val="black">
+                <a:alpha val="15000"/>
+              </a:prstClr>
+            </a:outerShdw>
+          </a:effectLst>
+        </p:spPr>
+        <p:style>
+          <a:lnRef idx="2">
+            <a:schemeClr val="accent1">
+              <a:shade val="50000"/>
+            </a:schemeClr>
+          </a:lnRef>
+          <a:fillRef idx="1">
+            <a:schemeClr val="accent1"/>
+          </a:fillRef>
+          <a:effectRef idx="0">
+            <a:schemeClr val="accent1"/>
+          </a:effectRef>
+          <a:fontRef idx="minor">
+            <a:schemeClr val="lt1"/>
+          </a:fontRef>
+        </p:style>
+        <p:txBody>
+          <a:bodyPr lIns="731520" tIns="72000" rIns="108000" bIns="72000" rtlCol="0" anchor="ctr"/>
+          <a:lstStyle/>
+          <a:p>
+            <a:endParaRPr lang="nl-NL" sz="1200" b="1" noProof="0" dirty="0">
+              <a:solidFill>
+                <a:schemeClr val="accent1"/>
+              </a:solidFill>
+            </a:endParaRPr>
+          </a:p>
+        </p:txBody>
+      </p:sp>
+      <p:sp>
+        <p:nvSpPr>
+          <p:cNvPr id="28" name="TextBox 27">
+            <a:extLst>
+              <a:ext uri="{FF2B5EF4-FFF2-40B4-BE49-F238E27FC236}">
+                <a16:creationId xmlns:a16="http://schemas.microsoft.com/office/drawing/2014/main" id="{BA2C6122-4344-B10E-8530-9A29D6086A1E}"/>
+              </a:ext>
+            </a:extLst>
+          </p:cNvPr>
+          <p:cNvSpPr txBox="1"/>
+          <p:nvPr/>
+        </p:nvSpPr>
+        <p:spPr>
+          <a:xfrm>
+            <a:off x="-1221448" y="4419492"/>
+            <a:ext cx="628847" cy="633443"/>
+          </a:xfrm>
+          <a:prstGeom prst="rect">
+            <a:avLst/>
+          </a:prstGeom>
+          <a:noFill/>
+        </p:spPr>
+        <p:txBody>
+          <a:bodyPr wrap="none" lIns="90000" rtlCol="0" anchor="t">
+            <a:spAutoFit/>
+          </a:bodyPr>
+          <a:lstStyle/>
+          <a:p>
+            <a:pPr algn="l">
+              <a:lnSpc>
+                <a:spcPct val="113000"/>
+              </a:lnSpc>
+            </a:pPr>
+            <a:r>
+              <a:rPr lang="en-US" sz="1600" dirty="0">
+                <a:solidFill>
+                  <a:schemeClr val="tx2"/>
+                </a:solidFill>
+              </a:rPr>
+              <a:t>3.12”</a:t>
+            </a:r>
+          </a:p>
+          <a:p>
+            <a:pPr algn="l">
+              <a:lnSpc>
+                <a:spcPct val="113000"/>
+              </a:lnSpc>
+            </a:pPr>
+            <a:r>
+              <a:rPr lang="en-US" sz="1600" dirty="0">
+                <a:solidFill>
+                  <a:schemeClr val="tx2"/>
+                </a:solidFill>
+              </a:rPr>
+              <a:t>9.57"</a:t>
+            </a:r>
+          </a:p>
+        </p:txBody>
+      </p:sp>
+      <p:sp>
+        <p:nvSpPr>
+          <p:cNvPr id="35" name="Rounded Rectangle 34">
+            <a:extLst>
+              <a:ext uri="{FF2B5EF4-FFF2-40B4-BE49-F238E27FC236}">
+                <a16:creationId xmlns:a16="http://schemas.microsoft.com/office/drawing/2014/main" id="{83843F98-5552-F249-15FC-915A5DD2B3A2}"/>
+              </a:ext>
+            </a:extLst>
+          </p:cNvPr>
+          <p:cNvSpPr/>
+          <p:nvPr/>
+        </p:nvSpPr>
+        <p:spPr>
+          <a:xfrm>
+            <a:off x="9777184" y="4883651"/>
+            <a:ext cx="2573808" cy="326727"/>
+          </a:xfrm>
+          <a:prstGeom prst="roundRect">
+            <a:avLst>
+              <a:gd name="adj" fmla="val 31904"/>
+            </a:avLst>
+          </a:prstGeom>
+          <a:gradFill>
+            <a:gsLst>
+              <a:gs pos="0">
+                <a:srgbClr val="57C968"/>
+              </a:gs>
+              <a:gs pos="25000">
+                <a:schemeClr val="bg2"/>
+              </a:gs>
+            </a:gsLst>
+            <a:lin ang="2700000" scaled="0"/>
+          </a:gradFill>
+          <a:ln>
+            <a:noFill/>
+          </a:ln>
+          <a:effectLst>
+            <a:outerShdw blurRad="190500" dist="38100" dir="2700000" algn="tl" rotWithShape="0">
+              <a:prstClr val="black">
+                <a:alpha val="15000"/>
+              </a:prstClr>
+            </a:outerShdw>
+          </a:effectLst>
+        </p:spPr>
+        <p:style>
+          <a:lnRef idx="2">
+            <a:schemeClr val="accent1">
+              <a:shade val="50000"/>
+            </a:schemeClr>
+          </a:lnRef>
+          <a:fillRef idx="1">
+            <a:schemeClr val="accent1"/>
+          </a:fillRef>
+          <a:effectRef idx="0">
+            <a:schemeClr val="accent1"/>
+          </a:effectRef>
+          <a:fontRef idx="minor">
+            <a:schemeClr val="lt1"/>
+          </a:fontRef>
+        </p:style>
+        <p:txBody>
+          <a:bodyPr lIns="109728" tIns="72000" rIns="108000" bIns="72000" rtlCol="0" anchor="ctr"/>
+          <a:lstStyle/>
+          <a:p>
+            <a:r>
+              <a:rPr lang="nl-NL" sz="1000" b="1" noProof="0" dirty="0">
+                <a:solidFill>
+                  <a:schemeClr val="accent1"/>
+                </a:solidFill>
+              </a:rPr>
+              <a:t>@@</a:t>
+            </a:r>
+          </a:p>
+        </p:txBody>
+      </p:sp>
+      <p:sp>
+        <p:nvSpPr>
+          <p:cNvPr id="39" name="Rounded Rectangle 38">
+            <a:extLst>
+              <a:ext uri="{FF2B5EF4-FFF2-40B4-BE49-F238E27FC236}">
+                <a16:creationId xmlns:a16="http://schemas.microsoft.com/office/drawing/2014/main" id="{0FAFCFC8-6780-C3CF-0AFE-C28A9D1462E6}"/>
+              </a:ext>
+            </a:extLst>
+          </p:cNvPr>
+          <p:cNvSpPr/>
+          <p:nvPr/>
+        </p:nvSpPr>
+        <p:spPr>
+          <a:xfrm>
+            <a:off x="9777184" y="4464888"/>
+            <a:ext cx="2573808" cy="326727"/>
+          </a:xfrm>
+          <a:prstGeom prst="roundRect">
+            <a:avLst>
+              <a:gd name="adj" fmla="val 31904"/>
+            </a:avLst>
+          </a:prstGeom>
+          <a:gradFill>
+            <a:gsLst>
+              <a:gs pos="0">
+                <a:srgbClr val="57C968"/>
+              </a:gs>
+              <a:gs pos="25000">
+                <a:schemeClr val="bg2"/>
+              </a:gs>
+            </a:gsLst>
+            <a:lin ang="2700000" scaled="0"/>
+          </a:gradFill>
+          <a:ln>
+            <a:noFill/>
+          </a:ln>
+          <a:effectLst>
+            <a:outerShdw blurRad="190500" dist="38100" dir="2700000" algn="tl" rotWithShape="0">
+              <a:prstClr val="black">
+                <a:alpha val="15000"/>
+              </a:prstClr>
+            </a:outerShdw>
+          </a:effectLst>
+        </p:spPr>
+        <p:style>
+          <a:lnRef idx="2">
+            <a:schemeClr val="accent1">
+              <a:shade val="50000"/>
+            </a:schemeClr>
+          </a:lnRef>
+          <a:fillRef idx="1">
+            <a:schemeClr val="accent1"/>
+          </a:fillRef>
+          <a:effectRef idx="0">
+            <a:schemeClr val="accent1"/>
+          </a:effectRef>
+          <a:fontRef idx="minor">
+            <a:schemeClr val="lt1"/>
+          </a:fontRef>
+        </p:style>
+        <p:txBody>
+          <a:bodyPr lIns="109728" tIns="72000" rIns="108000" bIns="72000" rtlCol="0" anchor="ctr"/>
+          <a:lstStyle/>
+          <a:p>
+            <a:r>
+              <a:rPr lang="nl-NL" sz="1000" b="1" noProof="0" dirty="0">
+                <a:solidFill>
+                  <a:schemeClr val="accent1"/>
+                </a:solidFill>
+              </a:rPr>
+              <a:t>@@</a:t>
+            </a:r>
+          </a:p>
+        </p:txBody>
+      </p:sp>
+      <p:sp>
+        <p:nvSpPr>
+          <p:cNvPr id="33" name="Rounded Rectangle 32">
+            <a:extLst>
+              <a:ext uri="{FF2B5EF4-FFF2-40B4-BE49-F238E27FC236}">
+                <a16:creationId xmlns:a16="http://schemas.microsoft.com/office/drawing/2014/main" id="{2FCE2CC5-2CF9-9538-8D61-0BD4B74475D0}"/>
+              </a:ext>
+            </a:extLst>
+          </p:cNvPr>
+          <p:cNvSpPr/>
+          <p:nvPr/>
+        </p:nvSpPr>
+        <p:spPr>
+          <a:xfrm>
+            <a:off x="9777184" y="4046125"/>
+            <a:ext cx="2573808" cy="326727"/>
+          </a:xfrm>
+          <a:prstGeom prst="roundRect">
+            <a:avLst>
+              <a:gd name="adj" fmla="val 31904"/>
+            </a:avLst>
+          </a:prstGeom>
+          <a:gradFill>
+            <a:gsLst>
+              <a:gs pos="0">
+                <a:srgbClr val="F9C640"/>
+              </a:gs>
+              <a:gs pos="25000">
+                <a:schemeClr val="bg2"/>
+              </a:gs>
+            </a:gsLst>
+            <a:lin ang="2700000" scaled="0"/>
+          </a:gradFill>
+          <a:ln>
+            <a:noFill/>
+          </a:ln>
+          <a:effectLst>
+            <a:outerShdw blurRad="190500" dist="38100" dir="2700000" algn="tl" rotWithShape="0">
+              <a:prstClr val="black">
+                <a:alpha val="15000"/>
+              </a:prstClr>
+            </a:outerShdw>
+          </a:effectLst>
+        </p:spPr>
+        <p:style>
+          <a:lnRef idx="2">
+            <a:schemeClr val="accent1">
+              <a:shade val="50000"/>
+            </a:schemeClr>
+          </a:lnRef>
+          <a:fillRef idx="1">
+            <a:schemeClr val="accent1"/>
+          </a:fillRef>
+          <a:effectRef idx="0">
+            <a:schemeClr val="accent1"/>
+          </a:effectRef>
+          <a:fontRef idx="minor">
+            <a:schemeClr val="lt1"/>
+          </a:fontRef>
+        </p:style>
+        <p:txBody>
+          <a:bodyPr lIns="109728" tIns="72000" rIns="108000" bIns="72000" rtlCol="0" anchor="ctr"/>
+          <a:lstStyle/>
+          <a:p>
+            <a:r>
+              <a:rPr lang="nl-NL" sz="1000" b="1" noProof="0" dirty="0">
+                <a:solidFill>
+                  <a:schemeClr val="accent1"/>
+                </a:solidFill>
+              </a:rPr>
+              <a:t>@@</a:t>
+            </a:r>
+          </a:p>
+        </p:txBody>
+      </p:sp>
+      <p:sp>
+        <p:nvSpPr>
+          <p:cNvPr id="38" name="Rounded Rectangle 37">
+            <a:extLst>
+              <a:ext uri="{FF2B5EF4-FFF2-40B4-BE49-F238E27FC236}">
+                <a16:creationId xmlns:a16="http://schemas.microsoft.com/office/drawing/2014/main" id="{163C28A4-A24D-2082-0456-41BCE8D4070C}"/>
+              </a:ext>
+            </a:extLst>
+          </p:cNvPr>
+          <p:cNvSpPr/>
+          <p:nvPr/>
+        </p:nvSpPr>
+        <p:spPr>
+          <a:xfrm>
+            <a:off x="9777184" y="3627362"/>
+            <a:ext cx="2573808" cy="326727"/>
+          </a:xfrm>
+          <a:prstGeom prst="roundRect">
+            <a:avLst>
+              <a:gd name="adj" fmla="val 31904"/>
+            </a:avLst>
+          </a:prstGeom>
+          <a:gradFill>
+            <a:gsLst>
+              <a:gs pos="0">
+                <a:srgbClr val="F9C640"/>
+              </a:gs>
+              <a:gs pos="25000">
+                <a:schemeClr val="bg2"/>
+              </a:gs>
+            </a:gsLst>
+            <a:lin ang="2700000" scaled="0"/>
+          </a:gradFill>
+          <a:ln>
+            <a:noFill/>
+          </a:ln>
+          <a:effectLst>
+            <a:outerShdw blurRad="190500" dist="38100" dir="2700000" algn="tl" rotWithShape="0">
+              <a:prstClr val="black">
+                <a:alpha val="15000"/>
+              </a:prstClr>
+            </a:outerShdw>
+          </a:effectLst>
+        </p:spPr>
+        <p:style>
+          <a:lnRef idx="2">
+            <a:schemeClr val="accent1">
+              <a:shade val="50000"/>
+            </a:schemeClr>
+          </a:lnRef>
+          <a:fillRef idx="1">
+            <a:schemeClr val="accent1"/>
+          </a:fillRef>
+          <a:effectRef idx="0">
+            <a:schemeClr val="accent1"/>
+          </a:effectRef>
+          <a:fontRef idx="minor">
+            <a:schemeClr val="lt1"/>
+          </a:fontRef>
+        </p:style>
+        <p:txBody>
+          <a:bodyPr lIns="109728" tIns="72000" rIns="108000" bIns="72000" rtlCol="0" anchor="ctr"/>
+          <a:lstStyle/>
+          <a:p>
+            <a:r>
+              <a:rPr lang="nl-NL" sz="1000" b="1" noProof="0" dirty="0">
+                <a:solidFill>
+                  <a:schemeClr val="accent1"/>
+                </a:solidFill>
+              </a:rPr>
+              <a:t>@@</a:t>
+            </a:r>
+          </a:p>
+        </p:txBody>
+      </p:sp>
+      <p:sp>
+        <p:nvSpPr>
+          <p:cNvPr id="37" name="Rounded Rectangle 36">
+            <a:extLst>
+              <a:ext uri="{FF2B5EF4-FFF2-40B4-BE49-F238E27FC236}">
+                <a16:creationId xmlns:a16="http://schemas.microsoft.com/office/drawing/2014/main" id="{29D25F0C-935C-F459-01EB-727B921D4669}"/>
+              </a:ext>
+            </a:extLst>
+          </p:cNvPr>
+          <p:cNvSpPr/>
+          <p:nvPr/>
+        </p:nvSpPr>
+        <p:spPr>
+          <a:xfrm>
+            <a:off x="9777184" y="5721177"/>
+            <a:ext cx="2573808" cy="326727"/>
+          </a:xfrm>
+          <a:prstGeom prst="roundRect">
+            <a:avLst>
+              <a:gd name="adj" fmla="val 31904"/>
+            </a:avLst>
+          </a:prstGeom>
+          <a:gradFill>
+            <a:gsLst>
+              <a:gs pos="0">
+                <a:srgbClr val="57C968"/>
+              </a:gs>
+              <a:gs pos="25000">
+                <a:schemeClr val="bg2"/>
+              </a:gs>
+            </a:gsLst>
+            <a:lin ang="2700000" scaled="0"/>
+          </a:gradFill>
+          <a:ln>
+            <a:noFill/>
+          </a:ln>
+          <a:effectLst>
+            <a:outerShdw blurRad="190500" dist="38100" dir="2700000" algn="tl" rotWithShape="0">
+              <a:prstClr val="black">
+                <a:alpha val="15000"/>
+              </a:prstClr>
+            </a:outerShdw>
+          </a:effectLst>
+        </p:spPr>
+        <p:style>
+          <a:lnRef idx="2">
+            <a:schemeClr val="accent1">
+              <a:shade val="50000"/>
+            </a:schemeClr>
+          </a:lnRef>
+          <a:fillRef idx="1">
+            <a:schemeClr val="accent1"/>
+          </a:fillRef>
+          <a:effectRef idx="0">
+            <a:schemeClr val="accent1"/>
+          </a:effectRef>
+          <a:fontRef idx="minor">
+            <a:schemeClr val="lt1"/>
+          </a:fontRef>
+        </p:style>
+        <p:txBody>
+          <a:bodyPr lIns="109728" tIns="72000" rIns="108000" bIns="72000" rtlCol="0" anchor="ctr"/>
+          <a:lstStyle/>
+          <a:p>
+            <a:r>
+              <a:rPr lang="nl-NL" sz="1000" b="1" noProof="0" dirty="0">
+                <a:solidFill>
+                  <a:schemeClr val="accent1"/>
+                </a:solidFill>
+              </a:rPr>
+              <a:t>@@</a:t>
+            </a:r>
+          </a:p>
+        </p:txBody>
+      </p:sp>
+      <p:sp>
+        <p:nvSpPr>
+          <p:cNvPr id="36" name="Rounded Rectangle 35">
+            <a:extLst>
+              <a:ext uri="{FF2B5EF4-FFF2-40B4-BE49-F238E27FC236}">
+                <a16:creationId xmlns:a16="http://schemas.microsoft.com/office/drawing/2014/main" id="{0D485807-6F5D-5A24-D787-AA03F0A92284}"/>
+              </a:ext>
+            </a:extLst>
+          </p:cNvPr>
+          <p:cNvSpPr/>
+          <p:nvPr/>
+        </p:nvSpPr>
+        <p:spPr>
+          <a:xfrm>
+            <a:off x="9777184" y="5302414"/>
+            <a:ext cx="2573808" cy="326727"/>
+          </a:xfrm>
+          <a:prstGeom prst="roundRect">
+            <a:avLst>
+              <a:gd name="adj" fmla="val 31904"/>
+            </a:avLst>
+          </a:prstGeom>
+          <a:gradFill>
+            <a:gsLst>
+              <a:gs pos="0">
+                <a:srgbClr val="57C968"/>
+              </a:gs>
+              <a:gs pos="25000">
+                <a:schemeClr val="bg2"/>
+              </a:gs>
+            </a:gsLst>
+            <a:lin ang="2700000" scaled="0"/>
+          </a:gradFill>
+          <a:ln>
+            <a:noFill/>
+          </a:ln>
+          <a:effectLst>
+            <a:outerShdw blurRad="190500" dist="38100" dir="2700000" algn="tl" rotWithShape="0">
+              <a:prstClr val="black">
+                <a:alpha val="15000"/>
+              </a:prstClr>
+            </a:outerShdw>
+          </a:effectLst>
+        </p:spPr>
+        <p:style>
+          <a:lnRef idx="2">
+            <a:schemeClr val="accent1">
+              <a:shade val="50000"/>
+            </a:schemeClr>
+          </a:lnRef>
+          <a:fillRef idx="1">
+            <a:schemeClr val="accent1"/>
+          </a:fillRef>
+          <a:effectRef idx="0">
+            <a:schemeClr val="accent1"/>
+          </a:effectRef>
+          <a:fontRef idx="minor">
+            <a:schemeClr val="lt1"/>
+          </a:fontRef>
+        </p:style>
+        <p:txBody>
+          <a:bodyPr lIns="109728" tIns="72000" rIns="108000" bIns="72000" rtlCol="0" anchor="ctr"/>
+          <a:lstStyle/>
+          <a:p>
+            <a:r>
+              <a:rPr lang="nl-NL" sz="1000" b="1" noProof="0" dirty="0">
+                <a:solidFill>
+                  <a:schemeClr val="accent1"/>
+                </a:solidFill>
+              </a:rPr>
+              <a:t>@@</a:t>
+            </a:r>
+          </a:p>
+        </p:txBody>
+      </p:sp>
+      <p:sp>
+        <p:nvSpPr>
+          <p:cNvPr id="40" name="TextBox 39">
+            <a:extLst>
+              <a:ext uri="{FF2B5EF4-FFF2-40B4-BE49-F238E27FC236}">
+                <a16:creationId xmlns:a16="http://schemas.microsoft.com/office/drawing/2014/main" id="{39CEFABB-E1D5-DFD1-40E4-722DA0AFDD35}"/>
+              </a:ext>
+            </a:extLst>
+          </p:cNvPr>
+          <p:cNvSpPr txBox="1"/>
+          <p:nvPr/>
+        </p:nvSpPr>
+        <p:spPr>
+          <a:xfrm>
+            <a:off x="11186130" y="4921755"/>
+            <a:ext cx="991126" cy="250518"/>
+          </a:xfrm>
+          <a:prstGeom prst="rect">
+            <a:avLst/>
+          </a:prstGeom>
+          <a:noFill/>
+        </p:spPr>
+        <p:txBody>
+          <a:bodyPr wrap="none" lIns="90000" rtlCol="0" anchor="t">
+            <a:spAutoFit/>
+          </a:bodyPr>
+          <a:lstStyle/>
+          <a:p>
+            <a:pPr algn="r">
+              <a:lnSpc>
+                <a:spcPct val="113000"/>
+              </a:lnSpc>
+            </a:pPr>
+            <a:r>
+              <a:rPr lang="en-US" sz="1000" b="1" dirty="0" err="1">
+                <a:solidFill>
+                  <a:schemeClr val="tx2"/>
+                </a:solidFill>
+                <a:latin typeface="Sigsterren" pitchFamily="2" charset="0"/>
+              </a:rPr>
+              <a:t>HHHHH</a:t>
+            </a:r>
+            <a:r>
+              <a:rPr lang="en-US" sz="1000" b="1" dirty="0">
+                <a:solidFill>
+                  <a:schemeClr val="tx2"/>
+                </a:solidFill>
+                <a:latin typeface="Sigsterren" pitchFamily="2" charset="0"/>
+              </a:rPr>
+              <a:t> </a:t>
+            </a:r>
+            <a:r>
+              <a:rPr lang="en-US" sz="1000" b="1" dirty="0">
+                <a:solidFill>
+                  <a:schemeClr val="tx2"/>
+                </a:solidFill>
+                <a:latin typeface="Calibri" panose="020F0502020204030204" pitchFamily="34" charset="0"/>
+                <a:cs typeface="Calibri" panose="020F0502020204030204" pitchFamily="34" charset="0"/>
+              </a:rPr>
+              <a:t>(</a:t>
+            </a:r>
+            <a:r>
+              <a:rPr lang="en-US" sz="1000" b="1" dirty="0" err="1">
+                <a:solidFill>
+                  <a:schemeClr val="tx2"/>
+                </a:solidFill>
+                <a:latin typeface="Calibri" panose="020F0502020204030204" pitchFamily="34" charset="0"/>
+                <a:cs typeface="Calibri" panose="020F0502020204030204" pitchFamily="34" charset="0"/>
+              </a:rPr>
+              <a:t>X.X</a:t>
+            </a:r>
+            <a:r>
+              <a:rPr lang="en-US" sz="1000" b="1" dirty="0">
+                <a:solidFill>
+                  <a:schemeClr val="tx2"/>
+                </a:solidFill>
+                <a:latin typeface="Calibri" panose="020F0502020204030204" pitchFamily="34" charset="0"/>
+                <a:cs typeface="Calibri" panose="020F0502020204030204" pitchFamily="34" charset="0"/>
+              </a:rPr>
+              <a:t>)</a:t>
+            </a:r>
+          </a:p>
+        </p:txBody>
+      </p:sp>
+      <p:sp>
+        <p:nvSpPr>
+          <p:cNvPr id="41" name="TextBox 40">
+            <a:extLst>
+              <a:ext uri="{FF2B5EF4-FFF2-40B4-BE49-F238E27FC236}">
+                <a16:creationId xmlns:a16="http://schemas.microsoft.com/office/drawing/2014/main" id="{A2EED059-C35B-30FB-216D-512052D0D647}"/>
+              </a:ext>
+            </a:extLst>
+          </p:cNvPr>
+          <p:cNvSpPr txBox="1"/>
+          <p:nvPr/>
+        </p:nvSpPr>
+        <p:spPr>
+          <a:xfrm>
+            <a:off x="11186130" y="4502992"/>
+            <a:ext cx="991126" cy="250518"/>
+          </a:xfrm>
+          <a:prstGeom prst="rect">
+            <a:avLst/>
+          </a:prstGeom>
+          <a:noFill/>
+        </p:spPr>
+        <p:txBody>
+          <a:bodyPr wrap="none" lIns="90000" rtlCol="0" anchor="t">
+            <a:spAutoFit/>
+          </a:bodyPr>
+          <a:lstStyle/>
+          <a:p>
+            <a:pPr algn="r">
+              <a:lnSpc>
+                <a:spcPct val="113000"/>
+              </a:lnSpc>
+            </a:pPr>
+            <a:r>
+              <a:rPr lang="en-US" sz="1000" b="1" dirty="0" err="1">
+                <a:solidFill>
+                  <a:schemeClr val="tx2"/>
+                </a:solidFill>
+                <a:latin typeface="Sigsterren" pitchFamily="2" charset="0"/>
+              </a:rPr>
+              <a:t>HHHHH</a:t>
+            </a:r>
+            <a:r>
+              <a:rPr lang="en-US" sz="1000" b="1" dirty="0">
+                <a:solidFill>
+                  <a:schemeClr val="tx2"/>
+                </a:solidFill>
+                <a:latin typeface="Sigsterren" pitchFamily="2" charset="0"/>
+              </a:rPr>
+              <a:t> </a:t>
+            </a:r>
+            <a:r>
+              <a:rPr lang="en-US" sz="1000" b="1" dirty="0">
+                <a:solidFill>
+                  <a:schemeClr val="tx2"/>
+                </a:solidFill>
+                <a:latin typeface="Calibri" panose="020F0502020204030204" pitchFamily="34" charset="0"/>
+                <a:cs typeface="Calibri" panose="020F0502020204030204" pitchFamily="34" charset="0"/>
+              </a:rPr>
+              <a:t>(</a:t>
+            </a:r>
+            <a:r>
+              <a:rPr lang="en-US" sz="1000" b="1" dirty="0" err="1">
+                <a:solidFill>
+                  <a:schemeClr val="tx2"/>
+                </a:solidFill>
+                <a:latin typeface="Calibri" panose="020F0502020204030204" pitchFamily="34" charset="0"/>
+                <a:cs typeface="Calibri" panose="020F0502020204030204" pitchFamily="34" charset="0"/>
+              </a:rPr>
+              <a:t>X.X</a:t>
+            </a:r>
+            <a:r>
+              <a:rPr lang="en-US" sz="1000" b="1" dirty="0">
+                <a:solidFill>
+                  <a:schemeClr val="tx2"/>
+                </a:solidFill>
+                <a:latin typeface="Calibri" panose="020F0502020204030204" pitchFamily="34" charset="0"/>
+                <a:cs typeface="Calibri" panose="020F0502020204030204" pitchFamily="34" charset="0"/>
+              </a:rPr>
+              <a:t>)</a:t>
+            </a:r>
+          </a:p>
+        </p:txBody>
+      </p:sp>
+      <p:sp>
+        <p:nvSpPr>
+          <p:cNvPr id="44" name="TextBox 43">
+            <a:extLst>
+              <a:ext uri="{FF2B5EF4-FFF2-40B4-BE49-F238E27FC236}">
+                <a16:creationId xmlns:a16="http://schemas.microsoft.com/office/drawing/2014/main" id="{1D4D9CB3-5679-F28D-FDD2-2E348A50D937}"/>
+              </a:ext>
+            </a:extLst>
+          </p:cNvPr>
+          <p:cNvSpPr txBox="1"/>
+          <p:nvPr/>
+        </p:nvSpPr>
+        <p:spPr>
+          <a:xfrm>
+            <a:off x="11186130" y="5759281"/>
+            <a:ext cx="991126" cy="250518"/>
+          </a:xfrm>
+          <a:prstGeom prst="rect">
+            <a:avLst/>
+          </a:prstGeom>
+          <a:noFill/>
+        </p:spPr>
+        <p:txBody>
+          <a:bodyPr wrap="none" lIns="90000" rtlCol="0" anchor="t">
+            <a:spAutoFit/>
+          </a:bodyPr>
+          <a:lstStyle/>
+          <a:p>
+            <a:pPr algn="r">
+              <a:lnSpc>
+                <a:spcPct val="113000"/>
+              </a:lnSpc>
+            </a:pPr>
+            <a:r>
+              <a:rPr lang="en-US" sz="1000" b="1" dirty="0" err="1">
+                <a:solidFill>
+                  <a:schemeClr val="tx2"/>
+                </a:solidFill>
+                <a:latin typeface="Sigsterren" pitchFamily="2" charset="0"/>
+              </a:rPr>
+              <a:t>HHHHH</a:t>
+            </a:r>
+            <a:r>
+              <a:rPr lang="en-US" sz="1000" b="1" dirty="0">
+                <a:solidFill>
+                  <a:schemeClr val="tx2"/>
+                </a:solidFill>
+                <a:latin typeface="Sigsterren" pitchFamily="2" charset="0"/>
+              </a:rPr>
+              <a:t> </a:t>
+            </a:r>
+            <a:r>
+              <a:rPr lang="en-US" sz="1000" b="1" dirty="0">
+                <a:solidFill>
+                  <a:schemeClr val="tx2"/>
+                </a:solidFill>
+                <a:latin typeface="Calibri" panose="020F0502020204030204" pitchFamily="34" charset="0"/>
+                <a:cs typeface="Calibri" panose="020F0502020204030204" pitchFamily="34" charset="0"/>
+              </a:rPr>
+              <a:t>(</a:t>
+            </a:r>
+            <a:r>
+              <a:rPr lang="en-US" sz="1000" b="1" dirty="0" err="1">
+                <a:solidFill>
+                  <a:schemeClr val="tx2"/>
+                </a:solidFill>
+                <a:latin typeface="Calibri" panose="020F0502020204030204" pitchFamily="34" charset="0"/>
+                <a:cs typeface="Calibri" panose="020F0502020204030204" pitchFamily="34" charset="0"/>
+              </a:rPr>
+              <a:t>X.X</a:t>
+            </a:r>
+            <a:r>
+              <a:rPr lang="en-US" sz="1000" b="1" dirty="0">
+                <a:solidFill>
+                  <a:schemeClr val="tx2"/>
+                </a:solidFill>
+                <a:latin typeface="Calibri" panose="020F0502020204030204" pitchFamily="34" charset="0"/>
+                <a:cs typeface="Calibri" panose="020F0502020204030204" pitchFamily="34" charset="0"/>
+              </a:rPr>
+              <a:t>)</a:t>
+            </a:r>
+          </a:p>
+        </p:txBody>
+      </p:sp>
+      <p:sp>
+        <p:nvSpPr>
+          <p:cNvPr id="45" name="TextBox 44">
+            <a:extLst>
+              <a:ext uri="{FF2B5EF4-FFF2-40B4-BE49-F238E27FC236}">
+                <a16:creationId xmlns:a16="http://schemas.microsoft.com/office/drawing/2014/main" id="{DFFE8365-B5FB-7907-3DD9-E01FD55B4B4E}"/>
+              </a:ext>
+            </a:extLst>
+          </p:cNvPr>
+          <p:cNvSpPr txBox="1"/>
+          <p:nvPr/>
+        </p:nvSpPr>
+        <p:spPr>
+          <a:xfrm>
+            <a:off x="11186130" y="5340518"/>
+            <a:ext cx="991126" cy="250518"/>
+          </a:xfrm>
+          <a:prstGeom prst="rect">
+            <a:avLst/>
+          </a:prstGeom>
+          <a:noFill/>
+        </p:spPr>
+        <p:txBody>
+          <a:bodyPr wrap="none" lIns="90000" rtlCol="0" anchor="t">
+            <a:spAutoFit/>
+          </a:bodyPr>
+          <a:lstStyle/>
+          <a:p>
+            <a:pPr algn="r">
+              <a:lnSpc>
+                <a:spcPct val="113000"/>
+              </a:lnSpc>
+            </a:pPr>
+            <a:r>
+              <a:rPr lang="en-US" sz="1000" b="1" dirty="0" err="1">
+                <a:solidFill>
+                  <a:schemeClr val="tx2"/>
+                </a:solidFill>
+                <a:latin typeface="Sigsterren" pitchFamily="2" charset="0"/>
+              </a:rPr>
+              <a:t>HHHHH</a:t>
+            </a:r>
+            <a:r>
+              <a:rPr lang="en-US" sz="1000" b="1" dirty="0">
+                <a:solidFill>
+                  <a:schemeClr val="tx2"/>
+                </a:solidFill>
+                <a:latin typeface="Sigsterren" pitchFamily="2" charset="0"/>
+              </a:rPr>
+              <a:t> </a:t>
+            </a:r>
+            <a:r>
+              <a:rPr lang="en-US" sz="1000" b="1" dirty="0">
+                <a:solidFill>
+                  <a:schemeClr val="tx2"/>
+                </a:solidFill>
+                <a:latin typeface="Calibri" panose="020F0502020204030204" pitchFamily="34" charset="0"/>
+                <a:cs typeface="Calibri" panose="020F0502020204030204" pitchFamily="34" charset="0"/>
+              </a:rPr>
+              <a:t>(</a:t>
+            </a:r>
+            <a:r>
+              <a:rPr lang="en-US" sz="1000" b="1" dirty="0" err="1">
+                <a:solidFill>
+                  <a:schemeClr val="tx2"/>
+                </a:solidFill>
+                <a:latin typeface="Calibri" panose="020F0502020204030204" pitchFamily="34" charset="0"/>
+                <a:cs typeface="Calibri" panose="020F0502020204030204" pitchFamily="34" charset="0"/>
+              </a:rPr>
+              <a:t>X.X</a:t>
+            </a:r>
+            <a:r>
+              <a:rPr lang="en-US" sz="1000" b="1" dirty="0">
+                <a:solidFill>
+                  <a:schemeClr val="tx2"/>
+                </a:solidFill>
+                <a:latin typeface="Calibri" panose="020F0502020204030204" pitchFamily="34" charset="0"/>
+                <a:cs typeface="Calibri" panose="020F0502020204030204" pitchFamily="34" charset="0"/>
+              </a:rPr>
+              <a:t>)</a:t>
+            </a:r>
+          </a:p>
+        </p:txBody>
+      </p:sp>
+      <p:sp>
+        <p:nvSpPr>
+          <p:cNvPr id="42" name="TextBox 41">
+            <a:extLst>
+              <a:ext uri="{FF2B5EF4-FFF2-40B4-BE49-F238E27FC236}">
+                <a16:creationId xmlns:a16="http://schemas.microsoft.com/office/drawing/2014/main" id="{C6CB82B0-D9B4-F3A1-C8D5-3B5C3ED98FE8}"/>
+              </a:ext>
+            </a:extLst>
+          </p:cNvPr>
+          <p:cNvSpPr txBox="1"/>
+          <p:nvPr/>
+        </p:nvSpPr>
+        <p:spPr>
+          <a:xfrm>
+            <a:off x="11186130" y="4084229"/>
+            <a:ext cx="991126" cy="250518"/>
+          </a:xfrm>
+          <a:prstGeom prst="rect">
+            <a:avLst/>
+          </a:prstGeom>
+          <a:noFill/>
+        </p:spPr>
+        <p:txBody>
+          <a:bodyPr wrap="none" lIns="90000" rtlCol="0" anchor="t">
+            <a:spAutoFit/>
+          </a:bodyPr>
+          <a:lstStyle/>
+          <a:p>
+            <a:pPr algn="r">
+              <a:lnSpc>
+                <a:spcPct val="113000"/>
+              </a:lnSpc>
+            </a:pPr>
+            <a:r>
+              <a:rPr lang="en-US" sz="1000" b="1" dirty="0" err="1">
+                <a:solidFill>
+                  <a:schemeClr val="tx2"/>
+                </a:solidFill>
+                <a:latin typeface="Sigsterren" pitchFamily="2" charset="0"/>
+              </a:rPr>
+              <a:t>HHHHH</a:t>
+            </a:r>
+            <a:r>
+              <a:rPr lang="en-US" sz="1000" b="1" dirty="0">
+                <a:solidFill>
+                  <a:schemeClr val="tx2"/>
+                </a:solidFill>
+                <a:latin typeface="Sigsterren" pitchFamily="2" charset="0"/>
+              </a:rPr>
+              <a:t> </a:t>
+            </a:r>
+            <a:r>
+              <a:rPr lang="en-US" sz="1000" b="1" dirty="0">
+                <a:solidFill>
+                  <a:schemeClr val="tx2"/>
+                </a:solidFill>
+                <a:latin typeface="Calibri" panose="020F0502020204030204" pitchFamily="34" charset="0"/>
+                <a:cs typeface="Calibri" panose="020F0502020204030204" pitchFamily="34" charset="0"/>
+              </a:rPr>
+              <a:t>(</a:t>
+            </a:r>
+            <a:r>
+              <a:rPr lang="en-US" sz="1000" b="1" dirty="0" err="1">
+                <a:solidFill>
+                  <a:schemeClr val="tx2"/>
+                </a:solidFill>
+                <a:latin typeface="Calibri" panose="020F0502020204030204" pitchFamily="34" charset="0"/>
+                <a:cs typeface="Calibri" panose="020F0502020204030204" pitchFamily="34" charset="0"/>
+              </a:rPr>
+              <a:t>X.X</a:t>
+            </a:r>
+            <a:r>
+              <a:rPr lang="en-US" sz="1000" b="1" dirty="0">
+                <a:solidFill>
+                  <a:schemeClr val="tx2"/>
+                </a:solidFill>
+                <a:latin typeface="Calibri" panose="020F0502020204030204" pitchFamily="34" charset="0"/>
+                <a:cs typeface="Calibri" panose="020F0502020204030204" pitchFamily="34" charset="0"/>
+              </a:rPr>
+              <a:t>)</a:t>
+            </a:r>
+          </a:p>
+        </p:txBody>
+      </p:sp>
+      <p:sp>
+        <p:nvSpPr>
+          <p:cNvPr id="43" name="TextBox 42">
+            <a:extLst>
+              <a:ext uri="{FF2B5EF4-FFF2-40B4-BE49-F238E27FC236}">
+                <a16:creationId xmlns:a16="http://schemas.microsoft.com/office/drawing/2014/main" id="{C5DF5BA5-0058-7FE9-D0AB-60E0DA268B78}"/>
+              </a:ext>
+            </a:extLst>
+          </p:cNvPr>
+          <p:cNvSpPr txBox="1"/>
+          <p:nvPr/>
+        </p:nvSpPr>
+        <p:spPr>
+          <a:xfrm>
+            <a:off x="11186130" y="3665466"/>
+            <a:ext cx="991126" cy="250518"/>
+          </a:xfrm>
+          <a:prstGeom prst="rect">
+            <a:avLst/>
+          </a:prstGeom>
+          <a:noFill/>
+        </p:spPr>
+        <p:txBody>
+          <a:bodyPr wrap="none" lIns="90000" rtlCol="0" anchor="t">
+            <a:spAutoFit/>
+          </a:bodyPr>
+          <a:lstStyle/>
+          <a:p>
+            <a:pPr algn="r">
+              <a:lnSpc>
+                <a:spcPct val="113000"/>
+              </a:lnSpc>
+            </a:pPr>
+            <a:r>
+              <a:rPr lang="en-US" sz="1000" b="1" dirty="0" err="1">
+                <a:solidFill>
+                  <a:schemeClr val="tx2"/>
+                </a:solidFill>
+                <a:latin typeface="Sigsterren" pitchFamily="2" charset="0"/>
+              </a:rPr>
+              <a:t>HHHHH</a:t>
+            </a:r>
+            <a:r>
+              <a:rPr lang="en-US" sz="1000" b="1" dirty="0">
+                <a:solidFill>
+                  <a:schemeClr val="tx2"/>
+                </a:solidFill>
+                <a:latin typeface="Sigsterren" pitchFamily="2" charset="0"/>
+              </a:rPr>
+              <a:t> </a:t>
+            </a:r>
+            <a:r>
+              <a:rPr lang="en-US" sz="1000" b="1" dirty="0">
+                <a:solidFill>
+                  <a:schemeClr val="tx2"/>
+                </a:solidFill>
+                <a:latin typeface="Calibri" panose="020F0502020204030204" pitchFamily="34" charset="0"/>
+                <a:cs typeface="Calibri" panose="020F0502020204030204" pitchFamily="34" charset="0"/>
+              </a:rPr>
+              <a:t>(</a:t>
+            </a:r>
+            <a:r>
+              <a:rPr lang="en-US" sz="1000" b="1" dirty="0" err="1">
+                <a:solidFill>
+                  <a:schemeClr val="tx2"/>
+                </a:solidFill>
+                <a:latin typeface="Calibri" panose="020F0502020204030204" pitchFamily="34" charset="0"/>
+                <a:cs typeface="Calibri" panose="020F0502020204030204" pitchFamily="34" charset="0"/>
+              </a:rPr>
+              <a:t>X.X</a:t>
+            </a:r>
+            <a:r>
+              <a:rPr lang="en-US" sz="1000" b="1" dirty="0">
+                <a:solidFill>
+                  <a:schemeClr val="tx2"/>
+                </a:solidFill>
+                <a:latin typeface="Calibri" panose="020F0502020204030204" pitchFamily="34" charset="0"/>
+                <a:cs typeface="Calibri" panose="020F0502020204030204" pitchFamily="34" charset="0"/>
+              </a:rPr>
+              <a:t>)</a:t>
+            </a:r>
+          </a:p>
+        </p:txBody>
+      </p:sp>
+      <p:sp>
+        <p:nvSpPr>
+          <p:cNvPr id="60" name="Triangle 59">
+            <a:extLst>
+              <a:ext uri="{FF2B5EF4-FFF2-40B4-BE49-F238E27FC236}">
+                <a16:creationId xmlns:a16="http://schemas.microsoft.com/office/drawing/2014/main" id="{ED6557AD-B7B1-2792-5C6A-4B879C331B8C}"/>
+              </a:ext>
+            </a:extLst>
+          </p:cNvPr>
+          <p:cNvSpPr/>
+          <p:nvPr/>
+        </p:nvSpPr>
+        <p:spPr>
+          <a:xfrm rot="5400000">
+            <a:off x="11223517" y="97630"/>
+            <a:ext cx="113704" cy="91353"/>
+          </a:xfrm>
+          <a:prstGeom prst="triangle">
+            <a:avLst/>
+          </a:prstGeom>
+          <a:solidFill>
+            <a:schemeClr val="tx2"/>
+          </a:solidFill>
+          <a:ln>
+            <a:noFill/>
+          </a:ln>
+        </p:spPr>
+        <p:style>
+          <a:lnRef idx="2">
+            <a:schemeClr val="accent1">
+              <a:shade val="50000"/>
+            </a:schemeClr>
+          </a:lnRef>
+          <a:fillRef idx="1">
+            <a:schemeClr val="accent1"/>
+          </a:fillRef>
+          <a:effectRef idx="0">
+            <a:schemeClr val="accent1"/>
+          </a:effectRef>
+          <a:fontRef idx="minor">
+            <a:schemeClr val="lt1"/>
+          </a:fontRef>
+        </p:style>
+        <p:txBody>
+          <a:bodyPr lIns="108000" tIns="72000" rIns="108000" bIns="72000" rtlCol="0" anchor="ctr"/>
+          <a:lstStyle/>
+          <a:p>
+            <a:pPr algn="ctr"/>
+            <a:endParaRPr lang="en-US" sz="1600">
+              <a:solidFill>
+                <a:schemeClr val="bg1"/>
+              </a:solidFill>
+            </a:endParaRPr>
+          </a:p>
+        </p:txBody>
+      </p:sp>
+      <p:pic>
+        <p:nvPicPr>
+          <p:cNvPr id="61" name="Picture 60">
+            <a:extLst>
+              <a:ext uri="{FF2B5EF4-FFF2-40B4-BE49-F238E27FC236}">
+                <a16:creationId xmlns:a16="http://schemas.microsoft.com/office/drawing/2014/main" id="{9F41F059-05DD-C108-C2D0-6033A3E6010F}"/>
+              </a:ext>
+            </a:extLst>
+          </p:cNvPr>
+          <p:cNvPicPr>
+            <a:picLocks noChangeAspect="1"/>
+          </p:cNvPicPr>
+          <p:nvPr/>
+        </p:nvPicPr>
+        <p:blipFill>
+          <a:blip r:embed="rId2"/>
+          <a:stretch>
+            <a:fillRect/>
+          </a:stretch>
+        </p:blipFill>
+        <p:spPr>
+          <a:xfrm>
+            <a:off x="10267839" y="52613"/>
+            <a:ext cx="203103" cy="172639"/>
+          </a:xfrm>
+          <a:prstGeom prst="rect">
+            <a:avLst/>
+          </a:prstGeom>
+        </p:spPr>
+      </p:pic>
+      <p:sp>
+        <p:nvSpPr>
+          <p:cNvPr id="62" name="TextBox 61">
+            <a:extLst>
+              <a:ext uri="{FF2B5EF4-FFF2-40B4-BE49-F238E27FC236}">
+                <a16:creationId xmlns:a16="http://schemas.microsoft.com/office/drawing/2014/main" id="{140A62AD-F7F5-B173-0898-322136FAD750}"/>
+              </a:ext>
+            </a:extLst>
+          </p:cNvPr>
+          <p:cNvSpPr txBox="1"/>
+          <p:nvPr/>
+        </p:nvSpPr>
+        <p:spPr>
+          <a:xfrm>
+            <a:off x="9145068" y="10898"/>
+            <a:ext cx="2110021" cy="264816"/>
+          </a:xfrm>
+          <a:prstGeom prst="rect">
+            <a:avLst/>
+          </a:prstGeom>
+          <a:noFill/>
+        </p:spPr>
+        <p:txBody>
+          <a:bodyPr wrap="none" lIns="90000" rtlCol="0" anchor="t">
+            <a:spAutoFit/>
+          </a:bodyPr>
+          <a:lstStyle/>
+          <a:p>
+            <a:pPr algn="r">
+              <a:lnSpc>
+                <a:spcPct val="113000"/>
+              </a:lnSpc>
+            </a:pPr>
+            <a:r>
+              <a:rPr lang="nl-NL" sz="1050" b="1" dirty="0" err="1">
+                <a:solidFill>
+                  <a:schemeClr val="bg1">
+                    <a:lumMod val="75000"/>
+                  </a:schemeClr>
+                </a:solidFill>
+              </a:rPr>
+              <a:t>PORTFOLIO_PERIOD_START_DATE</a:t>
+            </a:r>
+            <a:endParaRPr lang="nl-NL" sz="1050" b="1" dirty="0">
+              <a:solidFill>
+                <a:schemeClr val="bg1">
+                  <a:lumMod val="75000"/>
+                </a:schemeClr>
+              </a:solidFill>
+            </a:endParaRPr>
+          </a:p>
+        </p:txBody>
+      </p:sp>
+      <p:sp>
+        <p:nvSpPr>
+          <p:cNvPr id="63" name="TextBox 62">
+            <a:extLst>
+              <a:ext uri="{FF2B5EF4-FFF2-40B4-BE49-F238E27FC236}">
+                <a16:creationId xmlns:a16="http://schemas.microsoft.com/office/drawing/2014/main" id="{3201E155-D9D4-EC1C-28EA-14A8EA734445}"/>
+              </a:ext>
+            </a:extLst>
+          </p:cNvPr>
+          <p:cNvSpPr txBox="1"/>
+          <p:nvPr/>
+        </p:nvSpPr>
+        <p:spPr>
+          <a:xfrm>
+            <a:off x="11305651" y="10898"/>
+            <a:ext cx="1993003" cy="264816"/>
+          </a:xfrm>
+          <a:prstGeom prst="rect">
+            <a:avLst/>
+          </a:prstGeom>
+          <a:noFill/>
+        </p:spPr>
+        <p:txBody>
+          <a:bodyPr wrap="none" lIns="90000" rtlCol="0" anchor="t">
+            <a:spAutoFit/>
+          </a:bodyPr>
+          <a:lstStyle/>
+          <a:p>
+            <a:pPr>
+              <a:lnSpc>
+                <a:spcPct val="113000"/>
+              </a:lnSpc>
+            </a:pPr>
+            <a:r>
+              <a:rPr lang="nl-NL" sz="1050" b="1" dirty="0" err="1">
+                <a:solidFill>
+                  <a:schemeClr val="tx2"/>
+                </a:solidFill>
+              </a:rPr>
+              <a:t>PORTFOLIO_PERIOD_END_DATE</a:t>
+            </a:r>
+            <a:endParaRPr lang="nl-NL" sz="1050" b="1" noProof="0" dirty="0">
+              <a:solidFill>
+                <a:schemeClr val="tx2"/>
+              </a:solidFill>
+            </a:endParaRPr>
+          </a:p>
+        </p:txBody>
+      </p:sp>
+      <p:grpSp>
+        <p:nvGrpSpPr>
+          <p:cNvPr id="64" name="Group 63">
+            <a:extLst>
+              <a:ext uri="{FF2B5EF4-FFF2-40B4-BE49-F238E27FC236}">
+                <a16:creationId xmlns:a16="http://schemas.microsoft.com/office/drawing/2014/main" id="{5A4A8152-ED19-BB7D-D225-ADBF32692579}"/>
+              </a:ext>
+            </a:extLst>
+          </p:cNvPr>
+          <p:cNvGrpSpPr>
+            <a:grpSpLocks noChangeAspect="1"/>
+          </p:cNvGrpSpPr>
+          <p:nvPr/>
+        </p:nvGrpSpPr>
+        <p:grpSpPr>
+          <a:xfrm>
+            <a:off x="-392105" y="2517185"/>
+            <a:ext cx="98115" cy="92576"/>
+            <a:chOff x="-331054" y="2564812"/>
+            <a:chExt cx="141517" cy="133528"/>
+          </a:xfrm>
+          <a:solidFill>
+            <a:srgbClr val="57C968"/>
+          </a:solidFill>
+        </p:grpSpPr>
+        <p:sp>
+          <p:nvSpPr>
+            <p:cNvPr id="65" name="Freeform 64">
+              <a:extLst>
+                <a:ext uri="{FF2B5EF4-FFF2-40B4-BE49-F238E27FC236}">
+                  <a16:creationId xmlns:a16="http://schemas.microsoft.com/office/drawing/2014/main" id="{DBA9B3E6-245A-C0A0-185B-A829C03F5887}"/>
+                </a:ext>
+              </a:extLst>
+            </p:cNvPr>
+            <p:cNvSpPr/>
+            <p:nvPr/>
+          </p:nvSpPr>
+          <p:spPr>
+            <a:xfrm>
+              <a:off x="-331054" y="2564812"/>
+              <a:ext cx="141517" cy="82436"/>
+            </a:xfrm>
+            <a:custGeom>
+              <a:avLst/>
+              <a:gdLst>
+                <a:gd name="connsiteX0" fmla="*/ 70759 w 141517"/>
+                <a:gd name="connsiteY0" fmla="*/ 0 h 82436"/>
+                <a:gd name="connsiteX1" fmla="*/ 141517 w 141517"/>
+                <a:gd name="connsiteY1" fmla="*/ 82436 h 82436"/>
+                <a:gd name="connsiteX2" fmla="*/ 111805 w 141517"/>
+                <a:gd name="connsiteY2" fmla="*/ 82436 h 82436"/>
+                <a:gd name="connsiteX3" fmla="*/ 70759 w 141517"/>
+                <a:gd name="connsiteY3" fmla="*/ 34616 h 82436"/>
+                <a:gd name="connsiteX4" fmla="*/ 29713 w 141517"/>
+                <a:gd name="connsiteY4" fmla="*/ 82436 h 82436"/>
+                <a:gd name="connsiteX5" fmla="*/ 0 w 141517"/>
+                <a:gd name="connsiteY5" fmla="*/ 82436 h 82436"/>
+              </a:gdLst>
+              <a:ahLst/>
+              <a:cxnLst>
+                <a:cxn ang="0">
+                  <a:pos x="connsiteX0" y="connsiteY0"/>
+                </a:cxn>
+                <a:cxn ang="0">
+                  <a:pos x="connsiteX1" y="connsiteY1"/>
+                </a:cxn>
+                <a:cxn ang="0">
+                  <a:pos x="connsiteX2" y="connsiteY2"/>
+                </a:cxn>
+                <a:cxn ang="0">
+                  <a:pos x="connsiteX3" y="connsiteY3"/>
+                </a:cxn>
+                <a:cxn ang="0">
+                  <a:pos x="connsiteX4" y="connsiteY4"/>
+                </a:cxn>
+                <a:cxn ang="0">
+                  <a:pos x="connsiteX5" y="connsiteY5"/>
+                </a:cxn>
+              </a:cxnLst>
+              <a:rect l="l" t="t" r="r" b="b"/>
+              <a:pathLst>
+                <a:path w="141517" h="82436">
+                  <a:moveTo>
+                    <a:pt x="70759" y="0"/>
+                  </a:moveTo>
+                  <a:lnTo>
+                    <a:pt x="141517" y="82436"/>
+                  </a:lnTo>
+                  <a:lnTo>
+                    <a:pt x="111805" y="82436"/>
+                  </a:lnTo>
+                  <a:lnTo>
+                    <a:pt x="70759" y="34616"/>
+                  </a:lnTo>
+                  <a:lnTo>
+                    <a:pt x="29713" y="82436"/>
+                  </a:lnTo>
+                  <a:lnTo>
+                    <a:pt x="0" y="82436"/>
+                  </a:lnTo>
+                  <a:close/>
+                </a:path>
+              </a:pathLst>
+            </a:custGeom>
+            <a:grpFill/>
+            <a:ln>
+              <a:noFill/>
+            </a:ln>
+          </p:spPr>
+          <p:style>
+            <a:lnRef idx="2">
+              <a:schemeClr val="accent1">
+                <a:shade val="50000"/>
+              </a:schemeClr>
+            </a:lnRef>
+            <a:fillRef idx="1">
+              <a:schemeClr val="accent1"/>
+            </a:fillRef>
+            <a:effectRef idx="0">
+              <a:schemeClr val="accent1"/>
+            </a:effectRef>
+            <a:fontRef idx="minor">
+              <a:schemeClr val="lt1"/>
+            </a:fontRef>
+          </p:style>
+          <p:txBody>
+            <a:bodyPr wrap="square" lIns="108000" tIns="72000" rIns="108000" bIns="72000" rtlCol="0" anchor="ctr">
+              <a:noAutofit/>
+            </a:bodyPr>
+            <a:lstStyle/>
+            <a:p>
+              <a:pPr algn="ctr"/>
+              <a:endParaRPr lang="en-US" sz="1600" err="1">
+                <a:solidFill>
+                  <a:schemeClr val="bg1"/>
+                </a:solidFill>
+              </a:endParaRPr>
+            </a:p>
+          </p:txBody>
+        </p:sp>
+        <p:sp>
+          <p:nvSpPr>
+            <p:cNvPr id="66" name="Triangle 65">
+              <a:extLst>
+                <a:ext uri="{FF2B5EF4-FFF2-40B4-BE49-F238E27FC236}">
+                  <a16:creationId xmlns:a16="http://schemas.microsoft.com/office/drawing/2014/main" id="{218F299A-6098-C319-B388-95D3DE10D105}"/>
+                </a:ext>
+              </a:extLst>
+            </p:cNvPr>
+            <p:cNvSpPr/>
+            <p:nvPr/>
+          </p:nvSpPr>
+          <p:spPr>
+            <a:xfrm>
+              <a:off x="-331054" y="2615904"/>
+              <a:ext cx="141517" cy="82436"/>
+            </a:xfrm>
+            <a:prstGeom prst="triangle">
+              <a:avLst/>
+            </a:prstGeom>
+            <a:grpFill/>
+            <a:ln>
+              <a:noFill/>
+            </a:ln>
+          </p:spPr>
+          <p:style>
+            <a:lnRef idx="2">
+              <a:schemeClr val="accent1">
+                <a:shade val="50000"/>
+              </a:schemeClr>
+            </a:lnRef>
+            <a:fillRef idx="1">
+              <a:schemeClr val="accent1"/>
+            </a:fillRef>
+            <a:effectRef idx="0">
+              <a:schemeClr val="accent1"/>
+            </a:effectRef>
+            <a:fontRef idx="minor">
+              <a:schemeClr val="lt1"/>
+            </a:fontRef>
+          </p:style>
+          <p:txBody>
+            <a:bodyPr lIns="108000" tIns="72000" rIns="108000" bIns="72000" rtlCol="0" anchor="ctr"/>
+            <a:lstStyle/>
+            <a:p>
+              <a:pPr algn="ctr"/>
+              <a:endParaRPr lang="en-US" sz="1600" err="1">
+                <a:solidFill>
+                  <a:schemeClr val="bg1"/>
+                </a:solidFill>
+              </a:endParaRPr>
+            </a:p>
+          </p:txBody>
+        </p:sp>
+      </p:grpSp>
+      <p:grpSp>
+        <p:nvGrpSpPr>
+          <p:cNvPr id="67" name="Group 66">
+            <a:extLst>
+              <a:ext uri="{FF2B5EF4-FFF2-40B4-BE49-F238E27FC236}">
+                <a16:creationId xmlns:a16="http://schemas.microsoft.com/office/drawing/2014/main" id="{41E626CF-A101-28D5-EDEF-71AC26E45F17}"/>
+              </a:ext>
+            </a:extLst>
+          </p:cNvPr>
+          <p:cNvGrpSpPr>
+            <a:grpSpLocks noChangeAspect="1"/>
+          </p:cNvGrpSpPr>
+          <p:nvPr/>
+        </p:nvGrpSpPr>
+        <p:grpSpPr>
+          <a:xfrm rot="10800000">
+            <a:off x="-392106" y="2948284"/>
+            <a:ext cx="98115" cy="92576"/>
+            <a:chOff x="-331054" y="2564812"/>
+            <a:chExt cx="141517" cy="133528"/>
+          </a:xfrm>
+          <a:solidFill>
+            <a:srgbClr val="FFC000"/>
+          </a:solidFill>
+        </p:grpSpPr>
+        <p:sp>
+          <p:nvSpPr>
+            <p:cNvPr id="68" name="Freeform 67">
+              <a:extLst>
+                <a:ext uri="{FF2B5EF4-FFF2-40B4-BE49-F238E27FC236}">
+                  <a16:creationId xmlns:a16="http://schemas.microsoft.com/office/drawing/2014/main" id="{5013B576-3DBA-0ADE-F60C-A6C7DEDFCA1A}"/>
+                </a:ext>
+              </a:extLst>
+            </p:cNvPr>
+            <p:cNvSpPr/>
+            <p:nvPr/>
+          </p:nvSpPr>
+          <p:spPr>
+            <a:xfrm>
+              <a:off x="-331054" y="2564812"/>
+              <a:ext cx="141517" cy="82436"/>
+            </a:xfrm>
+            <a:custGeom>
+              <a:avLst/>
+              <a:gdLst>
+                <a:gd name="connsiteX0" fmla="*/ 70759 w 141517"/>
+                <a:gd name="connsiteY0" fmla="*/ 0 h 82436"/>
+                <a:gd name="connsiteX1" fmla="*/ 141517 w 141517"/>
+                <a:gd name="connsiteY1" fmla="*/ 82436 h 82436"/>
+                <a:gd name="connsiteX2" fmla="*/ 111805 w 141517"/>
+                <a:gd name="connsiteY2" fmla="*/ 82436 h 82436"/>
+                <a:gd name="connsiteX3" fmla="*/ 70759 w 141517"/>
+                <a:gd name="connsiteY3" fmla="*/ 34616 h 82436"/>
+                <a:gd name="connsiteX4" fmla="*/ 29713 w 141517"/>
+                <a:gd name="connsiteY4" fmla="*/ 82436 h 82436"/>
+                <a:gd name="connsiteX5" fmla="*/ 0 w 141517"/>
+                <a:gd name="connsiteY5" fmla="*/ 82436 h 82436"/>
+              </a:gdLst>
+              <a:ahLst/>
+              <a:cxnLst>
+                <a:cxn ang="0">
+                  <a:pos x="connsiteX0" y="connsiteY0"/>
+                </a:cxn>
+                <a:cxn ang="0">
+                  <a:pos x="connsiteX1" y="connsiteY1"/>
+                </a:cxn>
+                <a:cxn ang="0">
+                  <a:pos x="connsiteX2" y="connsiteY2"/>
+                </a:cxn>
+                <a:cxn ang="0">
+                  <a:pos x="connsiteX3" y="connsiteY3"/>
+                </a:cxn>
+                <a:cxn ang="0">
+                  <a:pos x="connsiteX4" y="connsiteY4"/>
+                </a:cxn>
+                <a:cxn ang="0">
+                  <a:pos x="connsiteX5" y="connsiteY5"/>
+                </a:cxn>
+              </a:cxnLst>
+              <a:rect l="l" t="t" r="r" b="b"/>
+              <a:pathLst>
+                <a:path w="141517" h="82436">
+                  <a:moveTo>
+                    <a:pt x="70759" y="0"/>
+                  </a:moveTo>
+                  <a:lnTo>
+                    <a:pt x="141517" y="82436"/>
+                  </a:lnTo>
+                  <a:lnTo>
+                    <a:pt x="111805" y="82436"/>
+                  </a:lnTo>
+                  <a:lnTo>
+                    <a:pt x="70759" y="34616"/>
+                  </a:lnTo>
+                  <a:lnTo>
+                    <a:pt x="29713" y="82436"/>
+                  </a:lnTo>
+                  <a:lnTo>
+                    <a:pt x="0" y="82436"/>
+                  </a:lnTo>
+                  <a:close/>
+                </a:path>
+              </a:pathLst>
+            </a:custGeom>
+            <a:grpFill/>
+            <a:ln>
+              <a:noFill/>
+            </a:ln>
+          </p:spPr>
+          <p:style>
+            <a:lnRef idx="2">
+              <a:schemeClr val="accent1">
+                <a:shade val="50000"/>
+              </a:schemeClr>
+            </a:lnRef>
+            <a:fillRef idx="1">
+              <a:schemeClr val="accent1"/>
+            </a:fillRef>
+            <a:effectRef idx="0">
+              <a:schemeClr val="accent1"/>
+            </a:effectRef>
+            <a:fontRef idx="minor">
+              <a:schemeClr val="lt1"/>
+            </a:fontRef>
+          </p:style>
+          <p:txBody>
+            <a:bodyPr wrap="square" lIns="108000" tIns="72000" rIns="108000" bIns="72000" rtlCol="0" anchor="ctr">
+              <a:noAutofit/>
+            </a:bodyPr>
+            <a:lstStyle/>
+            <a:p>
+              <a:pPr algn="ctr"/>
+              <a:endParaRPr lang="en-US" sz="1600" err="1">
+                <a:solidFill>
+                  <a:schemeClr val="bg1"/>
+                </a:solidFill>
+              </a:endParaRPr>
+            </a:p>
+          </p:txBody>
+        </p:sp>
+        <p:sp>
+          <p:nvSpPr>
+            <p:cNvPr id="69" name="Triangle 68">
+              <a:extLst>
+                <a:ext uri="{FF2B5EF4-FFF2-40B4-BE49-F238E27FC236}">
+                  <a16:creationId xmlns:a16="http://schemas.microsoft.com/office/drawing/2014/main" id="{C7C013D7-E009-E851-F4CA-41A5CDADF008}"/>
+                </a:ext>
+              </a:extLst>
+            </p:cNvPr>
+            <p:cNvSpPr/>
+            <p:nvPr/>
+          </p:nvSpPr>
+          <p:spPr>
+            <a:xfrm>
+              <a:off x="-331054" y="2615904"/>
+              <a:ext cx="141517" cy="82436"/>
+            </a:xfrm>
+            <a:prstGeom prst="triangle">
+              <a:avLst/>
+            </a:prstGeom>
+            <a:grpFill/>
+            <a:ln>
+              <a:noFill/>
+            </a:ln>
+          </p:spPr>
+          <p:style>
+            <a:lnRef idx="2">
+              <a:schemeClr val="accent1">
+                <a:shade val="50000"/>
+              </a:schemeClr>
+            </a:lnRef>
+            <a:fillRef idx="1">
+              <a:schemeClr val="accent1"/>
+            </a:fillRef>
+            <a:effectRef idx="0">
+              <a:schemeClr val="accent1"/>
+            </a:effectRef>
+            <a:fontRef idx="minor">
+              <a:schemeClr val="lt1"/>
+            </a:fontRef>
+          </p:style>
+          <p:txBody>
+            <a:bodyPr lIns="108000" tIns="72000" rIns="108000" bIns="72000" rtlCol="0" anchor="ctr"/>
+            <a:lstStyle/>
+            <a:p>
+              <a:pPr algn="ctr"/>
+              <a:endParaRPr lang="en-US" sz="1600" err="1">
+                <a:solidFill>
+                  <a:schemeClr val="bg1"/>
+                </a:solidFill>
+              </a:endParaRPr>
+            </a:p>
+          </p:txBody>
+        </p:sp>
+      </p:grpSp>
+      <p:sp>
+        <p:nvSpPr>
+          <p:cNvPr id="72" name="TextBox 71">
+            <a:extLst>
+              <a:ext uri="{FF2B5EF4-FFF2-40B4-BE49-F238E27FC236}">
+                <a16:creationId xmlns:a16="http://schemas.microsoft.com/office/drawing/2014/main" id="{44A5C37A-0A7F-F523-7D1F-D3CDCCE0AF1E}"/>
+              </a:ext>
+            </a:extLst>
+          </p:cNvPr>
+          <p:cNvSpPr txBox="1"/>
+          <p:nvPr/>
+        </p:nvSpPr>
+        <p:spPr>
+          <a:xfrm>
+            <a:off x="9777184" y="3305030"/>
+            <a:ext cx="579667" cy="322332"/>
+          </a:xfrm>
+          <a:prstGeom prst="rect">
+            <a:avLst/>
+          </a:prstGeom>
+          <a:noFill/>
+        </p:spPr>
+        <p:txBody>
+          <a:bodyPr wrap="none" lIns="90000" rtlCol="0" anchor="t">
+            <a:spAutoFit/>
+          </a:bodyPr>
+          <a:lstStyle/>
+          <a:p>
+            <a:pPr algn="l">
+              <a:lnSpc>
+                <a:spcPct val="113000"/>
+              </a:lnSpc>
+            </a:pPr>
+            <a:r>
+              <a:rPr lang="en-US" sz="1400" b="1" dirty="0">
+                <a:solidFill>
+                  <a:schemeClr val="tx2"/>
+                </a:solidFill>
+              </a:rPr>
+              <a:t>Team</a:t>
+            </a:r>
+          </a:p>
+        </p:txBody>
+      </p:sp>
+      <p:pic>
+        <p:nvPicPr>
+          <p:cNvPr id="12" name="Graphic 11">
+            <a:extLst>
+              <a:ext uri="{FF2B5EF4-FFF2-40B4-BE49-F238E27FC236}">
+                <a16:creationId xmlns:a16="http://schemas.microsoft.com/office/drawing/2014/main" id="{22681A2A-D48A-7D45-09C1-DF712BC51B3F}"/>
+              </a:ext>
+            </a:extLst>
+          </p:cNvPr>
+          <p:cNvPicPr>
+            <a:picLocks noChangeAspect="1"/>
+          </p:cNvPicPr>
+          <p:nvPr/>
+        </p:nvPicPr>
+        <p:blipFill>
+          <a:blip r:embed="rId3">
+            <a:extLst>
+              <a:ext uri="{96DAC541-7B7A-43D3-8B79-37D633B846F1}">
+                <asvg:svgBlip xmlns:asvg="http://schemas.microsoft.com/office/drawing/2016/SVG/main" r:embed="rId4"/>
+              </a:ext>
+            </a:extLst>
+          </a:blip>
+          <a:stretch>
+            <a:fillRect/>
+          </a:stretch>
+        </p:blipFill>
+        <p:spPr>
+          <a:xfrm>
+            <a:off x="8838256" y="6071736"/>
+            <a:ext cx="371130" cy="206558"/>
+          </a:xfrm>
+          <a:prstGeom prst="rect">
+            <a:avLst/>
+          </a:prstGeom>
+        </p:spPr>
+      </p:pic>
+      <p:sp>
+        <p:nvSpPr>
+          <p:cNvPr id="11" name="Rectangle 10">
+            <a:extLst>
+              <a:ext uri="{FF2B5EF4-FFF2-40B4-BE49-F238E27FC236}">
+                <a16:creationId xmlns:a16="http://schemas.microsoft.com/office/drawing/2014/main" id="{7E08760A-8484-48C1-CB6E-D8435415390D}"/>
+              </a:ext>
+            </a:extLst>
+          </p:cNvPr>
+          <p:cNvSpPr/>
+          <p:nvPr/>
+        </p:nvSpPr>
+        <p:spPr>
+          <a:xfrm>
+            <a:off x="512064" y="3200400"/>
+            <a:ext cx="8750808" cy="2843784"/>
+          </a:xfrm>
+          <a:prstGeom prst="rect">
+            <a:avLst/>
+          </a:prstGeom>
+          <a:solidFill>
+            <a:srgbClr val="F0089F"/>
+          </a:solidFill>
+          <a:ln>
+            <a:noFill/>
+          </a:ln>
+        </p:spPr>
+        <p:style>
+          <a:lnRef idx="2">
+            <a:schemeClr val="accent1">
+              <a:shade val="50000"/>
+            </a:schemeClr>
+          </a:lnRef>
+          <a:fillRef idx="1">
+            <a:schemeClr val="accent1"/>
+          </a:fillRef>
+          <a:effectRef idx="0">
+            <a:schemeClr val="accent1"/>
+          </a:effectRef>
+          <a:fontRef idx="minor">
+            <a:schemeClr val="lt1"/>
+          </a:fontRef>
+        </p:style>
+        <p:txBody>
+          <a:bodyPr lIns="108000" tIns="72000" rIns="108000" bIns="72000" rtlCol="0" anchor="ctr"/>
+          <a:lstStyle/>
+          <a:p>
+            <a:pPr algn="ctr"/>
+            <a:r>
+              <a:rPr lang="en-US" sz="1600" dirty="0" err="1">
+                <a:solidFill>
+                  <a:schemeClr val="bg1"/>
+                </a:solidFill>
+              </a:rPr>
+              <a:t>PORTFOLIO_PERIOD_MAINTAINABILITY_CHANGE</a:t>
+            </a:r>
+            <a:endParaRPr lang="en-US" sz="1600" dirty="0">
+              <a:solidFill>
+                <a:schemeClr val="bg1"/>
+              </a:solidFill>
+            </a:endParaRPr>
+          </a:p>
+        </p:txBody>
+      </p:sp>
+      <p:sp>
+        <p:nvSpPr>
+          <p:cNvPr id="10" name="TextBox 9">
+            <a:extLst>
+              <a:ext uri="{FF2B5EF4-FFF2-40B4-BE49-F238E27FC236}">
+                <a16:creationId xmlns:a16="http://schemas.microsoft.com/office/drawing/2014/main" id="{591DA0CB-C306-A533-81C2-F58E7AAD1A8B}"/>
+              </a:ext>
+            </a:extLst>
+          </p:cNvPr>
+          <p:cNvSpPr txBox="1"/>
+          <p:nvPr/>
+        </p:nvSpPr>
+        <p:spPr>
+          <a:xfrm>
+            <a:off x="2643466" y="6054740"/>
+            <a:ext cx="1276460" cy="223844"/>
+          </a:xfrm>
+          <a:prstGeom prst="rect">
+            <a:avLst/>
+          </a:prstGeom>
+          <a:noFill/>
+        </p:spPr>
+        <p:txBody>
+          <a:bodyPr wrap="none" lIns="90000" rtlCol="0" anchor="t">
+            <a:spAutoFit/>
+          </a:bodyPr>
+          <a:lstStyle/>
+          <a:p>
+            <a:pPr algn="l">
+              <a:lnSpc>
+                <a:spcPct val="113000"/>
+              </a:lnSpc>
+            </a:pPr>
+            <a:r>
+              <a:rPr lang="en-US" sz="800" dirty="0">
+                <a:solidFill>
+                  <a:schemeClr val="accent3"/>
+                </a:solidFill>
+              </a:rPr>
+              <a:t>Systems grouped by </a:t>
+            </a:r>
+            <a:r>
+              <a:rPr lang="en-US" sz="800" b="1" dirty="0">
+                <a:solidFill>
+                  <a:schemeClr val="accent3"/>
+                </a:solidFill>
+              </a:rPr>
+              <a:t>Team</a:t>
+            </a:r>
+          </a:p>
+        </p:txBody>
+      </p:sp>
+      <p:grpSp>
+        <p:nvGrpSpPr>
+          <p:cNvPr id="32" name="Group 31">
+            <a:extLst>
+              <a:ext uri="{FF2B5EF4-FFF2-40B4-BE49-F238E27FC236}">
+                <a16:creationId xmlns:a16="http://schemas.microsoft.com/office/drawing/2014/main" id="{271E0BEF-A934-E57C-D6AA-D9A39E9BA2AC}"/>
+              </a:ext>
+            </a:extLst>
+          </p:cNvPr>
+          <p:cNvGrpSpPr/>
+          <p:nvPr/>
+        </p:nvGrpSpPr>
+        <p:grpSpPr>
+          <a:xfrm>
+            <a:off x="516802" y="6117354"/>
+            <a:ext cx="300732" cy="98617"/>
+            <a:chOff x="586253" y="6116391"/>
+            <a:chExt cx="300732" cy="98617"/>
+          </a:xfrm>
+        </p:grpSpPr>
+        <p:sp>
+          <p:nvSpPr>
+            <p:cNvPr id="34" name="TextBox 33">
+              <a:extLst>
+                <a:ext uri="{FF2B5EF4-FFF2-40B4-BE49-F238E27FC236}">
+                  <a16:creationId xmlns:a16="http://schemas.microsoft.com/office/drawing/2014/main" id="{1B4993B0-C574-1A0C-D2CC-601F9A816244}"/>
+                </a:ext>
+              </a:extLst>
+            </p:cNvPr>
+            <p:cNvSpPr txBox="1"/>
+            <p:nvPr/>
+          </p:nvSpPr>
+          <p:spPr>
+            <a:xfrm>
+              <a:off x="710655" y="6116391"/>
+              <a:ext cx="176330" cy="98617"/>
+            </a:xfrm>
+            <a:prstGeom prst="rect">
+              <a:avLst/>
+            </a:prstGeom>
+            <a:noFill/>
+          </p:spPr>
+          <p:txBody>
+            <a:bodyPr wrap="none" lIns="0" tIns="0" rIns="0" bIns="0" rtlCol="0" anchor="t">
+              <a:spAutoFit/>
+            </a:bodyPr>
+            <a:lstStyle/>
+            <a:p>
+              <a:pPr algn="l">
+                <a:lnSpc>
+                  <a:spcPct val="113000"/>
+                </a:lnSpc>
+              </a:pPr>
+              <a:r>
+                <a:rPr lang="en-US" sz="600" dirty="0">
+                  <a:solidFill>
+                    <a:schemeClr val="tx2"/>
+                  </a:solidFill>
+                </a:rPr>
+                <a:t>1 star</a:t>
+              </a:r>
+            </a:p>
+          </p:txBody>
+        </p:sp>
+        <p:sp>
+          <p:nvSpPr>
+            <p:cNvPr id="46" name="Rounded Rectangle 45">
+              <a:extLst>
+                <a:ext uri="{FF2B5EF4-FFF2-40B4-BE49-F238E27FC236}">
+                  <a16:creationId xmlns:a16="http://schemas.microsoft.com/office/drawing/2014/main" id="{2046A2AD-8B2F-9F91-38E9-693651680A21}"/>
+                </a:ext>
+              </a:extLst>
+            </p:cNvPr>
+            <p:cNvSpPr>
+              <a:spLocks noChangeAspect="1"/>
+            </p:cNvSpPr>
+            <p:nvPr/>
+          </p:nvSpPr>
+          <p:spPr>
+            <a:xfrm>
+              <a:off x="586253" y="6119980"/>
+              <a:ext cx="89812" cy="91440"/>
+            </a:xfrm>
+            <a:prstGeom prst="roundRect">
+              <a:avLst/>
+            </a:prstGeom>
+            <a:solidFill>
+              <a:srgbClr val="C04035"/>
+            </a:solidFill>
+            <a:ln>
+              <a:noFill/>
+            </a:ln>
+          </p:spPr>
+          <p:style>
+            <a:lnRef idx="2">
+              <a:schemeClr val="accent1">
+                <a:shade val="50000"/>
+              </a:schemeClr>
+            </a:lnRef>
+            <a:fillRef idx="1">
+              <a:schemeClr val="accent1"/>
+            </a:fillRef>
+            <a:effectRef idx="0">
+              <a:schemeClr val="accent1"/>
+            </a:effectRef>
+            <a:fontRef idx="minor">
+              <a:schemeClr val="lt1"/>
+            </a:fontRef>
+          </p:style>
+          <p:txBody>
+            <a:bodyPr lIns="108000" tIns="72000" rIns="108000" bIns="72000" rtlCol="0" anchor="ctr"/>
+            <a:lstStyle/>
+            <a:p>
+              <a:pPr algn="ctr"/>
+              <a:endParaRPr lang="en-US" sz="1600" dirty="0" err="1">
+                <a:solidFill>
+                  <a:schemeClr val="bg1"/>
+                </a:solidFill>
+              </a:endParaRPr>
+            </a:p>
+          </p:txBody>
+        </p:sp>
+      </p:grpSp>
+      <p:grpSp>
+        <p:nvGrpSpPr>
+          <p:cNvPr id="47" name="Group 46">
+            <a:extLst>
+              <a:ext uri="{FF2B5EF4-FFF2-40B4-BE49-F238E27FC236}">
+                <a16:creationId xmlns:a16="http://schemas.microsoft.com/office/drawing/2014/main" id="{F9B65C6B-8B79-6E62-4E92-AAA9B9C460B0}"/>
+              </a:ext>
+            </a:extLst>
+          </p:cNvPr>
+          <p:cNvGrpSpPr/>
+          <p:nvPr/>
+        </p:nvGrpSpPr>
+        <p:grpSpPr>
+          <a:xfrm>
+            <a:off x="934179" y="6117354"/>
+            <a:ext cx="331190" cy="98617"/>
+            <a:chOff x="961765" y="6117353"/>
+            <a:chExt cx="331190" cy="98617"/>
+          </a:xfrm>
+        </p:grpSpPr>
+        <p:sp>
+          <p:nvSpPr>
+            <p:cNvPr id="48" name="TextBox 47">
+              <a:extLst>
+                <a:ext uri="{FF2B5EF4-FFF2-40B4-BE49-F238E27FC236}">
+                  <a16:creationId xmlns:a16="http://schemas.microsoft.com/office/drawing/2014/main" id="{9484B3FD-FF0C-A3DF-1F66-2F211858D6AE}"/>
+                </a:ext>
+              </a:extLst>
+            </p:cNvPr>
+            <p:cNvSpPr txBox="1"/>
+            <p:nvPr/>
+          </p:nvSpPr>
+          <p:spPr>
+            <a:xfrm>
+              <a:off x="1086167" y="6117353"/>
+              <a:ext cx="206788" cy="98617"/>
+            </a:xfrm>
+            <a:prstGeom prst="rect">
+              <a:avLst/>
+            </a:prstGeom>
+            <a:noFill/>
+          </p:spPr>
+          <p:txBody>
+            <a:bodyPr wrap="none" lIns="0" tIns="0" rIns="0" bIns="0" rtlCol="0" anchor="t">
+              <a:spAutoFit/>
+            </a:bodyPr>
+            <a:lstStyle/>
+            <a:p>
+              <a:pPr algn="l">
+                <a:lnSpc>
+                  <a:spcPct val="113000"/>
+                </a:lnSpc>
+              </a:pPr>
+              <a:r>
+                <a:rPr lang="en-US" sz="600" dirty="0">
+                  <a:solidFill>
+                    <a:schemeClr val="tx2"/>
+                  </a:solidFill>
+                </a:rPr>
+                <a:t>2 stars</a:t>
+              </a:r>
+            </a:p>
+          </p:txBody>
+        </p:sp>
+        <p:sp>
+          <p:nvSpPr>
+            <p:cNvPr id="49" name="Rounded Rectangle 48">
+              <a:extLst>
+                <a:ext uri="{FF2B5EF4-FFF2-40B4-BE49-F238E27FC236}">
+                  <a16:creationId xmlns:a16="http://schemas.microsoft.com/office/drawing/2014/main" id="{EB27BC39-4A7E-FD5B-9709-BE7E9679DD1A}"/>
+                </a:ext>
+              </a:extLst>
+            </p:cNvPr>
+            <p:cNvSpPr>
+              <a:spLocks noChangeAspect="1"/>
+            </p:cNvSpPr>
+            <p:nvPr/>
+          </p:nvSpPr>
+          <p:spPr>
+            <a:xfrm>
+              <a:off x="961765" y="6120942"/>
+              <a:ext cx="89812" cy="91440"/>
+            </a:xfrm>
+            <a:prstGeom prst="roundRect">
+              <a:avLst/>
+            </a:prstGeom>
+            <a:solidFill>
+              <a:srgbClr val="EF9819"/>
+            </a:solidFill>
+            <a:ln>
+              <a:noFill/>
+            </a:ln>
+          </p:spPr>
+          <p:style>
+            <a:lnRef idx="2">
+              <a:schemeClr val="accent1">
+                <a:shade val="50000"/>
+              </a:schemeClr>
+            </a:lnRef>
+            <a:fillRef idx="1">
+              <a:schemeClr val="accent1"/>
+            </a:fillRef>
+            <a:effectRef idx="0">
+              <a:schemeClr val="accent1"/>
+            </a:effectRef>
+            <a:fontRef idx="minor">
+              <a:schemeClr val="lt1"/>
+            </a:fontRef>
+          </p:style>
+          <p:txBody>
+            <a:bodyPr lIns="108000" tIns="72000" rIns="108000" bIns="72000" rtlCol="0" anchor="ctr"/>
+            <a:lstStyle/>
+            <a:p>
+              <a:pPr algn="ctr"/>
+              <a:endParaRPr lang="en-US" sz="1600" dirty="0" err="1">
+                <a:solidFill>
+                  <a:schemeClr val="bg1"/>
+                </a:solidFill>
+              </a:endParaRPr>
+            </a:p>
+          </p:txBody>
+        </p:sp>
+      </p:grpSp>
+      <p:grpSp>
+        <p:nvGrpSpPr>
+          <p:cNvPr id="50" name="Group 49">
+            <a:extLst>
+              <a:ext uri="{FF2B5EF4-FFF2-40B4-BE49-F238E27FC236}">
+                <a16:creationId xmlns:a16="http://schemas.microsoft.com/office/drawing/2014/main" id="{B897F31D-CA5A-7192-8289-A08702399B1B}"/>
+              </a:ext>
+            </a:extLst>
+          </p:cNvPr>
+          <p:cNvGrpSpPr/>
+          <p:nvPr/>
+        </p:nvGrpSpPr>
+        <p:grpSpPr>
+          <a:xfrm>
+            <a:off x="1382015" y="6117354"/>
+            <a:ext cx="331190" cy="98617"/>
+            <a:chOff x="1114165" y="6269753"/>
+            <a:chExt cx="331190" cy="98617"/>
+          </a:xfrm>
+        </p:grpSpPr>
+        <p:sp>
+          <p:nvSpPr>
+            <p:cNvPr id="51" name="TextBox 50">
+              <a:extLst>
+                <a:ext uri="{FF2B5EF4-FFF2-40B4-BE49-F238E27FC236}">
+                  <a16:creationId xmlns:a16="http://schemas.microsoft.com/office/drawing/2014/main" id="{827BB7F0-3643-9FFC-0DC9-10F85BE4FE62}"/>
+                </a:ext>
+              </a:extLst>
+            </p:cNvPr>
+            <p:cNvSpPr txBox="1"/>
+            <p:nvPr/>
+          </p:nvSpPr>
+          <p:spPr>
+            <a:xfrm>
+              <a:off x="1238567" y="6269753"/>
+              <a:ext cx="206788" cy="98617"/>
+            </a:xfrm>
+            <a:prstGeom prst="rect">
+              <a:avLst/>
+            </a:prstGeom>
+            <a:noFill/>
+          </p:spPr>
+          <p:txBody>
+            <a:bodyPr wrap="none" lIns="0" tIns="0" rIns="0" bIns="0" rtlCol="0" anchor="t">
+              <a:spAutoFit/>
+            </a:bodyPr>
+            <a:lstStyle/>
+            <a:p>
+              <a:pPr algn="l">
+                <a:lnSpc>
+                  <a:spcPct val="113000"/>
+                </a:lnSpc>
+              </a:pPr>
+              <a:r>
+                <a:rPr lang="en-US" sz="600" dirty="0">
+                  <a:solidFill>
+                    <a:schemeClr val="tx2"/>
+                  </a:solidFill>
+                </a:rPr>
+                <a:t>3 stars</a:t>
+              </a:r>
+            </a:p>
+          </p:txBody>
+        </p:sp>
+        <p:sp>
+          <p:nvSpPr>
+            <p:cNvPr id="52" name="Rounded Rectangle 51">
+              <a:extLst>
+                <a:ext uri="{FF2B5EF4-FFF2-40B4-BE49-F238E27FC236}">
+                  <a16:creationId xmlns:a16="http://schemas.microsoft.com/office/drawing/2014/main" id="{AAE21101-175A-55DC-43FB-66EB38068ECD}"/>
+                </a:ext>
+              </a:extLst>
+            </p:cNvPr>
+            <p:cNvSpPr>
+              <a:spLocks noChangeAspect="1"/>
+            </p:cNvSpPr>
+            <p:nvPr/>
+          </p:nvSpPr>
+          <p:spPr>
+            <a:xfrm>
+              <a:off x="1114165" y="6273342"/>
+              <a:ext cx="89812" cy="91440"/>
+            </a:xfrm>
+            <a:prstGeom prst="roundRect">
+              <a:avLst/>
+            </a:prstGeom>
+            <a:solidFill>
+              <a:srgbClr val="F9C640"/>
+            </a:solidFill>
+            <a:ln>
+              <a:noFill/>
+            </a:ln>
+          </p:spPr>
+          <p:style>
+            <a:lnRef idx="2">
+              <a:schemeClr val="accent1">
+                <a:shade val="50000"/>
+              </a:schemeClr>
+            </a:lnRef>
+            <a:fillRef idx="1">
+              <a:schemeClr val="accent1"/>
+            </a:fillRef>
+            <a:effectRef idx="0">
+              <a:schemeClr val="accent1"/>
+            </a:effectRef>
+            <a:fontRef idx="minor">
+              <a:schemeClr val="lt1"/>
+            </a:fontRef>
+          </p:style>
+          <p:txBody>
+            <a:bodyPr lIns="108000" tIns="72000" rIns="108000" bIns="72000" rtlCol="0" anchor="ctr"/>
+            <a:lstStyle/>
+            <a:p>
+              <a:pPr algn="ctr"/>
+              <a:endParaRPr lang="en-US" sz="1600" dirty="0" err="1">
+                <a:solidFill>
+                  <a:schemeClr val="bg1"/>
+                </a:solidFill>
+              </a:endParaRPr>
+            </a:p>
+          </p:txBody>
+        </p:sp>
+      </p:grpSp>
+      <p:grpSp>
+        <p:nvGrpSpPr>
+          <p:cNvPr id="53" name="Group 52">
+            <a:extLst>
+              <a:ext uri="{FF2B5EF4-FFF2-40B4-BE49-F238E27FC236}">
+                <a16:creationId xmlns:a16="http://schemas.microsoft.com/office/drawing/2014/main" id="{B08ED80E-3C0A-1305-A82E-5A6A5F21483D}"/>
+              </a:ext>
+            </a:extLst>
+          </p:cNvPr>
+          <p:cNvGrpSpPr/>
+          <p:nvPr/>
+        </p:nvGrpSpPr>
+        <p:grpSpPr>
+          <a:xfrm>
+            <a:off x="1829851" y="6117354"/>
+            <a:ext cx="331190" cy="98617"/>
+            <a:chOff x="1114165" y="6269753"/>
+            <a:chExt cx="331190" cy="98617"/>
+          </a:xfrm>
+        </p:grpSpPr>
+        <p:sp>
+          <p:nvSpPr>
+            <p:cNvPr id="54" name="TextBox 53">
+              <a:extLst>
+                <a:ext uri="{FF2B5EF4-FFF2-40B4-BE49-F238E27FC236}">
+                  <a16:creationId xmlns:a16="http://schemas.microsoft.com/office/drawing/2014/main" id="{C724DD9C-4498-BDBF-D550-CD5BFAFB9441}"/>
+                </a:ext>
+              </a:extLst>
+            </p:cNvPr>
+            <p:cNvSpPr txBox="1"/>
+            <p:nvPr/>
+          </p:nvSpPr>
+          <p:spPr>
+            <a:xfrm>
+              <a:off x="1238567" y="6269753"/>
+              <a:ext cx="206788" cy="98617"/>
+            </a:xfrm>
+            <a:prstGeom prst="rect">
+              <a:avLst/>
+            </a:prstGeom>
+            <a:noFill/>
+          </p:spPr>
+          <p:txBody>
+            <a:bodyPr wrap="none" lIns="0" tIns="0" rIns="0" bIns="0" rtlCol="0" anchor="t">
+              <a:spAutoFit/>
+            </a:bodyPr>
+            <a:lstStyle/>
+            <a:p>
+              <a:pPr algn="l">
+                <a:lnSpc>
+                  <a:spcPct val="113000"/>
+                </a:lnSpc>
+              </a:pPr>
+              <a:r>
+                <a:rPr lang="en-US" sz="600" dirty="0">
+                  <a:solidFill>
+                    <a:schemeClr val="tx2"/>
+                  </a:solidFill>
+                </a:rPr>
+                <a:t>4 stars</a:t>
+              </a:r>
+            </a:p>
+          </p:txBody>
+        </p:sp>
+        <p:sp>
+          <p:nvSpPr>
+            <p:cNvPr id="55" name="Rounded Rectangle 54">
+              <a:extLst>
+                <a:ext uri="{FF2B5EF4-FFF2-40B4-BE49-F238E27FC236}">
+                  <a16:creationId xmlns:a16="http://schemas.microsoft.com/office/drawing/2014/main" id="{0C61241F-CCB1-DA71-4D2B-5453293279F6}"/>
+                </a:ext>
+              </a:extLst>
+            </p:cNvPr>
+            <p:cNvSpPr>
+              <a:spLocks noChangeAspect="1"/>
+            </p:cNvSpPr>
+            <p:nvPr/>
+          </p:nvSpPr>
+          <p:spPr>
+            <a:xfrm>
+              <a:off x="1114165" y="6273342"/>
+              <a:ext cx="89812" cy="91440"/>
+            </a:xfrm>
+            <a:prstGeom prst="roundRect">
+              <a:avLst/>
+            </a:prstGeom>
+            <a:solidFill>
+              <a:srgbClr val="57C968"/>
+            </a:solidFill>
+            <a:ln>
+              <a:noFill/>
+            </a:ln>
+          </p:spPr>
+          <p:style>
+            <a:lnRef idx="2">
+              <a:schemeClr val="accent1">
+                <a:shade val="50000"/>
+              </a:schemeClr>
+            </a:lnRef>
+            <a:fillRef idx="1">
+              <a:schemeClr val="accent1"/>
+            </a:fillRef>
+            <a:effectRef idx="0">
+              <a:schemeClr val="accent1"/>
+            </a:effectRef>
+            <a:fontRef idx="minor">
+              <a:schemeClr val="lt1"/>
+            </a:fontRef>
+          </p:style>
+          <p:txBody>
+            <a:bodyPr lIns="108000" tIns="72000" rIns="108000" bIns="72000" rtlCol="0" anchor="ctr"/>
+            <a:lstStyle/>
+            <a:p>
+              <a:pPr algn="ctr"/>
+              <a:endParaRPr lang="en-US" sz="1600" dirty="0" err="1">
+                <a:solidFill>
+                  <a:schemeClr val="bg1"/>
+                </a:solidFill>
+              </a:endParaRPr>
+            </a:p>
+          </p:txBody>
+        </p:sp>
+      </p:grpSp>
+      <p:grpSp>
+        <p:nvGrpSpPr>
+          <p:cNvPr id="56" name="Group 55">
+            <a:extLst>
+              <a:ext uri="{FF2B5EF4-FFF2-40B4-BE49-F238E27FC236}">
+                <a16:creationId xmlns:a16="http://schemas.microsoft.com/office/drawing/2014/main" id="{1E546F09-32A9-F3EC-B92C-062BC866C320}"/>
+              </a:ext>
+            </a:extLst>
+          </p:cNvPr>
+          <p:cNvGrpSpPr/>
+          <p:nvPr/>
+        </p:nvGrpSpPr>
+        <p:grpSpPr>
+          <a:xfrm>
+            <a:off x="2277686" y="6117354"/>
+            <a:ext cx="331190" cy="98617"/>
+            <a:chOff x="1114165" y="6269753"/>
+            <a:chExt cx="331190" cy="98617"/>
+          </a:xfrm>
+        </p:grpSpPr>
+        <p:sp>
+          <p:nvSpPr>
+            <p:cNvPr id="57" name="TextBox 56">
+              <a:extLst>
+                <a:ext uri="{FF2B5EF4-FFF2-40B4-BE49-F238E27FC236}">
+                  <a16:creationId xmlns:a16="http://schemas.microsoft.com/office/drawing/2014/main" id="{382ACFC0-E430-DE80-02D2-87BE9F92063B}"/>
+                </a:ext>
+              </a:extLst>
+            </p:cNvPr>
+            <p:cNvSpPr txBox="1"/>
+            <p:nvPr/>
+          </p:nvSpPr>
+          <p:spPr>
+            <a:xfrm>
+              <a:off x="1238567" y="6269753"/>
+              <a:ext cx="206788" cy="98617"/>
+            </a:xfrm>
+            <a:prstGeom prst="rect">
+              <a:avLst/>
+            </a:prstGeom>
+            <a:noFill/>
+          </p:spPr>
+          <p:txBody>
+            <a:bodyPr wrap="none" lIns="0" tIns="0" rIns="0" bIns="0" rtlCol="0" anchor="t">
+              <a:spAutoFit/>
+            </a:bodyPr>
+            <a:lstStyle/>
+            <a:p>
+              <a:pPr algn="l">
+                <a:lnSpc>
+                  <a:spcPct val="113000"/>
+                </a:lnSpc>
+              </a:pPr>
+              <a:r>
+                <a:rPr lang="en-US" sz="600" dirty="0">
+                  <a:solidFill>
+                    <a:schemeClr val="tx2"/>
+                  </a:solidFill>
+                </a:rPr>
+                <a:t>5 stars</a:t>
+              </a:r>
+            </a:p>
+          </p:txBody>
+        </p:sp>
+        <p:sp>
+          <p:nvSpPr>
+            <p:cNvPr id="58" name="Rounded Rectangle 57">
+              <a:extLst>
+                <a:ext uri="{FF2B5EF4-FFF2-40B4-BE49-F238E27FC236}">
+                  <a16:creationId xmlns:a16="http://schemas.microsoft.com/office/drawing/2014/main" id="{B04AB406-F121-B87F-E22D-C5E38B6AB539}"/>
+                </a:ext>
+              </a:extLst>
+            </p:cNvPr>
+            <p:cNvSpPr>
+              <a:spLocks noChangeAspect="1"/>
+            </p:cNvSpPr>
+            <p:nvPr/>
+          </p:nvSpPr>
+          <p:spPr>
+            <a:xfrm>
+              <a:off x="1114165" y="6273342"/>
+              <a:ext cx="89812" cy="91440"/>
+            </a:xfrm>
+            <a:prstGeom prst="roundRect">
+              <a:avLst/>
+            </a:prstGeom>
+            <a:solidFill>
+              <a:srgbClr val="2C963F"/>
+            </a:solidFill>
+            <a:ln>
+              <a:noFill/>
+            </a:ln>
+          </p:spPr>
+          <p:style>
+            <a:lnRef idx="2">
+              <a:schemeClr val="accent1">
+                <a:shade val="50000"/>
+              </a:schemeClr>
+            </a:lnRef>
+            <a:fillRef idx="1">
+              <a:schemeClr val="accent1"/>
+            </a:fillRef>
+            <a:effectRef idx="0">
+              <a:schemeClr val="accent1"/>
+            </a:effectRef>
+            <a:fontRef idx="minor">
+              <a:schemeClr val="lt1"/>
+            </a:fontRef>
+          </p:style>
+          <p:txBody>
+            <a:bodyPr lIns="108000" tIns="72000" rIns="108000" bIns="72000" rtlCol="0" anchor="ctr"/>
+            <a:lstStyle/>
+            <a:p>
+              <a:pPr algn="ctr"/>
+              <a:endParaRPr lang="en-US" sz="1600" dirty="0" err="1">
+                <a:solidFill>
+                  <a:schemeClr val="bg1"/>
+                </a:solidFill>
+              </a:endParaRPr>
+            </a:p>
+          </p:txBody>
+        </p:sp>
+      </p:grpSp>
+      <p:sp>
+        <p:nvSpPr>
+          <p:cNvPr id="2" name="Rectangle 1">
+            <a:extLst>
+              <a:ext uri="{FF2B5EF4-FFF2-40B4-BE49-F238E27FC236}">
+                <a16:creationId xmlns:a16="http://schemas.microsoft.com/office/drawing/2014/main" id="{3E9E5116-69E0-E51E-082B-B9554195A4E4}"/>
+              </a:ext>
+            </a:extLst>
+          </p:cNvPr>
+          <p:cNvSpPr/>
+          <p:nvPr/>
+        </p:nvSpPr>
+        <p:spPr>
+          <a:xfrm>
+            <a:off x="1250238" y="7283752"/>
+            <a:ext cx="353366" cy="333633"/>
+          </a:xfrm>
+          <a:prstGeom prst="rect">
+            <a:avLst/>
+          </a:prstGeom>
+          <a:solidFill>
+            <a:srgbClr val="DC4A3D"/>
+          </a:solidFill>
+          <a:ln>
+            <a:noFill/>
+          </a:ln>
+        </p:spPr>
+        <p:style>
+          <a:lnRef idx="2">
+            <a:schemeClr val="accent1">
+              <a:shade val="50000"/>
+            </a:schemeClr>
+          </a:lnRef>
+          <a:fillRef idx="1">
+            <a:schemeClr val="accent1"/>
+          </a:fillRef>
+          <a:effectRef idx="0">
+            <a:schemeClr val="accent1"/>
+          </a:effectRef>
+          <a:fontRef idx="minor">
+            <a:schemeClr val="lt1"/>
+          </a:fontRef>
+        </p:style>
+        <p:txBody>
+          <a:bodyPr lIns="108000" tIns="72000" rIns="108000" bIns="72000" rtlCol="0" anchor="ctr"/>
+          <a:lstStyle/>
+          <a:p>
+            <a:pPr algn="ctr"/>
+            <a:endParaRPr lang="en-US" sz="1600" dirty="0" err="1">
+              <a:solidFill>
+                <a:schemeClr val="bg1"/>
+              </a:solidFill>
+            </a:endParaRPr>
+          </a:p>
+        </p:txBody>
+      </p:sp>
+      <p:sp>
+        <p:nvSpPr>
+          <p:cNvPr id="4" name="Rectangle 3">
+            <a:extLst>
+              <a:ext uri="{FF2B5EF4-FFF2-40B4-BE49-F238E27FC236}">
+                <a16:creationId xmlns:a16="http://schemas.microsoft.com/office/drawing/2014/main" id="{1A4EDA70-A68C-FFDC-E765-FC7BCDCDD238}"/>
+              </a:ext>
+            </a:extLst>
+          </p:cNvPr>
+          <p:cNvSpPr/>
+          <p:nvPr/>
+        </p:nvSpPr>
+        <p:spPr>
+          <a:xfrm>
+            <a:off x="2184054" y="7283752"/>
+            <a:ext cx="353366" cy="333633"/>
+          </a:xfrm>
+          <a:prstGeom prst="rect">
+            <a:avLst/>
+          </a:prstGeom>
+          <a:solidFill>
+            <a:schemeClr val="tx2"/>
+          </a:solidFill>
+          <a:ln>
+            <a:noFill/>
+          </a:ln>
+        </p:spPr>
+        <p:style>
+          <a:lnRef idx="2">
+            <a:schemeClr val="accent1">
+              <a:shade val="50000"/>
+            </a:schemeClr>
+          </a:lnRef>
+          <a:fillRef idx="1">
+            <a:schemeClr val="accent1"/>
+          </a:fillRef>
+          <a:effectRef idx="0">
+            <a:schemeClr val="accent1"/>
+          </a:effectRef>
+          <a:fontRef idx="minor">
+            <a:schemeClr val="lt1"/>
+          </a:fontRef>
+        </p:style>
+        <p:txBody>
+          <a:bodyPr lIns="108000" tIns="72000" rIns="108000" bIns="72000" rtlCol="0" anchor="ctr"/>
+          <a:lstStyle/>
+          <a:p>
+            <a:pPr algn="ctr"/>
+            <a:endParaRPr lang="en-US" sz="1600" dirty="0" err="1">
+              <a:solidFill>
+                <a:schemeClr val="bg1"/>
+              </a:solidFill>
+            </a:endParaRPr>
+          </a:p>
+        </p:txBody>
+      </p:sp>
+      <p:sp>
+        <p:nvSpPr>
+          <p:cNvPr id="5" name="Rectangle 4">
+            <a:extLst>
+              <a:ext uri="{FF2B5EF4-FFF2-40B4-BE49-F238E27FC236}">
+                <a16:creationId xmlns:a16="http://schemas.microsoft.com/office/drawing/2014/main" id="{C9E1B95C-2C18-0461-C0FB-F6256E72F9BC}"/>
+              </a:ext>
+            </a:extLst>
+          </p:cNvPr>
+          <p:cNvSpPr/>
+          <p:nvPr/>
+        </p:nvSpPr>
+        <p:spPr>
+          <a:xfrm>
+            <a:off x="3117870" y="7283752"/>
+            <a:ext cx="353366" cy="333633"/>
+          </a:xfrm>
+          <a:prstGeom prst="rect">
+            <a:avLst/>
+          </a:prstGeom>
+          <a:solidFill>
+            <a:srgbClr val="E79088"/>
+          </a:solidFill>
+          <a:ln>
+            <a:noFill/>
+          </a:ln>
+        </p:spPr>
+        <p:style>
+          <a:lnRef idx="2">
+            <a:schemeClr val="accent1">
+              <a:shade val="50000"/>
+            </a:schemeClr>
+          </a:lnRef>
+          <a:fillRef idx="1">
+            <a:schemeClr val="accent1"/>
+          </a:fillRef>
+          <a:effectRef idx="0">
+            <a:schemeClr val="accent1"/>
+          </a:effectRef>
+          <a:fontRef idx="minor">
+            <a:schemeClr val="lt1"/>
+          </a:fontRef>
+        </p:style>
+        <p:txBody>
+          <a:bodyPr lIns="108000" tIns="72000" rIns="108000" bIns="72000" rtlCol="0" anchor="ctr"/>
+          <a:lstStyle/>
+          <a:p>
+            <a:pPr algn="ctr"/>
+            <a:endParaRPr lang="en-US" sz="1600" dirty="0" err="1">
+              <a:solidFill>
+                <a:schemeClr val="bg1"/>
+              </a:solidFill>
+            </a:endParaRPr>
+          </a:p>
+        </p:txBody>
+      </p:sp>
+      <p:sp>
+        <p:nvSpPr>
+          <p:cNvPr id="13" name="Rectangle 12">
+            <a:extLst>
+              <a:ext uri="{FF2B5EF4-FFF2-40B4-BE49-F238E27FC236}">
+                <a16:creationId xmlns:a16="http://schemas.microsoft.com/office/drawing/2014/main" id="{8E27BA21-359B-E70F-FE48-61E12EB5EE48}"/>
+              </a:ext>
+            </a:extLst>
+          </p:cNvPr>
+          <p:cNvSpPr/>
+          <p:nvPr/>
+        </p:nvSpPr>
+        <p:spPr>
+          <a:xfrm>
+            <a:off x="4051686" y="7283752"/>
+            <a:ext cx="353366" cy="333633"/>
+          </a:xfrm>
+          <a:prstGeom prst="rect">
+            <a:avLst/>
+          </a:prstGeom>
+          <a:solidFill>
+            <a:schemeClr val="tx2"/>
+          </a:solidFill>
+          <a:ln>
+            <a:noFill/>
+          </a:ln>
+        </p:spPr>
+        <p:style>
+          <a:lnRef idx="2">
+            <a:schemeClr val="accent1">
+              <a:shade val="50000"/>
+            </a:schemeClr>
+          </a:lnRef>
+          <a:fillRef idx="1">
+            <a:schemeClr val="accent1"/>
+          </a:fillRef>
+          <a:effectRef idx="0">
+            <a:schemeClr val="accent1"/>
+          </a:effectRef>
+          <a:fontRef idx="minor">
+            <a:schemeClr val="lt1"/>
+          </a:fontRef>
+        </p:style>
+        <p:txBody>
+          <a:bodyPr lIns="108000" tIns="72000" rIns="108000" bIns="72000" rtlCol="0" anchor="ctr"/>
+          <a:lstStyle/>
+          <a:p>
+            <a:pPr algn="ctr"/>
+            <a:endParaRPr lang="en-US" sz="1600" dirty="0" err="1">
+              <a:solidFill>
+                <a:schemeClr val="bg1"/>
+              </a:solidFill>
+            </a:endParaRPr>
+          </a:p>
+        </p:txBody>
+      </p:sp>
+      <p:sp>
+        <p:nvSpPr>
+          <p:cNvPr id="14" name="Rectangle 13">
+            <a:extLst>
+              <a:ext uri="{FF2B5EF4-FFF2-40B4-BE49-F238E27FC236}">
+                <a16:creationId xmlns:a16="http://schemas.microsoft.com/office/drawing/2014/main" id="{AE0B16F0-DDF6-9CF3-B104-F6485E507845}"/>
+              </a:ext>
+            </a:extLst>
+          </p:cNvPr>
+          <p:cNvSpPr/>
+          <p:nvPr/>
+        </p:nvSpPr>
+        <p:spPr>
+          <a:xfrm>
+            <a:off x="4985502" y="7283752"/>
+            <a:ext cx="353366" cy="333633"/>
+          </a:xfrm>
+          <a:prstGeom prst="rect">
+            <a:avLst/>
+          </a:prstGeom>
+          <a:solidFill>
+            <a:schemeClr val="tx2"/>
+          </a:solidFill>
+          <a:ln>
+            <a:noFill/>
+          </a:ln>
+        </p:spPr>
+        <p:style>
+          <a:lnRef idx="2">
+            <a:schemeClr val="accent1">
+              <a:shade val="50000"/>
+            </a:schemeClr>
+          </a:lnRef>
+          <a:fillRef idx="1">
+            <a:schemeClr val="accent1"/>
+          </a:fillRef>
+          <a:effectRef idx="0">
+            <a:schemeClr val="accent1"/>
+          </a:effectRef>
+          <a:fontRef idx="minor">
+            <a:schemeClr val="lt1"/>
+          </a:fontRef>
+        </p:style>
+        <p:txBody>
+          <a:bodyPr lIns="108000" tIns="72000" rIns="108000" bIns="72000" rtlCol="0" anchor="ctr"/>
+          <a:lstStyle/>
+          <a:p>
+            <a:pPr algn="ctr"/>
+            <a:endParaRPr lang="en-US" sz="1600" dirty="0" err="1">
+              <a:solidFill>
+                <a:schemeClr val="bg1"/>
+              </a:solidFill>
+            </a:endParaRPr>
+          </a:p>
+        </p:txBody>
+      </p:sp>
+      <p:sp>
+        <p:nvSpPr>
+          <p:cNvPr id="15" name="Rectangle 14">
+            <a:extLst>
+              <a:ext uri="{FF2B5EF4-FFF2-40B4-BE49-F238E27FC236}">
+                <a16:creationId xmlns:a16="http://schemas.microsoft.com/office/drawing/2014/main" id="{47A92AEB-B1D9-C562-7E2B-868C9357F799}"/>
+              </a:ext>
+            </a:extLst>
+          </p:cNvPr>
+          <p:cNvSpPr/>
+          <p:nvPr/>
+        </p:nvSpPr>
+        <p:spPr>
+          <a:xfrm>
+            <a:off x="5919318" y="7283752"/>
+            <a:ext cx="353366" cy="333633"/>
+          </a:xfrm>
+          <a:prstGeom prst="rect">
+            <a:avLst/>
+          </a:prstGeom>
+          <a:solidFill>
+            <a:srgbClr val="F7F9F8"/>
+          </a:solidFill>
+          <a:ln>
+            <a:noFill/>
+          </a:ln>
+        </p:spPr>
+        <p:style>
+          <a:lnRef idx="2">
+            <a:schemeClr val="accent1">
+              <a:shade val="50000"/>
+            </a:schemeClr>
+          </a:lnRef>
+          <a:fillRef idx="1">
+            <a:schemeClr val="accent1"/>
+          </a:fillRef>
+          <a:effectRef idx="0">
+            <a:schemeClr val="accent1"/>
+          </a:effectRef>
+          <a:fontRef idx="minor">
+            <a:schemeClr val="lt1"/>
+          </a:fontRef>
+        </p:style>
+        <p:txBody>
+          <a:bodyPr lIns="108000" tIns="72000" rIns="108000" bIns="72000" rtlCol="0" anchor="ctr"/>
+          <a:lstStyle/>
+          <a:p>
+            <a:pPr algn="ctr"/>
+            <a:endParaRPr lang="en-US" sz="1600" dirty="0" err="1">
+              <a:solidFill>
+                <a:schemeClr val="bg1"/>
+              </a:solidFill>
+            </a:endParaRPr>
+          </a:p>
+        </p:txBody>
+      </p:sp>
+      <p:sp>
+        <p:nvSpPr>
+          <p:cNvPr id="18" name="Rectangle 17">
+            <a:extLst>
+              <a:ext uri="{FF2B5EF4-FFF2-40B4-BE49-F238E27FC236}">
+                <a16:creationId xmlns:a16="http://schemas.microsoft.com/office/drawing/2014/main" id="{D2E4372C-BEAF-561A-5355-3F3AB75E9B1C}"/>
+              </a:ext>
+            </a:extLst>
+          </p:cNvPr>
+          <p:cNvSpPr/>
+          <p:nvPr/>
+        </p:nvSpPr>
+        <p:spPr>
+          <a:xfrm>
+            <a:off x="6853134" y="7283752"/>
+            <a:ext cx="353366" cy="333633"/>
+          </a:xfrm>
+          <a:prstGeom prst="rect">
+            <a:avLst/>
+          </a:prstGeom>
+          <a:solidFill>
+            <a:schemeClr val="tx2"/>
+          </a:solidFill>
+          <a:ln>
+            <a:noFill/>
+          </a:ln>
+        </p:spPr>
+        <p:style>
+          <a:lnRef idx="2">
+            <a:schemeClr val="accent1">
+              <a:shade val="50000"/>
+            </a:schemeClr>
+          </a:lnRef>
+          <a:fillRef idx="1">
+            <a:schemeClr val="accent1"/>
+          </a:fillRef>
+          <a:effectRef idx="0">
+            <a:schemeClr val="accent1"/>
+          </a:effectRef>
+          <a:fontRef idx="minor">
+            <a:schemeClr val="lt1"/>
+          </a:fontRef>
+        </p:style>
+        <p:txBody>
+          <a:bodyPr lIns="108000" tIns="72000" rIns="108000" bIns="72000" rtlCol="0" anchor="ctr"/>
+          <a:lstStyle/>
+          <a:p>
+            <a:pPr algn="ctr"/>
+            <a:endParaRPr lang="en-US" sz="1600" dirty="0" err="1">
+              <a:solidFill>
+                <a:schemeClr val="bg1"/>
+              </a:solidFill>
+            </a:endParaRPr>
+          </a:p>
+        </p:txBody>
+      </p:sp>
+      <p:sp>
+        <p:nvSpPr>
+          <p:cNvPr id="19" name="Rectangle 18">
+            <a:extLst>
+              <a:ext uri="{FF2B5EF4-FFF2-40B4-BE49-F238E27FC236}">
+                <a16:creationId xmlns:a16="http://schemas.microsoft.com/office/drawing/2014/main" id="{C11F6519-88B1-FB73-3CE5-95965CDCC252}"/>
+              </a:ext>
+            </a:extLst>
+          </p:cNvPr>
+          <p:cNvSpPr/>
+          <p:nvPr/>
+        </p:nvSpPr>
+        <p:spPr>
+          <a:xfrm>
+            <a:off x="7786950" y="7283752"/>
+            <a:ext cx="353366" cy="333633"/>
+          </a:xfrm>
+          <a:prstGeom prst="rect">
+            <a:avLst/>
+          </a:prstGeom>
+          <a:solidFill>
+            <a:schemeClr val="tx2"/>
+          </a:solidFill>
+          <a:ln>
+            <a:noFill/>
+          </a:ln>
+        </p:spPr>
+        <p:style>
+          <a:lnRef idx="2">
+            <a:schemeClr val="accent1">
+              <a:shade val="50000"/>
+            </a:schemeClr>
+          </a:lnRef>
+          <a:fillRef idx="1">
+            <a:schemeClr val="accent1"/>
+          </a:fillRef>
+          <a:effectRef idx="0">
+            <a:schemeClr val="accent1"/>
+          </a:effectRef>
+          <a:fontRef idx="minor">
+            <a:schemeClr val="lt1"/>
+          </a:fontRef>
+        </p:style>
+        <p:txBody>
+          <a:bodyPr lIns="108000" tIns="72000" rIns="108000" bIns="72000" rtlCol="0" anchor="ctr"/>
+          <a:lstStyle/>
+          <a:p>
+            <a:pPr algn="ctr"/>
+            <a:endParaRPr lang="en-US" sz="1600" dirty="0" err="1">
+              <a:solidFill>
+                <a:schemeClr val="bg1"/>
+              </a:solidFill>
+            </a:endParaRPr>
+          </a:p>
+        </p:txBody>
+      </p:sp>
+      <p:sp>
+        <p:nvSpPr>
+          <p:cNvPr id="20" name="Rectangle 19">
+            <a:extLst>
+              <a:ext uri="{FF2B5EF4-FFF2-40B4-BE49-F238E27FC236}">
+                <a16:creationId xmlns:a16="http://schemas.microsoft.com/office/drawing/2014/main" id="{936211FC-EC5F-9920-1172-0756514BD9EB}"/>
+              </a:ext>
+            </a:extLst>
+          </p:cNvPr>
+          <p:cNvSpPr/>
+          <p:nvPr/>
+        </p:nvSpPr>
+        <p:spPr>
+          <a:xfrm>
+            <a:off x="8720766" y="7283752"/>
+            <a:ext cx="353366" cy="333633"/>
+          </a:xfrm>
+          <a:prstGeom prst="rect">
+            <a:avLst/>
+          </a:prstGeom>
+          <a:solidFill>
+            <a:srgbClr val="97DCA2"/>
+          </a:solidFill>
+          <a:ln>
+            <a:noFill/>
+          </a:ln>
+        </p:spPr>
+        <p:style>
+          <a:lnRef idx="2">
+            <a:schemeClr val="accent1">
+              <a:shade val="50000"/>
+            </a:schemeClr>
+          </a:lnRef>
+          <a:fillRef idx="1">
+            <a:schemeClr val="accent1"/>
+          </a:fillRef>
+          <a:effectRef idx="0">
+            <a:schemeClr val="accent1"/>
+          </a:effectRef>
+          <a:fontRef idx="minor">
+            <a:schemeClr val="lt1"/>
+          </a:fontRef>
+        </p:style>
+        <p:txBody>
+          <a:bodyPr lIns="108000" tIns="72000" rIns="108000" bIns="72000" rtlCol="0" anchor="ctr"/>
+          <a:lstStyle/>
+          <a:p>
+            <a:pPr algn="ctr"/>
+            <a:endParaRPr lang="en-US" sz="1600" dirty="0" err="1">
+              <a:solidFill>
+                <a:schemeClr val="bg1"/>
+              </a:solidFill>
+            </a:endParaRPr>
+          </a:p>
+        </p:txBody>
+      </p:sp>
+      <p:sp>
+        <p:nvSpPr>
+          <p:cNvPr id="21" name="Rectangle 20">
+            <a:extLst>
+              <a:ext uri="{FF2B5EF4-FFF2-40B4-BE49-F238E27FC236}">
+                <a16:creationId xmlns:a16="http://schemas.microsoft.com/office/drawing/2014/main" id="{A4B9E5EA-5C74-4035-BEEC-01DA2347190F}"/>
+              </a:ext>
+            </a:extLst>
+          </p:cNvPr>
+          <p:cNvSpPr/>
+          <p:nvPr/>
+        </p:nvSpPr>
+        <p:spPr>
+          <a:xfrm>
+            <a:off x="9654582" y="7283752"/>
+            <a:ext cx="353366" cy="333633"/>
+          </a:xfrm>
+          <a:prstGeom prst="rect">
+            <a:avLst/>
+          </a:prstGeom>
+          <a:solidFill>
+            <a:schemeClr val="tx2"/>
+          </a:solidFill>
+          <a:ln>
+            <a:noFill/>
+          </a:ln>
+        </p:spPr>
+        <p:style>
+          <a:lnRef idx="2">
+            <a:schemeClr val="accent1">
+              <a:shade val="50000"/>
+            </a:schemeClr>
+          </a:lnRef>
+          <a:fillRef idx="1">
+            <a:schemeClr val="accent1"/>
+          </a:fillRef>
+          <a:effectRef idx="0">
+            <a:schemeClr val="accent1"/>
+          </a:effectRef>
+          <a:fontRef idx="minor">
+            <a:schemeClr val="lt1"/>
+          </a:fontRef>
+        </p:style>
+        <p:txBody>
+          <a:bodyPr lIns="108000" tIns="72000" rIns="108000" bIns="72000" rtlCol="0" anchor="ctr"/>
+          <a:lstStyle/>
+          <a:p>
+            <a:pPr algn="ctr"/>
+            <a:endParaRPr lang="en-US" sz="1600" dirty="0" err="1">
+              <a:solidFill>
+                <a:schemeClr val="bg1"/>
+              </a:solidFill>
+            </a:endParaRPr>
+          </a:p>
+        </p:txBody>
+      </p:sp>
+      <p:sp>
+        <p:nvSpPr>
+          <p:cNvPr id="22" name="Rectangle 21">
+            <a:extLst>
+              <a:ext uri="{FF2B5EF4-FFF2-40B4-BE49-F238E27FC236}">
+                <a16:creationId xmlns:a16="http://schemas.microsoft.com/office/drawing/2014/main" id="{0117ACFD-4BD7-3D9D-182F-57F1D2EF2F0C}"/>
+              </a:ext>
+            </a:extLst>
+          </p:cNvPr>
+          <p:cNvSpPr/>
+          <p:nvPr/>
+        </p:nvSpPr>
+        <p:spPr>
+          <a:xfrm>
+            <a:off x="10588396" y="7283752"/>
+            <a:ext cx="353366" cy="333633"/>
+          </a:xfrm>
+          <a:prstGeom prst="rect">
+            <a:avLst/>
+          </a:prstGeom>
+          <a:solidFill>
+            <a:srgbClr val="57C969"/>
+          </a:solidFill>
+          <a:ln>
+            <a:noFill/>
+          </a:ln>
+        </p:spPr>
+        <p:style>
+          <a:lnRef idx="2">
+            <a:schemeClr val="accent1">
+              <a:shade val="50000"/>
+            </a:schemeClr>
+          </a:lnRef>
+          <a:fillRef idx="1">
+            <a:schemeClr val="accent1"/>
+          </a:fillRef>
+          <a:effectRef idx="0">
+            <a:schemeClr val="accent1"/>
+          </a:effectRef>
+          <a:fontRef idx="minor">
+            <a:schemeClr val="lt1"/>
+          </a:fontRef>
+        </p:style>
+        <p:txBody>
+          <a:bodyPr lIns="108000" tIns="72000" rIns="108000" bIns="72000" rtlCol="0" anchor="ctr"/>
+          <a:lstStyle/>
+          <a:p>
+            <a:pPr algn="ctr"/>
+            <a:endParaRPr lang="en-US" sz="1600" dirty="0" err="1">
+              <a:solidFill>
+                <a:schemeClr val="bg1"/>
+              </a:solidFill>
+            </a:endParaRPr>
+          </a:p>
+        </p:txBody>
+      </p:sp>
+      <p:sp>
+        <p:nvSpPr>
+          <p:cNvPr id="23" name="TextBox 22">
+            <a:extLst>
+              <a:ext uri="{FF2B5EF4-FFF2-40B4-BE49-F238E27FC236}">
+                <a16:creationId xmlns:a16="http://schemas.microsoft.com/office/drawing/2014/main" id="{43DC7E09-5E67-7748-DDEF-A7F159DAEFB3}"/>
+              </a:ext>
+            </a:extLst>
+          </p:cNvPr>
+          <p:cNvSpPr txBox="1"/>
+          <p:nvPr/>
+        </p:nvSpPr>
+        <p:spPr>
+          <a:xfrm>
+            <a:off x="1016317" y="7795967"/>
+            <a:ext cx="821207" cy="355162"/>
+          </a:xfrm>
+          <a:prstGeom prst="rect">
+            <a:avLst/>
+          </a:prstGeom>
+          <a:noFill/>
+        </p:spPr>
+        <p:txBody>
+          <a:bodyPr wrap="none" lIns="90000" rtlCol="0" anchor="t">
+            <a:spAutoFit/>
+          </a:bodyPr>
+          <a:lstStyle/>
+          <a:p>
+            <a:pPr algn="ctr">
+              <a:lnSpc>
+                <a:spcPct val="113000"/>
+              </a:lnSpc>
+            </a:pPr>
+            <a:r>
+              <a:rPr lang="en-US" sz="1600" dirty="0">
+                <a:solidFill>
+                  <a:schemeClr val="tx2"/>
+                </a:solidFill>
+              </a:rPr>
+              <a:t>CB5545</a:t>
+            </a:r>
+          </a:p>
+        </p:txBody>
+      </p:sp>
+      <p:sp>
+        <p:nvSpPr>
+          <p:cNvPr id="24" name="TextBox 23">
+            <a:extLst>
+              <a:ext uri="{FF2B5EF4-FFF2-40B4-BE49-F238E27FC236}">
+                <a16:creationId xmlns:a16="http://schemas.microsoft.com/office/drawing/2014/main" id="{392F5665-6AEB-88BE-2B39-86AAC71DA14A}"/>
+              </a:ext>
+            </a:extLst>
+          </p:cNvPr>
+          <p:cNvSpPr txBox="1"/>
+          <p:nvPr/>
+        </p:nvSpPr>
+        <p:spPr>
+          <a:xfrm>
+            <a:off x="2191705" y="7795967"/>
+            <a:ext cx="548697" cy="355162"/>
+          </a:xfrm>
+          <a:prstGeom prst="rect">
+            <a:avLst/>
+          </a:prstGeom>
+          <a:noFill/>
+        </p:spPr>
+        <p:txBody>
+          <a:bodyPr wrap="none" lIns="90000" rtlCol="0" anchor="t">
+            <a:spAutoFit/>
+          </a:bodyPr>
+          <a:lstStyle/>
+          <a:p>
+            <a:pPr algn="ctr">
+              <a:lnSpc>
+                <a:spcPct val="113000"/>
+              </a:lnSpc>
+            </a:pPr>
+            <a:r>
+              <a:rPr lang="en-US" sz="1600" dirty="0">
+                <a:solidFill>
+                  <a:schemeClr val="tx2"/>
+                </a:solidFill>
+              </a:rPr>
+              <a:t>@@</a:t>
+            </a:r>
+          </a:p>
+        </p:txBody>
+      </p:sp>
+      <p:sp>
+        <p:nvSpPr>
+          <p:cNvPr id="25" name="TextBox 24">
+            <a:extLst>
+              <a:ext uri="{FF2B5EF4-FFF2-40B4-BE49-F238E27FC236}">
+                <a16:creationId xmlns:a16="http://schemas.microsoft.com/office/drawing/2014/main" id="{739FE757-FDA2-AC9B-9BDA-14184BF2D044}"/>
+              </a:ext>
+            </a:extLst>
+          </p:cNvPr>
+          <p:cNvSpPr txBox="1"/>
+          <p:nvPr/>
+        </p:nvSpPr>
+        <p:spPr>
+          <a:xfrm>
+            <a:off x="10358483" y="7795967"/>
+            <a:ext cx="813193" cy="355162"/>
+          </a:xfrm>
+          <a:prstGeom prst="rect">
+            <a:avLst/>
+          </a:prstGeom>
+          <a:noFill/>
+        </p:spPr>
+        <p:txBody>
+          <a:bodyPr wrap="none" lIns="90000" rtlCol="0" anchor="t">
+            <a:spAutoFit/>
+          </a:bodyPr>
+          <a:lstStyle/>
+          <a:p>
+            <a:pPr algn="ctr">
+              <a:lnSpc>
+                <a:spcPct val="113000"/>
+              </a:lnSpc>
+            </a:pPr>
+            <a:r>
+              <a:rPr lang="en-US" sz="1600" dirty="0">
+                <a:solidFill>
+                  <a:schemeClr val="tx2"/>
+                </a:solidFill>
+              </a:rPr>
+              <a:t>57C969</a:t>
+            </a:r>
+          </a:p>
+        </p:txBody>
+      </p:sp>
+      <p:sp>
+        <p:nvSpPr>
+          <p:cNvPr id="26" name="TextBox 25">
+            <a:extLst>
+              <a:ext uri="{FF2B5EF4-FFF2-40B4-BE49-F238E27FC236}">
+                <a16:creationId xmlns:a16="http://schemas.microsoft.com/office/drawing/2014/main" id="{EDEEA041-B74B-F8F2-FF45-92D3B209B179}"/>
+              </a:ext>
+            </a:extLst>
+          </p:cNvPr>
+          <p:cNvSpPr txBox="1"/>
+          <p:nvPr/>
+        </p:nvSpPr>
+        <p:spPr>
+          <a:xfrm>
+            <a:off x="3997461" y="7795967"/>
+            <a:ext cx="548697" cy="355162"/>
+          </a:xfrm>
+          <a:prstGeom prst="rect">
+            <a:avLst/>
+          </a:prstGeom>
+          <a:noFill/>
+        </p:spPr>
+        <p:txBody>
+          <a:bodyPr wrap="none" lIns="90000" rtlCol="0" anchor="t">
+            <a:spAutoFit/>
+          </a:bodyPr>
+          <a:lstStyle/>
+          <a:p>
+            <a:pPr algn="ctr">
+              <a:lnSpc>
+                <a:spcPct val="113000"/>
+              </a:lnSpc>
+            </a:pPr>
+            <a:r>
+              <a:rPr lang="en-US" sz="1600" dirty="0">
+                <a:solidFill>
+                  <a:schemeClr val="tx2"/>
+                </a:solidFill>
+              </a:rPr>
+              <a:t>@@</a:t>
+            </a:r>
+          </a:p>
+        </p:txBody>
+      </p:sp>
+      <p:sp>
+        <p:nvSpPr>
+          <p:cNvPr id="27" name="TextBox 26">
+            <a:extLst>
+              <a:ext uri="{FF2B5EF4-FFF2-40B4-BE49-F238E27FC236}">
+                <a16:creationId xmlns:a16="http://schemas.microsoft.com/office/drawing/2014/main" id="{6F1C52C6-6B46-D72B-A870-A45F24A09431}"/>
+              </a:ext>
+            </a:extLst>
+          </p:cNvPr>
+          <p:cNvSpPr txBox="1"/>
+          <p:nvPr/>
+        </p:nvSpPr>
+        <p:spPr>
+          <a:xfrm>
+            <a:off x="2943805" y="7795967"/>
+            <a:ext cx="850254" cy="355162"/>
+          </a:xfrm>
+          <a:prstGeom prst="rect">
+            <a:avLst/>
+          </a:prstGeom>
+          <a:noFill/>
+        </p:spPr>
+        <p:txBody>
+          <a:bodyPr wrap="none" lIns="90000" rtlCol="0" anchor="t">
+            <a:spAutoFit/>
+          </a:bodyPr>
+          <a:lstStyle/>
+          <a:p>
+            <a:pPr algn="ctr">
+              <a:lnSpc>
+                <a:spcPct val="113000"/>
+              </a:lnSpc>
+            </a:pPr>
+            <a:r>
+              <a:rPr lang="en-US" sz="1600" dirty="0">
+                <a:solidFill>
+                  <a:schemeClr val="tx2"/>
+                </a:solidFill>
+              </a:rPr>
+              <a:t>DA948B</a:t>
+            </a:r>
+          </a:p>
+        </p:txBody>
+      </p:sp>
+      <p:sp>
+        <p:nvSpPr>
+          <p:cNvPr id="29" name="TextBox 28">
+            <a:extLst>
+              <a:ext uri="{FF2B5EF4-FFF2-40B4-BE49-F238E27FC236}">
+                <a16:creationId xmlns:a16="http://schemas.microsoft.com/office/drawing/2014/main" id="{AF6B9CFE-C200-5C19-2D52-F6BB4843D621}"/>
+              </a:ext>
+            </a:extLst>
+          </p:cNvPr>
+          <p:cNvSpPr txBox="1"/>
+          <p:nvPr/>
+        </p:nvSpPr>
+        <p:spPr>
+          <a:xfrm>
+            <a:off x="4900339" y="7795967"/>
+            <a:ext cx="548697" cy="355162"/>
+          </a:xfrm>
+          <a:prstGeom prst="rect">
+            <a:avLst/>
+          </a:prstGeom>
+          <a:noFill/>
+        </p:spPr>
+        <p:txBody>
+          <a:bodyPr wrap="none" lIns="90000" rtlCol="0" anchor="t">
+            <a:spAutoFit/>
+          </a:bodyPr>
+          <a:lstStyle/>
+          <a:p>
+            <a:pPr algn="ctr">
+              <a:lnSpc>
+                <a:spcPct val="113000"/>
+              </a:lnSpc>
+            </a:pPr>
+            <a:r>
+              <a:rPr lang="en-US" sz="1600" dirty="0">
+                <a:solidFill>
+                  <a:schemeClr val="tx2"/>
+                </a:solidFill>
+              </a:rPr>
+              <a:t>@@</a:t>
+            </a:r>
+          </a:p>
+        </p:txBody>
+      </p:sp>
+      <p:sp>
+        <p:nvSpPr>
+          <p:cNvPr id="30" name="TextBox 29">
+            <a:extLst>
+              <a:ext uri="{FF2B5EF4-FFF2-40B4-BE49-F238E27FC236}">
+                <a16:creationId xmlns:a16="http://schemas.microsoft.com/office/drawing/2014/main" id="{D2447BD0-2A55-1CE8-3031-BB5817119F5F}"/>
+              </a:ext>
+            </a:extLst>
+          </p:cNvPr>
+          <p:cNvSpPr txBox="1"/>
+          <p:nvPr/>
+        </p:nvSpPr>
+        <p:spPr>
+          <a:xfrm>
+            <a:off x="6706095" y="7795967"/>
+            <a:ext cx="548697" cy="355162"/>
+          </a:xfrm>
+          <a:prstGeom prst="rect">
+            <a:avLst/>
+          </a:prstGeom>
+          <a:noFill/>
+        </p:spPr>
+        <p:txBody>
+          <a:bodyPr wrap="none" lIns="90000" rtlCol="0" anchor="t">
+            <a:spAutoFit/>
+          </a:bodyPr>
+          <a:lstStyle/>
+          <a:p>
+            <a:pPr algn="ctr">
+              <a:lnSpc>
+                <a:spcPct val="113000"/>
+              </a:lnSpc>
+            </a:pPr>
+            <a:r>
+              <a:rPr lang="en-US" sz="1600" dirty="0">
+                <a:solidFill>
+                  <a:schemeClr val="tx2"/>
+                </a:solidFill>
+              </a:rPr>
+              <a:t>@@</a:t>
+            </a:r>
+          </a:p>
+        </p:txBody>
+      </p:sp>
+      <p:sp>
+        <p:nvSpPr>
+          <p:cNvPr id="31" name="TextBox 30">
+            <a:extLst>
+              <a:ext uri="{FF2B5EF4-FFF2-40B4-BE49-F238E27FC236}">
+                <a16:creationId xmlns:a16="http://schemas.microsoft.com/office/drawing/2014/main" id="{FA7D6663-5C77-8AD2-80EB-DD8618147848}"/>
+              </a:ext>
+            </a:extLst>
+          </p:cNvPr>
+          <p:cNvSpPr txBox="1"/>
+          <p:nvPr/>
+        </p:nvSpPr>
+        <p:spPr>
+          <a:xfrm>
+            <a:off x="5687801" y="7795967"/>
+            <a:ext cx="779529" cy="355162"/>
+          </a:xfrm>
+          <a:prstGeom prst="rect">
+            <a:avLst/>
+          </a:prstGeom>
+          <a:noFill/>
+        </p:spPr>
+        <p:txBody>
+          <a:bodyPr wrap="none" lIns="90000" rtlCol="0" anchor="t">
+            <a:spAutoFit/>
+          </a:bodyPr>
+          <a:lstStyle/>
+          <a:p>
+            <a:pPr algn="ctr">
+              <a:lnSpc>
+                <a:spcPct val="113000"/>
+              </a:lnSpc>
+            </a:pPr>
+            <a:r>
+              <a:rPr lang="en-US" sz="1600" dirty="0">
+                <a:solidFill>
+                  <a:schemeClr val="tx2"/>
+                </a:solidFill>
+              </a:rPr>
+              <a:t>F8F8F8</a:t>
+            </a:r>
+          </a:p>
+        </p:txBody>
+      </p:sp>
+      <p:sp>
+        <p:nvSpPr>
+          <p:cNvPr id="59" name="TextBox 58">
+            <a:extLst>
+              <a:ext uri="{FF2B5EF4-FFF2-40B4-BE49-F238E27FC236}">
+                <a16:creationId xmlns:a16="http://schemas.microsoft.com/office/drawing/2014/main" id="{2418E9BC-414C-B123-49CB-D287FD364617}"/>
+              </a:ext>
+            </a:extLst>
+          </p:cNvPr>
+          <p:cNvSpPr txBox="1"/>
+          <p:nvPr/>
+        </p:nvSpPr>
+        <p:spPr>
+          <a:xfrm>
+            <a:off x="8350654" y="7795967"/>
+            <a:ext cx="871092" cy="355162"/>
+          </a:xfrm>
+          <a:prstGeom prst="rect">
+            <a:avLst/>
+          </a:prstGeom>
+          <a:noFill/>
+        </p:spPr>
+        <p:txBody>
+          <a:bodyPr wrap="none" lIns="90000" rtlCol="0" anchor="t">
+            <a:spAutoFit/>
+          </a:bodyPr>
+          <a:lstStyle/>
+          <a:p>
+            <a:pPr algn="ctr">
+              <a:lnSpc>
+                <a:spcPct val="113000"/>
+              </a:lnSpc>
+            </a:pPr>
+            <a:r>
+              <a:rPr lang="en-US" sz="1600" dirty="0">
+                <a:solidFill>
+                  <a:schemeClr val="tx2"/>
+                </a:solidFill>
+              </a:rPr>
+              <a:t>A6DAA7</a:t>
+            </a:r>
+          </a:p>
+        </p:txBody>
+      </p:sp>
+      <p:sp>
+        <p:nvSpPr>
+          <p:cNvPr id="70" name="TextBox 69">
+            <a:extLst>
+              <a:ext uri="{FF2B5EF4-FFF2-40B4-BE49-F238E27FC236}">
+                <a16:creationId xmlns:a16="http://schemas.microsoft.com/office/drawing/2014/main" id="{1B09F2E4-0AA8-54C3-F328-3A363A4D114F}"/>
+              </a:ext>
+            </a:extLst>
+          </p:cNvPr>
+          <p:cNvSpPr txBox="1"/>
+          <p:nvPr/>
+        </p:nvSpPr>
+        <p:spPr>
+          <a:xfrm>
+            <a:off x="7608973" y="7795967"/>
+            <a:ext cx="548697" cy="355162"/>
+          </a:xfrm>
+          <a:prstGeom prst="rect">
+            <a:avLst/>
+          </a:prstGeom>
+          <a:noFill/>
+        </p:spPr>
+        <p:txBody>
+          <a:bodyPr wrap="none" lIns="90000" rtlCol="0" anchor="t">
+            <a:spAutoFit/>
+          </a:bodyPr>
+          <a:lstStyle/>
+          <a:p>
+            <a:pPr algn="ctr">
+              <a:lnSpc>
+                <a:spcPct val="113000"/>
+              </a:lnSpc>
+            </a:pPr>
+            <a:r>
+              <a:rPr lang="en-US" sz="1600" dirty="0">
+                <a:solidFill>
+                  <a:schemeClr val="tx2"/>
+                </a:solidFill>
+              </a:rPr>
+              <a:t>@@</a:t>
+            </a:r>
+          </a:p>
+        </p:txBody>
+      </p:sp>
+      <p:sp>
+        <p:nvSpPr>
+          <p:cNvPr id="71" name="TextBox 70">
+            <a:extLst>
+              <a:ext uri="{FF2B5EF4-FFF2-40B4-BE49-F238E27FC236}">
+                <a16:creationId xmlns:a16="http://schemas.microsoft.com/office/drawing/2014/main" id="{F998ECA3-6137-80F2-D84D-98F0946FDB04}"/>
+              </a:ext>
+            </a:extLst>
+          </p:cNvPr>
+          <p:cNvSpPr txBox="1"/>
+          <p:nvPr/>
+        </p:nvSpPr>
+        <p:spPr>
+          <a:xfrm>
+            <a:off x="9414729" y="7795967"/>
+            <a:ext cx="548697" cy="355162"/>
+          </a:xfrm>
+          <a:prstGeom prst="rect">
+            <a:avLst/>
+          </a:prstGeom>
+          <a:noFill/>
+        </p:spPr>
+        <p:txBody>
+          <a:bodyPr wrap="none" lIns="90000" rtlCol="0" anchor="t">
+            <a:spAutoFit/>
+          </a:bodyPr>
+          <a:lstStyle/>
+          <a:p>
+            <a:pPr algn="ctr">
+              <a:lnSpc>
+                <a:spcPct val="113000"/>
+              </a:lnSpc>
+            </a:pPr>
+            <a:r>
+              <a:rPr lang="en-US" sz="1600" dirty="0">
+                <a:solidFill>
+                  <a:schemeClr val="tx2"/>
+                </a:solidFill>
+              </a:rPr>
+              <a:t>@@</a:t>
+            </a:r>
+          </a:p>
+        </p:txBody>
+      </p:sp>
+    </p:spTree>
+    <p:extLst>
+      <p:ext uri="{BB962C8B-B14F-4D97-AF65-F5344CB8AC3E}">
+        <p14:creationId xmlns:p14="http://schemas.microsoft.com/office/powerpoint/2010/main" val="3074526409"/>
+      </p:ext>
+    </p:extLst>
+  </p:cSld>
+  <p:clrMapOvr>
+    <a:masterClrMapping/>
+  </p:clrMapOvr>
+</p:sld>
+</file>
+
+<file path=ppt/slides/slide15.xml><?xml version="1.0" encoding="utf-8"?>
+<p:sld xmlns:a="http://schemas.openxmlformats.org/drawingml/2006/main" xmlns:r="http://schemas.openxmlformats.org/officeDocument/2006/relationships" xmlns:p="http://schemas.openxmlformats.org/presentationml/2006/main">
+  <p:cSld>
+    <p:spTree>
+      <p:nvGrpSpPr>
+        <p:cNvPr id="1" name="">
+          <a:extLst>
+            <a:ext uri="{FF2B5EF4-FFF2-40B4-BE49-F238E27FC236}">
+              <a16:creationId xmlns:a16="http://schemas.microsoft.com/office/drawing/2014/main" id="{C876FA4F-56E0-38D4-2ADF-7F5EB3DFFC86}"/>
+            </a:ext>
+          </a:extLst>
+        </p:cNvPr>
+        <p:cNvGrpSpPr/>
+        <p:nvPr/>
+      </p:nvGrpSpPr>
+      <p:grpSpPr>
+        <a:xfrm>
+          <a:off x="0" y="0"/>
+          <a:ext cx="0" cy="0"/>
+          <a:chOff x="0" y="0"/>
+          <a:chExt cx="0" cy="0"/>
+        </a:xfrm>
+      </p:grpSpPr>
+      <p:sp>
+        <p:nvSpPr>
+          <p:cNvPr id="17" name="Rectangle 16">
+            <a:extLst>
+              <a:ext uri="{FF2B5EF4-FFF2-40B4-BE49-F238E27FC236}">
+                <a16:creationId xmlns:a16="http://schemas.microsoft.com/office/drawing/2014/main" id="{1FAB8F07-6D4B-916A-C1E3-E7E3096D579E}"/>
+              </a:ext>
+            </a:extLst>
+          </p:cNvPr>
+          <p:cNvSpPr/>
+          <p:nvPr/>
+        </p:nvSpPr>
+        <p:spPr>
+          <a:xfrm flipH="1">
+            <a:off x="0" y="1368000"/>
+            <a:ext cx="12192000" cy="1658842"/>
+          </a:xfrm>
+          <a:prstGeom prst="rect">
+            <a:avLst/>
+          </a:prstGeom>
+          <a:gradFill>
+            <a:gsLst>
+              <a:gs pos="0">
+                <a:schemeClr val="bg1"/>
+              </a:gs>
+              <a:gs pos="100000">
+                <a:schemeClr val="bg2"/>
+              </a:gs>
+            </a:gsLst>
+            <a:lin ang="2700000" scaled="0"/>
+          </a:gradFill>
+          <a:ln>
+            <a:noFill/>
+          </a:ln>
+          <a:effectLst>
+            <a:outerShdw blurRad="190500" dist="38100" dir="2700000" algn="tl" rotWithShape="0">
+              <a:prstClr val="black">
+                <a:alpha val="15000"/>
+              </a:prstClr>
+            </a:outerShdw>
+          </a:effectLst>
+        </p:spPr>
+        <p:style>
+          <a:lnRef idx="2">
+            <a:schemeClr val="accent1">
+              <a:shade val="50000"/>
+            </a:schemeClr>
+          </a:lnRef>
+          <a:fillRef idx="1">
+            <a:schemeClr val="accent1"/>
+          </a:fillRef>
+          <a:effectRef idx="0">
+            <a:schemeClr val="accent1"/>
+          </a:effectRef>
+          <a:fontRef idx="minor">
+            <a:schemeClr val="lt1"/>
+          </a:fontRef>
+        </p:style>
+        <p:txBody>
+          <a:bodyPr lIns="731520" tIns="72000" rIns="108000" bIns="72000" rtlCol="0" anchor="ctr"/>
+          <a:lstStyle/>
+          <a:p>
+            <a:endParaRPr lang="nl-NL" sz="1200" b="1" noProof="0" dirty="0">
+              <a:solidFill>
+                <a:schemeClr val="accent1"/>
+              </a:solidFill>
+            </a:endParaRPr>
+          </a:p>
+        </p:txBody>
+      </p:sp>
+      <p:sp>
+        <p:nvSpPr>
+          <p:cNvPr id="3" name="Slide Number Placeholder 2">
+            <a:extLst>
+              <a:ext uri="{FF2B5EF4-FFF2-40B4-BE49-F238E27FC236}">
+                <a16:creationId xmlns:a16="http://schemas.microsoft.com/office/drawing/2014/main" id="{76E08F0F-52CE-A816-71D0-86B4FA3FF4C4}"/>
+              </a:ext>
+            </a:extLst>
+          </p:cNvPr>
+          <p:cNvSpPr>
+            <a:spLocks noGrp="1"/>
+          </p:cNvSpPr>
+          <p:nvPr>
+            <p:ph type="sldNum" sz="quarter" idx="4"/>
+          </p:nvPr>
+        </p:nvSpPr>
+        <p:spPr/>
+        <p:txBody>
+          <a:bodyPr/>
+          <a:lstStyle/>
+          <a:p>
+            <a:fld id="{E242BD21-9B61-2246-BCB1-4BE5E1BEBE1C}" type="slidenum">
+              <a:rPr lang="en-US" smtClean="0"/>
+              <a:pPr/>
+              <a:t>15</a:t>
             </a:fld>
             <a:endParaRPr lang="en-US"/>
           </a:p>
@@ -38436,7 +42312,7 @@
 </p:sld>
 </file>
 
-<file path=ppt/slides/slide15.xml><?xml version="1.0" encoding="utf-8"?>
+<file path=ppt/slides/slide16.xml><?xml version="1.0" encoding="utf-8"?>
 <p:sld xmlns:a="http://schemas.openxmlformats.org/drawingml/2006/main" xmlns:r="http://schemas.openxmlformats.org/officeDocument/2006/relationships" xmlns:p="http://schemas.openxmlformats.org/presentationml/2006/main">
   <p:cSld>
     <p:spTree>
@@ -38553,7 +42429,7 @@
             <a:fld id="{E242BD21-9B61-2246-BCB1-4BE5E1BEBE1C}" type="slidenum">
               <a:rPr lang="en-US" smtClean="0"/>
               <a:pPr/>
-              <a:t>15</a:t>
+              <a:t>16</a:t>
             </a:fld>
             <a:endParaRPr lang="en-US"/>
           </a:p>
@@ -41211,7 +45087,7 @@
 </p:sld>
 </file>
 
-<file path=ppt/slides/slide16.xml><?xml version="1.0" encoding="utf-8"?>
+<file path=ppt/slides/slide17.xml><?xml version="1.0" encoding="utf-8"?>
 <p:sld xmlns:a="http://schemas.openxmlformats.org/drawingml/2006/main" xmlns:r="http://schemas.openxmlformats.org/officeDocument/2006/relationships" xmlns:p="http://schemas.openxmlformats.org/presentationml/2006/main">
   <p:cSld>
     <p:spTree>
@@ -41328,7 +45204,7 @@
             <a:fld id="{E242BD21-9B61-2246-BCB1-4BE5E1BEBE1C}" type="slidenum">
               <a:rPr lang="en-US" smtClean="0"/>
               <a:pPr/>
-              <a:t>16</a:t>
+              <a:t>17</a:t>
             </a:fld>
             <a:endParaRPr lang="en-US"/>
           </a:p>
@@ -43986,7 +47862,7 @@
 </p:sld>
 </file>
 
-<file path=ppt/slides/slide17.xml><?xml version="1.0" encoding="utf-8"?>
+<file path=ppt/slides/slide18.xml><?xml version="1.0" encoding="utf-8"?>
 <p:sld xmlns:a="http://schemas.openxmlformats.org/drawingml/2006/main" xmlns:r="http://schemas.openxmlformats.org/officeDocument/2006/relationships" xmlns:p="http://schemas.openxmlformats.org/presentationml/2006/main">
   <p:cSld>
     <p:spTree>
@@ -47402,15 +51278,6 @@
 </file>
 
 <file path=customXml/item1.xml><?xml version="1.0" encoding="utf-8"?>
-<?mso-contentType ?>
-<FormTemplates xmlns="http://schemas.microsoft.com/sharepoint/v3/contenttype/forms">
-  <Display>DocumentLibraryForm</Display>
-  <Edit>DocumentLibraryForm</Edit>
-  <New>DocumentLibraryForm</New>
-</FormTemplates>
-</file>
-
-<file path=customXml/item2.xml><?xml version="1.0" encoding="utf-8"?>
 <p:properties xmlns:p="http://schemas.microsoft.com/office/2006/metadata/properties" xmlns:xsi="http://www.w3.org/2001/XMLSchema-instance" xmlns:pc="http://schemas.microsoft.com/office/infopath/2007/PartnerControls">
   <documentManagement>
     <lcf76f155ced4ddcb4097134ff3c332f xmlns="fa937df2-abe2-4d38-b5f4-c228acba3827">
@@ -47419,6 +51286,15 @@
     <TaxCatchAll xmlns="bc8ba18a-4a58-4ad2-bfc0-6516af8e7dc2" xsi:nil="true"/>
   </documentManagement>
 </p:properties>
+</file>
+
+<file path=customXml/item2.xml><?xml version="1.0" encoding="utf-8"?>
+<?mso-contentType ?>
+<FormTemplates xmlns="http://schemas.microsoft.com/sharepoint/v3/contenttype/forms">
+  <Display>DocumentLibraryForm</Display>
+  <Edit>DocumentLibraryForm</Edit>
+  <New>DocumentLibraryForm</New>
+</FormTemplates>
 </file>
 
 <file path=customXml/item3.xml><?xml version="1.0" encoding="utf-8"?>
@@ -47645,14 +51521,6 @@
 </file>
 
 <file path=customXml/itemProps1.xml><?xml version="1.0" encoding="utf-8"?>
-<ds:datastoreItem xmlns:ds="http://schemas.openxmlformats.org/officeDocument/2006/customXml" ds:itemID="{570928F0-D7CA-4732-B7F3-1F945720D0AA}">
-  <ds:schemaRefs>
-    <ds:schemaRef ds:uri="http://schemas.microsoft.com/sharepoint/v3/contenttype/forms"/>
-  </ds:schemaRefs>
-</ds:datastoreItem>
-</file>
-
-<file path=customXml/itemProps2.xml><?xml version="1.0" encoding="utf-8"?>
 <ds:datastoreItem xmlns:ds="http://schemas.openxmlformats.org/officeDocument/2006/customXml" ds:itemID="{4B629362-CF15-4610-8FAC-A8E699942233}">
   <ds:schemaRefs>
     <ds:schemaRef ds:uri="http://schemas.microsoft.com/office/2006/documentManagement/types"/>
@@ -47665,6 +51533,14 @@
     <ds:schemaRef ds:uri="http://schemas.openxmlformats.org/package/2006/metadata/core-properties"/>
     <ds:schemaRef ds:uri="fa937df2-abe2-4d38-b5f4-c228acba3827"/>
     <ds:schemaRef ds:uri="http://purl.org/dc/dcmitype/"/>
+  </ds:schemaRefs>
+</ds:datastoreItem>
+</file>
+
+<file path=customXml/itemProps2.xml><?xml version="1.0" encoding="utf-8"?>
+<ds:datastoreItem xmlns:ds="http://schemas.openxmlformats.org/officeDocument/2006/customXml" ds:itemID="{570928F0-D7CA-4732-B7F3-1F945720D0AA}">
+  <ds:schemaRefs>
+    <ds:schemaRef ds:uri="http://schemas.microsoft.com/sharepoint/v3/contenttype/forms"/>
   </ds:schemaRefs>
 </ds:datastoreItem>
 </file>

</xml_diff>

<commit_message>
Minor bugfix regarding color ranges
</commit_message>
<xml_diff>
--- a/src/report_generator/presets/templates/sigrid-template.pptx
+++ b/src/report_generator/presets/templates/sigrid-template.pptx
@@ -38669,7 +38669,7 @@
             <a:avLst/>
           </a:prstGeom>
           <a:solidFill>
-            <a:schemeClr val="tx2"/>
+            <a:srgbClr val="F8DCD6"/>
           </a:solidFill>
           <a:ln>
             <a:noFill/>
@@ -38781,7 +38781,7 @@
             <a:avLst/>
           </a:prstGeom>
           <a:solidFill>
-            <a:schemeClr val="tx2"/>
+            <a:srgbClr val="D4EFDC"/>
           </a:solidFill>
           <a:ln>
             <a:noFill/>
@@ -39274,8 +39274,8 @@
         </p:nvSpPr>
         <p:spPr>
           <a:xfrm>
-            <a:off x="4900339" y="7795967"/>
-            <a:ext cx="548697" cy="355162"/>
+            <a:off x="4741642" y="7795967"/>
+            <a:ext cx="866092" cy="355162"/>
           </a:xfrm>
           <a:prstGeom prst="rect">
             <a:avLst/>
@@ -39299,7 +39299,7 @@
                   <a:schemeClr val="tx2"/>
                 </a:solidFill>
               </a:rPr>
-              <a:t>@@</a:t>
+              <a:t>F3DDD7</a:t>
             </a:r>
           </a:p>
         </p:txBody>
@@ -39318,8 +39318,8 @@
         </p:nvSpPr>
         <p:spPr>
           <a:xfrm>
-            <a:off x="6706095" y="7795967"/>
-            <a:ext cx="548697" cy="355162"/>
+            <a:off x="6545795" y="7795967"/>
+            <a:ext cx="869297" cy="355162"/>
           </a:xfrm>
           <a:prstGeom prst="rect">
             <a:avLst/>
@@ -39343,7 +39343,7 @@
                   <a:schemeClr val="tx2"/>
                 </a:solidFill>
               </a:rPr>
-              <a:t>@@</a:t>
+              <a:t>D9EEDD</a:t>
             </a:r>
           </a:p>
         </p:txBody>
@@ -39521,6 +39521,62 @@
               </a:rPr>
               <a:t>@@</a:t>
             </a:r>
+          </a:p>
+        </p:txBody>
+      </p:sp>
+      <p:sp>
+        <p:nvSpPr>
+          <p:cNvPr id="74" name="Rectangle 73">
+            <a:extLst>
+              <a:ext uri="{FF2B5EF4-FFF2-40B4-BE49-F238E27FC236}">
+                <a16:creationId xmlns:a16="http://schemas.microsoft.com/office/drawing/2014/main" id="{E0016F68-3929-B0A6-9A70-964CCDA5D054}"/>
+              </a:ext>
+            </a:extLst>
+          </p:cNvPr>
+          <p:cNvSpPr/>
+          <p:nvPr/>
+        </p:nvSpPr>
+        <p:spPr>
+          <a:xfrm>
+            <a:off x="5137902" y="8172752"/>
+            <a:ext cx="353366" cy="333633"/>
+          </a:xfrm>
+          <a:prstGeom prst="rect">
+            <a:avLst/>
+          </a:prstGeom>
+          <a:solidFill>
+            <a:schemeClr val="accent2"/>
+          </a:solidFill>
+          <a:ln>
+            <a:noFill/>
+          </a:ln>
+        </p:spPr>
+        <p:style>
+          <a:lnRef idx="2">
+            <a:schemeClr val="accent1">
+              <a:shade val="50000"/>
+            </a:schemeClr>
+          </a:lnRef>
+          <a:fillRef idx="1">
+            <a:schemeClr val="accent1"/>
+          </a:fillRef>
+          <a:effectRef idx="0">
+            <a:schemeClr val="accent1"/>
+          </a:effectRef>
+          <a:fontRef idx="minor">
+            <a:schemeClr val="lt1"/>
+          </a:fontRef>
+        </p:style>
+        <p:txBody>
+          <a:bodyPr lIns="108000" tIns="72000" rIns="108000" bIns="72000" rtlCol="0" anchor="ctr"/>
+          <a:lstStyle/>
+          <a:p>
+            <a:pPr algn="ctr"/>
+            <a:endParaRPr lang="en-US" sz="1600" dirty="0" err="1">
+              <a:solidFill>
+                <a:schemeClr val="bg1"/>
+              </a:solidFill>
+            </a:endParaRPr>
           </a:p>
         </p:txBody>
       </p:sp>

</xml_diff>